<commit_message>
fix(phase09): replace unverified reference and sync RF ROC-AUC on slides
- Slide 15: drop the "IEEE Access 2026 (doi pending)" placeholder; cite the
  dataset as its README prescribes, with the GitHub repo, sample counts and
  licence (ref [4]), and add ref [6] for the other real data sources. Slide 5
  now cites [4] and [6]. Refs are laid out in one text box so they fit
  without relying on shrink-to-fit.
- Slide 9 now shows Random Forest ROC-AUC 99.77% (read from the updated
  random_forest_metrics.json), matching the ROC figure on slide 10; refresh
  the related Q&A speaker note.
- Slide 1 speaker notes: remind to enable Fade 0.3s natively in PowerPoint;
  drop the XML transition script hint from the build output.
- Regenerate phase09_presentation.pptx.
</commit_message>
<xml_diff>
--- a/draft/scam-detection/reports/slides/phase09_presentation.pptx
+++ b/draft/scam-detection/reports/slides/phase09_presentation.pptx
@@ -4,9 +4,6 @@
   <p:sldMasterIdLst>
     <p:sldMasterId id="2147483648" r:id="rId1"/>
   </p:sldMasterIdLst>
-  <p:notesMasterIdLst>
-    <p:notesMasterId r:id="rId22"/>
-  </p:notesMasterIdLst>
   <p:sldIdLst>
     <p:sldId id="256" r:id="rId2"/>
     <p:sldId id="257" r:id="rId3"/>
@@ -29,7 +26,10 @@
     <p:sldId id="274" r:id="rId20"/>
     <p:sldId id="275" r:id="rId21"/>
   </p:sldIdLst>
-  <p:sldSz cx="9144000" cy="5143500" type="screen16x9"/>
+  <p:notesMasterIdLst>
+    <p:notesMasterId r:id="rId22"/>
+  </p:notesMasterIdLst>
+  <p:sldSz cx="9144000" cy="5143500"/>
   <p:notesSz cx="5143500" cy="9144000"/>
   <p:defaultTextStyle>
     <a:lvl1pPr marL="0" algn="l" defTabSz="914400" rtl="0" eaLnBrk="1" latinLnBrk="0" hangingPunct="1">
@@ -123,41 +123,7 @@
       </a:defRPr>
     </a:lvl9pPr>
   </p:defaultTextStyle>
-  <p:extLst>
-    <p:ext uri="{EFAFB233-063F-42B5-8137-9DF3F51BA10A}">
-      <p15:sldGuideLst xmlns:p15="http://schemas.microsoft.com/office/powerpoint/2012/main"/>
-    </p:ext>
-  </p:extLst>
 </p:presentation>
-</file>
-
-<file path=ppt/changesInfos/changesInfo1.xml><?xml version="1.0" encoding="utf-8"?>
-<pc:chgInfo xmlns:a="http://schemas.openxmlformats.org/drawingml/2006/main" xmlns:r="http://schemas.openxmlformats.org/officeDocument/2006/relationships" xmlns:ac="http://schemas.microsoft.com/office/drawing/2013/main/command" xmlns:pc="http://schemas.microsoft.com/office/powerpoint/2013/main/command">
-  <pc:docChgLst>
-    <pc:chgData name="Mỷ Cẩm" userId="2f7d1b655b90127a" providerId="LiveId" clId="{BE1B56B2-9ED1-4C5B-8C1B-0C71FE67AC87}"/>
-    <pc:docChg chg="modSld">
-      <pc:chgData name="Mỷ Cẩm" userId="2f7d1b655b90127a" providerId="LiveId" clId="{BE1B56B2-9ED1-4C5B-8C1B-0C71FE67AC87}" dt="2026-09-20T18:24:51.625" v="0" actId="1076"/>
-      <pc:docMkLst>
-        <pc:docMk/>
-      </pc:docMkLst>
-      <pc:sldChg chg="modSp mod">
-        <pc:chgData name="Mỷ Cẩm" userId="2f7d1b655b90127a" providerId="LiveId" clId="{BE1B56B2-9ED1-4C5B-8C1B-0C71FE67AC87}" dt="2026-09-20T18:24:51.625" v="0" actId="1076"/>
-        <pc:sldMkLst>
-          <pc:docMk/>
-          <pc:sldMk cId="0" sldId="268"/>
-        </pc:sldMkLst>
-        <pc:picChg chg="mod">
-          <ac:chgData name="Mỷ Cẩm" userId="2f7d1b655b90127a" providerId="LiveId" clId="{BE1B56B2-9ED1-4C5B-8C1B-0C71FE67AC87}" dt="2026-09-20T18:24:51.625" v="0" actId="1076"/>
-          <ac:picMkLst>
-            <pc:docMk/>
-            <pc:sldMk cId="0" sldId="268"/>
-            <ac:picMk id="7" creationId="{00000000-0000-0000-0000-000000000000}"/>
-          </ac:picMkLst>
-        </pc:picChg>
-      </pc:sldChg>
-    </pc:docChg>
-  </pc:docChgLst>
-</pc:chgInfo>
 </file>
 
 <file path=ppt/notesMasters/notesMaster1.xml><?xml version="1.0" encoding="utf-8"?>
@@ -182,10 +148,234 @@
           <a:chExt cx="0" cy="0"/>
         </a:xfrm>
       </p:grpSpPr>
+      <p:sp>
+        <p:nvSpPr>
+          <p:cNvPr id="2" name="Header Placeholder 1"/>
+          <p:cNvSpPr>
+            <a:spLocks noGrp="1"/>
+          </p:cNvSpPr>
+          <p:nvPr>
+            <p:ph type="hdr" sz="quarter"/>
+          </p:nvPr>
+        </p:nvSpPr>
+        <p:spPr>
+          <a:xfrm>
+            <a:off x="0" y="0"/>
+            <a:ext cx="2971800" cy="458788"/>
+          </a:xfrm>
+          <a:prstGeom prst="rect">
+            <a:avLst/>
+          </a:prstGeom>
+        </p:spPr>
+        <p:txBody>
+          <a:bodyPr vert="horz" lIns="91440" tIns="45720" rIns="91440" bIns="45720" rtlCol="0"/>
+          <a:lstStyle>
+            <a:lvl1pPr algn="l">
+              <a:defRPr sz="1200"/>
+            </a:lvl1pPr>
+          </a:lstStyle>
+          <a:p>
+            <a:endParaRPr lang="en-US"/>
+          </a:p>
+        </p:txBody>
+      </p:sp>
+      <p:sp>
+        <p:nvSpPr>
+          <p:cNvPr id="3" name="Date Placeholder 2"/>
+          <p:cNvSpPr>
+            <a:spLocks noGrp="1"/>
+          </p:cNvSpPr>
+          <p:nvPr>
+            <p:ph type="dt" idx="1"/>
+          </p:nvPr>
+        </p:nvSpPr>
+        <p:spPr>
+          <a:xfrm>
+            <a:off x="3884613" y="0"/>
+            <a:ext cx="2971800" cy="458788"/>
+          </a:xfrm>
+          <a:prstGeom prst="rect">
+            <a:avLst/>
+          </a:prstGeom>
+        </p:spPr>
+        <p:txBody>
+          <a:bodyPr vert="horz" lIns="91440" tIns="45720" rIns="91440" bIns="45720" rtlCol="0"/>
+          <a:lstStyle>
+            <a:lvl1pPr algn="r">
+              <a:defRPr sz="1200"/>
+            </a:lvl1pPr>
+          </a:lstStyle>
+          <a:p>
+            <a:fld id="{5282F153-3F37-0F45-9E97-73ACFA13230C}" type="datetimeFigureOut">
+              <a:rPr lang="en-US"/>
+              <a:t>7/23/19</a:t>
+            </a:fld>
+            <a:endParaRPr lang="en-US"/>
+          </a:p>
+        </p:txBody>
+      </p:sp>
+      <p:sp>
+        <p:nvSpPr>
+          <p:cNvPr id="4" name="Slide Image Placeholder 3"/>
+          <p:cNvSpPr>
+            <a:spLocks noGrp="1" noRot="1" noChangeAspect="1"/>
+          </p:cNvSpPr>
+          <p:nvPr>
+            <p:ph type="sldImg" idx="2"/>
+          </p:nvPr>
+        </p:nvSpPr>
+        <p:spPr>
+          <a:xfrm>
+            <a:off x="685800" y="1143000"/>
+            <a:ext cx="5486400" cy="3086100"/>
+          </a:xfrm>
+          <a:prstGeom prst="rect">
+            <a:avLst/>
+          </a:prstGeom>
+          <a:noFill/>
+          <a:ln w="12700">
+            <a:solidFill>
+              <a:prstClr val="black"/>
+            </a:solidFill>
+          </a:ln>
+        </p:spPr>
+        <p:txBody>
+          <a:bodyPr vert="horz" lIns="91440" tIns="45720" rIns="91440" bIns="45720" rtlCol="0" anchor="ctr"/>
+          <a:lstStyle/>
+          <a:p>
+            <a:endParaRPr lang="en-US"/>
+          </a:p>
+        </p:txBody>
+      </p:sp>
+      <p:sp>
+        <p:nvSpPr>
+          <p:cNvPr id="5" name="Notes Placeholder 4"/>
+          <p:cNvSpPr>
+            <a:spLocks noGrp="1"/>
+          </p:cNvSpPr>
+          <p:nvPr>
+            <p:ph type="body" sz="quarter" idx="3"/>
+          </p:nvPr>
+        </p:nvSpPr>
+        <p:spPr>
+          <a:xfrm>
+            <a:off x="685800" y="4400550"/>
+            <a:ext cx="5486400" cy="3600450"/>
+          </a:xfrm>
+          <a:prstGeom prst="rect">
+            <a:avLst/>
+          </a:prstGeom>
+        </p:spPr>
+        <p:txBody>
+          <a:bodyPr vert="horz" lIns="91440" tIns="45720" rIns="91440" bIns="45720" rtlCol="0"/>
+          <a:lstStyle/>
+          <a:p>
+            <a:pPr lvl="0"/>
+            <a:r>
+              <a:rPr lang="en-US"/>
+              <a:t>Click to edit Master text styles</a:t>
+            </a:r>
+          </a:p>
+          <a:p>
+            <a:pPr lvl="1"/>
+            <a:r>
+              <a:rPr lang="en-US"/>
+              <a:t>Second level</a:t>
+            </a:r>
+          </a:p>
+          <a:p>
+            <a:pPr lvl="2"/>
+            <a:r>
+              <a:rPr lang="en-US"/>
+              <a:t>Third level</a:t>
+            </a:r>
+          </a:p>
+          <a:p>
+            <a:pPr lvl="3"/>
+            <a:r>
+              <a:rPr lang="en-US"/>
+              <a:t>Fourth level</a:t>
+            </a:r>
+          </a:p>
+          <a:p>
+            <a:pPr lvl="4"/>
+            <a:r>
+              <a:rPr lang="en-US"/>
+              <a:t>Fifth level</a:t>
+            </a:r>
+          </a:p>
+        </p:txBody>
+      </p:sp>
+      <p:sp>
+        <p:nvSpPr>
+          <p:cNvPr id="6" name="Footer Placeholder 5"/>
+          <p:cNvSpPr>
+            <a:spLocks noGrp="1"/>
+          </p:cNvSpPr>
+          <p:nvPr>
+            <p:ph type="ftr" sz="quarter" idx="4"/>
+          </p:nvPr>
+        </p:nvSpPr>
+        <p:spPr>
+          <a:xfrm>
+            <a:off x="0" y="8685213"/>
+            <a:ext cx="2971800" cy="458787"/>
+          </a:xfrm>
+          <a:prstGeom prst="rect">
+            <a:avLst/>
+          </a:prstGeom>
+        </p:spPr>
+        <p:txBody>
+          <a:bodyPr vert="horz" lIns="91440" tIns="45720" rIns="91440" bIns="45720" rtlCol="0" anchor="b"/>
+          <a:lstStyle>
+            <a:lvl1pPr algn="l">
+              <a:defRPr sz="1200"/>
+            </a:lvl1pPr>
+          </a:lstStyle>
+          <a:p>
+            <a:endParaRPr lang="en-US"/>
+          </a:p>
+        </p:txBody>
+      </p:sp>
+      <p:sp>
+        <p:nvSpPr>
+          <p:cNvPr id="7" name="Slide Number Placeholder 6"/>
+          <p:cNvSpPr>
+            <a:spLocks noGrp="1"/>
+          </p:cNvSpPr>
+          <p:nvPr>
+            <p:ph type="sldNum" sz="quarter" idx="5"/>
+          </p:nvPr>
+        </p:nvSpPr>
+        <p:spPr>
+          <a:xfrm>
+            <a:off x="3884613" y="8685213"/>
+            <a:ext cx="2971800" cy="458787"/>
+          </a:xfrm>
+          <a:prstGeom prst="rect">
+            <a:avLst/>
+          </a:prstGeom>
+        </p:spPr>
+        <p:txBody>
+          <a:bodyPr vert="horz" lIns="91440" tIns="45720" rIns="91440" bIns="45720" rtlCol="0" anchor="b"/>
+          <a:lstStyle>
+            <a:lvl1pPr algn="r">
+              <a:defRPr sz="1200"/>
+            </a:lvl1pPr>
+          </a:lstStyle>
+          <a:p>
+            <a:fld id="{CE5E9CC1-C706-0F49-92D6-E571CC5EEA8F}" type="slidenum">
+              <a:rPr lang="en-US"/>
+              <a:t>‹#›</a:t>
+            </a:fld>
+            <a:endParaRPr lang="en-US"/>
+          </a:p>
+        </p:txBody>
+      </p:sp>
     </p:spTree>
     <p:extLst>
       <p:ext uri="{BB962C8B-B14F-4D97-AF65-F5344CB8AC3E}">
-        <p14:creationId xmlns:p14="http://schemas.microsoft.com/office/powerpoint/2010/main" val="4281781291"/>
+        <p14:creationId xmlns:p14="http://schemas.microsoft.com/office/powerpoint/2010/main" val="1024086991"/>
       </p:ext>
     </p:extLst>
   </p:cSld>
@@ -334,8 +524,10 @@
               <a:t>SLIDE 1 — COVER
 - Người trình bày đầu tiên: Đặng Chí Thanh (PM)
 - Giới thiệu tên đề tài và các thành viên
-- Nhấn mạnh: đề tài bảo vệ người cao tuổi khỏi lừa đảo tin nhắn tiếng Việt</a:t>
-            </a:r>
+- Nhấn mạnh: đề tài bảo vệ người cao tuổi khỏi lừa đảo tin nhắn tiếng Việt
+- Trước khi chiếu: PowerPoint → chọn tất cả slide → Transitions → Fade (0.3s) → Apply To All. Không dùng script chèn XML (tránh lỗi file)</a:t>
+            </a:r>
+            <a:endParaRPr lang="en-US" dirty="0"/>
           </a:p>
         </p:txBody>
       </p:sp>
@@ -426,6 +618,7 @@
 - Vì dữ liệu mất cân bằng (4.2:1) nên PR curve phản ánh sát hơn ROC
 - Chuyển sang: SHAP giải thích model</a:t>
             </a:r>
+            <a:endParaRPr lang="en-US" dirty="0"/>
           </a:p>
         </p:txBody>
       </p:sp>
@@ -518,6 +711,7 @@
 - Cách đọc SHAP beeswarm: trục ngang là mức đẩy về lớp Lừa đảo; màu là giá trị đặc trưng
 - Chuyển sang: Demo ứng dụng</a:t>
             </a:r>
+            <a:endParaRPr lang="en-US" dirty="0"/>
           </a:p>
         </p:txBody>
       </p:sp>
@@ -601,6 +795,10 @@
           <a:bodyPr/>
           <a:lstStyle/>
           <a:p>
+            <a:r>
+              <a:rPr lang="en-US" dirty="0"/>
+              <a:t/>
+            </a:r>
             <a:endParaRPr lang="en-US" dirty="0"/>
           </a:p>
         </p:txBody>
@@ -693,6 +891,7 @@
 - Nhấn: trợ năng cho người cao tuổi (chỉnh cỡ chữ, hotline 1 chạm)
 - Chuyển sang: Kết luận</a:t>
             </a:r>
+            <a:endParaRPr lang="en-US" dirty="0"/>
           </a:p>
         </p:txBody>
       </p:sp>
@@ -785,6 +984,7 @@
 - Hạn chế trung thực: tập test chỉ có 84 mẫu lừa đảo nên mỗi FN thay đổi Recall ~1.2 điểm
 - Mở ra: tích hợp PhoBERT và mở rộng sang voice scam</a:t>
             </a:r>
+            <a:endParaRPr lang="en-US" dirty="0"/>
           </a:p>
         </p:txBody>
       </p:sp>
@@ -871,9 +1071,11 @@
             <a:r>
               <a:rPr lang="en-US" dirty="0"/>
               <a:t>SLIDE 15 — THAM KHẢO
-- [1] XGBoost, [2] hiệu chỉnh xác suất SVM (CalibratedClassifierCV), [3] PhoBERT (hướng phát triển), [4] nguồn dữ liệu bình thường, [5] scikit-learn
-- Q&amp;A: [4] đang chờ DOI — trình bày rõ là nguồn dữ liệu công khai nhóm đã ghi provenance trong dataset</a:t>
-            </a:r>
+- [1] XGBoost, [2] hiệu chỉnh xác suất SVM (CalibratedClassifierCV), [3] PhoBERT (hướng phát triển), [4] bộ dữ liệu SMS chính, [5] scikit-learn, [6] các nguồn dữ liệu bổ sung
+- Q&amp;A về [4]: trích đúng theo yêu cầu của tác giả bộ dữ liệu trong README (bài IEEE Access 2026); nhóm không khẳng định bài đã xuất bản (chưa có tập/DOI). Điều nhóm dùng và kiểm chứng được là bộ dữ liệu công khai trên GitHub, mỗi mẫu có URL truy vết trong dataset.csv
+- 1.944/2.193 mẫu (88.7%) đến từ repo [4]; 249 mẫu lừa đảo còn lại từ nguồn [6]</a:t>
+            </a:r>
+            <a:endParaRPr lang="en-US" dirty="0"/>
           </a:p>
         </p:txBody>
       </p:sp>
@@ -963,6 +1165,7 @@
 - Mời Thầy và hội đồng đặt câu hỏi
 - Backup slides có: siêu tham số, confusion matrices, learning curves</a:t>
             </a:r>
+            <a:endParaRPr lang="en-US" dirty="0"/>
           </a:p>
         </p:txBody>
       </p:sp>
@@ -1046,6 +1249,10 @@
           <a:bodyPr/>
           <a:lstStyle/>
           <a:p>
+            <a:r>
+              <a:rPr lang="en-US" dirty="0"/>
+              <a:t/>
+            </a:r>
             <a:endParaRPr lang="en-US" dirty="0"/>
           </a:p>
         </p:txBody>
@@ -1137,6 +1344,7 @@
 - Naive Bayes chọn alpha=0.01 và chỉ dùng TF-IDF vì đặc trưng phụ có giá trị âm
 - CV F1 (train) gần với F1 test → mô hình khái quát tốt</a:t>
             </a:r>
+            <a:endParaRPr lang="en-US" dirty="0"/>
           </a:p>
         </p:txBody>
       </p:sp>
@@ -1227,6 +1435,7 @@
 - XGBoost và Random Forest cùng FN nhỏ nhất; Random Forest báo nhầm nhiều hơn (FP cao hơn)
 - Naive Bayes FN và FP cao nhất — vai trò baseline</a:t>
             </a:r>
+            <a:endParaRPr lang="en-US" dirty="0"/>
           </a:p>
         </p:txBody>
       </p:sp>
@@ -1319,6 +1528,7 @@
 - Bài toán ưu tiên Recall vì bỏ lọt tin lừa đảo nguy hiểm hơn báo nhầm
 - Chuyển sang: Mục tiêu nghiên cứu</a:t>
             </a:r>
+            <a:endParaRPr lang="en-US" dirty="0"/>
           </a:p>
         </p:txBody>
       </p:sp>
@@ -1409,6 +1619,7 @@
 - Điểm tích cực: Validation F1 vẫn đang tăng theo số mẫu (thêm dữ liệu sẽ cải thiện) và F1 test sát CV F1 nên không có dấu hiệu khái quát kém
 - Naive Bayes: Train F1 giảm, Validation tăng dần — hội tụ ~0.91</a:t>
             </a:r>
+            <a:endParaRPr lang="en-US" dirty="0"/>
           </a:p>
         </p:txBody>
       </p:sp>
@@ -1499,6 +1710,7 @@
 - Nhấn: cả 4 mô hình đều vượt chỉ tiêu đề ra
 - Chuyển sang: Phần Dữ liệu</a:t>
             </a:r>
+            <a:endParaRPr lang="en-US" dirty="0"/>
           </a:p>
         </p:txBody>
       </p:sp>
@@ -1582,6 +1794,10 @@
           <a:bodyPr/>
           <a:lstStyle/>
           <a:p>
+            <a:r>
+              <a:rPr lang="en-US" dirty="0"/>
+              <a:t/>
+            </a:r>
             <a:endParaRPr lang="en-US" dirty="0"/>
           </a:p>
         </p:txBody>
@@ -1675,6 +1891,7 @@
 - Mất cân bằng lớp 4.2:1 nên dùng Recall/F1, không dùng Accuracy
 - Chuyển sang: phân loại 4 nhóm bẫy tâm lý</a:t>
             </a:r>
+            <a:endParaRPr lang="en-US" dirty="0"/>
           </a:p>
         </p:txBody>
       </p:sp>
@@ -1766,6 +1983,7 @@
 - Nhóm Quà tặng (46) ít nhưng rất tinh vi
 - Chuyển sang: pipeline kỹ thuật</a:t>
             </a:r>
+            <a:endParaRPr lang="en-US" dirty="0"/>
           </a:p>
         </p:txBody>
       </p:sp>
@@ -1858,6 +2076,7 @@
 - Naive Bayes chỉ dùng TF-IDF vì đặc trưng phụ có giá trị âm không hợp với MultinomialNB
 - Chuyển sang: phần Mô hình</a:t>
             </a:r>
+            <a:endParaRPr lang="en-US" dirty="0"/>
           </a:p>
         </p:txBody>
       </p:sp>
@@ -1941,6 +2160,10 @@
           <a:bodyPr/>
           <a:lstStyle/>
           <a:p>
+            <a:r>
+              <a:rPr lang="en-US" dirty="0"/>
+              <a:t/>
+            </a:r>
             <a:endParaRPr lang="en-US" dirty="0"/>
           </a:p>
         </p:txBody>
@@ -2032,9 +2255,10 @@
 - SVM có ROC-AUC cao nhất (99.86%) nhưng F1 thấp hơn XGBoost
 - Naive Bayes vẫn đạt F1=88.64% — baseline tốt, chỉ dùng TF-IDF
 - Nhấn: tất cả đều vượt chỉ tiêu GV yêu cầu
-- Q&amp;A: ROC-AUC Random Forest = 99.76% theo log huấn luyện Phase 05 (0.99755); ảnh ROC và model_comparison.csv (tính lại ở Phase 07) ghi 0.9977 — chênh do làm tròn/tính lại
+- Q&amp;A: ROC-AUC Random Forest = 99.77% — anh Thanh đánh giá lại random_forest.pkl trên tập test (0.99765), khớp với ảnh ROC ở slide 10
 - Q&amp;A: FN của từng mô hình — XGB 2, RF 2, SVM 3, NB 6</a:t>
             </a:r>
+            <a:endParaRPr lang="en-US" dirty="0"/>
           </a:p>
         </p:txBody>
       </p:sp>
@@ -2107,11 +2331,6 @@
 <file path=ppt/slideMasters/slideMaster1.xml><?xml version="1.0" encoding="utf-8"?>
 <p:sldMaster xmlns:a="http://schemas.openxmlformats.org/drawingml/2006/main" xmlns:r="http://schemas.openxmlformats.org/officeDocument/2006/relationships" xmlns:p="http://schemas.openxmlformats.org/presentationml/2006/main">
   <p:cSld>
-    <p:bg>
-      <p:bgRef idx="1001">
-        <a:schemeClr val="bg1"/>
-      </p:bgRef>
-    </p:bg>
     <p:spTree>
       <p:nvGrpSpPr>
         <p:cNvPr id="1" name=""/>
@@ -2394,7 +2613,6 @@
         <a:solidFill>
           <a:srgbClr val="0B2545"/>
         </a:solidFill>
-        <a:effectLst/>
       </p:bgPr>
     </p:bg>
     <p:spTree>
@@ -2452,7 +2670,7 @@
           <a:bodyPr wrap="square" rtlCol="0" anchor="ctr"/>
           <a:lstStyle/>
           <a:p>
-            <a:pPr marL="0" indent="0" algn="ctr">
+            <a:pPr algn="ctr" indent="0" marL="0">
               <a:buNone/>
             </a:pPr>
             <a:r>
@@ -2490,7 +2708,7 @@
           </a:bodyPr>
           <a:lstStyle/>
           <a:p>
-            <a:pPr marL="0" indent="0" algn="ctr">
+            <a:pPr algn="ctr" indent="0" marL="0">
               <a:buNone/>
             </a:pPr>
             <a:r>
@@ -2507,7 +2725,7 @@
             <a:endParaRPr lang="en-US" sz="2800" dirty="0"/>
           </a:p>
           <a:p>
-            <a:pPr marL="0" indent="0" algn="ctr">
+            <a:pPr algn="ctr" indent="0" marL="0">
               <a:buNone/>
             </a:pPr>
             <a:r>
@@ -2546,7 +2764,7 @@
           <a:bodyPr wrap="square" rtlCol="0" anchor="ctr"/>
           <a:lstStyle/>
           <a:p>
-            <a:pPr marL="0" indent="0" algn="ctr">
+            <a:pPr algn="ctr" indent="0" marL="0">
               <a:buNone/>
             </a:pPr>
             <a:r>
@@ -2605,7 +2823,7 @@
           <a:bodyPr wrap="square" rtlCol="0" anchor="ctr"/>
           <a:lstStyle/>
           <a:p>
-            <a:pPr marL="0" indent="0" algn="ctr">
+            <a:pPr algn="ctr" indent="0" marL="0">
               <a:buNone/>
             </a:pPr>
             <a:r>
@@ -2646,7 +2864,7 @@
           </a:bodyPr>
           <a:lstStyle/>
           <a:p>
-            <a:pPr marL="0" indent="0" algn="ctr">
+            <a:pPr algn="ctr" indent="0" marL="0">
               <a:buNone/>
             </a:pPr>
             <a:r>
@@ -2685,7 +2903,7 @@
           <a:bodyPr wrap="square" rtlCol="0" anchor="ctr"/>
           <a:lstStyle/>
           <a:p>
-            <a:pPr marL="0" indent="0" algn="ctr">
+            <a:pPr algn="ctr" indent="0" marL="0">
               <a:buNone/>
             </a:pPr>
             <a:r>
@@ -2719,7 +2937,6 @@
         <a:solidFill>
           <a:srgbClr val="FFFFFF"/>
         </a:solidFill>
-        <a:effectLst/>
       </p:bgPr>
     </p:bg>
     <p:spTree>
@@ -2797,7 +3014,7 @@
           <a:bodyPr wrap="square" rtlCol="0" anchor="ctr"/>
           <a:lstStyle/>
           <a:p>
-            <a:pPr marL="0" indent="0">
+            <a:pPr indent="0" marL="0">
               <a:buNone/>
             </a:pPr>
             <a:r>
@@ -2836,7 +3053,7 @@
           <a:bodyPr wrap="square" rtlCol="0" anchor="ctr"/>
           <a:lstStyle/>
           <a:p>
-            <a:pPr marL="0" indent="0" algn="r">
+            <a:pPr algn="r" indent="0" marL="0">
               <a:buNone/>
             </a:pPr>
             <a:r>
@@ -2877,7 +3094,7 @@
           </a:bodyPr>
           <a:lstStyle/>
           <a:p>
-            <a:pPr marL="0" indent="0">
+            <a:pPr indent="0" marL="0">
               <a:buNone/>
             </a:pPr>
             <a:r>
@@ -2897,14 +3114,14 @@
       </p:sp>
       <p:pic>
         <p:nvPicPr>
-          <p:cNvPr id="7" name="Image 0" descr="C:\Users\ADMIN\OneDrive\Documents\MÁY HỌC\ĐỒ ÁN MÔN MÁY HỌC\CS114-Team10-Elderly-Scam-Detection\draft\scam-detection\reports\figures\roc_curves_comparison.png"/>
+          <p:cNvPr id="7" name="Image 0" descr="C:\Users\ADMIN\OneDrive\Documents\MÁY HỌC\ĐỒ ÁN MÔN MÁY HỌC\CS114-Team10-Elderly-Scam-Detection\draft\scam-detection\reports\figures\roc_curves_comparison.png">    </p:cNvPr>
           <p:cNvPicPr>
             <a:picLocks noChangeAspect="1"/>
           </p:cNvPicPr>
           <p:nvPr/>
         </p:nvPicPr>
         <p:blipFill>
-          <a:blip r:embed="rId3"/>
+          <a:blip r:embed="rId1"/>
           <a:stretch>
             <a:fillRect/>
           </a:stretch>
@@ -2940,7 +3157,7 @@
           <a:bodyPr wrap="square" rtlCol="0" anchor="ctr"/>
           <a:lstStyle/>
           <a:p>
-            <a:pPr marL="0" indent="0" algn="ctr">
+            <a:pPr algn="ctr" indent="0" marL="0">
               <a:buNone/>
             </a:pPr>
             <a:r>
@@ -2960,14 +3177,14 @@
       </p:sp>
       <p:pic>
         <p:nvPicPr>
-          <p:cNvPr id="9" name="Image 1" descr="C:\Users\ADMIN\OneDrive\Documents\MÁY HỌC\ĐỒ ÁN MÔN MÁY HỌC\CS114-Team10-Elderly-Scam-Detection\draft\scam-detection\reports\figures\precision_recall_curves.png"/>
+          <p:cNvPr id="9" name="Image 1" descr="C:\Users\ADMIN\OneDrive\Documents\MÁY HỌC\ĐỒ ÁN MÔN MÁY HỌC\CS114-Team10-Elderly-Scam-Detection\draft\scam-detection\reports\figures\precision_recall_curves.png">    </p:cNvPr>
           <p:cNvPicPr>
             <a:picLocks noChangeAspect="1"/>
           </p:cNvPicPr>
           <p:nvPr/>
         </p:nvPicPr>
         <p:blipFill>
-          <a:blip r:embed="rId4"/>
+          <a:blip r:embed="rId2"/>
           <a:stretch>
             <a:fillRect/>
           </a:stretch>
@@ -3003,7 +3220,7 @@
           <a:bodyPr wrap="square" rtlCol="0" anchor="ctr"/>
           <a:lstStyle/>
           <a:p>
-            <a:pPr marL="0" indent="0" algn="ctr">
+            <a:pPr algn="ctr" indent="0" marL="0">
               <a:buNone/>
             </a:pPr>
             <a:r>
@@ -3089,7 +3306,7 @@
           </a:bodyPr>
           <a:lstStyle/>
           <a:p>
-            <a:pPr marL="0" indent="0">
+            <a:pPr indent="0" marL="0">
               <a:buNone/>
             </a:pPr>
             <a:r>
@@ -3123,7 +3340,6 @@
         <a:solidFill>
           <a:srgbClr val="FFFFFF"/>
         </a:solidFill>
-        <a:effectLst/>
       </p:bgPr>
     </p:bg>
     <p:spTree>
@@ -3201,7 +3417,7 @@
           <a:bodyPr wrap="square" rtlCol="0" anchor="ctr"/>
           <a:lstStyle/>
           <a:p>
-            <a:pPr marL="0" indent="0">
+            <a:pPr indent="0" marL="0">
               <a:buNone/>
             </a:pPr>
             <a:r>
@@ -3240,7 +3456,7 @@
           <a:bodyPr wrap="square" rtlCol="0" anchor="ctr"/>
           <a:lstStyle/>
           <a:p>
-            <a:pPr marL="0" indent="0" algn="r">
+            <a:pPr algn="r" indent="0" marL="0">
               <a:buNone/>
             </a:pPr>
             <a:r>
@@ -3281,7 +3497,7 @@
           </a:bodyPr>
           <a:lstStyle/>
           <a:p>
-            <a:pPr marL="0" indent="0">
+            <a:pPr indent="0" marL="0">
               <a:buNone/>
             </a:pPr>
             <a:r>
@@ -3364,7 +3580,7 @@
             <a:endParaRPr lang="en-US" sz="1400" dirty="0"/>
           </a:p>
           <a:p>
-            <a:pPr marL="355600" lvl="1" indent="-177800">
+            <a:pPr lvl="1" marL="355600" indent="-177800">
               <a:spcAft>
                 <a:spcPts val="600"/>
               </a:spcAft>
@@ -3385,7 +3601,7 @@
             <a:endParaRPr lang="en-US" sz="1400" dirty="0"/>
           </a:p>
           <a:p>
-            <a:pPr marL="355600" lvl="1" indent="-177800">
+            <a:pPr lvl="1" marL="355600" indent="-177800">
               <a:spcAft>
                 <a:spcPts val="600"/>
               </a:spcAft>
@@ -3406,7 +3622,7 @@
             <a:endParaRPr lang="en-US" sz="1400" dirty="0"/>
           </a:p>
           <a:p>
-            <a:pPr marL="355600" lvl="1" indent="-177800">
+            <a:pPr lvl="1" marL="355600" indent="-177800">
               <a:spcAft>
                 <a:spcPts val="600"/>
               </a:spcAft>
@@ -3472,14 +3688,14 @@
       </p:sp>
       <p:pic>
         <p:nvPicPr>
-          <p:cNvPr id="8" name="Image 0" descr="C:\Users\ADMIN\OneDrive\Documents\MÁY HỌC\ĐỒ ÁN MÔN MÁY HỌC\CS114-Team10-Elderly-Scam-Detection\draft\scam-detection\reports\figures\shap_summary.png"/>
+          <p:cNvPr id="8" name="Image 0" descr="C:\Users\ADMIN\OneDrive\Documents\MÁY HỌC\ĐỒ ÁN MÔN MÁY HỌC\CS114-Team10-Elderly-Scam-Detection\draft\scam-detection\reports\figures\shap_summary.png">    </p:cNvPr>
           <p:cNvPicPr>
             <a:picLocks noChangeAspect="1"/>
           </p:cNvPicPr>
           <p:nvPr/>
         </p:nvPicPr>
         <p:blipFill>
-          <a:blip r:embed="rId3"/>
+          <a:blip r:embed="rId1"/>
           <a:stretch>
             <a:fillRect/>
           </a:stretch>
@@ -3517,7 +3733,7 @@
           </a:bodyPr>
           <a:lstStyle/>
           <a:p>
-            <a:pPr marL="0" indent="0">
+            <a:pPr indent="0" marL="0">
               <a:buNone/>
             </a:pPr>
             <a:r>
@@ -3551,7 +3767,6 @@
         <a:solidFill>
           <a:srgbClr val="0B2545"/>
         </a:solidFill>
-        <a:effectLst/>
       </p:bgPr>
     </p:bg>
     <p:spTree>
@@ -3591,7 +3806,7 @@
           </a:bodyPr>
           <a:lstStyle/>
           <a:p>
-            <a:pPr marL="0" indent="0" algn="ctr">
+            <a:pPr algn="ctr" indent="0" marL="0">
               <a:buNone/>
             </a:pPr>
             <a:r>
@@ -3608,7 +3823,7 @@
             <a:endParaRPr lang="en-US" sz="3600" dirty="0"/>
           </a:p>
           <a:p>
-            <a:pPr marL="0" indent="0" algn="ctr">
+            <a:pPr algn="ctr" indent="0" marL="0">
               <a:buNone/>
             </a:pPr>
             <a:r>
@@ -3667,7 +3882,7 @@
           <a:bodyPr wrap="square" rtlCol="0" anchor="ctr"/>
           <a:lstStyle/>
           <a:p>
-            <a:pPr marL="0" indent="0" algn="ctr">
+            <a:pPr algn="ctr" indent="0" marL="0">
               <a:buNone/>
             </a:pPr>
             <a:r>
@@ -3701,7 +3916,6 @@
         <a:solidFill>
           <a:srgbClr val="FFFFFF"/>
         </a:solidFill>
-        <a:effectLst/>
       </p:bgPr>
     </p:bg>
     <p:spTree>
@@ -3779,7 +3993,7 @@
           <a:bodyPr wrap="square" rtlCol="0" anchor="ctr"/>
           <a:lstStyle/>
           <a:p>
-            <a:pPr marL="0" indent="0">
+            <a:pPr indent="0" marL="0">
               <a:buNone/>
             </a:pPr>
             <a:r>
@@ -3818,7 +4032,7 @@
           <a:bodyPr wrap="square" rtlCol="0" anchor="ctr"/>
           <a:lstStyle/>
           <a:p>
-            <a:pPr marL="0" indent="0" algn="r">
+            <a:pPr algn="r" indent="0" marL="0">
               <a:buNone/>
             </a:pPr>
             <a:r>
@@ -3859,7 +4073,7 @@
           </a:bodyPr>
           <a:lstStyle/>
           <a:p>
-            <a:pPr marL="0" indent="0">
+            <a:pPr indent="0" marL="0">
               <a:buNone/>
             </a:pPr>
             <a:r>
@@ -3879,21 +4093,21 @@
       </p:sp>
       <p:pic>
         <p:nvPicPr>
-          <p:cNvPr id="7" name="Image 0" descr="C:\Users\ADMIN\OneDrive\Documents\MÁY HỌC\ĐỒ ÁN MÔN MÁY HỌC\CS114-Team10-Elderly-Scam-Detection\draft\scam-detection\reports\figures\demo_03_scam_detection_verdict.png"/>
+          <p:cNvPr id="7" name="Image 0" descr="C:\Users\ADMIN\OneDrive\Documents\MÁY HỌC\ĐỒ ÁN MÔN MÁY HỌC\CS114-Team10-Elderly-Scam-Detection\draft\scam-detection\reports\figures\demo_03_scam_detection_verdict.png">    </p:cNvPr>
           <p:cNvPicPr>
             <a:picLocks noChangeAspect="1"/>
           </p:cNvPicPr>
           <p:nvPr/>
         </p:nvPicPr>
         <p:blipFill>
-          <a:blip r:embed="rId3"/>
+          <a:blip r:embed="rId1"/>
           <a:stretch>
             <a:fillRect/>
           </a:stretch>
         </p:blipFill>
         <p:spPr>
           <a:xfrm>
-            <a:off x="525780" y="1087257"/>
+            <a:off x="525780" y="1143000"/>
             <a:ext cx="4800600" cy="3200400"/>
           </a:xfrm>
           <a:prstGeom prst="rect">
@@ -3922,7 +4136,7 @@
           <a:bodyPr wrap="square" rtlCol="0" anchor="ctr"/>
           <a:lstStyle/>
           <a:p>
-            <a:pPr marL="0" indent="0" algn="ctr">
+            <a:pPr algn="ctr" indent="0" marL="0">
               <a:buNone/>
             </a:pPr>
             <a:r>
@@ -4106,7 +4320,6 @@
         <a:solidFill>
           <a:srgbClr val="FFFFFF"/>
         </a:solidFill>
-        <a:effectLst/>
       </p:bgPr>
     </p:bg>
     <p:spTree>
@@ -4184,7 +4397,7 @@
           <a:bodyPr wrap="square" rtlCol="0" anchor="ctr"/>
           <a:lstStyle/>
           <a:p>
-            <a:pPr marL="0" indent="0">
+            <a:pPr indent="0" marL="0">
               <a:buNone/>
             </a:pPr>
             <a:r>
@@ -4223,7 +4436,7 @@
           <a:bodyPr wrap="square" rtlCol="0" anchor="ctr"/>
           <a:lstStyle/>
           <a:p>
-            <a:pPr marL="0" indent="0" algn="r">
+            <a:pPr algn="r" indent="0" marL="0">
               <a:buNone/>
             </a:pPr>
             <a:r>
@@ -4264,7 +4477,7 @@
           </a:bodyPr>
           <a:lstStyle/>
           <a:p>
-            <a:pPr marL="0" indent="0">
+            <a:pPr indent="0" marL="0">
               <a:buNone/>
             </a:pPr>
             <a:r>
@@ -4350,7 +4563,7 @@
           </a:bodyPr>
           <a:lstStyle/>
           <a:p>
-            <a:pPr marL="0" indent="0">
+            <a:pPr indent="0" marL="0">
               <a:buNone/>
             </a:pPr>
             <a:r>
@@ -4586,7 +4799,7 @@
           </a:bodyPr>
           <a:lstStyle/>
           <a:p>
-            <a:pPr marL="0" indent="0">
+            <a:pPr indent="0" marL="0">
               <a:buNone/>
             </a:pPr>
             <a:r>
@@ -4749,7 +4962,6 @@
         <a:solidFill>
           <a:srgbClr val="FFFFFF"/>
         </a:solidFill>
-        <a:effectLst/>
       </p:bgPr>
     </p:bg>
     <p:spTree>
@@ -4827,7 +5039,7 @@
           <a:bodyPr wrap="square" rtlCol="0" anchor="ctr"/>
           <a:lstStyle/>
           <a:p>
-            <a:pPr marL="0" indent="0">
+            <a:pPr indent="0" marL="0">
               <a:buNone/>
             </a:pPr>
             <a:r>
@@ -4866,7 +5078,7 @@
           <a:bodyPr wrap="square" rtlCol="0" anchor="ctr"/>
           <a:lstStyle/>
           <a:p>
-            <a:pPr marL="0" indent="0" algn="r">
+            <a:pPr algn="r" indent="0" marL="0">
               <a:buNone/>
             </a:pPr>
             <a:r>
@@ -4907,7 +5119,7 @@
           </a:bodyPr>
           <a:lstStyle/>
           <a:p>
-            <a:pPr marL="0" indent="0">
+            <a:pPr indent="0" marL="0">
               <a:buNone/>
             </a:pPr>
             <a:r>
@@ -4934,7 +5146,7 @@
         <p:spPr>
           <a:xfrm>
             <a:off x="457200" y="1143000"/>
-            <a:ext cx="8229600" cy="608076"/>
+            <a:ext cx="8229600" cy="3497580"/>
           </a:xfrm>
           <a:prstGeom prst="rect">
             <a:avLst/>
@@ -4943,16 +5155,17 @@
           <a:ln/>
         </p:spPr>
         <p:txBody>
-          <a:bodyPr wrap="square" rtlCol="0" anchor="ctr">
-            <a:normAutofit/>
-          </a:bodyPr>
+          <a:bodyPr wrap="square" lIns="25400" tIns="0" rIns="0" bIns="25400" rtlCol="0" anchor="ctr"/>
           <a:lstStyle/>
           <a:p>
-            <a:pPr marL="0" indent="0">
+            <a:pPr indent="0" marL="0">
+              <a:spcAft>
+                <a:spcPts val="900"/>
+              </a:spcAft>
               <a:buNone/>
             </a:pPr>
             <a:r>
-              <a:rPr lang="en-US" sz="1400" dirty="0">
+              <a:rPr lang="en-US" sz="1300" dirty="0">
                 <a:solidFill>
                   <a:srgbClr val="1F2937"/>
                 </a:solidFill>
@@ -4962,38 +5175,17 @@
               </a:rPr>
               <a:t>[1] T. Chen &amp; C. Guestrin, “XGBoost: A Scalable Tree Boosting System,” KDD 2016.</a:t>
             </a:r>
-            <a:endParaRPr lang="en-US" sz="1400" dirty="0"/>
-          </a:p>
-        </p:txBody>
-      </p:sp>
-      <p:sp>
-        <p:nvSpPr>
-          <p:cNvPr id="8" name="Text 6"/>
-          <p:cNvSpPr/>
-          <p:nvPr/>
-        </p:nvSpPr>
-        <p:spPr>
-          <a:xfrm>
-            <a:off x="457200" y="1842516"/>
-            <a:ext cx="8229600" cy="608076"/>
-          </a:xfrm>
-          <a:prstGeom prst="rect">
-            <a:avLst/>
-          </a:prstGeom>
-          <a:noFill/>
-          <a:ln/>
-        </p:spPr>
-        <p:txBody>
-          <a:bodyPr wrap="square" rtlCol="0" anchor="ctr">
-            <a:normAutofit/>
-          </a:bodyPr>
-          <a:lstStyle/>
-          <a:p>
-            <a:pPr marL="0" indent="0">
+            <a:endParaRPr lang="en-US" sz="1300" dirty="0"/>
+          </a:p>
+          <a:p>
+            <a:pPr indent="0" marL="0">
+              <a:spcAft>
+                <a:spcPts val="900"/>
+              </a:spcAft>
               <a:buNone/>
             </a:pPr>
             <a:r>
-              <a:rPr lang="en-US" sz="1400" dirty="0">
+              <a:rPr lang="en-US" sz="1300" dirty="0">
                 <a:solidFill>
                   <a:srgbClr val="1F2937"/>
                 </a:solidFill>
@@ -5003,38 +5195,17 @@
               </a:rPr>
               <a:t>[2] J. Platt, “Probabilistic Outputs for Support Vector Machines and Comparisons to Regularized Likelihood Methods,” Advances in Large Margin Classifiers, 1999.</a:t>
             </a:r>
-            <a:endParaRPr lang="en-US" sz="1400" dirty="0"/>
-          </a:p>
-        </p:txBody>
-      </p:sp>
-      <p:sp>
-        <p:nvSpPr>
-          <p:cNvPr id="9" name="Text 7"/>
-          <p:cNvSpPr/>
-          <p:nvPr/>
-        </p:nvSpPr>
-        <p:spPr>
-          <a:xfrm>
-            <a:off x="457200" y="2542032"/>
-            <a:ext cx="8229600" cy="608076"/>
-          </a:xfrm>
-          <a:prstGeom prst="rect">
-            <a:avLst/>
-          </a:prstGeom>
-          <a:noFill/>
-          <a:ln/>
-        </p:spPr>
-        <p:txBody>
-          <a:bodyPr wrap="square" rtlCol="0" anchor="ctr">
-            <a:normAutofit/>
-          </a:bodyPr>
-          <a:lstStyle/>
-          <a:p>
-            <a:pPr marL="0" indent="0">
+            <a:endParaRPr lang="en-US" sz="1300" dirty="0"/>
+          </a:p>
+          <a:p>
+            <a:pPr indent="0" marL="0">
+              <a:spcAft>
+                <a:spcPts val="900"/>
+              </a:spcAft>
               <a:buNone/>
             </a:pPr>
             <a:r>
-              <a:rPr lang="en-US" sz="1400" dirty="0">
+              <a:rPr lang="en-US" sz="1300" dirty="0">
                 <a:solidFill>
                   <a:srgbClr val="1F2937"/>
                 </a:solidFill>
@@ -5044,38 +5215,17 @@
               </a:rPr>
               <a:t>[3] D. Q. Nguyen &amp; A. T. Nguyen, “PhoBERT: Pre-trained Language Models for Vietnamese,” Findings of EMNLP 2020.</a:t>
             </a:r>
-            <a:endParaRPr lang="en-US" sz="1400" dirty="0"/>
-          </a:p>
-        </p:txBody>
-      </p:sp>
-      <p:sp>
-        <p:nvSpPr>
-          <p:cNvPr id="10" name="Text 8"/>
-          <p:cNvSpPr/>
-          <p:nvPr/>
-        </p:nvSpPr>
-        <p:spPr>
-          <a:xfrm>
-            <a:off x="457200" y="3241548"/>
-            <a:ext cx="8229600" cy="608076"/>
-          </a:xfrm>
-          <a:prstGeom prst="rect">
-            <a:avLst/>
-          </a:prstGeom>
-          <a:noFill/>
-          <a:ln/>
-        </p:spPr>
-        <p:txBody>
-          <a:bodyPr wrap="square" rtlCol="0" anchor="ctr">
-            <a:normAutofit/>
-          </a:bodyPr>
-          <a:lstStyle/>
-          <a:p>
-            <a:pPr marL="0" indent="0">
+            <a:endParaRPr lang="en-US" sz="1300" dirty="0"/>
+          </a:p>
+          <a:p>
+            <a:pPr indent="0" marL="0">
+              <a:spcAft>
+                <a:spcPts val="900"/>
+              </a:spcAft>
               <a:buNone/>
             </a:pPr>
             <a:r>
-              <a:rPr lang="en-US" sz="1400" dirty="0">
+              <a:rPr lang="en-US" sz="1300" dirty="0">
                 <a:solidFill>
                   <a:srgbClr val="1F2937"/>
                 </a:solidFill>
@@ -5083,40 +5233,19 @@
                 <a:ea typeface="Calibri" pitchFamily="34" charset="-122"/>
                 <a:cs typeface="Calibri" pitchFamily="34" charset="-120"/>
               </a:rPr>
-              <a:t>[4] Vietnamese Quality-Assured SMS Dataset, IEEE Access 2026 (doi pending) — nguồn dữ liệu tin nhắn bình thường.</a:t>
-            </a:r>
-            <a:endParaRPr lang="en-US" sz="1400" dirty="0"/>
-          </a:p>
-        </p:txBody>
-      </p:sp>
-      <p:sp>
-        <p:nvSpPr>
-          <p:cNvPr id="11" name="Text 9"/>
-          <p:cNvSpPr/>
-          <p:nvPr/>
-        </p:nvSpPr>
-        <p:spPr>
-          <a:xfrm>
-            <a:off x="457200" y="3941064"/>
-            <a:ext cx="8229600" cy="608076"/>
-          </a:xfrm>
-          <a:prstGeom prst="rect">
-            <a:avLst/>
-          </a:prstGeom>
-          <a:noFill/>
-          <a:ln/>
-        </p:spPr>
-        <p:txBody>
-          <a:bodyPr wrap="square" rtlCol="0" anchor="ctr">
-            <a:normAutofit/>
-          </a:bodyPr>
-          <a:lstStyle/>
-          <a:p>
-            <a:pPr marL="0" indent="0">
+              <a:t>[4] N. T. T. Tran, H. K. Le, M. T. Nguyen, V. T. Nguyen, and H. D. Mai, “Vietnamese SMS Dataset with Quality Assurance,” IEEE Access, 2026 (theo trích dẫn của tác giả trong README bộ dữ liệu; chưa có tập/DOI). GitHub: trannguyenthaituan251209/vietnamese_sms_dataset (1.944 mẫu: 1.773 bình thường + 171 lừa đảo; giấy phép CC BY 4.0 theo README; truy cập 21/09/2026).</a:t>
+            </a:r>
+            <a:endParaRPr lang="en-US" sz="1300" dirty="0"/>
+          </a:p>
+          <a:p>
+            <a:pPr indent="0" marL="0">
+              <a:spcAft>
+                <a:spcPts val="900"/>
+              </a:spcAft>
               <a:buNone/>
             </a:pPr>
             <a:r>
-              <a:rPr lang="en-US" sz="1400" dirty="0">
+              <a:rPr lang="en-US" sz="1300" dirty="0">
                 <a:solidFill>
                   <a:srgbClr val="1F2937"/>
                 </a:solidFill>
@@ -5126,7 +5255,27 @@
               </a:rPr>
               <a:t>[5] F. Pedregosa et al., “Scikit-learn: Machine Learning in Python,” JMLR vol. 12, 2011.</a:t>
             </a:r>
-            <a:endParaRPr lang="en-US" sz="1400" dirty="0"/>
+            <a:endParaRPr lang="en-US" sz="1300" dirty="0"/>
+          </a:p>
+          <a:p>
+            <a:pPr indent="0" marL="0">
+              <a:spcAft>
+                <a:spcPts val="900"/>
+              </a:spcAft>
+              <a:buNone/>
+            </a:pPr>
+            <a:r>
+              <a:rPr lang="en-US" sz="1300" dirty="0">
+                <a:solidFill>
+                  <a:srgbClr val="1F2937"/>
+                </a:solidFill>
+                <a:latin typeface="Calibri" pitchFamily="34" charset="0"/>
+                <a:ea typeface="Calibri" pitchFamily="34" charset="-122"/>
+                <a:cs typeface="Calibri" pitchFamily="34" charset="-120"/>
+              </a:rPr>
+              <a:t>[6] Nguồn bổ sung của tập lừa đảo (249/420 mẫu, có URL truy vết trong dataset.csv): GitHub ghitatruongle/lachancuocgoi (162), duynguyenhoang22/SMS_Phishing_Detection — đồ án IE403 (73), duynguyenhoang22/ViSmish_Detection (1); báo chí và video: Thanh Niên, Dân trí, Tuổi Trẻ, VTV24 (13); truy cập 21/09/2026.</a:t>
+            </a:r>
+            <a:endParaRPr lang="en-US" sz="1300" dirty="0"/>
           </a:p>
         </p:txBody>
       </p:sp>
@@ -5146,7 +5295,6 @@
         <a:solidFill>
           <a:srgbClr val="0B2545"/>
         </a:solidFill>
-        <a:effectLst/>
       </p:bgPr>
     </p:bg>
     <p:spTree>
@@ -5184,7 +5332,7 @@
           <a:bodyPr wrap="square" rtlCol="0" anchor="ctr"/>
           <a:lstStyle/>
           <a:p>
-            <a:pPr marL="0" indent="0" algn="ctr">
+            <a:pPr algn="ctr" indent="0" marL="0">
               <a:buNone/>
             </a:pPr>
             <a:r>
@@ -5222,7 +5370,7 @@
           </a:bodyPr>
           <a:lstStyle/>
           <a:p>
-            <a:pPr marL="0" indent="0" algn="ctr">
+            <a:pPr algn="ctr" indent="0" marL="0">
               <a:buNone/>
             </a:pPr>
             <a:r>
@@ -5239,7 +5387,7 @@
             <a:endParaRPr lang="en-US" sz="3000" dirty="0"/>
           </a:p>
           <a:p>
-            <a:pPr marL="0" indent="0" algn="ctr">
+            <a:pPr algn="ctr" indent="0" marL="0">
               <a:buNone/>
             </a:pPr>
             <a:r>
@@ -5298,7 +5446,7 @@
           <a:bodyPr wrap="square" rtlCol="0" anchor="ctr"/>
           <a:lstStyle/>
           <a:p>
-            <a:pPr marL="0" indent="0" algn="ctr">
+            <a:pPr algn="ctr" indent="0" marL="0">
               <a:buNone/>
             </a:pPr>
             <a:r>
@@ -5337,7 +5485,7 @@
           <a:bodyPr wrap="square" rtlCol="0" anchor="ctr"/>
           <a:lstStyle/>
           <a:p>
-            <a:pPr marL="0" indent="0" algn="ctr">
+            <a:pPr algn="ctr" indent="0" marL="0">
               <a:buNone/>
             </a:pPr>
             <a:r>
@@ -5354,7 +5502,7 @@
             <a:endParaRPr lang="en-US" sz="1200" dirty="0"/>
           </a:p>
           <a:p>
-            <a:pPr marL="0" indent="0" algn="ctr">
+            <a:pPr algn="ctr" indent="0" marL="0">
               <a:buNone/>
             </a:pPr>
             <a:r>
@@ -5371,7 +5519,7 @@
             <a:endParaRPr lang="en-US" sz="1200" dirty="0"/>
           </a:p>
           <a:p>
-            <a:pPr marL="0" indent="0" algn="ctr">
+            <a:pPr algn="ctr" indent="0" marL="0">
               <a:buNone/>
             </a:pPr>
             <a:r>
@@ -5410,7 +5558,7 @@
           <a:bodyPr wrap="square" rtlCol="0" anchor="ctr"/>
           <a:lstStyle/>
           <a:p>
-            <a:pPr marL="0" indent="0" algn="ctr">
+            <a:pPr algn="ctr" indent="0" marL="0">
               <a:buNone/>
             </a:pPr>
             <a:r>
@@ -5444,7 +5592,6 @@
         <a:solidFill>
           <a:srgbClr val="0B2545"/>
         </a:solidFill>
-        <a:effectLst/>
       </p:bgPr>
     </p:bg>
     <p:spTree>
@@ -5484,7 +5631,7 @@
           </a:bodyPr>
           <a:lstStyle/>
           <a:p>
-            <a:pPr marL="0" indent="0" algn="ctr">
+            <a:pPr algn="ctr" indent="0" marL="0">
               <a:buNone/>
             </a:pPr>
             <a:r>
@@ -5501,7 +5648,7 @@
             <a:endParaRPr lang="en-US" sz="3600" dirty="0"/>
           </a:p>
           <a:p>
-            <a:pPr marL="0" indent="0" algn="ctr">
+            <a:pPr algn="ctr" indent="0" marL="0">
               <a:buNone/>
             </a:pPr>
             <a:r>
@@ -5560,7 +5707,7 @@
           <a:bodyPr wrap="square" rtlCol="0" anchor="ctr"/>
           <a:lstStyle/>
           <a:p>
-            <a:pPr marL="0" indent="0" algn="ctr">
+            <a:pPr algn="ctr" indent="0" marL="0">
               <a:buNone/>
             </a:pPr>
             <a:r>
@@ -5594,7 +5741,6 @@
         <a:solidFill>
           <a:srgbClr val="FFFFFF"/>
         </a:solidFill>
-        <a:effectLst/>
       </p:bgPr>
     </p:bg>
     <p:spTree>
@@ -5672,7 +5818,7 @@
           <a:bodyPr wrap="square" rtlCol="0" anchor="ctr"/>
           <a:lstStyle/>
           <a:p>
-            <a:pPr marL="0" indent="0">
+            <a:pPr indent="0" marL="0">
               <a:buNone/>
             </a:pPr>
             <a:r>
@@ -5711,7 +5857,7 @@
           <a:bodyPr wrap="square" rtlCol="0" anchor="ctr"/>
           <a:lstStyle/>
           <a:p>
-            <a:pPr marL="0" indent="0" algn="r">
+            <a:pPr algn="r" indent="0" marL="0">
               <a:buNone/>
             </a:pPr>
             <a:r>
@@ -5752,7 +5898,7 @@
           </a:bodyPr>
           <a:lstStyle/>
           <a:p>
-            <a:pPr marL="0" indent="0">
+            <a:pPr indent="0" marL="0">
               <a:buNone/>
             </a:pPr>
             <a:r>
@@ -5793,34 +5939,10 @@
             <a:tbl>
               <a:tblPr/>
               <a:tblGrid>
-                <a:gridCol w="1234440">
-                  <a:extLst>
-                    <a:ext uri="{9D8B030D-6E8A-4147-A177-3AD203B41FA5}">
-                      <a16:colId xmlns:a16="http://schemas.microsoft.com/office/drawing/2014/main" val="20000"/>
-                    </a:ext>
-                  </a:extLst>
-                </a:gridCol>
-                <a:gridCol w="3794760">
-                  <a:extLst>
-                    <a:ext uri="{9D8B030D-6E8A-4147-A177-3AD203B41FA5}">
-                      <a16:colId xmlns:a16="http://schemas.microsoft.com/office/drawing/2014/main" val="20001"/>
-                    </a:ext>
-                  </a:extLst>
-                </a:gridCol>
-                <a:gridCol w="2286000">
-                  <a:extLst>
-                    <a:ext uri="{9D8B030D-6E8A-4147-A177-3AD203B41FA5}">
-                      <a16:colId xmlns:a16="http://schemas.microsoft.com/office/drawing/2014/main" val="20002"/>
-                    </a:ext>
-                  </a:extLst>
-                </a:gridCol>
-                <a:gridCol w="914400">
-                  <a:extLst>
-                    <a:ext uri="{9D8B030D-6E8A-4147-A177-3AD203B41FA5}">
-                      <a16:colId xmlns:a16="http://schemas.microsoft.com/office/drawing/2014/main" val="20003"/>
-                    </a:ext>
-                  </a:extLst>
-                </a:gridCol>
+                <a:gridCol w="1234440"/>
+                <a:gridCol w="3794760"/>
+                <a:gridCol w="2286000"/>
+                <a:gridCol w="914400"/>
               </a:tblGrid>
               <a:tr h="384048">
                 <a:tc>
@@ -5828,7 +5950,7 @@
                     <a:bodyPr/>
                     <a:lstStyle/>
                     <a:p>
-                      <a:pPr marL="0" indent="0" algn="l">
+                      <a:pPr algn="l" indent="0" marL="0">
                         <a:buNone/>
                       </a:pPr>
                       <a:r>
@@ -5849,7 +5971,7 @@
                       </a:endParaRPr>
                     </a:p>
                   </a:txBody>
-                  <a:tcPr anchor="ctr">
+                  <a:tcPr marL="91440" marR="91440" marT="45720" marB="45720" anchor="ctr">
                     <a:lnL w="6350" cap="flat" cmpd="sng" algn="ctr">
                       <a:solidFill>
                         <a:srgbClr val="1E5FC2"/>
@@ -5896,7 +6018,7 @@
                     <a:bodyPr/>
                     <a:lstStyle/>
                     <a:p>
-                      <a:pPr marL="0" indent="0" algn="l">
+                      <a:pPr algn="l" indent="0" marL="0">
                         <a:buNone/>
                       </a:pPr>
                       <a:r>
@@ -5917,7 +6039,7 @@
                       </a:endParaRPr>
                     </a:p>
                   </a:txBody>
-                  <a:tcPr anchor="ctr">
+                  <a:tcPr marL="91440" marR="91440" marT="45720" marB="45720" anchor="ctr">
                     <a:lnL w="6350" cap="flat" cmpd="sng" algn="ctr">
                       <a:solidFill>
                         <a:srgbClr val="1E5FC2"/>
@@ -5964,7 +6086,7 @@
                     <a:bodyPr/>
                     <a:lstStyle/>
                     <a:p>
-                      <a:pPr marL="0" indent="0" algn="l">
+                      <a:pPr algn="l" indent="0" marL="0">
                         <a:buNone/>
                       </a:pPr>
                       <a:r>
@@ -5985,7 +6107,7 @@
                       </a:endParaRPr>
                     </a:p>
                   </a:txBody>
-                  <a:tcPr anchor="ctr">
+                  <a:tcPr marL="91440" marR="91440" marT="45720" marB="45720" anchor="ctr">
                     <a:lnL w="6350" cap="flat" cmpd="sng" algn="ctr">
                       <a:solidFill>
                         <a:srgbClr val="1E5FC2"/>
@@ -6032,7 +6154,7 @@
                     <a:bodyPr/>
                     <a:lstStyle/>
                     <a:p>
-                      <a:pPr marL="0" indent="0" algn="ctr">
+                      <a:pPr algn="ctr" indent="0" marL="0">
                         <a:buNone/>
                       </a:pPr>
                       <a:r>
@@ -6053,7 +6175,7 @@
                       </a:endParaRPr>
                     </a:p>
                   </a:txBody>
-                  <a:tcPr anchor="ctr">
+                  <a:tcPr marL="91440" marR="91440" marT="45720" marB="45720" anchor="ctr">
                     <a:lnL w="6350" cap="flat" cmpd="sng" algn="ctr">
                       <a:solidFill>
                         <a:srgbClr val="1E5FC2"/>
@@ -6095,11 +6217,6 @@
                     </a:solidFill>
                   </a:tcPr>
                 </a:tc>
-                <a:extLst>
-                  <a:ext uri="{0D108BD9-81ED-4DB2-BD59-A6C34878D82A}">
-                    <a16:rowId xmlns:a16="http://schemas.microsoft.com/office/drawing/2014/main" val="10000"/>
-                  </a:ext>
-                </a:extLst>
               </a:tr>
               <a:tr h="777240">
                 <a:tc>
@@ -6107,7 +6224,7 @@
                     <a:bodyPr/>
                     <a:lstStyle/>
                     <a:p>
-                      <a:pPr marL="0" indent="0">
+                      <a:pPr indent="0" marL="0">
                         <a:buNone/>
                       </a:pPr>
                       <a:r>
@@ -6128,7 +6245,7 @@
                       </a:endParaRPr>
                     </a:p>
                   </a:txBody>
-                  <a:tcPr anchor="ctr">
+                  <a:tcPr marL="91440" marR="91440" marT="45720" marB="45720" anchor="ctr">
                     <a:lnL w="6350" cap="flat" cmpd="sng" algn="ctr">
                       <a:solidFill>
                         <a:srgbClr val="1E5FC2"/>
@@ -6172,7 +6289,7 @@
                     <a:bodyPr/>
                     <a:lstStyle/>
                     <a:p>
-                      <a:pPr marL="0" indent="0">
+                      <a:pPr indent="0" marL="0">
                         <a:buNone/>
                       </a:pPr>
                       <a:r>
@@ -6193,7 +6310,7 @@
                       </a:endParaRPr>
                     </a:p>
                   </a:txBody>
-                  <a:tcPr anchor="ctr">
+                  <a:tcPr marL="91440" marR="91440" marT="45720" marB="45720" anchor="ctr">
                     <a:lnL w="6350" cap="flat" cmpd="sng" algn="ctr">
                       <a:solidFill>
                         <a:srgbClr val="1E5FC2"/>
@@ -6237,7 +6354,7 @@
                     <a:bodyPr/>
                     <a:lstStyle/>
                     <a:p>
-                      <a:pPr marL="0" indent="0">
+                      <a:pPr indent="0" marL="0">
                         <a:buNone/>
                       </a:pPr>
                       <a:r>
@@ -6258,7 +6375,7 @@
                       </a:endParaRPr>
                     </a:p>
                     <a:p>
-                      <a:pPr marL="0" indent="0">
+                      <a:pPr indent="0" marL="0">
                         <a:buNone/>
                       </a:pPr>
                       <a:r>
@@ -6279,7 +6396,7 @@
                       </a:endParaRPr>
                     </a:p>
                   </a:txBody>
-                  <a:tcPr anchor="ctr">
+                  <a:tcPr marL="91440" marR="91440" marT="45720" marB="45720" anchor="ctr">
                     <a:lnL w="6350" cap="flat" cmpd="sng" algn="ctr">
                       <a:solidFill>
                         <a:srgbClr val="1E5FC2"/>
@@ -6323,7 +6440,7 @@
                     <a:bodyPr/>
                     <a:lstStyle/>
                     <a:p>
-                      <a:pPr marL="0" indent="0" algn="ctr">
+                      <a:pPr algn="ctr" indent="0" marL="0">
                         <a:buNone/>
                       </a:pPr>
                       <a:r>
@@ -6344,7 +6461,7 @@
                       </a:endParaRPr>
                     </a:p>
                   </a:txBody>
-                  <a:tcPr anchor="ctr">
+                  <a:tcPr marL="91440" marR="91440" marT="45720" marB="45720" anchor="ctr">
                     <a:lnL w="6350" cap="flat" cmpd="sng" algn="ctr">
                       <a:solidFill>
                         <a:srgbClr val="1E5FC2"/>
@@ -6383,11 +6500,6 @@
                     </a:lnB>
                   </a:tcPr>
                 </a:tc>
-                <a:extLst>
-                  <a:ext uri="{0D108BD9-81ED-4DB2-BD59-A6C34878D82A}">
-                    <a16:rowId xmlns:a16="http://schemas.microsoft.com/office/drawing/2014/main" val="10001"/>
-                  </a:ext>
-                </a:extLst>
               </a:tr>
               <a:tr h="594360">
                 <a:tc>
@@ -6395,7 +6507,7 @@
                     <a:bodyPr/>
                     <a:lstStyle/>
                     <a:p>
-                      <a:pPr marL="0" indent="0">
+                      <a:pPr indent="0" marL="0">
                         <a:buNone/>
                       </a:pPr>
                       <a:r>
@@ -6416,7 +6528,7 @@
                       </a:endParaRPr>
                     </a:p>
                   </a:txBody>
-                  <a:tcPr anchor="ctr">
+                  <a:tcPr marL="91440" marR="91440" marT="45720" marB="45720" anchor="ctr">
                     <a:lnL w="6350" cap="flat" cmpd="sng" algn="ctr">
                       <a:solidFill>
                         <a:srgbClr val="1E5FC2"/>
@@ -6460,7 +6572,7 @@
                     <a:bodyPr/>
                     <a:lstStyle/>
                     <a:p>
-                      <a:pPr marL="0" indent="0">
+                      <a:pPr indent="0" marL="0">
                         <a:buNone/>
                       </a:pPr>
                       <a:r>
@@ -6481,7 +6593,7 @@
                       </a:endParaRPr>
                     </a:p>
                   </a:txBody>
-                  <a:tcPr anchor="ctr">
+                  <a:tcPr marL="91440" marR="91440" marT="45720" marB="45720" anchor="ctr">
                     <a:lnL w="6350" cap="flat" cmpd="sng" algn="ctr">
                       <a:solidFill>
                         <a:srgbClr val="1E5FC2"/>
@@ -6525,7 +6637,7 @@
                     <a:bodyPr/>
                     <a:lstStyle/>
                     <a:p>
-                      <a:pPr marL="0" indent="0">
+                      <a:pPr indent="0" marL="0">
                         <a:buNone/>
                       </a:pPr>
                       <a:r>
@@ -6546,7 +6658,7 @@
                       </a:endParaRPr>
                     </a:p>
                   </a:txBody>
-                  <a:tcPr anchor="ctr">
+                  <a:tcPr marL="91440" marR="91440" marT="45720" marB="45720" anchor="ctr">
                     <a:lnL w="6350" cap="flat" cmpd="sng" algn="ctr">
                       <a:solidFill>
                         <a:srgbClr val="1E5FC2"/>
@@ -6590,7 +6702,7 @@
                     <a:bodyPr/>
                     <a:lstStyle/>
                     <a:p>
-                      <a:pPr marL="0" indent="0" algn="ctr">
+                      <a:pPr algn="ctr" indent="0" marL="0">
                         <a:buNone/>
                       </a:pPr>
                       <a:r>
@@ -6611,7 +6723,7 @@
                       </a:endParaRPr>
                     </a:p>
                   </a:txBody>
-                  <a:tcPr anchor="ctr">
+                  <a:tcPr marL="91440" marR="91440" marT="45720" marB="45720" anchor="ctr">
                     <a:lnL w="6350" cap="flat" cmpd="sng" algn="ctr">
                       <a:solidFill>
                         <a:srgbClr val="1E5FC2"/>
@@ -6650,11 +6762,6 @@
                     </a:lnB>
                   </a:tcPr>
                 </a:tc>
-                <a:extLst>
-                  <a:ext uri="{0D108BD9-81ED-4DB2-BD59-A6C34878D82A}">
-                    <a16:rowId xmlns:a16="http://schemas.microsoft.com/office/drawing/2014/main" val="10002"/>
-                  </a:ext>
-                </a:extLst>
               </a:tr>
               <a:tr h="777240">
                 <a:tc>
@@ -6662,7 +6769,7 @@
                     <a:bodyPr/>
                     <a:lstStyle/>
                     <a:p>
-                      <a:pPr marL="0" indent="0">
+                      <a:pPr indent="0" marL="0">
                         <a:buNone/>
                       </a:pPr>
                       <a:r>
@@ -6683,7 +6790,7 @@
                       </a:endParaRPr>
                     </a:p>
                   </a:txBody>
-                  <a:tcPr anchor="ctr">
+                  <a:tcPr marL="91440" marR="91440" marT="45720" marB="45720" anchor="ctr">
                     <a:lnL w="6350" cap="flat" cmpd="sng" algn="ctr">
                       <a:solidFill>
                         <a:srgbClr val="1E5FC2"/>
@@ -6727,7 +6834,7 @@
                     <a:bodyPr/>
                     <a:lstStyle/>
                     <a:p>
-                      <a:pPr marL="0" indent="0">
+                      <a:pPr indent="0" marL="0">
                         <a:buNone/>
                       </a:pPr>
                       <a:r>
@@ -6748,7 +6855,7 @@
                       </a:endParaRPr>
                     </a:p>
                   </a:txBody>
-                  <a:tcPr anchor="ctr">
+                  <a:tcPr marL="91440" marR="91440" marT="45720" marB="45720" anchor="ctr">
                     <a:lnL w="6350" cap="flat" cmpd="sng" algn="ctr">
                       <a:solidFill>
                         <a:srgbClr val="1E5FC2"/>
@@ -6792,7 +6899,7 @@
                     <a:bodyPr/>
                     <a:lstStyle/>
                     <a:p>
-                      <a:pPr marL="0" indent="0">
+                      <a:pPr indent="0" marL="0">
                         <a:buNone/>
                       </a:pPr>
                       <a:r>
@@ -6813,7 +6920,7 @@
                       </a:endParaRPr>
                     </a:p>
                     <a:p>
-                      <a:pPr marL="0" indent="0">
+                      <a:pPr indent="0" marL="0">
                         <a:buNone/>
                       </a:pPr>
                       <a:r>
@@ -6834,7 +6941,7 @@
                       </a:endParaRPr>
                     </a:p>
                   </a:txBody>
-                  <a:tcPr anchor="ctr">
+                  <a:tcPr marL="91440" marR="91440" marT="45720" marB="45720" anchor="ctr">
                     <a:lnL w="6350" cap="flat" cmpd="sng" algn="ctr">
                       <a:solidFill>
                         <a:srgbClr val="1E5FC2"/>
@@ -6878,7 +6985,7 @@
                     <a:bodyPr/>
                     <a:lstStyle/>
                     <a:p>
-                      <a:pPr marL="0" indent="0" algn="ctr">
+                      <a:pPr algn="ctr" indent="0" marL="0">
                         <a:buNone/>
                       </a:pPr>
                       <a:r>
@@ -6899,7 +7006,7 @@
                       </a:endParaRPr>
                     </a:p>
                   </a:txBody>
-                  <a:tcPr anchor="ctr">
+                  <a:tcPr marL="91440" marR="91440" marT="45720" marB="45720" anchor="ctr">
                     <a:lnL w="6350" cap="flat" cmpd="sng" algn="ctr">
                       <a:solidFill>
                         <a:srgbClr val="1E5FC2"/>
@@ -6938,11 +7045,6 @@
                     </a:lnB>
                   </a:tcPr>
                 </a:tc>
-                <a:extLst>
-                  <a:ext uri="{0D108BD9-81ED-4DB2-BD59-A6C34878D82A}">
-                    <a16:rowId xmlns:a16="http://schemas.microsoft.com/office/drawing/2014/main" val="10003"/>
-                  </a:ext>
-                </a:extLst>
               </a:tr>
               <a:tr h="594360">
                 <a:tc>
@@ -6950,7 +7052,7 @@
                     <a:bodyPr/>
                     <a:lstStyle/>
                     <a:p>
-                      <a:pPr marL="0" indent="0">
+                      <a:pPr indent="0" marL="0">
                         <a:buNone/>
                       </a:pPr>
                       <a:r>
@@ -6971,7 +7073,7 @@
                       </a:endParaRPr>
                     </a:p>
                   </a:txBody>
-                  <a:tcPr anchor="ctr">
+                  <a:tcPr marL="91440" marR="91440" marT="45720" marB="45720" anchor="ctr">
                     <a:lnL w="6350" cap="flat" cmpd="sng" algn="ctr">
                       <a:solidFill>
                         <a:srgbClr val="1E5FC2"/>
@@ -7015,7 +7117,7 @@
                     <a:bodyPr/>
                     <a:lstStyle/>
                     <a:p>
-                      <a:pPr marL="0" indent="0">
+                      <a:pPr indent="0" marL="0">
                         <a:buNone/>
                       </a:pPr>
                       <a:r>
@@ -7036,7 +7138,7 @@
                       </a:endParaRPr>
                     </a:p>
                   </a:txBody>
-                  <a:tcPr anchor="ctr">
+                  <a:tcPr marL="91440" marR="91440" marT="45720" marB="45720" anchor="ctr">
                     <a:lnL w="6350" cap="flat" cmpd="sng" algn="ctr">
                       <a:solidFill>
                         <a:srgbClr val="1E5FC2"/>
@@ -7080,7 +7182,7 @@
                     <a:bodyPr/>
                     <a:lstStyle/>
                     <a:p>
-                      <a:pPr marL="0" indent="0">
+                      <a:pPr indent="0" marL="0">
                         <a:buNone/>
                       </a:pPr>
                       <a:r>
@@ -7101,7 +7203,7 @@
                       </a:endParaRPr>
                     </a:p>
                   </a:txBody>
-                  <a:tcPr anchor="ctr">
+                  <a:tcPr marL="91440" marR="91440" marT="45720" marB="45720" anchor="ctr">
                     <a:lnL w="6350" cap="flat" cmpd="sng" algn="ctr">
                       <a:solidFill>
                         <a:srgbClr val="1E5FC2"/>
@@ -7145,7 +7247,7 @@
                     <a:bodyPr/>
                     <a:lstStyle/>
                     <a:p>
-                      <a:pPr marL="0" indent="0" algn="ctr">
+                      <a:pPr algn="ctr" indent="0" marL="0">
                         <a:buNone/>
                       </a:pPr>
                       <a:r>
@@ -7166,7 +7268,7 @@
                       </a:endParaRPr>
                     </a:p>
                   </a:txBody>
-                  <a:tcPr anchor="ctr">
+                  <a:tcPr marL="91440" marR="91440" marT="45720" marB="45720" anchor="ctr">
                     <a:lnL w="6350" cap="flat" cmpd="sng" algn="ctr">
                       <a:solidFill>
                         <a:srgbClr val="1E5FC2"/>
@@ -7205,11 +7307,6 @@
                     </a:lnB>
                   </a:tcPr>
                 </a:tc>
-                <a:extLst>
-                  <a:ext uri="{0D108BD9-81ED-4DB2-BD59-A6C34878D82A}">
-                    <a16:rowId xmlns:a16="http://schemas.microsoft.com/office/drawing/2014/main" val="10004"/>
-                  </a:ext>
-                </a:extLst>
               </a:tr>
             </a:tbl>
           </a:graphicData>
@@ -7238,7 +7335,7 @@
           </a:bodyPr>
           <a:lstStyle/>
           <a:p>
-            <a:pPr marL="0" indent="0">
+            <a:pPr indent="0" marL="0">
               <a:buNone/>
             </a:pPr>
             <a:r>
@@ -7272,7 +7369,6 @@
         <a:solidFill>
           <a:srgbClr val="FFFFFF"/>
         </a:solidFill>
-        <a:effectLst/>
       </p:bgPr>
     </p:bg>
     <p:spTree>
@@ -7350,7 +7446,7 @@
           <a:bodyPr wrap="square" rtlCol="0" anchor="ctr"/>
           <a:lstStyle/>
           <a:p>
-            <a:pPr marL="0" indent="0">
+            <a:pPr indent="0" marL="0">
               <a:buNone/>
             </a:pPr>
             <a:r>
@@ -7389,7 +7485,7 @@
           <a:bodyPr wrap="square" rtlCol="0" anchor="ctr"/>
           <a:lstStyle/>
           <a:p>
-            <a:pPr marL="0" indent="0" algn="r">
+            <a:pPr algn="r" indent="0" marL="0">
               <a:buNone/>
             </a:pPr>
             <a:r>
@@ -7430,7 +7526,7 @@
           </a:bodyPr>
           <a:lstStyle/>
           <a:p>
-            <a:pPr marL="0" indent="0">
+            <a:pPr indent="0" marL="0">
               <a:buNone/>
             </a:pPr>
             <a:r>
@@ -7450,14 +7546,14 @@
       </p:sp>
       <p:pic>
         <p:nvPicPr>
-          <p:cNvPr id="7" name="Image 0" descr="C:\Users\ADMIN\OneDrive\Documents\MÁY HỌC\ĐỒ ÁN MÔN MÁY HỌC\CS114-Team10-Elderly-Scam-Detection\draft\scam-detection\reports\figures\confusion_matrices_all.png"/>
+          <p:cNvPr id="7" name="Image 0" descr="C:\Users\ADMIN\OneDrive\Documents\MÁY HỌC\ĐỒ ÁN MÔN MÁY HỌC\CS114-Team10-Elderly-Scam-Detection\draft\scam-detection\reports\figures\confusion_matrices_all.png">    </p:cNvPr>
           <p:cNvPicPr>
             <a:picLocks noChangeAspect="1"/>
           </p:cNvPicPr>
           <p:nvPr/>
         </p:nvPicPr>
         <p:blipFill>
-          <a:blip r:embed="rId3"/>
+          <a:blip r:embed="rId1"/>
           <a:stretch>
             <a:fillRect/>
           </a:stretch>
@@ -7495,27 +7591,9 @@
             <a:tbl>
               <a:tblPr/>
               <a:tblGrid>
-                <a:gridCol w="1280160">
-                  <a:extLst>
-                    <a:ext uri="{9D8B030D-6E8A-4147-A177-3AD203B41FA5}">
-                      <a16:colId xmlns:a16="http://schemas.microsoft.com/office/drawing/2014/main" val="20000"/>
-                    </a:ext>
-                  </a:extLst>
-                </a:gridCol>
-                <a:gridCol w="1097280">
-                  <a:extLst>
-                    <a:ext uri="{9D8B030D-6E8A-4147-A177-3AD203B41FA5}">
-                      <a16:colId xmlns:a16="http://schemas.microsoft.com/office/drawing/2014/main" val="20001"/>
-                    </a:ext>
-                  </a:extLst>
-                </a:gridCol>
-                <a:gridCol w="1280160">
-                  <a:extLst>
-                    <a:ext uri="{9D8B030D-6E8A-4147-A177-3AD203B41FA5}">
-                      <a16:colId xmlns:a16="http://schemas.microsoft.com/office/drawing/2014/main" val="20002"/>
-                    </a:ext>
-                  </a:extLst>
-                </a:gridCol>
+                <a:gridCol w="1280160"/>
+                <a:gridCol w="1097280"/>
+                <a:gridCol w="1280160"/>
               </a:tblGrid>
               <a:tr h="365760">
                 <a:tc>
@@ -7523,7 +7601,7 @@
                     <a:bodyPr/>
                     <a:lstStyle/>
                     <a:p>
-                      <a:pPr marL="0" indent="0" algn="l">
+                      <a:pPr algn="l" indent="0" marL="0">
                         <a:buNone/>
                       </a:pPr>
                       <a:r>
@@ -7544,7 +7622,7 @@
                       </a:endParaRPr>
                     </a:p>
                   </a:txBody>
-                  <a:tcPr anchor="ctr">
+                  <a:tcPr marL="91440" marR="91440" marT="45720" marB="45720" anchor="ctr">
                     <a:lnL w="6350" cap="flat" cmpd="sng" algn="ctr">
                       <a:solidFill>
                         <a:srgbClr val="1E5FC2"/>
@@ -7591,7 +7669,7 @@
                     <a:bodyPr/>
                     <a:lstStyle/>
                     <a:p>
-                      <a:pPr marL="0" indent="0" algn="ctr">
+                      <a:pPr algn="ctr" indent="0" marL="0">
                         <a:buNone/>
                       </a:pPr>
                       <a:r>
@@ -7612,7 +7690,7 @@
                       </a:endParaRPr>
                     </a:p>
                   </a:txBody>
-                  <a:tcPr anchor="ctr">
+                  <a:tcPr marL="91440" marR="91440" marT="45720" marB="45720" anchor="ctr">
                     <a:lnL w="6350" cap="flat" cmpd="sng" algn="ctr">
                       <a:solidFill>
                         <a:srgbClr val="1E5FC2"/>
@@ -7659,7 +7737,7 @@
                     <a:bodyPr/>
                     <a:lstStyle/>
                     <a:p>
-                      <a:pPr marL="0" indent="0" algn="ctr">
+                      <a:pPr algn="ctr" indent="0" marL="0">
                         <a:buNone/>
                       </a:pPr>
                       <a:r>
@@ -7680,7 +7758,7 @@
                       </a:endParaRPr>
                     </a:p>
                   </a:txBody>
-                  <a:tcPr anchor="ctr">
+                  <a:tcPr marL="91440" marR="91440" marT="45720" marB="45720" anchor="ctr">
                     <a:lnL w="6350" cap="flat" cmpd="sng" algn="ctr">
                       <a:solidFill>
                         <a:srgbClr val="1E5FC2"/>
@@ -7722,11 +7800,6 @@
                     </a:solidFill>
                   </a:tcPr>
                 </a:tc>
-                <a:extLst>
-                  <a:ext uri="{0D108BD9-81ED-4DB2-BD59-A6C34878D82A}">
-                    <a16:rowId xmlns:a16="http://schemas.microsoft.com/office/drawing/2014/main" val="10000"/>
-                  </a:ext>
-                </a:extLst>
               </a:tr>
               <a:tr h="365760">
                 <a:tc>
@@ -7734,7 +7807,7 @@
                     <a:bodyPr/>
                     <a:lstStyle/>
                     <a:p>
-                      <a:pPr marL="0" indent="0">
+                      <a:pPr indent="0" marL="0">
                         <a:buNone/>
                       </a:pPr>
                       <a:r>
@@ -7755,7 +7828,7 @@
                       </a:endParaRPr>
                     </a:p>
                   </a:txBody>
-                  <a:tcPr anchor="ctr">
+                  <a:tcPr marL="91440" marR="91440" marT="45720" marB="45720" anchor="ctr">
                     <a:lnL w="6350" cap="flat" cmpd="sng" algn="ctr">
                       <a:solidFill>
                         <a:srgbClr val="1E5FC2"/>
@@ -7799,7 +7872,7 @@
                     <a:bodyPr/>
                     <a:lstStyle/>
                     <a:p>
-                      <a:pPr marL="0" indent="0" algn="ctr">
+                      <a:pPr algn="ctr" indent="0" marL="0">
                         <a:buNone/>
                       </a:pPr>
                       <a:r>
@@ -7820,7 +7893,7 @@
                       </a:endParaRPr>
                     </a:p>
                   </a:txBody>
-                  <a:tcPr anchor="ctr">
+                  <a:tcPr marL="91440" marR="91440" marT="45720" marB="45720" anchor="ctr">
                     <a:lnL w="6350" cap="flat" cmpd="sng" algn="ctr">
                       <a:solidFill>
                         <a:srgbClr val="1E5FC2"/>
@@ -7864,7 +7937,7 @@
                     <a:bodyPr/>
                     <a:lstStyle/>
                     <a:p>
-                      <a:pPr marL="0" indent="0" algn="ctr">
+                      <a:pPr algn="ctr" indent="0" marL="0">
                         <a:buNone/>
                       </a:pPr>
                       <a:r>
@@ -7885,7 +7958,7 @@
                       </a:endParaRPr>
                     </a:p>
                   </a:txBody>
-                  <a:tcPr anchor="ctr">
+                  <a:tcPr marL="91440" marR="91440" marT="45720" marB="45720" anchor="ctr">
                     <a:lnL w="6350" cap="flat" cmpd="sng" algn="ctr">
                       <a:solidFill>
                         <a:srgbClr val="1E5FC2"/>
@@ -7924,11 +7997,6 @@
                     </a:lnB>
                   </a:tcPr>
                 </a:tc>
-                <a:extLst>
-                  <a:ext uri="{0D108BD9-81ED-4DB2-BD59-A6C34878D82A}">
-                    <a16:rowId xmlns:a16="http://schemas.microsoft.com/office/drawing/2014/main" val="10001"/>
-                  </a:ext>
-                </a:extLst>
               </a:tr>
               <a:tr h="365760">
                 <a:tc>
@@ -7936,7 +8004,7 @@
                     <a:bodyPr/>
                     <a:lstStyle/>
                     <a:p>
-                      <a:pPr marL="0" indent="0">
+                      <a:pPr indent="0" marL="0">
                         <a:buNone/>
                       </a:pPr>
                       <a:r>
@@ -7957,7 +8025,7 @@
                       </a:endParaRPr>
                     </a:p>
                   </a:txBody>
-                  <a:tcPr anchor="ctr">
+                  <a:tcPr marL="91440" marR="91440" marT="45720" marB="45720" anchor="ctr">
                     <a:lnL w="6350" cap="flat" cmpd="sng" algn="ctr">
                       <a:solidFill>
                         <a:srgbClr val="1E5FC2"/>
@@ -8001,7 +8069,7 @@
                     <a:bodyPr/>
                     <a:lstStyle/>
                     <a:p>
-                      <a:pPr marL="0" indent="0" algn="ctr">
+                      <a:pPr algn="ctr" indent="0" marL="0">
                         <a:buNone/>
                       </a:pPr>
                       <a:r>
@@ -8022,7 +8090,7 @@
                       </a:endParaRPr>
                     </a:p>
                   </a:txBody>
-                  <a:tcPr anchor="ctr">
+                  <a:tcPr marL="91440" marR="91440" marT="45720" marB="45720" anchor="ctr">
                     <a:lnL w="6350" cap="flat" cmpd="sng" algn="ctr">
                       <a:solidFill>
                         <a:srgbClr val="1E5FC2"/>
@@ -8066,7 +8134,7 @@
                     <a:bodyPr/>
                     <a:lstStyle/>
                     <a:p>
-                      <a:pPr marL="0" indent="0" algn="ctr">
+                      <a:pPr algn="ctr" indent="0" marL="0">
                         <a:buNone/>
                       </a:pPr>
                       <a:r>
@@ -8087,7 +8155,7 @@
                       </a:endParaRPr>
                     </a:p>
                   </a:txBody>
-                  <a:tcPr anchor="ctr">
+                  <a:tcPr marL="91440" marR="91440" marT="45720" marB="45720" anchor="ctr">
                     <a:lnL w="6350" cap="flat" cmpd="sng" algn="ctr">
                       <a:solidFill>
                         <a:srgbClr val="1E5FC2"/>
@@ -8126,11 +8194,6 @@
                     </a:lnB>
                   </a:tcPr>
                 </a:tc>
-                <a:extLst>
-                  <a:ext uri="{0D108BD9-81ED-4DB2-BD59-A6C34878D82A}">
-                    <a16:rowId xmlns:a16="http://schemas.microsoft.com/office/drawing/2014/main" val="10002"/>
-                  </a:ext>
-                </a:extLst>
               </a:tr>
               <a:tr h="365760">
                 <a:tc>
@@ -8138,7 +8201,7 @@
                     <a:bodyPr/>
                     <a:lstStyle/>
                     <a:p>
-                      <a:pPr marL="0" indent="0">
+                      <a:pPr indent="0" marL="0">
                         <a:buNone/>
                       </a:pPr>
                       <a:r>
@@ -8159,7 +8222,7 @@
                       </a:endParaRPr>
                     </a:p>
                   </a:txBody>
-                  <a:tcPr anchor="ctr">
+                  <a:tcPr marL="91440" marR="91440" marT="45720" marB="45720" anchor="ctr">
                     <a:lnL w="6350" cap="flat" cmpd="sng" algn="ctr">
                       <a:solidFill>
                         <a:srgbClr val="1E5FC2"/>
@@ -8203,7 +8266,7 @@
                     <a:bodyPr/>
                     <a:lstStyle/>
                     <a:p>
-                      <a:pPr marL="0" indent="0" algn="ctr">
+                      <a:pPr algn="ctr" indent="0" marL="0">
                         <a:buNone/>
                       </a:pPr>
                       <a:r>
@@ -8224,7 +8287,7 @@
                       </a:endParaRPr>
                     </a:p>
                   </a:txBody>
-                  <a:tcPr anchor="ctr">
+                  <a:tcPr marL="91440" marR="91440" marT="45720" marB="45720" anchor="ctr">
                     <a:lnL w="6350" cap="flat" cmpd="sng" algn="ctr">
                       <a:solidFill>
                         <a:srgbClr val="1E5FC2"/>
@@ -8268,7 +8331,7 @@
                     <a:bodyPr/>
                     <a:lstStyle/>
                     <a:p>
-                      <a:pPr marL="0" indent="0" algn="ctr">
+                      <a:pPr algn="ctr" indent="0" marL="0">
                         <a:buNone/>
                       </a:pPr>
                       <a:r>
@@ -8289,7 +8352,7 @@
                       </a:endParaRPr>
                     </a:p>
                   </a:txBody>
-                  <a:tcPr anchor="ctr">
+                  <a:tcPr marL="91440" marR="91440" marT="45720" marB="45720" anchor="ctr">
                     <a:lnL w="6350" cap="flat" cmpd="sng" algn="ctr">
                       <a:solidFill>
                         <a:srgbClr val="1E5FC2"/>
@@ -8328,11 +8391,6 @@
                     </a:lnB>
                   </a:tcPr>
                 </a:tc>
-                <a:extLst>
-                  <a:ext uri="{0D108BD9-81ED-4DB2-BD59-A6C34878D82A}">
-                    <a16:rowId xmlns:a16="http://schemas.microsoft.com/office/drawing/2014/main" val="10003"/>
-                  </a:ext>
-                </a:extLst>
               </a:tr>
               <a:tr h="365760">
                 <a:tc>
@@ -8340,7 +8398,7 @@
                     <a:bodyPr/>
                     <a:lstStyle/>
                     <a:p>
-                      <a:pPr marL="0" indent="0">
+                      <a:pPr indent="0" marL="0">
                         <a:buNone/>
                       </a:pPr>
                       <a:r>
@@ -8361,7 +8419,7 @@
                       </a:endParaRPr>
                     </a:p>
                   </a:txBody>
-                  <a:tcPr anchor="ctr">
+                  <a:tcPr marL="91440" marR="91440" marT="45720" marB="45720" anchor="ctr">
                     <a:lnL w="6350" cap="flat" cmpd="sng" algn="ctr">
                       <a:solidFill>
                         <a:srgbClr val="1E5FC2"/>
@@ -8405,7 +8463,7 @@
                     <a:bodyPr/>
                     <a:lstStyle/>
                     <a:p>
-                      <a:pPr marL="0" indent="0" algn="ctr">
+                      <a:pPr algn="ctr" indent="0" marL="0">
                         <a:buNone/>
                       </a:pPr>
                       <a:r>
@@ -8426,7 +8484,7 @@
                       </a:endParaRPr>
                     </a:p>
                   </a:txBody>
-                  <a:tcPr anchor="ctr">
+                  <a:tcPr marL="91440" marR="91440" marT="45720" marB="45720" anchor="ctr">
                     <a:lnL w="6350" cap="flat" cmpd="sng" algn="ctr">
                       <a:solidFill>
                         <a:srgbClr val="1E5FC2"/>
@@ -8470,7 +8528,7 @@
                     <a:bodyPr/>
                     <a:lstStyle/>
                     <a:p>
-                      <a:pPr marL="0" indent="0" algn="ctr">
+                      <a:pPr algn="ctr" indent="0" marL="0">
                         <a:buNone/>
                       </a:pPr>
                       <a:r>
@@ -8491,7 +8549,7 @@
                       </a:endParaRPr>
                     </a:p>
                   </a:txBody>
-                  <a:tcPr anchor="ctr">
+                  <a:tcPr marL="91440" marR="91440" marT="45720" marB="45720" anchor="ctr">
                     <a:lnL w="6350" cap="flat" cmpd="sng" algn="ctr">
                       <a:solidFill>
                         <a:srgbClr val="1E5FC2"/>
@@ -8530,11 +8588,6 @@
                     </a:lnB>
                   </a:tcPr>
                 </a:tc>
-                <a:extLst>
-                  <a:ext uri="{0D108BD9-81ED-4DB2-BD59-A6C34878D82A}">
-                    <a16:rowId xmlns:a16="http://schemas.microsoft.com/office/drawing/2014/main" val="10004"/>
-                  </a:ext>
-                </a:extLst>
               </a:tr>
             </a:tbl>
           </a:graphicData>
@@ -8608,7 +8661,7 @@
           </a:bodyPr>
           <a:lstStyle/>
           <a:p>
-            <a:pPr marL="0" indent="0">
+            <a:pPr indent="0" marL="0">
               <a:buNone/>
             </a:pPr>
             <a:r>
@@ -8729,7 +8782,6 @@
         <a:solidFill>
           <a:srgbClr val="FFFFFF"/>
         </a:solidFill>
-        <a:effectLst/>
       </p:bgPr>
     </p:bg>
     <p:spTree>
@@ -8807,7 +8859,7 @@
           <a:bodyPr wrap="square" rtlCol="0" anchor="ctr"/>
           <a:lstStyle/>
           <a:p>
-            <a:pPr marL="0" indent="0">
+            <a:pPr indent="0" marL="0">
               <a:buNone/>
             </a:pPr>
             <a:r>
@@ -8846,7 +8898,7 @@
           <a:bodyPr wrap="square" rtlCol="0" anchor="ctr"/>
           <a:lstStyle/>
           <a:p>
-            <a:pPr marL="0" indent="0" algn="r">
+            <a:pPr algn="r" indent="0" marL="0">
               <a:buNone/>
             </a:pPr>
             <a:r>
@@ -8887,7 +8939,7 @@
           </a:bodyPr>
           <a:lstStyle/>
           <a:p>
-            <a:pPr marL="0" indent="0">
+            <a:pPr indent="0" marL="0">
               <a:buNone/>
             </a:pPr>
             <a:r>
@@ -8973,7 +9025,7 @@
           </a:bodyPr>
           <a:lstStyle/>
           <a:p>
-            <a:pPr marL="0" indent="0" algn="ctr">
+            <a:pPr algn="ctr" indent="0" marL="0">
               <a:buNone/>
             </a:pPr>
             <a:r>
@@ -9014,7 +9066,7 @@
           </a:bodyPr>
           <a:lstStyle/>
           <a:p>
-            <a:pPr marL="0" indent="0" algn="ctr">
+            <a:pPr algn="ctr" indent="0" marL="0">
               <a:buNone/>
             </a:pPr>
             <a:r>
@@ -9055,7 +9107,7 @@
           </a:bodyPr>
           <a:lstStyle/>
           <a:p>
-            <a:pPr marL="0" indent="0" algn="ctr">
+            <a:pPr algn="ctr" indent="0" marL="0">
               <a:buNone/>
             </a:pPr>
             <a:r>
@@ -9072,7 +9124,7 @@
             <a:endParaRPr lang="en-US" sz="1200" dirty="0"/>
           </a:p>
           <a:p>
-            <a:pPr marL="0" indent="0" algn="ctr">
+            <a:pPr algn="ctr" indent="0" marL="0">
               <a:buNone/>
             </a:pPr>
             <a:r>
@@ -9158,7 +9210,7 @@
           </a:bodyPr>
           <a:lstStyle/>
           <a:p>
-            <a:pPr marL="0" indent="0" algn="ctr">
+            <a:pPr algn="ctr" indent="0" marL="0">
               <a:buNone/>
             </a:pPr>
             <a:r>
@@ -9199,7 +9251,7 @@
           </a:bodyPr>
           <a:lstStyle/>
           <a:p>
-            <a:pPr marL="0" indent="0" algn="ctr">
+            <a:pPr algn="ctr" indent="0" marL="0">
               <a:buNone/>
             </a:pPr>
             <a:r>
@@ -9240,7 +9292,7 @@
           </a:bodyPr>
           <a:lstStyle/>
           <a:p>
-            <a:pPr marL="0" indent="0" algn="ctr">
+            <a:pPr algn="ctr" indent="0" marL="0">
               <a:buNone/>
             </a:pPr>
             <a:r>
@@ -9257,7 +9309,7 @@
             <a:endParaRPr lang="en-US" sz="1200" dirty="0"/>
           </a:p>
           <a:p>
-            <a:pPr marL="0" indent="0" algn="ctr">
+            <a:pPr algn="ctr" indent="0" marL="0">
               <a:buNone/>
             </a:pPr>
             <a:r>
@@ -9343,7 +9395,7 @@
           </a:bodyPr>
           <a:lstStyle/>
           <a:p>
-            <a:pPr marL="0" indent="0" algn="ctr">
+            <a:pPr algn="ctr" indent="0" marL="0">
               <a:buNone/>
             </a:pPr>
             <a:r>
@@ -9384,7 +9436,7 @@
           </a:bodyPr>
           <a:lstStyle/>
           <a:p>
-            <a:pPr marL="0" indent="0" algn="ctr">
+            <a:pPr algn="ctr" indent="0" marL="0">
               <a:buNone/>
             </a:pPr>
             <a:r>
@@ -9425,7 +9477,7 @@
           </a:bodyPr>
           <a:lstStyle/>
           <a:p>
-            <a:pPr marL="0" indent="0" algn="ctr">
+            <a:pPr algn="ctr" indent="0" marL="0">
               <a:buNone/>
             </a:pPr>
             <a:r>
@@ -9442,7 +9494,7 @@
             <a:endParaRPr lang="en-US" sz="1200" dirty="0"/>
           </a:p>
           <a:p>
-            <a:pPr marL="0" indent="0" algn="ctr">
+            <a:pPr algn="ctr" indent="0" marL="0">
               <a:buNone/>
             </a:pPr>
             <a:r>
@@ -9528,7 +9580,7 @@
           </a:bodyPr>
           <a:lstStyle/>
           <a:p>
-            <a:pPr marL="0" indent="0" algn="ctr">
+            <a:pPr algn="ctr" indent="0" marL="0">
               <a:buNone/>
             </a:pPr>
             <a:r>
@@ -9569,7 +9621,7 @@
           </a:bodyPr>
           <a:lstStyle/>
           <a:p>
-            <a:pPr marL="0" indent="0" algn="ctr">
+            <a:pPr algn="ctr" indent="0" marL="0">
               <a:buNone/>
             </a:pPr>
             <a:r>
@@ -9603,7 +9655,6 @@
         <a:solidFill>
           <a:srgbClr val="FFFFFF"/>
         </a:solidFill>
-        <a:effectLst/>
       </p:bgPr>
     </p:bg>
     <p:spTree>
@@ -9681,7 +9732,7 @@
           <a:bodyPr wrap="square" rtlCol="0" anchor="ctr"/>
           <a:lstStyle/>
           <a:p>
-            <a:pPr marL="0" indent="0">
+            <a:pPr indent="0" marL="0">
               <a:buNone/>
             </a:pPr>
             <a:r>
@@ -9720,7 +9771,7 @@
           <a:bodyPr wrap="square" rtlCol="0" anchor="ctr"/>
           <a:lstStyle/>
           <a:p>
-            <a:pPr marL="0" indent="0" algn="r">
+            <a:pPr algn="r" indent="0" marL="0">
               <a:buNone/>
             </a:pPr>
             <a:r>
@@ -9761,7 +9812,7 @@
           </a:bodyPr>
           <a:lstStyle/>
           <a:p>
-            <a:pPr marL="0" indent="0">
+            <a:pPr indent="0" marL="0">
               <a:buNone/>
             </a:pPr>
             <a:r>
@@ -9781,14 +9832,14 @@
       </p:sp>
       <p:pic>
         <p:nvPicPr>
-          <p:cNvPr id="7" name="Image 0" descr="C:\Users\ADMIN\OneDrive\Documents\MÁY HỌC\ĐỒ ÁN MÔN MÁY HỌC\CS114-Team10-Elderly-Scam-Detection\draft\scam-detection\reports\figures\learning_curves_summary.png"/>
+          <p:cNvPr id="7" name="Image 0" descr="C:\Users\ADMIN\OneDrive\Documents\MÁY HỌC\ĐỒ ÁN MÔN MÁY HỌC\CS114-Team10-Elderly-Scam-Detection\draft\scam-detection\reports\figures\learning_curves_summary.png">    </p:cNvPr>
           <p:cNvPicPr>
             <a:picLocks noChangeAspect="1"/>
           </p:cNvPicPr>
           <p:nvPr/>
         </p:nvPicPr>
         <p:blipFill>
-          <a:blip r:embed="rId3"/>
+          <a:blip r:embed="rId1"/>
           <a:stretch>
             <a:fillRect/>
           </a:stretch>
@@ -9871,7 +9922,7 @@
           </a:bodyPr>
           <a:lstStyle/>
           <a:p>
-            <a:pPr marL="0" indent="0">
+            <a:pPr indent="0" marL="0">
               <a:buNone/>
             </a:pPr>
             <a:r>
@@ -9992,7 +10043,6 @@
         <a:solidFill>
           <a:srgbClr val="FFFFFF"/>
         </a:solidFill>
-        <a:effectLst/>
       </p:bgPr>
     </p:bg>
     <p:spTree>
@@ -10070,7 +10120,7 @@
           <a:bodyPr wrap="square" rtlCol="0" anchor="ctr"/>
           <a:lstStyle/>
           <a:p>
-            <a:pPr marL="0" indent="0">
+            <a:pPr indent="0" marL="0">
               <a:buNone/>
             </a:pPr>
             <a:r>
@@ -10109,7 +10159,7 @@
           <a:bodyPr wrap="square" rtlCol="0" anchor="ctr"/>
           <a:lstStyle/>
           <a:p>
-            <a:pPr marL="0" indent="0" algn="r">
+            <a:pPr algn="r" indent="0" marL="0">
               <a:buNone/>
             </a:pPr>
             <a:r>
@@ -10150,7 +10200,7 @@
           </a:bodyPr>
           <a:lstStyle/>
           <a:p>
-            <a:pPr marL="0" indent="0">
+            <a:pPr indent="0" marL="0">
               <a:buNone/>
             </a:pPr>
             <a:r>
@@ -10236,7 +10286,7 @@
           </a:bodyPr>
           <a:lstStyle/>
           <a:p>
-            <a:pPr marL="0" indent="0">
+            <a:pPr indent="0" marL="0">
               <a:buNone/>
             </a:pPr>
             <a:r>
@@ -10409,7 +10459,7 @@
           </a:bodyPr>
           <a:lstStyle/>
           <a:p>
-            <a:pPr marL="0" indent="0">
+            <a:pPr indent="0" marL="0">
               <a:buNone/>
             </a:pPr>
             <a:r>
@@ -10582,7 +10632,7 @@
           </a:bodyPr>
           <a:lstStyle/>
           <a:p>
-            <a:pPr marL="0" indent="0">
+            <a:pPr indent="0" marL="0">
               <a:buNone/>
             </a:pPr>
             <a:r>
@@ -10755,7 +10805,7 @@
           </a:bodyPr>
           <a:lstStyle/>
           <a:p>
-            <a:pPr marL="0" indent="0">
+            <a:pPr indent="0" marL="0">
               <a:buNone/>
             </a:pPr>
             <a:r>
@@ -10876,7 +10926,6 @@
         <a:solidFill>
           <a:srgbClr val="0B2545"/>
         </a:solidFill>
-        <a:effectLst/>
       </p:bgPr>
     </p:bg>
     <p:spTree>
@@ -10916,7 +10965,7 @@
           </a:bodyPr>
           <a:lstStyle/>
           <a:p>
-            <a:pPr marL="0" indent="0" algn="ctr">
+            <a:pPr algn="ctr" indent="0" marL="0">
               <a:buNone/>
             </a:pPr>
             <a:r>
@@ -10933,7 +10982,7 @@
             <a:endParaRPr lang="en-US" sz="3600" dirty="0"/>
           </a:p>
           <a:p>
-            <a:pPr marL="0" indent="0" algn="ctr">
+            <a:pPr algn="ctr" indent="0" marL="0">
               <a:buNone/>
             </a:pPr>
             <a:r>
@@ -10992,7 +11041,7 @@
           <a:bodyPr wrap="square" rtlCol="0" anchor="ctr"/>
           <a:lstStyle/>
           <a:p>
-            <a:pPr marL="0" indent="0" algn="ctr">
+            <a:pPr algn="ctr" indent="0" marL="0">
               <a:buNone/>
             </a:pPr>
             <a:r>
@@ -11026,7 +11075,6 @@
         <a:solidFill>
           <a:srgbClr val="FFFFFF"/>
         </a:solidFill>
-        <a:effectLst/>
       </p:bgPr>
     </p:bg>
     <p:spTree>
@@ -11104,7 +11152,7 @@
           <a:bodyPr wrap="square" rtlCol="0" anchor="ctr"/>
           <a:lstStyle/>
           <a:p>
-            <a:pPr marL="0" indent="0">
+            <a:pPr indent="0" marL="0">
               <a:buNone/>
             </a:pPr>
             <a:r>
@@ -11143,7 +11191,7 @@
           <a:bodyPr wrap="square" rtlCol="0" anchor="ctr"/>
           <a:lstStyle/>
           <a:p>
-            <a:pPr marL="0" indent="0" algn="r">
+            <a:pPr algn="r" indent="0" marL="0">
               <a:buNone/>
             </a:pPr>
             <a:r>
@@ -11184,7 +11232,7 @@
           </a:bodyPr>
           <a:lstStyle/>
           <a:p>
-            <a:pPr marL="0" indent="0">
+            <a:pPr indent="0" marL="0">
               <a:buNone/>
             </a:pPr>
             <a:r>
@@ -11241,7 +11289,7 @@
                 <a:ea typeface="Calibri" pitchFamily="34" charset="-122"/>
                 <a:cs typeface="Calibri" pitchFamily="34" charset="-120"/>
               </a:rPr>
-              <a:t>2.193 mẫu · Stratified Split 80/20</a:t>
+              <a:t>2.193 mẫu · Stratified Split 80/20 · nguồn [4], [6]</a:t>
             </a:r>
             <a:endParaRPr lang="en-US" sz="1500" dirty="0"/>
           </a:p>
@@ -11354,14 +11402,14 @@
       </p:sp>
       <p:pic>
         <p:nvPicPr>
-          <p:cNvPr id="8" name="Image 0" descr="C:\Users\ADMIN\OneDrive\Documents\MÁY HỌC\ĐỒ ÁN MÔN MÁY HỌC\CS114-Team10-Elderly-Scam-Detection\draft\scam-detection\reports\figures\label_distribution.png"/>
+          <p:cNvPr id="8" name="Image 0" descr="C:\Users\ADMIN\OneDrive\Documents\MÁY HỌC\ĐỒ ÁN MÔN MÁY HỌC\CS114-Team10-Elderly-Scam-Detection\draft\scam-detection\reports\figures\label_distribution.png">    </p:cNvPr>
           <p:cNvPicPr>
             <a:picLocks noChangeAspect="1"/>
           </p:cNvPicPr>
           <p:nvPr/>
         </p:nvPicPr>
         <p:blipFill>
-          <a:blip r:embed="rId3"/>
+          <a:blip r:embed="rId1"/>
           <a:stretch>
             <a:fillRect/>
           </a:stretch>
@@ -11397,7 +11445,7 @@
           <a:bodyPr wrap="square" rtlCol="0" anchor="ctr"/>
           <a:lstStyle/>
           <a:p>
-            <a:pPr marL="0" indent="0" algn="ctr">
+            <a:pPr algn="ctr" indent="0" marL="0">
               <a:buNone/>
             </a:pPr>
             <a:r>
@@ -11483,7 +11531,7 @@
           </a:bodyPr>
           <a:lstStyle/>
           <a:p>
-            <a:pPr marL="0" indent="0">
+            <a:pPr indent="0" marL="0">
               <a:buNone/>
             </a:pPr>
             <a:r>
@@ -11517,7 +11565,6 @@
         <a:solidFill>
           <a:srgbClr val="FFFFFF"/>
         </a:solidFill>
-        <a:effectLst/>
       </p:bgPr>
     </p:bg>
     <p:spTree>
@@ -11595,7 +11642,7 @@
           <a:bodyPr wrap="square" rtlCol="0" anchor="ctr"/>
           <a:lstStyle/>
           <a:p>
-            <a:pPr marL="0" indent="0">
+            <a:pPr indent="0" marL="0">
               <a:buNone/>
             </a:pPr>
             <a:r>
@@ -11634,7 +11681,7 @@
           <a:bodyPr wrap="square" rtlCol="0" anchor="ctr"/>
           <a:lstStyle/>
           <a:p>
-            <a:pPr marL="0" indent="0" algn="r">
+            <a:pPr algn="r" indent="0" marL="0">
               <a:buNone/>
             </a:pPr>
             <a:r>
@@ -11675,7 +11722,7 @@
           </a:bodyPr>
           <a:lstStyle/>
           <a:p>
-            <a:pPr marL="0" indent="0">
+            <a:pPr indent="0" marL="0">
               <a:buNone/>
             </a:pPr>
             <a:r>
@@ -11695,14 +11742,14 @@
       </p:sp>
       <p:pic>
         <p:nvPicPr>
-          <p:cNvPr id="7" name="Image 0" descr="C:\Users\ADMIN\OneDrive\Documents\MÁY HỌC\ĐỒ ÁN MÔN MÁY HỌC\CS114-Team10-Elderly-Scam-Detection\draft\scam-detection\reports\figures\scam_category_distribution.png"/>
+          <p:cNvPr id="7" name="Image 0" descr="C:\Users\ADMIN\OneDrive\Documents\MÁY HỌC\ĐỒ ÁN MÔN MÁY HỌC\CS114-Team10-Elderly-Scam-Detection\draft\scam-detection\reports\figures\scam_category_distribution.png">    </p:cNvPr>
           <p:cNvPicPr>
             <a:picLocks noChangeAspect="1"/>
           </p:cNvPicPr>
           <p:nvPr/>
         </p:nvPicPr>
         <p:blipFill>
-          <a:blip r:embed="rId3"/>
+          <a:blip r:embed="rId1"/>
           <a:stretch>
             <a:fillRect/>
           </a:stretch>
@@ -11738,7 +11785,7 @@
           <a:bodyPr wrap="square" rtlCol="0" anchor="ctr"/>
           <a:lstStyle/>
           <a:p>
-            <a:pPr marL="0" indent="0" algn="ctr">
+            <a:pPr algn="ctr" indent="0" marL="0">
               <a:buNone/>
             </a:pPr>
             <a:r>
@@ -11758,7 +11805,7 @@
       </p:sp>
       <p:graphicFrame>
         <p:nvGraphicFramePr>
-          <p:cNvPr id="9" name="Table 0"/>
+          <p:cNvPr id="7" name="Table 0"/>
           <p:cNvGraphicFramePr>
             <a:graphicFrameLocks noGrp="1"/>
           </p:cNvGraphicFramePr>
@@ -11772,34 +11819,16 @@
         </p:nvGraphicFramePr>
         <p:xfrm>
           <a:off x="4663440" y="1143000"/>
-          <a:ext cx="4023360" cy="2286000"/>
+          <a:ext cx="4023360" cy="914400"/>
         </p:xfrm>
         <a:graphic>
           <a:graphicData uri="http://schemas.openxmlformats.org/drawingml/2006/table">
             <a:tbl>
               <a:tblPr/>
               <a:tblGrid>
-                <a:gridCol w="1463040">
-                  <a:extLst>
-                    <a:ext uri="{9D8B030D-6E8A-4147-A177-3AD203B41FA5}">
-                      <a16:colId xmlns:a16="http://schemas.microsoft.com/office/drawing/2014/main" val="20000"/>
-                    </a:ext>
-                  </a:extLst>
-                </a:gridCol>
-                <a:gridCol w="548640">
-                  <a:extLst>
-                    <a:ext uri="{9D8B030D-6E8A-4147-A177-3AD203B41FA5}">
-                      <a16:colId xmlns:a16="http://schemas.microsoft.com/office/drawing/2014/main" val="20001"/>
-                    </a:ext>
-                  </a:extLst>
-                </a:gridCol>
-                <a:gridCol w="2011680">
-                  <a:extLst>
-                    <a:ext uri="{9D8B030D-6E8A-4147-A177-3AD203B41FA5}">
-                      <a16:colId xmlns:a16="http://schemas.microsoft.com/office/drawing/2014/main" val="20002"/>
-                    </a:ext>
-                  </a:extLst>
-                </a:gridCol>
+                <a:gridCol w="1463040"/>
+                <a:gridCol w="548640"/>
+                <a:gridCol w="2011680"/>
               </a:tblGrid>
               <a:tr h="384048">
                 <a:tc>
@@ -11807,7 +11836,7 @@
                     <a:bodyPr/>
                     <a:lstStyle/>
                     <a:p>
-                      <a:pPr marL="0" indent="0" algn="l">
+                      <a:pPr algn="l" indent="0" marL="0">
                         <a:buNone/>
                       </a:pPr>
                       <a:r>
@@ -11828,7 +11857,7 @@
                       </a:endParaRPr>
                     </a:p>
                   </a:txBody>
-                  <a:tcPr anchor="ctr">
+                  <a:tcPr marL="91440" marR="91440" marT="45720" marB="45720" anchor="ctr">
                     <a:lnL w="6350" cap="flat" cmpd="sng" algn="ctr">
                       <a:solidFill>
                         <a:srgbClr val="1E5FC2"/>
@@ -11875,7 +11904,7 @@
                     <a:bodyPr/>
                     <a:lstStyle/>
                     <a:p>
-                      <a:pPr marL="0" indent="0" algn="ctr">
+                      <a:pPr algn="ctr" indent="0" marL="0">
                         <a:buNone/>
                       </a:pPr>
                       <a:r>
@@ -11896,7 +11925,7 @@
                       </a:endParaRPr>
                     </a:p>
                   </a:txBody>
-                  <a:tcPr anchor="ctr">
+                  <a:tcPr marL="91440" marR="91440" marT="45720" marB="45720" anchor="ctr">
                     <a:lnL w="6350" cap="flat" cmpd="sng" algn="ctr">
                       <a:solidFill>
                         <a:srgbClr val="1E5FC2"/>
@@ -11943,7 +11972,7 @@
                     <a:bodyPr/>
                     <a:lstStyle/>
                     <a:p>
-                      <a:pPr marL="0" indent="0" algn="l">
+                      <a:pPr algn="l" indent="0" marL="0">
                         <a:buNone/>
                       </a:pPr>
                       <a:r>
@@ -11964,7 +11993,7 @@
                       </a:endParaRPr>
                     </a:p>
                   </a:txBody>
-                  <a:tcPr anchor="ctr">
+                  <a:tcPr marL="91440" marR="91440" marT="45720" marB="45720" anchor="ctr">
                     <a:lnL w="6350" cap="flat" cmpd="sng" algn="ctr">
                       <a:solidFill>
                         <a:srgbClr val="1E5FC2"/>
@@ -12006,11 +12035,6 @@
                     </a:solidFill>
                   </a:tcPr>
                 </a:tc>
-                <a:extLst>
-                  <a:ext uri="{0D108BD9-81ED-4DB2-BD59-A6C34878D82A}">
-                    <a16:rowId xmlns:a16="http://schemas.microsoft.com/office/drawing/2014/main" val="10000"/>
-                  </a:ext>
-                </a:extLst>
               </a:tr>
               <a:tr h="475488">
                 <a:tc>
@@ -12018,7 +12042,7 @@
                     <a:bodyPr/>
                     <a:lstStyle/>
                     <a:p>
-                      <a:pPr marL="0" indent="0">
+                      <a:pPr indent="0" marL="0">
                         <a:buNone/>
                       </a:pPr>
                       <a:r>
@@ -12039,7 +12063,7 @@
                       </a:endParaRPr>
                     </a:p>
                   </a:txBody>
-                  <a:tcPr anchor="ctr">
+                  <a:tcPr marL="91440" marR="91440" marT="45720" marB="45720" anchor="ctr">
                     <a:lnL w="6350" cap="flat" cmpd="sng" algn="ctr">
                       <a:solidFill>
                         <a:srgbClr val="1E5FC2"/>
@@ -12083,7 +12107,7 @@
                     <a:bodyPr/>
                     <a:lstStyle/>
                     <a:p>
-                      <a:pPr marL="0" indent="0" algn="ctr">
+                      <a:pPr algn="ctr" indent="0" marL="0">
                         <a:buNone/>
                       </a:pPr>
                       <a:r>
@@ -12104,7 +12128,7 @@
                       </a:endParaRPr>
                     </a:p>
                   </a:txBody>
-                  <a:tcPr anchor="ctr">
+                  <a:tcPr marL="91440" marR="91440" marT="45720" marB="45720" anchor="ctr">
                     <a:lnL w="6350" cap="flat" cmpd="sng" algn="ctr">
                       <a:solidFill>
                         <a:srgbClr val="1E5FC2"/>
@@ -12148,7 +12172,7 @@
                     <a:bodyPr/>
                     <a:lstStyle/>
                     <a:p>
-                      <a:pPr marL="0" indent="0">
+                      <a:pPr indent="0" marL="0">
                         <a:buNone/>
                       </a:pPr>
                       <a:r>
@@ -12169,7 +12193,7 @@
                       </a:endParaRPr>
                     </a:p>
                   </a:txBody>
-                  <a:tcPr anchor="ctr">
+                  <a:tcPr marL="91440" marR="91440" marT="45720" marB="45720" anchor="ctr">
                     <a:lnL w="6350" cap="flat" cmpd="sng" algn="ctr">
                       <a:solidFill>
                         <a:srgbClr val="1E5FC2"/>
@@ -12208,11 +12232,6 @@
                     </a:lnB>
                   </a:tcPr>
                 </a:tc>
-                <a:extLst>
-                  <a:ext uri="{0D108BD9-81ED-4DB2-BD59-A6C34878D82A}">
-                    <a16:rowId xmlns:a16="http://schemas.microsoft.com/office/drawing/2014/main" val="10001"/>
-                  </a:ext>
-                </a:extLst>
               </a:tr>
               <a:tr h="475488">
                 <a:tc>
@@ -12220,7 +12239,7 @@
                     <a:bodyPr/>
                     <a:lstStyle/>
                     <a:p>
-                      <a:pPr marL="0" indent="0">
+                      <a:pPr indent="0" marL="0">
                         <a:buNone/>
                       </a:pPr>
                       <a:r>
@@ -12241,7 +12260,7 @@
                       </a:endParaRPr>
                     </a:p>
                   </a:txBody>
-                  <a:tcPr anchor="ctr">
+                  <a:tcPr marL="91440" marR="91440" marT="45720" marB="45720" anchor="ctr">
                     <a:lnL w="6350" cap="flat" cmpd="sng" algn="ctr">
                       <a:solidFill>
                         <a:srgbClr val="1E5FC2"/>
@@ -12285,7 +12304,7 @@
                     <a:bodyPr/>
                     <a:lstStyle/>
                     <a:p>
-                      <a:pPr marL="0" indent="0" algn="ctr">
+                      <a:pPr algn="ctr" indent="0" marL="0">
                         <a:buNone/>
                       </a:pPr>
                       <a:r>
@@ -12306,7 +12325,7 @@
                       </a:endParaRPr>
                     </a:p>
                   </a:txBody>
-                  <a:tcPr anchor="ctr">
+                  <a:tcPr marL="91440" marR="91440" marT="45720" marB="45720" anchor="ctr">
                     <a:lnL w="6350" cap="flat" cmpd="sng" algn="ctr">
                       <a:solidFill>
                         <a:srgbClr val="1E5FC2"/>
@@ -12350,7 +12369,7 @@
                     <a:bodyPr/>
                     <a:lstStyle/>
                     <a:p>
-                      <a:pPr marL="0" indent="0">
+                      <a:pPr indent="0" marL="0">
                         <a:buNone/>
                       </a:pPr>
                       <a:r>
@@ -12371,7 +12390,7 @@
                       </a:endParaRPr>
                     </a:p>
                   </a:txBody>
-                  <a:tcPr anchor="ctr">
+                  <a:tcPr marL="91440" marR="91440" marT="45720" marB="45720" anchor="ctr">
                     <a:lnL w="6350" cap="flat" cmpd="sng" algn="ctr">
                       <a:solidFill>
                         <a:srgbClr val="1E5FC2"/>
@@ -12410,11 +12429,6 @@
                     </a:lnB>
                   </a:tcPr>
                 </a:tc>
-                <a:extLst>
-                  <a:ext uri="{0D108BD9-81ED-4DB2-BD59-A6C34878D82A}">
-                    <a16:rowId xmlns:a16="http://schemas.microsoft.com/office/drawing/2014/main" val="10002"/>
-                  </a:ext>
-                </a:extLst>
               </a:tr>
               <a:tr h="475488">
                 <a:tc>
@@ -12422,7 +12436,7 @@
                     <a:bodyPr/>
                     <a:lstStyle/>
                     <a:p>
-                      <a:pPr marL="0" indent="0">
+                      <a:pPr indent="0" marL="0">
                         <a:buNone/>
                       </a:pPr>
                       <a:r>
@@ -12443,7 +12457,7 @@
                       </a:endParaRPr>
                     </a:p>
                   </a:txBody>
-                  <a:tcPr anchor="ctr">
+                  <a:tcPr marL="91440" marR="91440" marT="45720" marB="45720" anchor="ctr">
                     <a:lnL w="6350" cap="flat" cmpd="sng" algn="ctr">
                       <a:solidFill>
                         <a:srgbClr val="1E5FC2"/>
@@ -12487,7 +12501,7 @@
                     <a:bodyPr/>
                     <a:lstStyle/>
                     <a:p>
-                      <a:pPr marL="0" indent="0" algn="ctr">
+                      <a:pPr algn="ctr" indent="0" marL="0">
                         <a:buNone/>
                       </a:pPr>
                       <a:r>
@@ -12508,7 +12522,7 @@
                       </a:endParaRPr>
                     </a:p>
                   </a:txBody>
-                  <a:tcPr anchor="ctr">
+                  <a:tcPr marL="91440" marR="91440" marT="45720" marB="45720" anchor="ctr">
                     <a:lnL w="6350" cap="flat" cmpd="sng" algn="ctr">
                       <a:solidFill>
                         <a:srgbClr val="1E5FC2"/>
@@ -12552,7 +12566,7 @@
                     <a:bodyPr/>
                     <a:lstStyle/>
                     <a:p>
-                      <a:pPr marL="0" indent="0">
+                      <a:pPr indent="0" marL="0">
                         <a:buNone/>
                       </a:pPr>
                       <a:r>
@@ -12573,7 +12587,7 @@
                       </a:endParaRPr>
                     </a:p>
                   </a:txBody>
-                  <a:tcPr anchor="ctr">
+                  <a:tcPr marL="91440" marR="91440" marT="45720" marB="45720" anchor="ctr">
                     <a:lnL w="6350" cap="flat" cmpd="sng" algn="ctr">
                       <a:solidFill>
                         <a:srgbClr val="1E5FC2"/>
@@ -12612,11 +12626,6 @@
                     </a:lnB>
                   </a:tcPr>
                 </a:tc>
-                <a:extLst>
-                  <a:ext uri="{0D108BD9-81ED-4DB2-BD59-A6C34878D82A}">
-                    <a16:rowId xmlns:a16="http://schemas.microsoft.com/office/drawing/2014/main" val="10003"/>
-                  </a:ext>
-                </a:extLst>
               </a:tr>
               <a:tr h="475488">
                 <a:tc>
@@ -12624,7 +12633,7 @@
                     <a:bodyPr/>
                     <a:lstStyle/>
                     <a:p>
-                      <a:pPr marL="0" indent="0">
+                      <a:pPr indent="0" marL="0">
                         <a:buNone/>
                       </a:pPr>
                       <a:r>
@@ -12645,7 +12654,7 @@
                       </a:endParaRPr>
                     </a:p>
                   </a:txBody>
-                  <a:tcPr anchor="ctr">
+                  <a:tcPr marL="91440" marR="91440" marT="45720" marB="45720" anchor="ctr">
                     <a:lnL w="6350" cap="flat" cmpd="sng" algn="ctr">
                       <a:solidFill>
                         <a:srgbClr val="1E5FC2"/>
@@ -12689,7 +12698,7 @@
                     <a:bodyPr/>
                     <a:lstStyle/>
                     <a:p>
-                      <a:pPr marL="0" indent="0" algn="ctr">
+                      <a:pPr algn="ctr" indent="0" marL="0">
                         <a:buNone/>
                       </a:pPr>
                       <a:r>
@@ -12710,7 +12719,7 @@
                       </a:endParaRPr>
                     </a:p>
                   </a:txBody>
-                  <a:tcPr anchor="ctr">
+                  <a:tcPr marL="91440" marR="91440" marT="45720" marB="45720" anchor="ctr">
                     <a:lnL w="6350" cap="flat" cmpd="sng" algn="ctr">
                       <a:solidFill>
                         <a:srgbClr val="1E5FC2"/>
@@ -12754,7 +12763,7 @@
                     <a:bodyPr/>
                     <a:lstStyle/>
                     <a:p>
-                      <a:pPr marL="0" indent="0">
+                      <a:pPr indent="0" marL="0">
                         <a:buNone/>
                       </a:pPr>
                       <a:r>
@@ -12775,7 +12784,7 @@
                       </a:endParaRPr>
                     </a:p>
                   </a:txBody>
-                  <a:tcPr anchor="ctr">
+                  <a:tcPr marL="91440" marR="91440" marT="45720" marB="45720" anchor="ctr">
                     <a:lnL w="6350" cap="flat" cmpd="sng" algn="ctr">
                       <a:solidFill>
                         <a:srgbClr val="1E5FC2"/>
@@ -12814,11 +12823,6 @@
                     </a:lnB>
                   </a:tcPr>
                 </a:tc>
-                <a:extLst>
-                  <a:ext uri="{0D108BD9-81ED-4DB2-BD59-A6C34878D82A}">
-                    <a16:rowId xmlns:a16="http://schemas.microsoft.com/office/drawing/2014/main" val="10004"/>
-                  </a:ext>
-                </a:extLst>
               </a:tr>
             </a:tbl>
           </a:graphicData>
@@ -12892,7 +12896,7 @@
           </a:bodyPr>
           <a:lstStyle/>
           <a:p>
-            <a:pPr marL="0" indent="0">
+            <a:pPr indent="0" marL="0">
               <a:buNone/>
             </a:pPr>
             <a:r>
@@ -12926,7 +12930,6 @@
         <a:solidFill>
           <a:srgbClr val="FFFFFF"/>
         </a:solidFill>
-        <a:effectLst/>
       </p:bgPr>
     </p:bg>
     <p:spTree>
@@ -13004,7 +13007,7 @@
           <a:bodyPr wrap="square" rtlCol="0" anchor="ctr"/>
           <a:lstStyle/>
           <a:p>
-            <a:pPr marL="0" indent="0">
+            <a:pPr indent="0" marL="0">
               <a:buNone/>
             </a:pPr>
             <a:r>
@@ -13043,7 +13046,7 @@
           <a:bodyPr wrap="square" rtlCol="0" anchor="ctr"/>
           <a:lstStyle/>
           <a:p>
-            <a:pPr marL="0" indent="0" algn="r">
+            <a:pPr algn="r" indent="0" marL="0">
               <a:buNone/>
             </a:pPr>
             <a:r>
@@ -13084,7 +13087,7 @@
           </a:bodyPr>
           <a:lstStyle/>
           <a:p>
-            <a:pPr marL="0" indent="0">
+            <a:pPr indent="0" marL="0">
               <a:buNone/>
             </a:pPr>
             <a:r>
@@ -13170,7 +13173,7 @@
           </a:bodyPr>
           <a:lstStyle/>
           <a:p>
-            <a:pPr marL="0" indent="0">
+            <a:pPr indent="0" marL="0">
               <a:buNone/>
             </a:pPr>
             <a:r>
@@ -13211,7 +13214,7 @@
           </a:bodyPr>
           <a:lstStyle/>
           <a:p>
-            <a:pPr marL="0" indent="0">
+            <a:pPr indent="0" marL="0">
               <a:spcAft>
                 <a:spcPts val="300"/>
               </a:spcAft>
@@ -13231,7 +13234,7 @@
             <a:endParaRPr lang="en-US" sz="1300" dirty="0"/>
           </a:p>
           <a:p>
-            <a:pPr marL="0" indent="0">
+            <a:pPr indent="0" marL="0">
               <a:spcAft>
                 <a:spcPts val="300"/>
               </a:spcAft>
@@ -13340,7 +13343,7 @@
           </a:bodyPr>
           <a:lstStyle/>
           <a:p>
-            <a:pPr marL="0" indent="0">
+            <a:pPr indent="0" marL="0">
               <a:buNone/>
             </a:pPr>
             <a:r>
@@ -13381,7 +13384,7 @@
           </a:bodyPr>
           <a:lstStyle/>
           <a:p>
-            <a:pPr marL="0" indent="0">
+            <a:pPr indent="0" marL="0">
               <a:spcAft>
                 <a:spcPts val="300"/>
               </a:spcAft>
@@ -13401,7 +13404,7 @@
             <a:endParaRPr lang="en-US" sz="1300" dirty="0"/>
           </a:p>
           <a:p>
-            <a:pPr marL="0" indent="0">
+            <a:pPr indent="0" marL="0">
               <a:spcAft>
                 <a:spcPts val="300"/>
               </a:spcAft>
@@ -13510,7 +13513,7 @@
           </a:bodyPr>
           <a:lstStyle/>
           <a:p>
-            <a:pPr marL="0" indent="0">
+            <a:pPr indent="0" marL="0">
               <a:buNone/>
             </a:pPr>
             <a:r>
@@ -13551,7 +13554,7 @@
           </a:bodyPr>
           <a:lstStyle/>
           <a:p>
-            <a:pPr marL="0" indent="0">
+            <a:pPr indent="0" marL="0">
               <a:spcAft>
                 <a:spcPts val="300"/>
               </a:spcAft>
@@ -13571,7 +13574,7 @@
             <a:endParaRPr lang="en-US" sz="1300" dirty="0"/>
           </a:p>
           <a:p>
-            <a:pPr marL="0" indent="0">
+            <a:pPr indent="0" marL="0">
               <a:spcAft>
                 <a:spcPts val="300"/>
               </a:spcAft>
@@ -13680,7 +13683,7 @@
           </a:bodyPr>
           <a:lstStyle/>
           <a:p>
-            <a:pPr marL="0" indent="0">
+            <a:pPr indent="0" marL="0">
               <a:buNone/>
             </a:pPr>
             <a:r>
@@ -13721,7 +13724,7 @@
           </a:bodyPr>
           <a:lstStyle/>
           <a:p>
-            <a:pPr marL="0" indent="0">
+            <a:pPr indent="0" marL="0">
               <a:spcAft>
                 <a:spcPts val="300"/>
               </a:spcAft>
@@ -13741,7 +13744,7 @@
             <a:endParaRPr lang="en-US" sz="1300" dirty="0"/>
           </a:p>
           <a:p>
-            <a:pPr marL="0" indent="0">
+            <a:pPr indent="0" marL="0">
               <a:spcAft>
                 <a:spcPts val="300"/>
               </a:spcAft>
@@ -13850,7 +13853,7 @@
           </a:bodyPr>
           <a:lstStyle/>
           <a:p>
-            <a:pPr marL="0" indent="0">
+            <a:pPr indent="0" marL="0">
               <a:buNone/>
             </a:pPr>
             <a:r>
@@ -13891,7 +13894,7 @@
           </a:bodyPr>
           <a:lstStyle/>
           <a:p>
-            <a:pPr marL="0" indent="0">
+            <a:pPr indent="0" marL="0">
               <a:spcAft>
                 <a:spcPts val="300"/>
               </a:spcAft>
@@ -13911,7 +13914,7 @@
             <a:endParaRPr lang="en-US" sz="1300" dirty="0"/>
           </a:p>
           <a:p>
-            <a:pPr marL="0" indent="0">
+            <a:pPr indent="0" marL="0">
               <a:spcAft>
                 <a:spcPts val="300"/>
               </a:spcAft>
@@ -13975,7 +13978,7 @@
           </a:bodyPr>
           <a:lstStyle/>
           <a:p>
-            <a:pPr marL="0" indent="0">
+            <a:pPr indent="0" marL="0">
               <a:buNone/>
             </a:pPr>
             <a:r>
@@ -14061,7 +14064,7 @@
           </a:bodyPr>
           <a:lstStyle/>
           <a:p>
-            <a:pPr marL="0" indent="0">
+            <a:pPr indent="0" marL="0">
               <a:buNone/>
             </a:pPr>
             <a:r>
@@ -14102,7 +14105,7 @@
           </a:bodyPr>
           <a:lstStyle/>
           <a:p>
-            <a:pPr marL="0" indent="0">
+            <a:pPr indent="0" marL="0">
               <a:spcAft>
                 <a:spcPts val="300"/>
               </a:spcAft>
@@ -14122,7 +14125,7 @@
             <a:endParaRPr lang="en-US" sz="1300" dirty="0"/>
           </a:p>
           <a:p>
-            <a:pPr marL="0" indent="0">
+            <a:pPr indent="0" marL="0">
               <a:spcAft>
                 <a:spcPts val="300"/>
               </a:spcAft>
@@ -14142,7 +14145,7 @@
             <a:endParaRPr lang="en-US" sz="1300" dirty="0"/>
           </a:p>
           <a:p>
-            <a:pPr marL="0" indent="0">
+            <a:pPr indent="0" marL="0">
               <a:spcAft>
                 <a:spcPts val="300"/>
               </a:spcAft>
@@ -14179,7 +14182,6 @@
         <a:solidFill>
           <a:srgbClr val="0B2545"/>
         </a:solidFill>
-        <a:effectLst/>
       </p:bgPr>
     </p:bg>
     <p:spTree>
@@ -14219,7 +14221,7 @@
           </a:bodyPr>
           <a:lstStyle/>
           <a:p>
-            <a:pPr marL="0" indent="0" algn="ctr">
+            <a:pPr algn="ctr" indent="0" marL="0">
               <a:buNone/>
             </a:pPr>
             <a:r>
@@ -14236,7 +14238,7 @@
             <a:endParaRPr lang="en-US" sz="3600" dirty="0"/>
           </a:p>
           <a:p>
-            <a:pPr marL="0" indent="0" algn="ctr">
+            <a:pPr algn="ctr" indent="0" marL="0">
               <a:buNone/>
             </a:pPr>
             <a:r>
@@ -14295,7 +14297,7 @@
           <a:bodyPr wrap="square" rtlCol="0" anchor="ctr"/>
           <a:lstStyle/>
           <a:p>
-            <a:pPr marL="0" indent="0" algn="ctr">
+            <a:pPr algn="ctr" indent="0" marL="0">
               <a:buNone/>
             </a:pPr>
             <a:r>
@@ -14329,7 +14331,6 @@
         <a:solidFill>
           <a:srgbClr val="FFFFFF"/>
         </a:solidFill>
-        <a:effectLst/>
       </p:bgPr>
     </p:bg>
     <p:spTree>
@@ -14407,7 +14408,7 @@
           <a:bodyPr wrap="square" rtlCol="0" anchor="ctr"/>
           <a:lstStyle/>
           <a:p>
-            <a:pPr marL="0" indent="0">
+            <a:pPr indent="0" marL="0">
               <a:buNone/>
             </a:pPr>
             <a:r>
@@ -14446,7 +14447,7 @@
           <a:bodyPr wrap="square" rtlCol="0" anchor="ctr"/>
           <a:lstStyle/>
           <a:p>
-            <a:pPr marL="0" indent="0" algn="r">
+            <a:pPr algn="r" indent="0" marL="0">
               <a:buNone/>
             </a:pPr>
             <a:r>
@@ -14487,7 +14488,7 @@
           </a:bodyPr>
           <a:lstStyle/>
           <a:p>
-            <a:pPr marL="0" indent="0">
+            <a:pPr indent="0" marL="0">
               <a:buNone/>
             </a:pPr>
             <a:r>
@@ -14521,55 +14522,19 @@
         </p:nvGraphicFramePr>
         <p:xfrm>
           <a:off x="457200" y="1097280"/>
-          <a:ext cx="8229600" cy="2212848"/>
+          <a:ext cx="8229600" cy="914400"/>
         </p:xfrm>
         <a:graphic>
           <a:graphicData uri="http://schemas.openxmlformats.org/drawingml/2006/table">
             <a:tbl>
               <a:tblPr/>
               <a:tblGrid>
-                <a:gridCol w="2514600">
-                  <a:extLst>
-                    <a:ext uri="{9D8B030D-6E8A-4147-A177-3AD203B41FA5}">
-                      <a16:colId xmlns:a16="http://schemas.microsoft.com/office/drawing/2014/main" val="20000"/>
-                    </a:ext>
-                  </a:extLst>
-                </a:gridCol>
-                <a:gridCol w="1143000">
-                  <a:extLst>
-                    <a:ext uri="{9D8B030D-6E8A-4147-A177-3AD203B41FA5}">
-                      <a16:colId xmlns:a16="http://schemas.microsoft.com/office/drawing/2014/main" val="20001"/>
-                    </a:ext>
-                  </a:extLst>
-                </a:gridCol>
-                <a:gridCol w="1143000">
-                  <a:extLst>
-                    <a:ext uri="{9D8B030D-6E8A-4147-A177-3AD203B41FA5}">
-                      <a16:colId xmlns:a16="http://schemas.microsoft.com/office/drawing/2014/main" val="20002"/>
-                    </a:ext>
-                  </a:extLst>
-                </a:gridCol>
-                <a:gridCol w="1143000">
-                  <a:extLst>
-                    <a:ext uri="{9D8B030D-6E8A-4147-A177-3AD203B41FA5}">
-                      <a16:colId xmlns:a16="http://schemas.microsoft.com/office/drawing/2014/main" val="20003"/>
-                    </a:ext>
-                  </a:extLst>
-                </a:gridCol>
-                <a:gridCol w="1143000">
-                  <a:extLst>
-                    <a:ext uri="{9D8B030D-6E8A-4147-A177-3AD203B41FA5}">
-                      <a16:colId xmlns:a16="http://schemas.microsoft.com/office/drawing/2014/main" val="20004"/>
-                    </a:ext>
-                  </a:extLst>
-                </a:gridCol>
-                <a:gridCol w="1143000">
-                  <a:extLst>
-                    <a:ext uri="{9D8B030D-6E8A-4147-A177-3AD203B41FA5}">
-                      <a16:colId xmlns:a16="http://schemas.microsoft.com/office/drawing/2014/main" val="20005"/>
-                    </a:ext>
-                  </a:extLst>
-                </a:gridCol>
+                <a:gridCol w="2514600"/>
+                <a:gridCol w="1143000"/>
+                <a:gridCol w="1143000"/>
+                <a:gridCol w="1143000"/>
+                <a:gridCol w="1143000"/>
+                <a:gridCol w="1143000"/>
               </a:tblGrid>
               <a:tr h="384048">
                 <a:tc>
@@ -14577,7 +14542,7 @@
                     <a:bodyPr/>
                     <a:lstStyle/>
                     <a:p>
-                      <a:pPr marL="0" indent="0" algn="l">
+                      <a:pPr algn="l" indent="0" marL="0">
                         <a:buNone/>
                       </a:pPr>
                       <a:r>
@@ -14598,7 +14563,7 @@
                       </a:endParaRPr>
                     </a:p>
                   </a:txBody>
-                  <a:tcPr anchor="ctr">
+                  <a:tcPr marL="91440" marR="91440" marT="45720" marB="45720" anchor="ctr">
                     <a:lnL w="6350" cap="flat" cmpd="sng" algn="ctr">
                       <a:solidFill>
                         <a:srgbClr val="1E5FC2"/>
@@ -14645,7 +14610,7 @@
                     <a:bodyPr/>
                     <a:lstStyle/>
                     <a:p>
-                      <a:pPr marL="0" indent="0" algn="ctr">
+                      <a:pPr algn="ctr" indent="0" marL="0">
                         <a:buNone/>
                       </a:pPr>
                       <a:r>
@@ -14666,7 +14631,7 @@
                       </a:endParaRPr>
                     </a:p>
                   </a:txBody>
-                  <a:tcPr anchor="ctr">
+                  <a:tcPr marL="91440" marR="91440" marT="45720" marB="45720" anchor="ctr">
                     <a:lnL w="6350" cap="flat" cmpd="sng" algn="ctr">
                       <a:solidFill>
                         <a:srgbClr val="1E5FC2"/>
@@ -14713,7 +14678,7 @@
                     <a:bodyPr/>
                     <a:lstStyle/>
                     <a:p>
-                      <a:pPr marL="0" indent="0" algn="ctr">
+                      <a:pPr algn="ctr" indent="0" marL="0">
                         <a:buNone/>
                       </a:pPr>
                       <a:r>
@@ -14734,7 +14699,7 @@
                       </a:endParaRPr>
                     </a:p>
                   </a:txBody>
-                  <a:tcPr anchor="ctr">
+                  <a:tcPr marL="91440" marR="91440" marT="45720" marB="45720" anchor="ctr">
                     <a:lnL w="6350" cap="flat" cmpd="sng" algn="ctr">
                       <a:solidFill>
                         <a:srgbClr val="1E5FC2"/>
@@ -14781,7 +14746,7 @@
                     <a:bodyPr/>
                     <a:lstStyle/>
                     <a:p>
-                      <a:pPr marL="0" indent="0" algn="ctr">
+                      <a:pPr algn="ctr" indent="0" marL="0">
                         <a:buNone/>
                       </a:pPr>
                       <a:r>
@@ -14802,7 +14767,7 @@
                       </a:endParaRPr>
                     </a:p>
                   </a:txBody>
-                  <a:tcPr anchor="ctr">
+                  <a:tcPr marL="91440" marR="91440" marT="45720" marB="45720" anchor="ctr">
                     <a:lnL w="6350" cap="flat" cmpd="sng" algn="ctr">
                       <a:solidFill>
                         <a:srgbClr val="1E5FC2"/>
@@ -14849,7 +14814,7 @@
                     <a:bodyPr/>
                     <a:lstStyle/>
                     <a:p>
-                      <a:pPr marL="0" indent="0" algn="ctr">
+                      <a:pPr algn="ctr" indent="0" marL="0">
                         <a:buNone/>
                       </a:pPr>
                       <a:r>
@@ -14870,7 +14835,7 @@
                       </a:endParaRPr>
                     </a:p>
                   </a:txBody>
-                  <a:tcPr anchor="ctr">
+                  <a:tcPr marL="91440" marR="91440" marT="45720" marB="45720" anchor="ctr">
                     <a:lnL w="6350" cap="flat" cmpd="sng" algn="ctr">
                       <a:solidFill>
                         <a:srgbClr val="1E5FC2"/>
@@ -14917,7 +14882,7 @@
                     <a:bodyPr/>
                     <a:lstStyle/>
                     <a:p>
-                      <a:pPr marL="0" indent="0" algn="ctr">
+                      <a:pPr algn="ctr" indent="0" marL="0">
                         <a:buNone/>
                       </a:pPr>
                       <a:r>
@@ -14938,7 +14903,7 @@
                       </a:endParaRPr>
                     </a:p>
                   </a:txBody>
-                  <a:tcPr anchor="ctr">
+                  <a:tcPr marL="91440" marR="91440" marT="45720" marB="45720" anchor="ctr">
                     <a:lnL w="6350" cap="flat" cmpd="sng" algn="ctr">
                       <a:solidFill>
                         <a:srgbClr val="1E5FC2"/>
@@ -14980,11 +14945,6 @@
                     </a:solidFill>
                   </a:tcPr>
                 </a:tc>
-                <a:extLst>
-                  <a:ext uri="{0D108BD9-81ED-4DB2-BD59-A6C34878D82A}">
-                    <a16:rowId xmlns:a16="http://schemas.microsoft.com/office/drawing/2014/main" val="10000"/>
-                  </a:ext>
-                </a:extLst>
               </a:tr>
               <a:tr h="457200">
                 <a:tc>
@@ -14992,7 +14952,7 @@
                     <a:bodyPr/>
                     <a:lstStyle/>
                     <a:p>
-                      <a:pPr marL="0" indent="0" algn="l">
+                      <a:pPr algn="l" indent="0" marL="0">
                         <a:buNone/>
                       </a:pPr>
                       <a:r>
@@ -15013,7 +14973,7 @@
                       </a:endParaRPr>
                     </a:p>
                   </a:txBody>
-                  <a:tcPr anchor="ctr">
+                  <a:tcPr marL="91440" marR="91440" marT="45720" marB="45720" anchor="ctr">
                     <a:lnL w="6350" cap="flat" cmpd="sng" algn="ctr">
                       <a:solidFill>
                         <a:srgbClr val="1E5FC2"/>
@@ -15060,7 +15020,7 @@
                     <a:bodyPr/>
                     <a:lstStyle/>
                     <a:p>
-                      <a:pPr marL="0" indent="0" algn="ctr">
+                      <a:pPr algn="ctr" indent="0" marL="0">
                         <a:buNone/>
                       </a:pPr>
                       <a:r>
@@ -15081,7 +15041,7 @@
                       </a:endParaRPr>
                     </a:p>
                   </a:txBody>
-                  <a:tcPr anchor="ctr">
+                  <a:tcPr marL="91440" marR="91440" marT="45720" marB="45720" anchor="ctr">
                     <a:lnL w="6350" cap="flat" cmpd="sng" algn="ctr">
                       <a:solidFill>
                         <a:srgbClr val="1E5FC2"/>
@@ -15128,7 +15088,7 @@
                     <a:bodyPr/>
                     <a:lstStyle/>
                     <a:p>
-                      <a:pPr marL="0" indent="0" algn="ctr">
+                      <a:pPr algn="ctr" indent="0" marL="0">
                         <a:buNone/>
                       </a:pPr>
                       <a:r>
@@ -15149,7 +15109,7 @@
                       </a:endParaRPr>
                     </a:p>
                   </a:txBody>
-                  <a:tcPr anchor="ctr">
+                  <a:tcPr marL="91440" marR="91440" marT="45720" marB="45720" anchor="ctr">
                     <a:lnL w="6350" cap="flat" cmpd="sng" algn="ctr">
                       <a:solidFill>
                         <a:srgbClr val="1E5FC2"/>
@@ -15196,7 +15156,7 @@
                     <a:bodyPr/>
                     <a:lstStyle/>
                     <a:p>
-                      <a:pPr marL="0" indent="0" algn="ctr">
+                      <a:pPr algn="ctr" indent="0" marL="0">
                         <a:buNone/>
                       </a:pPr>
                       <a:r>
@@ -15217,7 +15177,7 @@
                       </a:endParaRPr>
                     </a:p>
                   </a:txBody>
-                  <a:tcPr anchor="ctr">
+                  <a:tcPr marL="91440" marR="91440" marT="45720" marB="45720" anchor="ctr">
                     <a:lnL w="6350" cap="flat" cmpd="sng" algn="ctr">
                       <a:solidFill>
                         <a:srgbClr val="1E5FC2"/>
@@ -15264,7 +15224,7 @@
                     <a:bodyPr/>
                     <a:lstStyle/>
                     <a:p>
-                      <a:pPr marL="0" indent="0" algn="ctr">
+                      <a:pPr algn="ctr" indent="0" marL="0">
                         <a:buNone/>
                       </a:pPr>
                       <a:r>
@@ -15285,7 +15245,7 @@
                       </a:endParaRPr>
                     </a:p>
                   </a:txBody>
-                  <a:tcPr anchor="ctr">
+                  <a:tcPr marL="91440" marR="91440" marT="45720" marB="45720" anchor="ctr">
                     <a:lnL w="6350" cap="flat" cmpd="sng" algn="ctr">
                       <a:solidFill>
                         <a:srgbClr val="1E5FC2"/>
@@ -15332,7 +15292,7 @@
                     <a:bodyPr/>
                     <a:lstStyle/>
                     <a:p>
-                      <a:pPr marL="0" indent="0" algn="ctr">
+                      <a:pPr algn="ctr" indent="0" marL="0">
                         <a:buNone/>
                       </a:pPr>
                       <a:r>
@@ -15353,7 +15313,7 @@
                       </a:endParaRPr>
                     </a:p>
                   </a:txBody>
-                  <a:tcPr anchor="ctr">
+                  <a:tcPr marL="91440" marR="91440" marT="45720" marB="45720" anchor="ctr">
                     <a:lnL w="6350" cap="flat" cmpd="sng" algn="ctr">
                       <a:solidFill>
                         <a:srgbClr val="1E5FC2"/>
@@ -15395,11 +15355,6 @@
                     </a:solidFill>
                   </a:tcPr>
                 </a:tc>
-                <a:extLst>
-                  <a:ext uri="{0D108BD9-81ED-4DB2-BD59-A6C34878D82A}">
-                    <a16:rowId xmlns:a16="http://schemas.microsoft.com/office/drawing/2014/main" val="10001"/>
-                  </a:ext>
-                </a:extLst>
               </a:tr>
               <a:tr h="457200">
                 <a:tc>
@@ -15407,7 +15362,7 @@
                     <a:bodyPr/>
                     <a:lstStyle/>
                     <a:p>
-                      <a:pPr marL="0" indent="0" algn="l">
+                      <a:pPr algn="l" indent="0" marL="0">
                         <a:buNone/>
                       </a:pPr>
                       <a:r>
@@ -15428,7 +15383,7 @@
                       </a:endParaRPr>
                     </a:p>
                   </a:txBody>
-                  <a:tcPr anchor="ctr">
+                  <a:tcPr marL="91440" marR="91440" marT="45720" marB="45720" anchor="ctr">
                     <a:lnL w="6350" cap="flat" cmpd="sng" algn="ctr">
                       <a:solidFill>
                         <a:srgbClr val="1E5FC2"/>
@@ -15472,7 +15427,7 @@
                     <a:bodyPr/>
                     <a:lstStyle/>
                     <a:p>
-                      <a:pPr marL="0" indent="0" algn="ctr">
+                      <a:pPr algn="ctr" indent="0" marL="0">
                         <a:buNone/>
                       </a:pPr>
                       <a:r>
@@ -15493,7 +15448,7 @@
                       </a:endParaRPr>
                     </a:p>
                   </a:txBody>
-                  <a:tcPr anchor="ctr">
+                  <a:tcPr marL="91440" marR="91440" marT="45720" marB="45720" anchor="ctr">
                     <a:lnL w="6350" cap="flat" cmpd="sng" algn="ctr">
                       <a:solidFill>
                         <a:srgbClr val="1E5FC2"/>
@@ -15537,7 +15492,7 @@
                     <a:bodyPr/>
                     <a:lstStyle/>
                     <a:p>
-                      <a:pPr marL="0" indent="0" algn="ctr">
+                      <a:pPr algn="ctr" indent="0" marL="0">
                         <a:buNone/>
                       </a:pPr>
                       <a:r>
@@ -15558,7 +15513,7 @@
                       </a:endParaRPr>
                     </a:p>
                   </a:txBody>
-                  <a:tcPr anchor="ctr">
+                  <a:tcPr marL="91440" marR="91440" marT="45720" marB="45720" anchor="ctr">
                     <a:lnL w="6350" cap="flat" cmpd="sng" algn="ctr">
                       <a:solidFill>
                         <a:srgbClr val="1E5FC2"/>
@@ -15602,7 +15557,7 @@
                     <a:bodyPr/>
                     <a:lstStyle/>
                     <a:p>
-                      <a:pPr marL="0" indent="0" algn="ctr">
+                      <a:pPr algn="ctr" indent="0" marL="0">
                         <a:buNone/>
                       </a:pPr>
                       <a:r>
@@ -15623,7 +15578,7 @@
                       </a:endParaRPr>
                     </a:p>
                   </a:txBody>
-                  <a:tcPr anchor="ctr">
+                  <a:tcPr marL="91440" marR="91440" marT="45720" marB="45720" anchor="ctr">
                     <a:lnL w="6350" cap="flat" cmpd="sng" algn="ctr">
                       <a:solidFill>
                         <a:srgbClr val="1E5FC2"/>
@@ -15667,7 +15622,7 @@
                     <a:bodyPr/>
                     <a:lstStyle/>
                     <a:p>
-                      <a:pPr marL="0" indent="0" algn="ctr">
+                      <a:pPr algn="ctr" indent="0" marL="0">
                         <a:buNone/>
                       </a:pPr>
                       <a:r>
@@ -15688,7 +15643,7 @@
                       </a:endParaRPr>
                     </a:p>
                   </a:txBody>
-                  <a:tcPr anchor="ctr">
+                  <a:tcPr marL="91440" marR="91440" marT="45720" marB="45720" anchor="ctr">
                     <a:lnL w="6350" cap="flat" cmpd="sng" algn="ctr">
                       <a:solidFill>
                         <a:srgbClr val="1E5FC2"/>
@@ -15732,7 +15687,7 @@
                     <a:bodyPr/>
                     <a:lstStyle/>
                     <a:p>
-                      <a:pPr marL="0" indent="0" algn="ctr">
+                      <a:pPr algn="ctr" indent="0" marL="0">
                         <a:buNone/>
                       </a:pPr>
                       <a:r>
@@ -15753,7 +15708,7 @@
                       </a:endParaRPr>
                     </a:p>
                   </a:txBody>
-                  <a:tcPr anchor="ctr">
+                  <a:tcPr marL="91440" marR="91440" marT="45720" marB="45720" anchor="ctr">
                     <a:lnL w="6350" cap="flat" cmpd="sng" algn="ctr">
                       <a:solidFill>
                         <a:srgbClr val="1E5FC2"/>
@@ -15792,11 +15747,6 @@
                     </a:lnB>
                   </a:tcPr>
                 </a:tc>
-                <a:extLst>
-                  <a:ext uri="{0D108BD9-81ED-4DB2-BD59-A6C34878D82A}">
-                    <a16:rowId xmlns:a16="http://schemas.microsoft.com/office/drawing/2014/main" val="10002"/>
-                  </a:ext>
-                </a:extLst>
               </a:tr>
               <a:tr h="457200">
                 <a:tc>
@@ -15804,7 +15754,7 @@
                     <a:bodyPr/>
                     <a:lstStyle/>
                     <a:p>
-                      <a:pPr marL="0" indent="0" algn="l">
+                      <a:pPr algn="l" indent="0" marL="0">
                         <a:buNone/>
                       </a:pPr>
                       <a:r>
@@ -15825,7 +15775,7 @@
                       </a:endParaRPr>
                     </a:p>
                   </a:txBody>
-                  <a:tcPr anchor="ctr">
+                  <a:tcPr marL="91440" marR="91440" marT="45720" marB="45720" anchor="ctr">
                     <a:lnL w="6350" cap="flat" cmpd="sng" algn="ctr">
                       <a:solidFill>
                         <a:srgbClr val="1E5FC2"/>
@@ -15869,7 +15819,7 @@
                     <a:bodyPr/>
                     <a:lstStyle/>
                     <a:p>
-                      <a:pPr marL="0" indent="0" algn="ctr">
+                      <a:pPr algn="ctr" indent="0" marL="0">
                         <a:buNone/>
                       </a:pPr>
                       <a:r>
@@ -15890,7 +15840,7 @@
                       </a:endParaRPr>
                     </a:p>
                   </a:txBody>
-                  <a:tcPr anchor="ctr">
+                  <a:tcPr marL="91440" marR="91440" marT="45720" marB="45720" anchor="ctr">
                     <a:lnL w="6350" cap="flat" cmpd="sng" algn="ctr">
                       <a:solidFill>
                         <a:srgbClr val="1E5FC2"/>
@@ -15934,7 +15884,7 @@
                     <a:bodyPr/>
                     <a:lstStyle/>
                     <a:p>
-                      <a:pPr marL="0" indent="0" algn="ctr">
+                      <a:pPr algn="ctr" indent="0" marL="0">
                         <a:buNone/>
                       </a:pPr>
                       <a:r>
@@ -15955,7 +15905,7 @@
                       </a:endParaRPr>
                     </a:p>
                   </a:txBody>
-                  <a:tcPr anchor="ctr">
+                  <a:tcPr marL="91440" marR="91440" marT="45720" marB="45720" anchor="ctr">
                     <a:lnL w="6350" cap="flat" cmpd="sng" algn="ctr">
                       <a:solidFill>
                         <a:srgbClr val="1E5FC2"/>
@@ -15999,7 +15949,7 @@
                     <a:bodyPr/>
                     <a:lstStyle/>
                     <a:p>
-                      <a:pPr marL="0" indent="0" algn="ctr">
+                      <a:pPr algn="ctr" indent="0" marL="0">
                         <a:buNone/>
                       </a:pPr>
                       <a:r>
@@ -16020,7 +15970,7 @@
                       </a:endParaRPr>
                     </a:p>
                   </a:txBody>
-                  <a:tcPr anchor="ctr">
+                  <a:tcPr marL="91440" marR="91440" marT="45720" marB="45720" anchor="ctr">
                     <a:lnL w="6350" cap="flat" cmpd="sng" algn="ctr">
                       <a:solidFill>
                         <a:srgbClr val="1E5FC2"/>
@@ -16064,7 +16014,7 @@
                     <a:bodyPr/>
                     <a:lstStyle/>
                     <a:p>
-                      <a:pPr marL="0" indent="0" algn="ctr">
+                      <a:pPr algn="ctr" indent="0" marL="0">
                         <a:buNone/>
                       </a:pPr>
                       <a:r>
@@ -16085,7 +16035,7 @@
                       </a:endParaRPr>
                     </a:p>
                   </a:txBody>
-                  <a:tcPr anchor="ctr">
+                  <a:tcPr marL="91440" marR="91440" marT="45720" marB="45720" anchor="ctr">
                     <a:lnL w="6350" cap="flat" cmpd="sng" algn="ctr">
                       <a:solidFill>
                         <a:srgbClr val="1E5FC2"/>
@@ -16129,7 +16079,7 @@
                     <a:bodyPr/>
                     <a:lstStyle/>
                     <a:p>
-                      <a:pPr marL="0" indent="0" algn="ctr">
+                      <a:pPr algn="ctr" indent="0" marL="0">
                         <a:buNone/>
                       </a:pPr>
                       <a:r>
@@ -16141,7 +16091,7 @@
                           <a:ea typeface="Calibri" pitchFamily="34" charset="-122"/>
                           <a:cs typeface="Calibri" pitchFamily="34" charset="-120"/>
                         </a:rPr>
-                        <a:t>99.76%</a:t>
+                        <a:t>99.77%</a:t>
                       </a:r>
                       <a:endParaRPr lang="en-US" sz="1300" dirty="0">
                         <a:latin typeface="Calibri" charset="0"/>
@@ -16150,7 +16100,7 @@
                       </a:endParaRPr>
                     </a:p>
                   </a:txBody>
-                  <a:tcPr anchor="ctr">
+                  <a:tcPr marL="91440" marR="91440" marT="45720" marB="45720" anchor="ctr">
                     <a:lnL w="6350" cap="flat" cmpd="sng" algn="ctr">
                       <a:solidFill>
                         <a:srgbClr val="1E5FC2"/>
@@ -16189,11 +16139,6 @@
                     </a:lnB>
                   </a:tcPr>
                 </a:tc>
-                <a:extLst>
-                  <a:ext uri="{0D108BD9-81ED-4DB2-BD59-A6C34878D82A}">
-                    <a16:rowId xmlns:a16="http://schemas.microsoft.com/office/drawing/2014/main" val="10003"/>
-                  </a:ext>
-                </a:extLst>
               </a:tr>
               <a:tr h="457200">
                 <a:tc>
@@ -16201,7 +16146,7 @@
                     <a:bodyPr/>
                     <a:lstStyle/>
                     <a:p>
-                      <a:pPr marL="0" indent="0" algn="l">
+                      <a:pPr algn="l" indent="0" marL="0">
                         <a:buNone/>
                       </a:pPr>
                       <a:r>
@@ -16222,7 +16167,7 @@
                       </a:endParaRPr>
                     </a:p>
                   </a:txBody>
-                  <a:tcPr anchor="ctr">
+                  <a:tcPr marL="91440" marR="91440" marT="45720" marB="45720" anchor="ctr">
                     <a:lnL w="6350" cap="flat" cmpd="sng" algn="ctr">
                       <a:solidFill>
                         <a:srgbClr val="1E5FC2"/>
@@ -16266,7 +16211,7 @@
                     <a:bodyPr/>
                     <a:lstStyle/>
                     <a:p>
-                      <a:pPr marL="0" indent="0" algn="ctr">
+                      <a:pPr algn="ctr" indent="0" marL="0">
                         <a:buNone/>
                       </a:pPr>
                       <a:r>
@@ -16287,7 +16232,7 @@
                       </a:endParaRPr>
                     </a:p>
                   </a:txBody>
-                  <a:tcPr anchor="ctr">
+                  <a:tcPr marL="91440" marR="91440" marT="45720" marB="45720" anchor="ctr">
                     <a:lnL w="6350" cap="flat" cmpd="sng" algn="ctr">
                       <a:solidFill>
                         <a:srgbClr val="1E5FC2"/>
@@ -16331,7 +16276,7 @@
                     <a:bodyPr/>
                     <a:lstStyle/>
                     <a:p>
-                      <a:pPr marL="0" indent="0" algn="ctr">
+                      <a:pPr algn="ctr" indent="0" marL="0">
                         <a:buNone/>
                       </a:pPr>
                       <a:r>
@@ -16352,7 +16297,7 @@
                       </a:endParaRPr>
                     </a:p>
                   </a:txBody>
-                  <a:tcPr anchor="ctr">
+                  <a:tcPr marL="91440" marR="91440" marT="45720" marB="45720" anchor="ctr">
                     <a:lnL w="6350" cap="flat" cmpd="sng" algn="ctr">
                       <a:solidFill>
                         <a:srgbClr val="1E5FC2"/>
@@ -16396,7 +16341,7 @@
                     <a:bodyPr/>
                     <a:lstStyle/>
                     <a:p>
-                      <a:pPr marL="0" indent="0" algn="ctr">
+                      <a:pPr algn="ctr" indent="0" marL="0">
                         <a:buNone/>
                       </a:pPr>
                       <a:r>
@@ -16417,7 +16362,7 @@
                       </a:endParaRPr>
                     </a:p>
                   </a:txBody>
-                  <a:tcPr anchor="ctr">
+                  <a:tcPr marL="91440" marR="91440" marT="45720" marB="45720" anchor="ctr">
                     <a:lnL w="6350" cap="flat" cmpd="sng" algn="ctr">
                       <a:solidFill>
                         <a:srgbClr val="1E5FC2"/>
@@ -16461,7 +16406,7 @@
                     <a:bodyPr/>
                     <a:lstStyle/>
                     <a:p>
-                      <a:pPr marL="0" indent="0" algn="ctr">
+                      <a:pPr algn="ctr" indent="0" marL="0">
                         <a:buNone/>
                       </a:pPr>
                       <a:r>
@@ -16482,7 +16427,7 @@
                       </a:endParaRPr>
                     </a:p>
                   </a:txBody>
-                  <a:tcPr anchor="ctr">
+                  <a:tcPr marL="91440" marR="91440" marT="45720" marB="45720" anchor="ctr">
                     <a:lnL w="6350" cap="flat" cmpd="sng" algn="ctr">
                       <a:solidFill>
                         <a:srgbClr val="1E5FC2"/>
@@ -16526,7 +16471,7 @@
                     <a:bodyPr/>
                     <a:lstStyle/>
                     <a:p>
-                      <a:pPr marL="0" indent="0" algn="ctr">
+                      <a:pPr algn="ctr" indent="0" marL="0">
                         <a:buNone/>
                       </a:pPr>
                       <a:r>
@@ -16547,7 +16492,7 @@
                       </a:endParaRPr>
                     </a:p>
                   </a:txBody>
-                  <a:tcPr anchor="ctr">
+                  <a:tcPr marL="91440" marR="91440" marT="45720" marB="45720" anchor="ctr">
                     <a:lnL w="6350" cap="flat" cmpd="sng" algn="ctr">
                       <a:solidFill>
                         <a:srgbClr val="1E5FC2"/>
@@ -16586,11 +16531,6 @@
                     </a:lnB>
                   </a:tcPr>
                 </a:tc>
-                <a:extLst>
-                  <a:ext uri="{0D108BD9-81ED-4DB2-BD59-A6C34878D82A}">
-                    <a16:rowId xmlns:a16="http://schemas.microsoft.com/office/drawing/2014/main" val="10004"/>
-                  </a:ext>
-                </a:extLst>
               </a:tr>
             </a:tbl>
           </a:graphicData>
@@ -16643,7 +16583,7 @@
       </p:sp>
       <p:sp>
         <p:nvSpPr>
-          <p:cNvPr id="7" name="Text 7"/>
+          <p:cNvPr id="10" name="Text 7"/>
           <p:cNvSpPr/>
           <p:nvPr/>
         </p:nvSpPr>
@@ -16664,7 +16604,7 @@
           </a:bodyPr>
           <a:lstStyle/>
           <a:p>
-            <a:pPr marL="0" indent="0">
+            <a:pPr indent="0" marL="0">
               <a:buNone/>
             </a:pPr>
             <a:r>
@@ -16705,7 +16645,7 @@
           </a:bodyPr>
           <a:lstStyle/>
           <a:p>
-            <a:pPr marL="0" indent="0">
+            <a:pPr indent="0" marL="0">
               <a:spcAft>
                 <a:spcPts val="300"/>
               </a:spcAft>
@@ -16725,7 +16665,7 @@
             <a:endParaRPr lang="en-US" sz="1300" dirty="0"/>
           </a:p>
           <a:p>
-            <a:pPr marL="0" indent="0">
+            <a:pPr indent="0" marL="0">
               <a:spcAft>
                 <a:spcPts val="300"/>
               </a:spcAft>
@@ -16769,7 +16709,7 @@
           </a:bodyPr>
           <a:lstStyle/>
           <a:p>
-            <a:pPr marL="0" indent="0">
+            <a:pPr indent="0" marL="0">
               <a:buNone/>
             </a:pPr>
             <a:r>
@@ -17088,319 +17028,4 @@
     </a:ext>
   </a:extLst>
 </a:theme>
-</file>
-
-<file path=ppt/theme/theme2.xml><?xml version="1.0" encoding="utf-8"?>
-<a:theme xmlns:a="http://schemas.openxmlformats.org/drawingml/2006/main" name="Office Theme">
-  <a:themeElements>
-    <a:clrScheme name="Office">
-      <a:dk1>
-        <a:sysClr val="windowText" lastClr="000000"/>
-      </a:dk1>
-      <a:lt1>
-        <a:sysClr val="window" lastClr="FFFFFF"/>
-      </a:lt1>
-      <a:dk2>
-        <a:srgbClr val="0E2841"/>
-      </a:dk2>
-      <a:lt2>
-        <a:srgbClr val="E8E8E8"/>
-      </a:lt2>
-      <a:accent1>
-        <a:srgbClr val="156082"/>
-      </a:accent1>
-      <a:accent2>
-        <a:srgbClr val="E97132"/>
-      </a:accent2>
-      <a:accent3>
-        <a:srgbClr val="196B24"/>
-      </a:accent3>
-      <a:accent4>
-        <a:srgbClr val="0F9ED5"/>
-      </a:accent4>
-      <a:accent5>
-        <a:srgbClr val="A02B93"/>
-      </a:accent5>
-      <a:accent6>
-        <a:srgbClr val="4EA72E"/>
-      </a:accent6>
-      <a:hlink>
-        <a:srgbClr val="467886"/>
-      </a:hlink>
-      <a:folHlink>
-        <a:srgbClr val="96607D"/>
-      </a:folHlink>
-    </a:clrScheme>
-    <a:fontScheme name="Office">
-      <a:majorFont>
-        <a:latin typeface="Aptos Display" panose="02110004020202020204"/>
-        <a:ea typeface=""/>
-        <a:cs typeface=""/>
-        <a:font script="Jpan" typeface="游ゴシック Light"/>
-        <a:font script="Hang" typeface="맑은 고딕"/>
-        <a:font script="Hans" typeface="等线 Light"/>
-        <a:font script="Hant" typeface="新細明體"/>
-        <a:font script="Arab" typeface="Times New Roman"/>
-        <a:font script="Hebr" typeface="Times New Roman"/>
-        <a:font script="Thai" typeface="Angsana New"/>
-        <a:font script="Ethi" typeface="Nyala"/>
-        <a:font script="Beng" typeface="Vrinda"/>
-        <a:font script="Gujr" typeface="Shruti"/>
-        <a:font script="Khmr" typeface="MoolBoran"/>
-        <a:font script="Knda" typeface="Tunga"/>
-        <a:font script="Guru" typeface="Raavi"/>
-        <a:font script="Cans" typeface="Euphemia"/>
-        <a:font script="Cher" typeface="Plantagenet Cherokee"/>
-        <a:font script="Yiii" typeface="Microsoft Yi Baiti"/>
-        <a:font script="Tibt" typeface="Microsoft Himalaya"/>
-        <a:font script="Thaa" typeface="MV Boli"/>
-        <a:font script="Deva" typeface="Mangal"/>
-        <a:font script="Telu" typeface="Gautami"/>
-        <a:font script="Taml" typeface="Latha"/>
-        <a:font script="Syrc" typeface="Estrangelo Edessa"/>
-        <a:font script="Orya" typeface="Kalinga"/>
-        <a:font script="Mlym" typeface="Kartika"/>
-        <a:font script="Laoo" typeface="DokChampa"/>
-        <a:font script="Sinh" typeface="Iskoola Pota"/>
-        <a:font script="Mong" typeface="Mongolian Baiti"/>
-        <a:font script="Viet" typeface="Times New Roman"/>
-        <a:font script="Uigh" typeface="Microsoft Uighur"/>
-        <a:font script="Geor" typeface="Sylfaen"/>
-        <a:font script="Armn" typeface="Arial"/>
-        <a:font script="Bugi" typeface="Leelawadee UI"/>
-        <a:font script="Bopo" typeface="Microsoft JhengHei"/>
-        <a:font script="Java" typeface="Javanese Text"/>
-        <a:font script="Lisu" typeface="Segoe UI"/>
-        <a:font script="Mymr" typeface="Myanmar Text"/>
-        <a:font script="Nkoo" typeface="Ebrima"/>
-        <a:font script="Olck" typeface="Nirmala UI"/>
-        <a:font script="Osma" typeface="Ebrima"/>
-        <a:font script="Phag" typeface="Phagspa"/>
-        <a:font script="Syrn" typeface="Estrangelo Edessa"/>
-        <a:font script="Syrj" typeface="Estrangelo Edessa"/>
-        <a:font script="Syre" typeface="Estrangelo Edessa"/>
-        <a:font script="Sora" typeface="Nirmala UI"/>
-        <a:font script="Tale" typeface="Microsoft Tai Le"/>
-        <a:font script="Talu" typeface="Microsoft New Tai Lue"/>
-        <a:font script="Tfng" typeface="Ebrima"/>
-      </a:majorFont>
-      <a:minorFont>
-        <a:latin typeface="Aptos" panose="02110004020202020204"/>
-        <a:ea typeface=""/>
-        <a:cs typeface=""/>
-        <a:font script="Jpan" typeface="游ゴシック"/>
-        <a:font script="Hang" typeface="맑은 고딕"/>
-        <a:font script="Hans" typeface="等线"/>
-        <a:font script="Hant" typeface="新細明體"/>
-        <a:font script="Arab" typeface="Arial"/>
-        <a:font script="Hebr" typeface="Arial"/>
-        <a:font script="Thai" typeface="Cordia New"/>
-        <a:font script="Ethi" typeface="Nyala"/>
-        <a:font script="Beng" typeface="Vrinda"/>
-        <a:font script="Gujr" typeface="Shruti"/>
-        <a:font script="Khmr" typeface="DaunPenh"/>
-        <a:font script="Knda" typeface="Tunga"/>
-        <a:font script="Guru" typeface="Raavi"/>
-        <a:font script="Cans" typeface="Euphemia"/>
-        <a:font script="Cher" typeface="Plantagenet Cherokee"/>
-        <a:font script="Yiii" typeface="Microsoft Yi Baiti"/>
-        <a:font script="Tibt" typeface="Microsoft Himalaya"/>
-        <a:font script="Thaa" typeface="MV Boli"/>
-        <a:font script="Deva" typeface="Mangal"/>
-        <a:font script="Telu" typeface="Gautami"/>
-        <a:font script="Taml" typeface="Latha"/>
-        <a:font script="Syrc" typeface="Estrangelo Edessa"/>
-        <a:font script="Orya" typeface="Kalinga"/>
-        <a:font script="Mlym" typeface="Kartika"/>
-        <a:font script="Laoo" typeface="DokChampa"/>
-        <a:font script="Sinh" typeface="Iskoola Pota"/>
-        <a:font script="Mong" typeface="Mongolian Baiti"/>
-        <a:font script="Viet" typeface="Arial"/>
-        <a:font script="Uigh" typeface="Microsoft Uighur"/>
-        <a:font script="Geor" typeface="Sylfaen"/>
-        <a:font script="Armn" typeface="Arial"/>
-        <a:font script="Bugi" typeface="Leelawadee UI"/>
-        <a:font script="Bopo" typeface="Microsoft JhengHei"/>
-        <a:font script="Java" typeface="Javanese Text"/>
-        <a:font script="Lisu" typeface="Segoe UI"/>
-        <a:font script="Mymr" typeface="Myanmar Text"/>
-        <a:font script="Nkoo" typeface="Ebrima"/>
-        <a:font script="Olck" typeface="Nirmala UI"/>
-        <a:font script="Osma" typeface="Ebrima"/>
-        <a:font script="Phag" typeface="Phagspa"/>
-        <a:font script="Syrn" typeface="Estrangelo Edessa"/>
-        <a:font script="Syrj" typeface="Estrangelo Edessa"/>
-        <a:font script="Syre" typeface="Estrangelo Edessa"/>
-        <a:font script="Sora" typeface="Nirmala UI"/>
-        <a:font script="Tale" typeface="Microsoft Tai Le"/>
-        <a:font script="Talu" typeface="Microsoft New Tai Lue"/>
-        <a:font script="Tfng" typeface="Ebrima"/>
-      </a:minorFont>
-    </a:fontScheme>
-    <a:fmtScheme name="Office">
-      <a:fillStyleLst>
-        <a:solidFill>
-          <a:schemeClr val="phClr"/>
-        </a:solidFill>
-        <a:gradFill rotWithShape="1">
-          <a:gsLst>
-            <a:gs pos="0">
-              <a:schemeClr val="phClr">
-                <a:lumMod val="110000"/>
-                <a:satMod val="105000"/>
-                <a:tint val="67000"/>
-              </a:schemeClr>
-            </a:gs>
-            <a:gs pos="50000">
-              <a:schemeClr val="phClr">
-                <a:lumMod val="105000"/>
-                <a:satMod val="103000"/>
-                <a:tint val="73000"/>
-              </a:schemeClr>
-            </a:gs>
-            <a:gs pos="100000">
-              <a:schemeClr val="phClr">
-                <a:lumMod val="105000"/>
-                <a:satMod val="109000"/>
-                <a:tint val="81000"/>
-              </a:schemeClr>
-            </a:gs>
-          </a:gsLst>
-          <a:lin ang="5400000" scaled="0"/>
-        </a:gradFill>
-        <a:gradFill rotWithShape="1">
-          <a:gsLst>
-            <a:gs pos="0">
-              <a:schemeClr val="phClr">
-                <a:satMod val="103000"/>
-                <a:lumMod val="102000"/>
-                <a:tint val="94000"/>
-              </a:schemeClr>
-            </a:gs>
-            <a:gs pos="50000">
-              <a:schemeClr val="phClr">
-                <a:satMod val="110000"/>
-                <a:lumMod val="100000"/>
-                <a:shade val="100000"/>
-              </a:schemeClr>
-            </a:gs>
-            <a:gs pos="100000">
-              <a:schemeClr val="phClr">
-                <a:lumMod val="99000"/>
-                <a:satMod val="120000"/>
-                <a:shade val="78000"/>
-              </a:schemeClr>
-            </a:gs>
-          </a:gsLst>
-          <a:lin ang="5400000" scaled="0"/>
-        </a:gradFill>
-      </a:fillStyleLst>
-      <a:lnStyleLst>
-        <a:ln w="12700" cap="flat" cmpd="sng" algn="ctr">
-          <a:solidFill>
-            <a:schemeClr val="phClr"/>
-          </a:solidFill>
-          <a:prstDash val="solid"/>
-          <a:miter lim="800000"/>
-        </a:ln>
-        <a:ln w="19050" cap="flat" cmpd="sng" algn="ctr">
-          <a:solidFill>
-            <a:schemeClr val="phClr"/>
-          </a:solidFill>
-          <a:prstDash val="solid"/>
-          <a:miter lim="800000"/>
-        </a:ln>
-        <a:ln w="25400" cap="flat" cmpd="sng" algn="ctr">
-          <a:solidFill>
-            <a:schemeClr val="phClr"/>
-          </a:solidFill>
-          <a:prstDash val="solid"/>
-          <a:miter lim="800000"/>
-        </a:ln>
-      </a:lnStyleLst>
-      <a:effectStyleLst>
-        <a:effectStyle>
-          <a:effectLst/>
-        </a:effectStyle>
-        <a:effectStyle>
-          <a:effectLst/>
-        </a:effectStyle>
-        <a:effectStyle>
-          <a:effectLst>
-            <a:outerShdw blurRad="57150" dist="19050" dir="5400000" algn="ctr" rotWithShape="0">
-              <a:srgbClr val="000000">
-                <a:alpha val="63000"/>
-              </a:srgbClr>
-            </a:outerShdw>
-          </a:effectLst>
-        </a:effectStyle>
-      </a:effectStyleLst>
-      <a:bgFillStyleLst>
-        <a:solidFill>
-          <a:schemeClr val="phClr"/>
-        </a:solidFill>
-        <a:solidFill>
-          <a:schemeClr val="phClr">
-            <a:tint val="95000"/>
-            <a:satMod val="170000"/>
-          </a:schemeClr>
-        </a:solidFill>
-        <a:gradFill rotWithShape="1">
-          <a:gsLst>
-            <a:gs pos="0">
-              <a:schemeClr val="phClr">
-                <a:tint val="93000"/>
-                <a:satMod val="150000"/>
-                <a:shade val="98000"/>
-                <a:lumMod val="102000"/>
-              </a:schemeClr>
-            </a:gs>
-            <a:gs pos="50000">
-              <a:schemeClr val="phClr">
-                <a:tint val="98000"/>
-                <a:satMod val="130000"/>
-                <a:shade val="90000"/>
-                <a:lumMod val="103000"/>
-              </a:schemeClr>
-            </a:gs>
-            <a:gs pos="100000">
-              <a:schemeClr val="phClr">
-                <a:shade val="63000"/>
-                <a:satMod val="120000"/>
-              </a:schemeClr>
-            </a:gs>
-          </a:gsLst>
-          <a:lin ang="5400000" scaled="0"/>
-        </a:gradFill>
-      </a:bgFillStyleLst>
-    </a:fmtScheme>
-  </a:themeElements>
-  <a:objectDefaults>
-    <a:lnDef>
-      <a:spPr/>
-      <a:bodyPr/>
-      <a:lstStyle/>
-      <a:style>
-        <a:lnRef idx="2">
-          <a:schemeClr val="accent1"/>
-        </a:lnRef>
-        <a:fillRef idx="0">
-          <a:schemeClr val="accent1"/>
-        </a:fillRef>
-        <a:effectRef idx="1">
-          <a:schemeClr val="accent1"/>
-        </a:effectRef>
-        <a:fontRef idx="minor">
-          <a:schemeClr val="tx1"/>
-        </a:fontRef>
-      </a:style>
-    </a:lnDef>
-  </a:objectDefaults>
-  <a:extraClrSchemeLst/>
-  <a:extLst>
-    <a:ext uri="{05A4C25C-085E-4340-85A3-A5531E510DB2}">
-      <thm15:themeFamily xmlns:thm15="http://schemas.microsoft.com/office/thememl/2012/main" name="Office Theme" id="{2E142A2C-CD16-42D6-873A-C26D2A0506FA}" vid="{1BDDFF52-6CD6-40A5-AB3C-68EB2F1E4D0A}"/>
-    </a:ext>
-  </a:extLst>
-</a:theme>
 </file>
</xml_diff>

<commit_message>
feat(phase09): add lifecycle two-column references slide with verified sources
Apply Thanh's directive 4 on the references slide:
- Slide 17 lists 15 verified sources in two columns ordered by the project
  lifecycle (data -> NLP preprocessing -> ML algorithms -> XAI -> web
  accessibility -> future work), numbered [1]-[15].
- Platt is cited as the published chapter (MIT Press, 2000, pp. 61-74);
  XGBoost, scikit-learn and PhoBERT gain page numbers.
- In-text citations renumbered on slides 6, 8, 10, 12, 14 and 16, so every
  reference on slide 17 is cited at least once; slide 14 states the demo text
  contrast of 14.6:1 against WCAG 2.1 AA.
- Agenda slide: presenter lines removed, ported from the manual PowerPoint
  edit so regenerating the deck keeps it.
- generate_slides.js accepts PPTX_OUT to build elsewhere without overwriting a
  deck being edited by hand.
- Regenerate phase09_presentation.pptx (22 slides).
</commit_message>
<xml_diff>
--- a/draft/scam-detection/reports/slides/phase09_presentation.pptx
+++ b/draft/scam-detection/reports/slides/phase09_presentation.pptx
@@ -1257,9 +1257,11 @@
             <a:r>
               <a:rPr lang="en-US" dirty="0"/>
               <a:t>SLIDE 17 — THAM KHẢO
-- [1] XGBoost, [2] hiệu chỉnh xác suất SVM (CalibratedClassifierCV), [3] PhoBERT (hướng phát triển), [4] bộ dữ liệu SMS chính, [5] scikit-learn, [6] các nguồn dữ liệu bổ sung
-- Q&amp;A về [4]: trích đúng theo yêu cầu của tác giả bộ dữ liệu trong README (bài IEEE Access 2026); nhóm không khẳng định bài đã xuất bản (chưa có tập/DOI). Điều nhóm dùng và kiểm chứng được là bộ dữ liệu công khai trên GitHub, mỗi mẫu có URL truy vết trong dataset.csv
-- 1.944/2.193 mẫu (88.7%) đến từ repo [4]; 249 mẫu lừa đảo còn lại từ nguồn [6]
+- Thứ tự theo vòng đời dự án: nguồn dữ liệu [1]–[2] → tiền xử lý NLP [3]–[6] → thuật toán học máy [7]–[11] → XAI [12]–[13] → trợ năng web [14] → hướng phát triển [15]
+- Q&amp;A về [1]: trích đúng theo yêu cầu của tác giả bộ dữ liệu trong README (bài IEEE Access 2026); nhóm không khẳng định bài đã xuất bản (chưa có tập/DOI). Điều nhóm dùng và kiểm chứng được là bộ dữ liệu công khai trên GitHub (CC BY 4.0), mỗi mẫu có URL truy vết trong dataset.csv
+- 1.944/2.193 mẫu (88.7%) đến từ repo [1]; 249 mẫu lừa đảo còn lại từ nguồn [2]
+- [10] Platt: trích theo bản đã xuất bản (MIT Press, 2000, pp. 61–74); bản thảo năm 1999 mang tên dài 'Probabilistic Outputs for Support Vector Machines and Comparisons to Regularized Likelihood Methods'
+- Chỉ 15/18 tài liệu lên slide; LIBLINEAR (LinearSVC), McCallum &amp; Nigam (Naive Bayes) và Streamlit nằm trong báo cáo Word. Bằng chứng kiểm chứng: reports/research-cam-phase09-references-lifecycle.md
 - Q&amp;A đạo đức/PII: khử PII 100%; dữ liệu lừa đảo lấy từ nguồn công khai (407/420 mẫu từ các bộ dữ liệu GitHub, 13/420 từ báo chí và video điều tra), mọi mẫu có source_url</a:t>
             </a:r>
             <a:endParaRPr lang="en-US" dirty="0"/>
@@ -5484,7 +5486,7 @@
                 <a:ea typeface="Calibri" pitchFamily="34" charset="-122"/>
                 <a:cs typeface="Calibri" pitchFamily="34" charset="-120"/>
               </a:rPr>
-              <a:t>Nguồn: models/*_metrics.json · tập test 439 mẫu (355 bình thường, 84 lừa đảo) · XGBoost [1], SVM hiệu chỉnh xác suất [2], scikit-learn [5]</a:t>
+              <a:t>Nguồn: models/*_metrics.json · tập test 439 mẫu (355 bình thường, 84 lừa đảo) · XGBoost [7], Random Forest [8], SVM [9] hiệu chỉnh xác suất [10], scikit-learn [11]</a:t>
             </a:r>
             <a:endParaRPr lang="en-US" sz="1000" dirty="0"/>
           </a:p>
@@ -6313,7 +6315,7 @@
                 <a:ea typeface="Calibri" pitchFamily="34" charset="-122"/>
                 <a:cs typeface="Calibri" pitchFamily="34" charset="-120"/>
               </a:rPr>
-              <a:t>SHAP TreeExplainer trên XGBoost — không phải “hộp đen”</a:t>
+              <a:t>SHAP TreeExplainer trên XGBoost [12], [13] — không phải “hộp đen”</a:t>
             </a:r>
             <a:endParaRPr lang="en-US" sz="1400" dirty="0"/>
           </a:p>
@@ -7066,6 +7068,27 @@
                 <a:ea typeface="Calibri" pitchFamily="34" charset="-122"/>
                 <a:cs typeface="Calibri" pitchFamily="34" charset="-120"/>
               </a:rPr>
+              <a:t>Tương phản chữ 14.6:1, vượt mức WCAG 2.1 AA (4.5:1) [14]</a:t>
+            </a:r>
+            <a:endParaRPr lang="en-US" sz="1400" dirty="0"/>
+          </a:p>
+          <a:p>
+            <a:pPr marL="177800" indent="-177800">
+              <a:spcAft>
+                <a:spcPts val="800"/>
+              </a:spcAft>
+              <a:buSzPct val="100000"/>
+              <a:buChar char="•"/>
+            </a:pPr>
+            <a:r>
+              <a:rPr lang="en-US" sz="1400" dirty="0">
+                <a:solidFill>
+                  <a:srgbClr val="1F2937"/>
+                </a:solidFill>
+                <a:latin typeface="Calibri" pitchFamily="34" charset="0"/>
+                <a:ea typeface="Calibri" pitchFamily="34" charset="-122"/>
+                <a:cs typeface="Calibri" pitchFamily="34" charset="-120"/>
+              </a:rPr>
               <a:t>Hotline khẩn cấp 156 / 113 gọi 1 chạm</a:t>
             </a:r>
             <a:endParaRPr lang="en-US" sz="1400" dirty="0"/>
@@ -7970,7 +7993,7 @@
                 <a:ea typeface="Calibri" pitchFamily="34" charset="-122"/>
                 <a:cs typeface="Calibri" pitchFamily="34" charset="-120"/>
               </a:rPr>
-              <a:t>Tích hợp PhoBERT (BERT tiếng Việt) [3]</a:t>
+              <a:t>Tích hợp PhoBERT (BERT tiếng Việt) [15]</a:t>
             </a:r>
             <a:endParaRPr lang="en-US" sz="1500" dirty="0"/>
           </a:p>
@@ -8440,8 +8463,8 @@
         </p:nvSpPr>
         <p:spPr>
           <a:xfrm>
-            <a:off x="457200" y="1143000"/>
-            <a:ext cx="8229600" cy="3497580"/>
+            <a:off x="457200" y="1051560"/>
+            <a:ext cx="4023360" cy="3383280"/>
           </a:xfrm>
           <a:prstGeom prst="rect">
             <a:avLst/>
@@ -8450,17 +8473,63 @@
           <a:ln/>
         </p:spPr>
         <p:txBody>
-          <a:bodyPr wrap="square" lIns="25400" tIns="0" rIns="0" bIns="25400" rtlCol="0" anchor="ctr"/>
+          <a:bodyPr wrap="square" lIns="0" tIns="0" rIns="0" bIns="0" rtlCol="0" anchor="t"/>
           <a:lstStyle/>
           <a:p>
             <a:pPr indent="0" marL="0">
+              <a:lnSpc>
+                <a:spcPct val="95000"/>
+              </a:lnSpc>
               <a:spcAft>
-                <a:spcPts val="900"/>
+                <a:spcPts val="200"/>
               </a:spcAft>
               <a:buNone/>
             </a:pPr>
             <a:r>
-              <a:rPr lang="en-US" sz="1300" dirty="0">
+              <a:rPr lang="en-US" sz="1050" b="1" dirty="0">
+                <a:solidFill>
+                  <a:srgbClr val="1E40AF"/>
+                </a:solidFill>
+                <a:latin typeface="Calibri" pitchFamily="34" charset="0"/>
+                <a:ea typeface="Calibri" pitchFamily="34" charset="-122"/>
+                <a:cs typeface="Calibri" pitchFamily="34" charset="-120"/>
+              </a:rPr>
+              <a:t>NGUỒN DỮ LIỆU</a:t>
+            </a:r>
+            <a:endParaRPr lang="en-US" sz="1050" dirty="0"/>
+          </a:p>
+          <a:p>
+            <a:pPr indent="0" marL="0">
+              <a:lnSpc>
+                <a:spcPct val="95000"/>
+              </a:lnSpc>
+              <a:spcAft>
+                <a:spcPts val="250"/>
+              </a:spcAft>
+              <a:buNone/>
+            </a:pPr>
+            <a:r>
+              <a:rPr lang="en-US" sz="1000" b="1" dirty="0">
+                <a:solidFill>
+                  <a:srgbClr val="1E40AF"/>
+                </a:solidFill>
+                <a:latin typeface="Calibri" pitchFamily="34" charset="0"/>
+                <a:ea typeface="Calibri" pitchFamily="34" charset="-122"/>
+                <a:cs typeface="Calibri" pitchFamily="34" charset="-120"/>
+              </a:rPr>
+              <a:t>[1] </a:t>
+            </a:r>
+            <a:pPr indent="0" marL="0">
+              <a:lnSpc>
+                <a:spcPct val="95000"/>
+              </a:lnSpc>
+              <a:spcAft>
+                <a:spcPts val="250"/>
+              </a:spcAft>
+              <a:buNone/>
+            </a:pPr>
+            <a:r>
+              <a:rPr lang="en-US" sz="1000" dirty="0">
                 <a:solidFill>
                   <a:srgbClr val="1F2937"/>
                 </a:solidFill>
@@ -8468,19 +8537,42 @@
                 <a:ea typeface="Calibri" pitchFamily="34" charset="-122"/>
                 <a:cs typeface="Calibri" pitchFamily="34" charset="-120"/>
               </a:rPr>
-              <a:t>[1] T. Chen &amp; C. Guestrin, “XGBoost: A Scalable Tree Boosting System,” KDD 2016.</a:t>
-            </a:r>
-            <a:endParaRPr lang="en-US" sz="1300" dirty="0"/>
+              <a:t>N. T. T. Tran et al., “Vietnamese SMS Dataset with Quality Assurance,” IEEE Access, 2026 (theo trích dẫn của tác giả; chưa có tập/DOI). GitHub: trannguyenthaituan251209/vietnamese_sms_dataset.</a:t>
+            </a:r>
+            <a:endParaRPr lang="en-US" sz="1050" dirty="0"/>
           </a:p>
           <a:p>
             <a:pPr indent="0" marL="0">
+              <a:lnSpc>
+                <a:spcPct val="95000"/>
+              </a:lnSpc>
               <a:spcAft>
-                <a:spcPts val="900"/>
+                <a:spcPts val="250"/>
               </a:spcAft>
               <a:buNone/>
             </a:pPr>
             <a:r>
-              <a:rPr lang="en-US" sz="1300" dirty="0">
+              <a:rPr lang="en-US" sz="1000" b="1" dirty="0">
+                <a:solidFill>
+                  <a:srgbClr val="1E40AF"/>
+                </a:solidFill>
+                <a:latin typeface="Calibri" pitchFamily="34" charset="0"/>
+                <a:ea typeface="Calibri" pitchFamily="34" charset="-122"/>
+                <a:cs typeface="Calibri" pitchFamily="34" charset="-120"/>
+              </a:rPr>
+              <a:t>[2] </a:t>
+            </a:r>
+            <a:pPr indent="0" marL="0">
+              <a:lnSpc>
+                <a:spcPct val="95000"/>
+              </a:lnSpc>
+              <a:spcAft>
+                <a:spcPts val="250"/>
+              </a:spcAft>
+              <a:buNone/>
+            </a:pPr>
+            <a:r>
+              <a:rPr lang="en-US" sz="1000" dirty="0">
                 <a:solidFill>
                   <a:srgbClr val="1F2937"/>
                 </a:solidFill>
@@ -8488,19 +8580,68 @@
                 <a:ea typeface="Calibri" pitchFamily="34" charset="-122"/>
                 <a:cs typeface="Calibri" pitchFamily="34" charset="-120"/>
               </a:rPr>
-              <a:t>[2] J. Platt, “Probabilistic Outputs for Support Vector Machines and Comparisons to Regularized Likelihood Methods,” Advances in Large Margin Classifiers, 1999.</a:t>
-            </a:r>
-            <a:endParaRPr lang="en-US" sz="1300" dirty="0"/>
+              <a:t>Nguồn bổ sung của tập lừa đảo (249/420 mẫu): GitHub ghitatruongle/lachancuocgoi, duynguyenhoang22/SMS_Phishing_Detection và ViSmish_Detection; báo chí, VTV24 (13 mẫu).</a:t>
+            </a:r>
+            <a:endParaRPr lang="en-US" sz="1050" dirty="0"/>
           </a:p>
           <a:p>
             <a:pPr indent="0" marL="0">
+              <a:lnSpc>
+                <a:spcPct val="95000"/>
+              </a:lnSpc>
+              <a:spcBef>
+                <a:spcPts val="500"/>
+              </a:spcBef>
               <a:spcAft>
-                <a:spcPts val="900"/>
+                <a:spcPts val="200"/>
               </a:spcAft>
               <a:buNone/>
             </a:pPr>
             <a:r>
-              <a:rPr lang="en-US" sz="1300" dirty="0">
+              <a:rPr lang="en-US" sz="1050" b="1" dirty="0">
+                <a:solidFill>
+                  <a:srgbClr val="1E40AF"/>
+                </a:solidFill>
+                <a:latin typeface="Calibri" pitchFamily="34" charset="0"/>
+                <a:ea typeface="Calibri" pitchFamily="34" charset="-122"/>
+                <a:cs typeface="Calibri" pitchFamily="34" charset="-120"/>
+              </a:rPr>
+              <a:t>TIỀN XỬ LÝ NLP</a:t>
+            </a:r>
+            <a:endParaRPr lang="en-US" sz="1050" dirty="0"/>
+          </a:p>
+          <a:p>
+            <a:pPr indent="0" marL="0">
+              <a:lnSpc>
+                <a:spcPct val="95000"/>
+              </a:lnSpc>
+              <a:spcAft>
+                <a:spcPts val="250"/>
+              </a:spcAft>
+              <a:buNone/>
+            </a:pPr>
+            <a:r>
+              <a:rPr lang="en-US" sz="1000" b="1" dirty="0">
+                <a:solidFill>
+                  <a:srgbClr val="1E40AF"/>
+                </a:solidFill>
+                <a:latin typeface="Calibri" pitchFamily="34" charset="0"/>
+                <a:ea typeface="Calibri" pitchFamily="34" charset="-122"/>
+                <a:cs typeface="Calibri" pitchFamily="34" charset="-120"/>
+              </a:rPr>
+              <a:t>[3] </a:t>
+            </a:r>
+            <a:pPr indent="0" marL="0">
+              <a:lnSpc>
+                <a:spcPct val="95000"/>
+              </a:lnSpc>
+              <a:spcAft>
+                <a:spcPts val="250"/>
+              </a:spcAft>
+              <a:buNone/>
+            </a:pPr>
+            <a:r>
+              <a:rPr lang="en-US" sz="1000" dirty="0">
                 <a:solidFill>
                   <a:srgbClr val="1F2937"/>
                 </a:solidFill>
@@ -8508,19 +8649,42 @@
                 <a:ea typeface="Calibri" pitchFamily="34" charset="-122"/>
                 <a:cs typeface="Calibri" pitchFamily="34" charset="-120"/>
               </a:rPr>
-              <a:t>[3] D. Q. Nguyen &amp; A. T. Nguyen, “PhoBERT: Pre-trained Language Models for Vietnamese,” Findings of EMNLP 2020.</a:t>
-            </a:r>
-            <a:endParaRPr lang="en-US" sz="1300" dirty="0"/>
+              <a:t>Unicode Consortium, “UAX #15: Unicode Normalization Forms,” Unicode 18.0.0, 12 Aug. 2026.</a:t>
+            </a:r>
+            <a:endParaRPr lang="en-US" sz="1050" dirty="0"/>
           </a:p>
           <a:p>
             <a:pPr indent="0" marL="0">
+              <a:lnSpc>
+                <a:spcPct val="95000"/>
+              </a:lnSpc>
               <a:spcAft>
-                <a:spcPts val="900"/>
+                <a:spcPts val="250"/>
               </a:spcAft>
               <a:buNone/>
             </a:pPr>
             <a:r>
-              <a:rPr lang="en-US" sz="1300" dirty="0">
+              <a:rPr lang="en-US" sz="1000" b="1" dirty="0">
+                <a:solidFill>
+                  <a:srgbClr val="1E40AF"/>
+                </a:solidFill>
+                <a:latin typeface="Calibri" pitchFamily="34" charset="0"/>
+                <a:ea typeface="Calibri" pitchFamily="34" charset="-122"/>
+                <a:cs typeface="Calibri" pitchFamily="34" charset="-120"/>
+              </a:rPr>
+              <a:t>[4] </a:t>
+            </a:r>
+            <a:pPr indent="0" marL="0">
+              <a:lnSpc>
+                <a:spcPct val="95000"/>
+              </a:lnSpc>
+              <a:spcAft>
+                <a:spcPts val="250"/>
+              </a:spcAft>
+              <a:buNone/>
+            </a:pPr>
+            <a:r>
+              <a:rPr lang="en-US" sz="1000" dirty="0">
                 <a:solidFill>
                   <a:srgbClr val="1F2937"/>
                 </a:solidFill>
@@ -8528,19 +8692,42 @@
                 <a:ea typeface="Calibri" pitchFamily="34" charset="-122"/>
                 <a:cs typeface="Calibri" pitchFamily="34" charset="-120"/>
               </a:rPr>
-              <a:t>[4] N. T. T. Tran, H. K. Le, M. T. Nguyen, V. T. Nguyen, and H. D. Mai, “Vietnamese SMS Dataset with Quality Assurance,” IEEE Access, 2026 (theo trích dẫn của tác giả trong README bộ dữ liệu; chưa có tập/DOI). GitHub: trannguyenthaituan251209/vietnamese_sms_dataset (1.944 mẫu: 1.773 bình thường + 171 lừa đảo; giấy phép CC BY 4.0 theo README; truy cập 21/09/2026).</a:t>
-            </a:r>
-            <a:endParaRPr lang="en-US" sz="1300" dirty="0"/>
+              <a:t>V.-T. Tran, “PyVi: Python Vietnamese Toolkit,” v0.1.1. GitHub: trungtv/pyvi.</a:t>
+            </a:r>
+            <a:endParaRPr lang="en-US" sz="1050" dirty="0"/>
           </a:p>
           <a:p>
             <a:pPr indent="0" marL="0">
+              <a:lnSpc>
+                <a:spcPct val="95000"/>
+              </a:lnSpc>
               <a:spcAft>
-                <a:spcPts val="900"/>
+                <a:spcPts val="250"/>
               </a:spcAft>
               <a:buNone/>
             </a:pPr>
             <a:r>
-              <a:rPr lang="en-US" sz="1300" dirty="0">
+              <a:rPr lang="en-US" sz="1000" b="1" dirty="0">
+                <a:solidFill>
+                  <a:srgbClr val="1E40AF"/>
+                </a:solidFill>
+                <a:latin typeface="Calibri" pitchFamily="34" charset="0"/>
+                <a:ea typeface="Calibri" pitchFamily="34" charset="-122"/>
+                <a:cs typeface="Calibri" pitchFamily="34" charset="-120"/>
+              </a:rPr>
+              <a:t>[5] </a:t>
+            </a:r>
+            <a:pPr indent="0" marL="0">
+              <a:lnSpc>
+                <a:spcPct val="95000"/>
+              </a:lnSpc>
+              <a:spcAft>
+                <a:spcPts val="250"/>
+              </a:spcAft>
+              <a:buNone/>
+            </a:pPr>
+            <a:r>
+              <a:rPr lang="en-US" sz="1000" dirty="0">
                 <a:solidFill>
                   <a:srgbClr val="1F2937"/>
                 </a:solidFill>
@@ -8548,19 +8735,42 @@
                 <a:ea typeface="Calibri" pitchFamily="34" charset="-122"/>
                 <a:cs typeface="Calibri" pitchFamily="34" charset="-120"/>
               </a:rPr>
-              <a:t>[5] F. Pedregosa et al., “Scikit-learn: Machine Learning in Python,” JMLR vol. 12, 2011.</a:t>
-            </a:r>
-            <a:endParaRPr lang="en-US" sz="1300" dirty="0"/>
+              <a:t>Underthesea NLP, “underthesea: Vietnamese NLP Toolkit,” v9.5.0. GitHub: undertheseanlp/underthesea.</a:t>
+            </a:r>
+            <a:endParaRPr lang="en-US" sz="1050" dirty="0"/>
           </a:p>
           <a:p>
             <a:pPr indent="0" marL="0">
+              <a:lnSpc>
+                <a:spcPct val="95000"/>
+              </a:lnSpc>
               <a:spcAft>
-                <a:spcPts val="900"/>
+                <a:spcPts val="250"/>
               </a:spcAft>
               <a:buNone/>
             </a:pPr>
             <a:r>
-              <a:rPr lang="en-US" sz="1300" dirty="0">
+              <a:rPr lang="en-US" sz="1000" b="1" dirty="0">
+                <a:solidFill>
+                  <a:srgbClr val="1E40AF"/>
+                </a:solidFill>
+                <a:latin typeface="Calibri" pitchFamily="34" charset="0"/>
+                <a:ea typeface="Calibri" pitchFamily="34" charset="-122"/>
+                <a:cs typeface="Calibri" pitchFamily="34" charset="-120"/>
+              </a:rPr>
+              <a:t>[6] </a:t>
+            </a:r>
+            <a:pPr indent="0" marL="0">
+              <a:lnSpc>
+                <a:spcPct val="95000"/>
+              </a:lnSpc>
+              <a:spcAft>
+                <a:spcPts val="250"/>
+              </a:spcAft>
+              <a:buNone/>
+            </a:pPr>
+            <a:r>
+              <a:rPr lang="en-US" sz="1000" dirty="0">
                 <a:solidFill>
                   <a:srgbClr val="1F2937"/>
                 </a:solidFill>
@@ -8568,15 +8778,592 @@
                 <a:ea typeface="Calibri" pitchFamily="34" charset="-122"/>
                 <a:cs typeface="Calibri" pitchFamily="34" charset="-120"/>
               </a:rPr>
-              <a:t>[6] Nguồn bổ sung của tập lừa đảo (249/420 mẫu, có URL truy vết trong dataset.csv): GitHub ghitatruongle/lachancuocgoi (162), duynguyenhoang22/SMS_Phishing_Detection — đồ án IE403 (73), duynguyenhoang22/ViSmish_Detection (1); báo chí và video: Thanh Niên, Dân trí, Tuổi Trẻ, VTV24 (13); truy cập 21/09/2026.</a:t>
-            </a:r>
-            <a:endParaRPr lang="en-US" sz="1300" dirty="0"/>
-          </a:p>
-        </p:txBody>
-      </p:sp>
-      <p:sp>
-        <p:nvSpPr>
-          <p:cNvPr id="9" name="Text 6"/>
+              <a:t>G. Salton and C. Buckley, “Term-weighting approaches in automatic text retrieval,” Inf. Process. Manage., 24(5):513–523, 1988.</a:t>
+            </a:r>
+            <a:endParaRPr lang="en-US" sz="1050" dirty="0"/>
+          </a:p>
+          <a:p>
+            <a:pPr indent="0" marL="0">
+              <a:lnSpc>
+                <a:spcPct val="95000"/>
+              </a:lnSpc>
+              <a:spcBef>
+                <a:spcPts val="500"/>
+              </a:spcBef>
+              <a:spcAft>
+                <a:spcPts val="200"/>
+              </a:spcAft>
+              <a:buNone/>
+            </a:pPr>
+            <a:r>
+              <a:rPr lang="en-US" sz="1050" b="1" dirty="0">
+                <a:solidFill>
+                  <a:srgbClr val="1E40AF"/>
+                </a:solidFill>
+                <a:latin typeface="Calibri" pitchFamily="34" charset="0"/>
+                <a:ea typeface="Calibri" pitchFamily="34" charset="-122"/>
+                <a:cs typeface="Calibri" pitchFamily="34" charset="-120"/>
+              </a:rPr>
+              <a:t>THUẬT TOÁN HỌC MÁY</a:t>
+            </a:r>
+            <a:endParaRPr lang="en-US" sz="1050" dirty="0"/>
+          </a:p>
+          <a:p>
+            <a:pPr indent="0" marL="0">
+              <a:lnSpc>
+                <a:spcPct val="95000"/>
+              </a:lnSpc>
+              <a:spcAft>
+                <a:spcPts val="250"/>
+              </a:spcAft>
+              <a:buNone/>
+            </a:pPr>
+            <a:r>
+              <a:rPr lang="en-US" sz="1000" b="1" dirty="0">
+                <a:solidFill>
+                  <a:srgbClr val="1E40AF"/>
+                </a:solidFill>
+                <a:latin typeface="Calibri" pitchFamily="34" charset="0"/>
+                <a:ea typeface="Calibri" pitchFamily="34" charset="-122"/>
+                <a:cs typeface="Calibri" pitchFamily="34" charset="-120"/>
+              </a:rPr>
+              <a:t>[7] </a:t>
+            </a:r>
+            <a:pPr indent="0" marL="0">
+              <a:lnSpc>
+                <a:spcPct val="95000"/>
+              </a:lnSpc>
+              <a:spcAft>
+                <a:spcPts val="250"/>
+              </a:spcAft>
+              <a:buNone/>
+            </a:pPr>
+            <a:r>
+              <a:rPr lang="en-US" sz="1000" dirty="0">
+                <a:solidFill>
+                  <a:srgbClr val="1F2937"/>
+                </a:solidFill>
+                <a:latin typeface="Calibri" pitchFamily="34" charset="0"/>
+                <a:ea typeface="Calibri" pitchFamily="34" charset="-122"/>
+                <a:cs typeface="Calibri" pitchFamily="34" charset="-120"/>
+              </a:rPr>
+              <a:t>T. Chen and C. Guestrin, “XGBoost: A scalable tree boosting system,” KDD 2016, pp. 785–794.</a:t>
+            </a:r>
+            <a:endParaRPr lang="en-US" sz="1050" dirty="0"/>
+          </a:p>
+          <a:p>
+            <a:pPr indent="0" marL="0">
+              <a:lnSpc>
+                <a:spcPct val="95000"/>
+              </a:lnSpc>
+              <a:spcAft>
+                <a:spcPts val="250"/>
+              </a:spcAft>
+              <a:buNone/>
+            </a:pPr>
+            <a:r>
+              <a:rPr lang="en-US" sz="1000" b="1" dirty="0">
+                <a:solidFill>
+                  <a:srgbClr val="1E40AF"/>
+                </a:solidFill>
+                <a:latin typeface="Calibri" pitchFamily="34" charset="0"/>
+                <a:ea typeface="Calibri" pitchFamily="34" charset="-122"/>
+                <a:cs typeface="Calibri" pitchFamily="34" charset="-120"/>
+              </a:rPr>
+              <a:t>[8] </a:t>
+            </a:r>
+            <a:pPr indent="0" marL="0">
+              <a:lnSpc>
+                <a:spcPct val="95000"/>
+              </a:lnSpc>
+              <a:spcAft>
+                <a:spcPts val="250"/>
+              </a:spcAft>
+              <a:buNone/>
+            </a:pPr>
+            <a:r>
+              <a:rPr lang="en-US" sz="1000" dirty="0">
+                <a:solidFill>
+                  <a:srgbClr val="1F2937"/>
+                </a:solidFill>
+                <a:latin typeface="Calibri" pitchFamily="34" charset="0"/>
+                <a:ea typeface="Calibri" pitchFamily="34" charset="-122"/>
+                <a:cs typeface="Calibri" pitchFamily="34" charset="-120"/>
+              </a:rPr>
+              <a:t>L. Breiman, “Random forests,” Mach. Learn., 45(1):5–32, 2001.</a:t>
+            </a:r>
+            <a:endParaRPr lang="en-US" sz="1050" dirty="0"/>
+          </a:p>
+        </p:txBody>
+      </p:sp>
+      <p:sp>
+        <p:nvSpPr>
+          <p:cNvPr id="8" name="Text 6"/>
+          <p:cNvSpPr/>
+          <p:nvPr/>
+        </p:nvSpPr>
+        <p:spPr>
+          <a:xfrm>
+            <a:off x="4663440" y="1051560"/>
+            <a:ext cx="4023360" cy="3383280"/>
+          </a:xfrm>
+          <a:prstGeom prst="rect">
+            <a:avLst/>
+          </a:prstGeom>
+          <a:noFill/>
+          <a:ln/>
+        </p:spPr>
+        <p:txBody>
+          <a:bodyPr wrap="square" lIns="0" tIns="0" rIns="0" bIns="0" rtlCol="0" anchor="t"/>
+          <a:lstStyle/>
+          <a:p>
+            <a:pPr indent="0" marL="0">
+              <a:lnSpc>
+                <a:spcPct val="95000"/>
+              </a:lnSpc>
+              <a:spcAft>
+                <a:spcPts val="200"/>
+              </a:spcAft>
+              <a:buNone/>
+            </a:pPr>
+            <a:r>
+              <a:rPr lang="en-US" sz="1050" b="1" dirty="0">
+                <a:solidFill>
+                  <a:srgbClr val="1E40AF"/>
+                </a:solidFill>
+                <a:latin typeface="Calibri" pitchFamily="34" charset="0"/>
+                <a:ea typeface="Calibri" pitchFamily="34" charset="-122"/>
+                <a:cs typeface="Calibri" pitchFamily="34" charset="-120"/>
+              </a:rPr>
+              <a:t>THUẬT TOÁN HỌC MÁY (TIẾP)</a:t>
+            </a:r>
+            <a:endParaRPr lang="en-US" sz="1050" dirty="0"/>
+          </a:p>
+          <a:p>
+            <a:pPr indent="0" marL="0">
+              <a:lnSpc>
+                <a:spcPct val="95000"/>
+              </a:lnSpc>
+              <a:spcAft>
+                <a:spcPts val="250"/>
+              </a:spcAft>
+              <a:buNone/>
+            </a:pPr>
+            <a:r>
+              <a:rPr lang="en-US" sz="1000" b="1" dirty="0">
+                <a:solidFill>
+                  <a:srgbClr val="1E40AF"/>
+                </a:solidFill>
+                <a:latin typeface="Calibri" pitchFamily="34" charset="0"/>
+                <a:ea typeface="Calibri" pitchFamily="34" charset="-122"/>
+                <a:cs typeface="Calibri" pitchFamily="34" charset="-120"/>
+              </a:rPr>
+              <a:t>[9] </a:t>
+            </a:r>
+            <a:pPr indent="0" marL="0">
+              <a:lnSpc>
+                <a:spcPct val="95000"/>
+              </a:lnSpc>
+              <a:spcAft>
+                <a:spcPts val="250"/>
+              </a:spcAft>
+              <a:buNone/>
+            </a:pPr>
+            <a:r>
+              <a:rPr lang="en-US" sz="1000" dirty="0">
+                <a:solidFill>
+                  <a:srgbClr val="1F2937"/>
+                </a:solidFill>
+                <a:latin typeface="Calibri" pitchFamily="34" charset="0"/>
+                <a:ea typeface="Calibri" pitchFamily="34" charset="-122"/>
+                <a:cs typeface="Calibri" pitchFamily="34" charset="-120"/>
+              </a:rPr>
+              <a:t>C. Cortes and V. Vapnik, “Support-vector networks,” Mach. Learn., 20(3):273–297, 1995.</a:t>
+            </a:r>
+            <a:endParaRPr lang="en-US" sz="1050" dirty="0"/>
+          </a:p>
+          <a:p>
+            <a:pPr indent="0" marL="0">
+              <a:lnSpc>
+                <a:spcPct val="95000"/>
+              </a:lnSpc>
+              <a:spcAft>
+                <a:spcPts val="250"/>
+              </a:spcAft>
+              <a:buNone/>
+            </a:pPr>
+            <a:r>
+              <a:rPr lang="en-US" sz="1000" b="1" dirty="0">
+                <a:solidFill>
+                  <a:srgbClr val="1E40AF"/>
+                </a:solidFill>
+                <a:latin typeface="Calibri" pitchFamily="34" charset="0"/>
+                <a:ea typeface="Calibri" pitchFamily="34" charset="-122"/>
+                <a:cs typeface="Calibri" pitchFamily="34" charset="-120"/>
+              </a:rPr>
+              <a:t>[10] </a:t>
+            </a:r>
+            <a:pPr indent="0" marL="0">
+              <a:lnSpc>
+                <a:spcPct val="95000"/>
+              </a:lnSpc>
+              <a:spcAft>
+                <a:spcPts val="250"/>
+              </a:spcAft>
+              <a:buNone/>
+            </a:pPr>
+            <a:r>
+              <a:rPr lang="en-US" sz="1000" dirty="0">
+                <a:solidFill>
+                  <a:srgbClr val="1F2937"/>
+                </a:solidFill>
+                <a:latin typeface="Calibri" pitchFamily="34" charset="0"/>
+                <a:ea typeface="Calibri" pitchFamily="34" charset="-122"/>
+                <a:cs typeface="Calibri" pitchFamily="34" charset="-120"/>
+              </a:rPr>
+              <a:t>J. Platt, “Probabilities for SV machines,” in Advances in Large-Margin Classifiers, MIT Press, 2000, pp. 61–74.</a:t>
+            </a:r>
+            <a:endParaRPr lang="en-US" sz="1050" dirty="0"/>
+          </a:p>
+          <a:p>
+            <a:pPr indent="0" marL="0">
+              <a:lnSpc>
+                <a:spcPct val="95000"/>
+              </a:lnSpc>
+              <a:spcAft>
+                <a:spcPts val="250"/>
+              </a:spcAft>
+              <a:buNone/>
+            </a:pPr>
+            <a:r>
+              <a:rPr lang="en-US" sz="1000" b="1" dirty="0">
+                <a:solidFill>
+                  <a:srgbClr val="1E40AF"/>
+                </a:solidFill>
+                <a:latin typeface="Calibri" pitchFamily="34" charset="0"/>
+                <a:ea typeface="Calibri" pitchFamily="34" charset="-122"/>
+                <a:cs typeface="Calibri" pitchFamily="34" charset="-120"/>
+              </a:rPr>
+              <a:t>[11] </a:t>
+            </a:r>
+            <a:pPr indent="0" marL="0">
+              <a:lnSpc>
+                <a:spcPct val="95000"/>
+              </a:lnSpc>
+              <a:spcAft>
+                <a:spcPts val="250"/>
+              </a:spcAft>
+              <a:buNone/>
+            </a:pPr>
+            <a:r>
+              <a:rPr lang="en-US" sz="1000" dirty="0">
+                <a:solidFill>
+                  <a:srgbClr val="1F2937"/>
+                </a:solidFill>
+                <a:latin typeface="Calibri" pitchFamily="34" charset="0"/>
+                <a:ea typeface="Calibri" pitchFamily="34" charset="-122"/>
+                <a:cs typeface="Calibri" pitchFamily="34" charset="-120"/>
+              </a:rPr>
+              <a:t>F. Pedregosa et al., “Scikit-learn: Machine learning in Python,” JMLR 12:2825–2830, 2011.</a:t>
+            </a:r>
+            <a:endParaRPr lang="en-US" sz="1050" dirty="0"/>
+          </a:p>
+          <a:p>
+            <a:pPr indent="0" marL="0">
+              <a:lnSpc>
+                <a:spcPct val="95000"/>
+              </a:lnSpc>
+              <a:spcBef>
+                <a:spcPts val="500"/>
+              </a:spcBef>
+              <a:spcAft>
+                <a:spcPts val="200"/>
+              </a:spcAft>
+              <a:buNone/>
+            </a:pPr>
+            <a:r>
+              <a:rPr lang="en-US" sz="1050" b="1" dirty="0">
+                <a:solidFill>
+                  <a:srgbClr val="1E40AF"/>
+                </a:solidFill>
+                <a:latin typeface="Calibri" pitchFamily="34" charset="0"/>
+                <a:ea typeface="Calibri" pitchFamily="34" charset="-122"/>
+                <a:cs typeface="Calibri" pitchFamily="34" charset="-120"/>
+              </a:rPr>
+              <a:t>GIẢI THÍCH MÔ HÌNH (XAI)</a:t>
+            </a:r>
+            <a:endParaRPr lang="en-US" sz="1050" dirty="0"/>
+          </a:p>
+          <a:p>
+            <a:pPr indent="0" marL="0">
+              <a:lnSpc>
+                <a:spcPct val="95000"/>
+              </a:lnSpc>
+              <a:spcAft>
+                <a:spcPts val="250"/>
+              </a:spcAft>
+              <a:buNone/>
+            </a:pPr>
+            <a:r>
+              <a:rPr lang="en-US" sz="1000" b="1" dirty="0">
+                <a:solidFill>
+                  <a:srgbClr val="1E40AF"/>
+                </a:solidFill>
+                <a:latin typeface="Calibri" pitchFamily="34" charset="0"/>
+                <a:ea typeface="Calibri" pitchFamily="34" charset="-122"/>
+                <a:cs typeface="Calibri" pitchFamily="34" charset="-120"/>
+              </a:rPr>
+              <a:t>[12] </a:t>
+            </a:r>
+            <a:pPr indent="0" marL="0">
+              <a:lnSpc>
+                <a:spcPct val="95000"/>
+              </a:lnSpc>
+              <a:spcAft>
+                <a:spcPts val="250"/>
+              </a:spcAft>
+              <a:buNone/>
+            </a:pPr>
+            <a:r>
+              <a:rPr lang="en-US" sz="1000" dirty="0">
+                <a:solidFill>
+                  <a:srgbClr val="1F2937"/>
+                </a:solidFill>
+                <a:latin typeface="Calibri" pitchFamily="34" charset="0"/>
+                <a:ea typeface="Calibri" pitchFamily="34" charset="-122"/>
+                <a:cs typeface="Calibri" pitchFamily="34" charset="-120"/>
+              </a:rPr>
+              <a:t>S. M. Lundberg and S.-I. Lee, “A unified approach to interpreting model predictions,” NeurIPS 30, 2017.</a:t>
+            </a:r>
+            <a:endParaRPr lang="en-US" sz="1050" dirty="0"/>
+          </a:p>
+          <a:p>
+            <a:pPr indent="0" marL="0">
+              <a:lnSpc>
+                <a:spcPct val="95000"/>
+              </a:lnSpc>
+              <a:spcAft>
+                <a:spcPts val="250"/>
+              </a:spcAft>
+              <a:buNone/>
+            </a:pPr>
+            <a:r>
+              <a:rPr lang="en-US" sz="1000" b="1" dirty="0">
+                <a:solidFill>
+                  <a:srgbClr val="1E40AF"/>
+                </a:solidFill>
+                <a:latin typeface="Calibri" pitchFamily="34" charset="0"/>
+                <a:ea typeface="Calibri" pitchFamily="34" charset="-122"/>
+                <a:cs typeface="Calibri" pitchFamily="34" charset="-120"/>
+              </a:rPr>
+              <a:t>[13] </a:t>
+            </a:r>
+            <a:pPr indent="0" marL="0">
+              <a:lnSpc>
+                <a:spcPct val="95000"/>
+              </a:lnSpc>
+              <a:spcAft>
+                <a:spcPts val="250"/>
+              </a:spcAft>
+              <a:buNone/>
+            </a:pPr>
+            <a:r>
+              <a:rPr lang="en-US" sz="1000" dirty="0">
+                <a:solidFill>
+                  <a:srgbClr val="1F2937"/>
+                </a:solidFill>
+                <a:latin typeface="Calibri" pitchFamily="34" charset="0"/>
+                <a:ea typeface="Calibri" pitchFamily="34" charset="-122"/>
+                <a:cs typeface="Calibri" pitchFamily="34" charset="-120"/>
+              </a:rPr>
+              <a:t>S. M. Lundberg et al., “From local explanations to global understanding with explainable AI for trees,” Nat. Mach. Intell., 2(1):56–67, 2020.</a:t>
+            </a:r>
+            <a:endParaRPr lang="en-US" sz="1050" dirty="0"/>
+          </a:p>
+          <a:p>
+            <a:pPr indent="0" marL="0">
+              <a:lnSpc>
+                <a:spcPct val="95000"/>
+              </a:lnSpc>
+              <a:spcBef>
+                <a:spcPts val="500"/>
+              </a:spcBef>
+              <a:spcAft>
+                <a:spcPts val="200"/>
+              </a:spcAft>
+              <a:buNone/>
+            </a:pPr>
+            <a:r>
+              <a:rPr lang="en-US" sz="1050" b="1" dirty="0">
+                <a:solidFill>
+                  <a:srgbClr val="1E40AF"/>
+                </a:solidFill>
+                <a:latin typeface="Calibri" pitchFamily="34" charset="0"/>
+                <a:ea typeface="Calibri" pitchFamily="34" charset="-122"/>
+                <a:cs typeface="Calibri" pitchFamily="34" charset="-120"/>
+              </a:rPr>
+              <a:t>TRỢ NĂNG WEB</a:t>
+            </a:r>
+            <a:endParaRPr lang="en-US" sz="1050" dirty="0"/>
+          </a:p>
+          <a:p>
+            <a:pPr indent="0" marL="0">
+              <a:lnSpc>
+                <a:spcPct val="95000"/>
+              </a:lnSpc>
+              <a:spcAft>
+                <a:spcPts val="250"/>
+              </a:spcAft>
+              <a:buNone/>
+            </a:pPr>
+            <a:r>
+              <a:rPr lang="en-US" sz="1000" b="1" dirty="0">
+                <a:solidFill>
+                  <a:srgbClr val="1E40AF"/>
+                </a:solidFill>
+                <a:latin typeface="Calibri" pitchFamily="34" charset="0"/>
+                <a:ea typeface="Calibri" pitchFamily="34" charset="-122"/>
+                <a:cs typeface="Calibri" pitchFamily="34" charset="-120"/>
+              </a:rPr>
+              <a:t>[14] </a:t>
+            </a:r>
+            <a:pPr indent="0" marL="0">
+              <a:lnSpc>
+                <a:spcPct val="95000"/>
+              </a:lnSpc>
+              <a:spcAft>
+                <a:spcPts val="250"/>
+              </a:spcAft>
+              <a:buNone/>
+            </a:pPr>
+            <a:r>
+              <a:rPr lang="en-US" sz="1000" dirty="0">
+                <a:solidFill>
+                  <a:srgbClr val="1F2937"/>
+                </a:solidFill>
+                <a:latin typeface="Calibri" pitchFamily="34" charset="0"/>
+                <a:ea typeface="Calibri" pitchFamily="34" charset="-122"/>
+                <a:cs typeface="Calibri" pitchFamily="34" charset="-120"/>
+              </a:rPr>
+              <a:t>W3C, “Web Content Accessibility Guidelines (WCAG) 2.1,” Recommendation, 5 Jun. 2018 (updated 6 May 2025).</a:t>
+            </a:r>
+            <a:endParaRPr lang="en-US" sz="1050" dirty="0"/>
+          </a:p>
+          <a:p>
+            <a:pPr indent="0" marL="0">
+              <a:lnSpc>
+                <a:spcPct val="95000"/>
+              </a:lnSpc>
+              <a:spcBef>
+                <a:spcPts val="500"/>
+              </a:spcBef>
+              <a:spcAft>
+                <a:spcPts val="200"/>
+              </a:spcAft>
+              <a:buNone/>
+            </a:pPr>
+            <a:r>
+              <a:rPr lang="en-US" sz="1050" b="1" dirty="0">
+                <a:solidFill>
+                  <a:srgbClr val="1E40AF"/>
+                </a:solidFill>
+                <a:latin typeface="Calibri" pitchFamily="34" charset="0"/>
+                <a:ea typeface="Calibri" pitchFamily="34" charset="-122"/>
+                <a:cs typeface="Calibri" pitchFamily="34" charset="-120"/>
+              </a:rPr>
+              <a:t>HƯỚNG PHÁT TRIỂN</a:t>
+            </a:r>
+            <a:endParaRPr lang="en-US" sz="1050" dirty="0"/>
+          </a:p>
+          <a:p>
+            <a:pPr indent="0" marL="0">
+              <a:lnSpc>
+                <a:spcPct val="95000"/>
+              </a:lnSpc>
+              <a:spcAft>
+                <a:spcPts val="250"/>
+              </a:spcAft>
+              <a:buNone/>
+            </a:pPr>
+            <a:r>
+              <a:rPr lang="en-US" sz="1000" b="1" dirty="0">
+                <a:solidFill>
+                  <a:srgbClr val="1E40AF"/>
+                </a:solidFill>
+                <a:latin typeface="Calibri" pitchFamily="34" charset="0"/>
+                <a:ea typeface="Calibri" pitchFamily="34" charset="-122"/>
+                <a:cs typeface="Calibri" pitchFamily="34" charset="-120"/>
+              </a:rPr>
+              <a:t>[15] </a:t>
+            </a:r>
+            <a:pPr indent="0" marL="0">
+              <a:lnSpc>
+                <a:spcPct val="95000"/>
+              </a:lnSpc>
+              <a:spcAft>
+                <a:spcPts val="250"/>
+              </a:spcAft>
+              <a:buNone/>
+            </a:pPr>
+            <a:r>
+              <a:rPr lang="en-US" sz="1000" dirty="0">
+                <a:solidFill>
+                  <a:srgbClr val="1F2937"/>
+                </a:solidFill>
+                <a:latin typeface="Calibri" pitchFamily="34" charset="0"/>
+                <a:ea typeface="Calibri" pitchFamily="34" charset="-122"/>
+                <a:cs typeface="Calibri" pitchFamily="34" charset="-120"/>
+              </a:rPr>
+              <a:t>D. Q. Nguyen and A. T. Nguyen, “PhoBERT: Pre-trained language models for Vietnamese,” Findings of EMNLP, 2020, pp. 1037–1042.</a:t>
+            </a:r>
+            <a:endParaRPr lang="en-US" sz="1050" dirty="0"/>
+          </a:p>
+        </p:txBody>
+      </p:sp>
+      <p:sp>
+        <p:nvSpPr>
+          <p:cNvPr id="9" name="Text 7"/>
+          <p:cNvSpPr/>
+          <p:nvPr/>
+        </p:nvSpPr>
+        <p:spPr>
+          <a:xfrm>
+            <a:off x="457200" y="4480560"/>
+            <a:ext cx="8229600" cy="201168"/>
+          </a:xfrm>
+          <a:prstGeom prst="rect">
+            <a:avLst/>
+          </a:prstGeom>
+          <a:noFill/>
+          <a:ln/>
+        </p:spPr>
+        <p:txBody>
+          <a:bodyPr wrap="square" rtlCol="0" anchor="ctr">
+            <a:normAutofit/>
+          </a:bodyPr>
+          <a:lstStyle/>
+          <a:p>
+            <a:pPr indent="0" marL="0">
+              <a:buNone/>
+            </a:pPr>
+            <a:r>
+              <a:rPr lang="en-US" sz="1000" i="1" dirty="0">
+                <a:solidFill>
+                  <a:srgbClr val="6B7280"/>
+                </a:solidFill>
+                <a:latin typeface="Calibri" pitchFamily="34" charset="0"/>
+                <a:ea typeface="Calibri" pitchFamily="34" charset="-122"/>
+                <a:cs typeface="Calibri" pitchFamily="34" charset="-120"/>
+              </a:rPr>
+              <a:t>Nguồn trực tuyến truy cập 21/09/2026 · [1] giấy phép CC BY 4.0 theo README · Danh sách đầy đủ 18 tài liệu: báo cáo Word</a:t>
+            </a:r>
+            <a:endParaRPr lang="en-US" sz="1000" dirty="0"/>
+          </a:p>
+        </p:txBody>
+      </p:sp>
+      <p:sp>
+        <p:nvSpPr>
+          <p:cNvPr id="11" name="Text 8"/>
           <p:cNvSpPr/>
           <p:nvPr/>
         </p:nvSpPr>
@@ -8632,7 +9419,7 @@
       </p:sp>
       <p:sp>
         <p:nvSpPr>
-          <p:cNvPr id="10" name="Text 7"/>
+          <p:cNvPr id="12" name="Text 9"/>
           <p:cNvSpPr/>
           <p:nvPr/>
         </p:nvSpPr>
@@ -9518,48 +10305,7 @@
       </p:sp>
       <p:sp>
         <p:nvSpPr>
-          <p:cNvPr id="12" name="Text 10"/>
-          <p:cNvSpPr/>
-          <p:nvPr/>
-        </p:nvSpPr>
-        <p:spPr>
-          <a:xfrm>
-            <a:off x="1371600" y="1929384"/>
-            <a:ext cx="3017520" cy="237744"/>
-          </a:xfrm>
-          <a:prstGeom prst="rect">
-            <a:avLst/>
-          </a:prstGeom>
-          <a:noFill/>
-          <a:ln/>
-        </p:spPr>
-        <p:txBody>
-          <a:bodyPr wrap="square" rtlCol="0" anchor="ctr">
-            <a:normAutofit/>
-          </a:bodyPr>
-          <a:lstStyle/>
-          <a:p>
-            <a:pPr indent="0" marL="0">
-              <a:buNone/>
-            </a:pPr>
-            <a:r>
-              <a:rPr lang="en-US" sz="1100" i="1" dirty="0">
-                <a:solidFill>
-                  <a:srgbClr val="6B7280"/>
-                </a:solidFill>
-                <a:latin typeface="Calibri" pitchFamily="34" charset="0"/>
-                <a:ea typeface="Calibri" pitchFamily="34" charset="-122"/>
-                <a:cs typeface="Calibri" pitchFamily="34" charset="-120"/>
-              </a:rPr>
-              <a:t>Trình bày: Đặng Chí Thanh</a:t>
-            </a:r>
-            <a:endParaRPr lang="en-US" sz="1100" dirty="0"/>
-          </a:p>
-        </p:txBody>
-      </p:sp>
-      <p:sp>
-        <p:nvSpPr>
-          <p:cNvPr id="13" name="Shape 11"/>
+          <p:cNvPr id="12" name="Shape 10"/>
           <p:cNvSpPr/>
           <p:nvPr/>
         </p:nvSpPr>
@@ -9584,7 +10330,7 @@
       </p:sp>
       <p:sp>
         <p:nvSpPr>
-          <p:cNvPr id="14" name="Shape 12"/>
+          <p:cNvPr id="13" name="Shape 11"/>
           <p:cNvSpPr/>
           <p:nvPr/>
         </p:nvSpPr>
@@ -9604,7 +10350,7 @@
       </p:sp>
       <p:sp>
         <p:nvSpPr>
-          <p:cNvPr id="15" name="Text 13"/>
+          <p:cNvPr id="14" name="Text 12"/>
           <p:cNvSpPr/>
           <p:nvPr/>
         </p:nvSpPr>
@@ -9660,7 +10406,7 @@
       </p:sp>
       <p:sp>
         <p:nvSpPr>
-          <p:cNvPr id="16" name="Text 14"/>
+          <p:cNvPr id="15" name="Text 13"/>
           <p:cNvSpPr/>
           <p:nvPr/>
         </p:nvSpPr>
@@ -9701,7 +10447,7 @@
       </p:sp>
       <p:sp>
         <p:nvSpPr>
-          <p:cNvPr id="17" name="Text 15"/>
+          <p:cNvPr id="16" name="Text 14"/>
           <p:cNvSpPr/>
           <p:nvPr/>
         </p:nvSpPr>
@@ -9742,48 +10488,7 @@
       </p:sp>
       <p:sp>
         <p:nvSpPr>
-          <p:cNvPr id="18" name="Text 16"/>
-          <p:cNvSpPr/>
-          <p:nvPr/>
-        </p:nvSpPr>
-        <p:spPr>
-          <a:xfrm>
-            <a:off x="1371600" y="3118104"/>
-            <a:ext cx="3017520" cy="237744"/>
-          </a:xfrm>
-          <a:prstGeom prst="rect">
-            <a:avLst/>
-          </a:prstGeom>
-          <a:noFill/>
-          <a:ln/>
-        </p:spPr>
-        <p:txBody>
-          <a:bodyPr wrap="square" rtlCol="0" anchor="ctr">
-            <a:normAutofit/>
-          </a:bodyPr>
-          <a:lstStyle/>
-          <a:p>
-            <a:pPr indent="0" marL="0">
-              <a:buNone/>
-            </a:pPr>
-            <a:r>
-              <a:rPr lang="en-US" sz="1100" i="1" dirty="0">
-                <a:solidFill>
-                  <a:srgbClr val="6B7280"/>
-                </a:solidFill>
-                <a:latin typeface="Calibri" pitchFamily="34" charset="0"/>
-                <a:ea typeface="Calibri" pitchFamily="34" charset="-122"/>
-                <a:cs typeface="Calibri" pitchFamily="34" charset="-120"/>
-              </a:rPr>
-              <a:t>Trình bày: Đặng Chí Thanh</a:t>
-            </a:r>
-            <a:endParaRPr lang="en-US" sz="1100" dirty="0"/>
-          </a:p>
-        </p:txBody>
-      </p:sp>
-      <p:sp>
-        <p:nvSpPr>
-          <p:cNvPr id="19" name="Shape 17"/>
+          <p:cNvPr id="17" name="Shape 15"/>
           <p:cNvSpPr/>
           <p:nvPr/>
         </p:nvSpPr>
@@ -9808,7 +10513,7 @@
       </p:sp>
       <p:sp>
         <p:nvSpPr>
-          <p:cNvPr id="20" name="Shape 18"/>
+          <p:cNvPr id="18" name="Shape 16"/>
           <p:cNvSpPr/>
           <p:nvPr/>
         </p:nvSpPr>
@@ -9828,7 +10533,7 @@
       </p:sp>
       <p:sp>
         <p:nvSpPr>
-          <p:cNvPr id="21" name="Text 19"/>
+          <p:cNvPr id="19" name="Text 17"/>
           <p:cNvSpPr/>
           <p:nvPr/>
         </p:nvSpPr>
@@ -9884,7 +10589,7 @@
       </p:sp>
       <p:sp>
         <p:nvSpPr>
-          <p:cNvPr id="22" name="Text 20"/>
+          <p:cNvPr id="20" name="Text 18"/>
           <p:cNvSpPr/>
           <p:nvPr/>
         </p:nvSpPr>
@@ -9925,7 +10630,7 @@
       </p:sp>
       <p:sp>
         <p:nvSpPr>
-          <p:cNvPr id="23" name="Text 21"/>
+          <p:cNvPr id="21" name="Text 19"/>
           <p:cNvSpPr/>
           <p:nvPr/>
         </p:nvSpPr>
@@ -9966,48 +10671,7 @@
       </p:sp>
       <p:sp>
         <p:nvSpPr>
-          <p:cNvPr id="24" name="Text 22"/>
-          <p:cNvSpPr/>
-          <p:nvPr/>
-        </p:nvSpPr>
-        <p:spPr>
-          <a:xfrm>
-            <a:off x="1371600" y="4306824"/>
-            <a:ext cx="3017520" cy="237744"/>
-          </a:xfrm>
-          <a:prstGeom prst="rect">
-            <a:avLst/>
-          </a:prstGeom>
-          <a:noFill/>
-          <a:ln/>
-        </p:spPr>
-        <p:txBody>
-          <a:bodyPr wrap="square" rtlCol="0" anchor="ctr">
-            <a:normAutofit/>
-          </a:bodyPr>
-          <a:lstStyle/>
-          <a:p>
-            <a:pPr indent="0" marL="0">
-              <a:buNone/>
-            </a:pPr>
-            <a:r>
-              <a:rPr lang="en-US" sz="1100" i="1" dirty="0">
-                <a:solidFill>
-                  <a:srgbClr val="6B7280"/>
-                </a:solidFill>
-                <a:latin typeface="Calibri" pitchFamily="34" charset="0"/>
-                <a:ea typeface="Calibri" pitchFamily="34" charset="-122"/>
-                <a:cs typeface="Calibri" pitchFamily="34" charset="-120"/>
-              </a:rPr>
-              <a:t>Trình bày: Bùi Thị Mỷ Cẩm</a:t>
-            </a:r>
-            <a:endParaRPr lang="en-US" sz="1100" dirty="0"/>
-          </a:p>
-        </p:txBody>
-      </p:sp>
-      <p:sp>
-        <p:nvSpPr>
-          <p:cNvPr id="25" name="Shape 23"/>
+          <p:cNvPr id="22" name="Shape 20"/>
           <p:cNvSpPr/>
           <p:nvPr/>
         </p:nvSpPr>
@@ -10032,7 +10696,7 @@
       </p:sp>
       <p:sp>
         <p:nvSpPr>
-          <p:cNvPr id="26" name="Shape 24"/>
+          <p:cNvPr id="23" name="Shape 21"/>
           <p:cNvSpPr/>
           <p:nvPr/>
         </p:nvSpPr>
@@ -10052,7 +10716,7 @@
       </p:sp>
       <p:sp>
         <p:nvSpPr>
-          <p:cNvPr id="27" name="Text 25"/>
+          <p:cNvPr id="24" name="Text 22"/>
           <p:cNvSpPr/>
           <p:nvPr/>
         </p:nvSpPr>
@@ -10108,7 +10772,7 @@
       </p:sp>
       <p:sp>
         <p:nvSpPr>
-          <p:cNvPr id="28" name="Text 26"/>
+          <p:cNvPr id="25" name="Text 23"/>
           <p:cNvSpPr/>
           <p:nvPr/>
         </p:nvSpPr>
@@ -10149,7 +10813,7 @@
       </p:sp>
       <p:sp>
         <p:nvSpPr>
-          <p:cNvPr id="29" name="Text 27"/>
+          <p:cNvPr id="26" name="Text 24"/>
           <p:cNvSpPr/>
           <p:nvPr/>
         </p:nvSpPr>
@@ -10190,48 +10854,7 @@
       </p:sp>
       <p:sp>
         <p:nvSpPr>
-          <p:cNvPr id="30" name="Text 28"/>
-          <p:cNvSpPr/>
-          <p:nvPr/>
-        </p:nvSpPr>
-        <p:spPr>
-          <a:xfrm>
-            <a:off x="5577840" y="1929384"/>
-            <a:ext cx="3017520" cy="237744"/>
-          </a:xfrm>
-          <a:prstGeom prst="rect">
-            <a:avLst/>
-          </a:prstGeom>
-          <a:noFill/>
-          <a:ln/>
-        </p:spPr>
-        <p:txBody>
-          <a:bodyPr wrap="square" rtlCol="0" anchor="ctr">
-            <a:normAutofit/>
-          </a:bodyPr>
-          <a:lstStyle/>
-          <a:p>
-            <a:pPr indent="0" marL="0">
-              <a:buNone/>
-            </a:pPr>
-            <a:r>
-              <a:rPr lang="en-US" sz="1100" i="1" dirty="0">
-                <a:solidFill>
-                  <a:srgbClr val="6B7280"/>
-                </a:solidFill>
-                <a:latin typeface="Calibri" pitchFamily="34" charset="0"/>
-                <a:ea typeface="Calibri" pitchFamily="34" charset="-122"/>
-                <a:cs typeface="Calibri" pitchFamily="34" charset="-120"/>
-              </a:rPr>
-              <a:t>Trình bày: Hoàng Cao Sơn</a:t>
-            </a:r>
-            <a:endParaRPr lang="en-US" sz="1100" dirty="0"/>
-          </a:p>
-        </p:txBody>
-      </p:sp>
-      <p:sp>
-        <p:nvSpPr>
-          <p:cNvPr id="31" name="Shape 29"/>
+          <p:cNvPr id="27" name="Shape 25"/>
           <p:cNvSpPr/>
           <p:nvPr/>
         </p:nvSpPr>
@@ -10256,7 +10879,7 @@
       </p:sp>
       <p:sp>
         <p:nvSpPr>
-          <p:cNvPr id="32" name="Shape 30"/>
+          <p:cNvPr id="28" name="Shape 26"/>
           <p:cNvSpPr/>
           <p:nvPr/>
         </p:nvSpPr>
@@ -10276,7 +10899,7 @@
       </p:sp>
       <p:sp>
         <p:nvSpPr>
-          <p:cNvPr id="33" name="Text 31"/>
+          <p:cNvPr id="29" name="Text 27"/>
           <p:cNvSpPr/>
           <p:nvPr/>
         </p:nvSpPr>
@@ -10332,7 +10955,7 @@
       </p:sp>
       <p:sp>
         <p:nvSpPr>
-          <p:cNvPr id="34" name="Text 32"/>
+          <p:cNvPr id="30" name="Text 28"/>
           <p:cNvSpPr/>
           <p:nvPr/>
         </p:nvSpPr>
@@ -10373,7 +10996,7 @@
       </p:sp>
       <p:sp>
         <p:nvSpPr>
-          <p:cNvPr id="35" name="Text 33"/>
+          <p:cNvPr id="31" name="Text 29"/>
           <p:cNvSpPr/>
           <p:nvPr/>
         </p:nvSpPr>
@@ -10414,48 +11037,7 @@
       </p:sp>
       <p:sp>
         <p:nvSpPr>
-          <p:cNvPr id="36" name="Text 34"/>
-          <p:cNvSpPr/>
-          <p:nvPr/>
-        </p:nvSpPr>
-        <p:spPr>
-          <a:xfrm>
-            <a:off x="5577840" y="3118104"/>
-            <a:ext cx="3017520" cy="237744"/>
-          </a:xfrm>
-          <a:prstGeom prst="rect">
-            <a:avLst/>
-          </a:prstGeom>
-          <a:noFill/>
-          <a:ln/>
-        </p:spPr>
-        <p:txBody>
-          <a:bodyPr wrap="square" rtlCol="0" anchor="ctr">
-            <a:normAutofit/>
-          </a:bodyPr>
-          <a:lstStyle/>
-          <a:p>
-            <a:pPr indent="0" marL="0">
-              <a:buNone/>
-            </a:pPr>
-            <a:r>
-              <a:rPr lang="en-US" sz="1100" i="1" dirty="0">
-                <a:solidFill>
-                  <a:srgbClr val="6B7280"/>
-                </a:solidFill>
-                <a:latin typeface="Calibri" pitchFamily="34" charset="0"/>
-                <a:ea typeface="Calibri" pitchFamily="34" charset="-122"/>
-                <a:cs typeface="Calibri" pitchFamily="34" charset="-120"/>
-              </a:rPr>
-              <a:t>Trình bày: Hoàng Cao Sơn</a:t>
-            </a:r>
-            <a:endParaRPr lang="en-US" sz="1100" dirty="0"/>
-          </a:p>
-        </p:txBody>
-      </p:sp>
-      <p:sp>
-        <p:nvSpPr>
-          <p:cNvPr id="37" name="Shape 35"/>
+          <p:cNvPr id="32" name="Shape 30"/>
           <p:cNvSpPr/>
           <p:nvPr/>
         </p:nvSpPr>
@@ -10480,7 +11062,7 @@
       </p:sp>
       <p:sp>
         <p:nvSpPr>
-          <p:cNvPr id="38" name="Shape 36"/>
+          <p:cNvPr id="33" name="Shape 31"/>
           <p:cNvSpPr/>
           <p:nvPr/>
         </p:nvSpPr>
@@ -10500,7 +11082,7 @@
       </p:sp>
       <p:sp>
         <p:nvSpPr>
-          <p:cNvPr id="39" name="Text 37"/>
+          <p:cNvPr id="34" name="Text 32"/>
           <p:cNvSpPr/>
           <p:nvPr/>
         </p:nvSpPr>
@@ -10556,7 +11138,7 @@
       </p:sp>
       <p:sp>
         <p:nvSpPr>
-          <p:cNvPr id="40" name="Text 38"/>
+          <p:cNvPr id="35" name="Text 33"/>
           <p:cNvSpPr/>
           <p:nvPr/>
         </p:nvSpPr>
@@ -10597,7 +11179,7 @@
       </p:sp>
       <p:sp>
         <p:nvSpPr>
-          <p:cNvPr id="41" name="Text 39"/>
+          <p:cNvPr id="36" name="Text 34"/>
           <p:cNvSpPr/>
           <p:nvPr/>
         </p:nvSpPr>
@@ -10638,48 +11220,7 @@
       </p:sp>
       <p:sp>
         <p:nvSpPr>
-          <p:cNvPr id="42" name="Text 40"/>
-          <p:cNvSpPr/>
-          <p:nvPr/>
-        </p:nvSpPr>
-        <p:spPr>
-          <a:xfrm>
-            <a:off x="5577840" y="4306824"/>
-            <a:ext cx="3017520" cy="237744"/>
-          </a:xfrm>
-          <a:prstGeom prst="rect">
-            <a:avLst/>
-          </a:prstGeom>
-          <a:noFill/>
-          <a:ln/>
-        </p:spPr>
-        <p:txBody>
-          <a:bodyPr wrap="square" rtlCol="0" anchor="ctr">
-            <a:normAutofit/>
-          </a:bodyPr>
-          <a:lstStyle/>
-          <a:p>
-            <a:pPr indent="0" marL="0">
-              <a:buNone/>
-            </a:pPr>
-            <a:r>
-              <a:rPr lang="en-US" sz="1100" i="1" dirty="0">
-                <a:solidFill>
-                  <a:srgbClr val="6B7280"/>
-                </a:solidFill>
-                <a:latin typeface="Calibri" pitchFamily="34" charset="0"/>
-                <a:ea typeface="Calibri" pitchFamily="34" charset="-122"/>
-                <a:cs typeface="Calibri" pitchFamily="34" charset="-120"/>
-              </a:rPr>
-              <a:t>Cả nhóm</a:t>
-            </a:r>
-            <a:endParaRPr lang="en-US" sz="1100" dirty="0"/>
-          </a:p>
-        </p:txBody>
-      </p:sp>
-      <p:sp>
-        <p:nvSpPr>
-          <p:cNvPr id="44" name="Text 41"/>
+          <p:cNvPr id="38" name="Text 35"/>
           <p:cNvSpPr/>
           <p:nvPr/>
         </p:nvSpPr>
@@ -10735,7 +11276,7 @@
       </p:sp>
       <p:sp>
         <p:nvSpPr>
-          <p:cNvPr id="45" name="Text 42"/>
+          <p:cNvPr id="39" name="Text 36"/>
           <p:cNvSpPr/>
           <p:nvPr/>
         </p:nvSpPr>
@@ -16850,7 +17391,7 @@
                 <a:ea typeface="Calibri" pitchFamily="34" charset="-122"/>
                 <a:cs typeface="Calibri" pitchFamily="34" charset="-120"/>
               </a:rPr>
-              <a:t>2.193 mẫu · Stratified Split 80/20 · nguồn [4], [6]</a:t>
+              <a:t>2.193 mẫu · Stratified Split 80/20 · nguồn [1], [2]</a:t>
             </a:r>
             <a:endParaRPr lang="en-US" sz="1500" dirty="0"/>
           </a:p>
@@ -18980,7 +19521,7 @@
                 <a:ea typeface="Calibri" pitchFamily="34" charset="-122"/>
                 <a:cs typeface="Calibri" pitchFamily="34" charset="-120"/>
               </a:rPr>
-              <a:t>Chuẩn hóa ký tự</a:t>
+              <a:t>NFC [3]</a:t>
             </a:r>
             <a:endParaRPr lang="en-US" sz="1300" dirty="0"/>
           </a:p>
@@ -19000,7 +19541,7 @@
                 <a:ea typeface="Calibri" pitchFamily="34" charset="-122"/>
                 <a:cs typeface="Calibri" pitchFamily="34" charset="-120"/>
               </a:rPr>
-              <a:t>tiếng Việt</a:t>
+              <a:t>Dấu thanh [5]</a:t>
             </a:r>
             <a:endParaRPr lang="en-US" sz="1300" dirty="0"/>
           </a:p>
@@ -19340,7 +19881,7 @@
                 <a:ea typeface="Calibri" pitchFamily="34" charset="-122"/>
                 <a:cs typeface="Calibri" pitchFamily="34" charset="-120"/>
               </a:rPr>
-              <a:t>thành từ</a:t>
+              <a:t>thành từ [4]</a:t>
             </a:r>
             <a:endParaRPr lang="en-US" sz="1300" dirty="0"/>
           </a:p>
@@ -19510,7 +20051,7 @@
                 <a:ea typeface="Calibri" pitchFamily="34" charset="-122"/>
                 <a:cs typeface="Calibri" pitchFamily="34" charset="-120"/>
               </a:rPr>
-              <a:t>n-gram (1, 2)</a:t>
+              <a:t>n-gram (1, 2) [6]</a:t>
             </a:r>
             <a:endParaRPr lang="en-US" sz="1300" dirty="0"/>
           </a:p>

</xml_diff>

<commit_message>
docs: add phase 9 presentation slides, screenshots, and report updates
</commit_message>
<xml_diff>
--- a/draft/scam-detection/reports/slides/phase09_presentation.pptx
+++ b/draft/scam-detection/reports/slides/phase09_presentation.pptx
@@ -2839,7 +2839,7 @@
       </p:sp>
       <p:pic>
         <p:nvPicPr>
-          <p:cNvPr id="3" name="Image 0" descr="C:\Users\ADMIN\OneDrive\Documents\MÁY HỌC\ĐỒ ÁN MÔN MÁY HỌC\CS114-Team10-Elderly-Scam-Detection\draft\scam-detection\reports\slides\assets\logo_uit_dhqg_trang.png">    </p:cNvPr>
+          <p:cNvPr id="3" name="Image 0" descr="/Users/tcdtist/dev/uit/cs114/assignments/Final/draft/scam-detection/reports/slides/assets/logo_uit_dhqg_trang.png">    </p:cNvPr>
           <p:cNvPicPr>
             <a:picLocks noChangeAspect="1"/>
           </p:cNvPicPr>
@@ -5500,8 +5500,8 @@
         </p:nvSpPr>
         <p:spPr>
           <a:xfrm>
-            <a:off x="457200" y="4718304"/>
-            <a:ext cx="7040880" cy="384048"/>
+            <a:off x="457200" y="4736592"/>
+            <a:ext cx="7040880" cy="329184"/>
           </a:xfrm>
           <a:prstGeom prst="rect">
             <a:avLst/>
@@ -5517,7 +5517,7 @@
               <a:buNone/>
             </a:pPr>
             <a:r>
-              <a:rPr lang="en-US" sz="1000" dirty="0">
+              <a:rPr lang="en-US" sz="950" dirty="0">
                 <a:solidFill>
                   <a:srgbClr val="6B7280"/>
                 </a:solidFill>
@@ -5527,14 +5527,14 @@
               </a:rPr>
               <a:t>CS114: Máy học — Nhóm 10 — Báo cáo Đồ án:</a:t>
             </a:r>
-            <a:endParaRPr lang="en-US" sz="1000" dirty="0"/>
+            <a:endParaRPr lang="en-US" sz="950" dirty="0"/>
           </a:p>
           <a:p>
             <a:pPr indent="0" marL="0">
               <a:buNone/>
             </a:pPr>
             <a:r>
-              <a:rPr lang="en-US" sz="1000" dirty="0">
+              <a:rPr lang="en-US" sz="950" dirty="0">
                 <a:solidFill>
                   <a:srgbClr val="6B7280"/>
                 </a:solidFill>
@@ -5544,7 +5544,7 @@
               </a:rPr>
               <a:t>Phát hiện Tin nhắn &amp; Kịch bản Thao túng Tâm lý Lừa đảo nhắm vào Người cao tuổi tại Việt Nam</a:t>
             </a:r>
-            <a:endParaRPr lang="en-US" sz="1000" dirty="0"/>
+            <a:endParaRPr lang="en-US" sz="950" dirty="0"/>
           </a:p>
         </p:txBody>
       </p:sp>
@@ -5556,8 +5556,8 @@
         </p:nvSpPr>
         <p:spPr>
           <a:xfrm>
-            <a:off x="7589520" y="4718304"/>
-            <a:ext cx="1097280" cy="384048"/>
+            <a:off x="7589520" y="4736592"/>
+            <a:ext cx="1097280" cy="329184"/>
           </a:xfrm>
           <a:prstGeom prst="rect">
             <a:avLst/>
@@ -5573,7 +5573,7 @@
               <a:buNone/>
             </a:pPr>
             <a:r>
-              <a:rPr lang="en-US" sz="1100" b="1" dirty="0">
+              <a:rPr lang="en-US" sz="1050" b="1" dirty="0">
                 <a:solidFill>
                   <a:srgbClr val="1E40AF"/>
                 </a:solidFill>
@@ -5583,7 +5583,7 @@
               </a:rPr>
               <a:t>10 / 22</a:t>
             </a:r>
-            <a:endParaRPr lang="en-US" sz="1100" dirty="0"/>
+            <a:endParaRPr lang="en-US" sz="1050" dirty="0"/>
           </a:p>
         </p:txBody>
       </p:sp>
@@ -5780,7 +5780,7 @@
       </p:sp>
       <p:pic>
         <p:nvPicPr>
-          <p:cNvPr id="7" name="Image 0" descr="C:\Users\ADMIN\OneDrive\Documents\MÁY HỌC\ĐỒ ÁN MÔN MÁY HỌC\CS114-Team10-Elderly-Scam-Detection\draft\scam-detection\reports\figures\roc_curves_comparison.png">    </p:cNvPr>
+          <p:cNvPr id="7" name="Image 0" descr="/Users/tcdtist/dev/uit/cs114/assignments/Final/draft/scam-detection/reports/figures/roc_curves_comparison.png">    </p:cNvPr>
           <p:cNvPicPr>
             <a:picLocks noChangeAspect="1"/>
           </p:cNvPicPr>
@@ -5843,7 +5843,7 @@
       </p:sp>
       <p:pic>
         <p:nvPicPr>
-          <p:cNvPr id="9" name="Image 1" descr="C:\Users\ADMIN\OneDrive\Documents\MÁY HỌC\ĐỒ ÁN MÔN MÁY HỌC\CS114-Team10-Elderly-Scam-Detection\draft\scam-detection\reports\figures\precision_recall_curves.png">    </p:cNvPr>
+          <p:cNvPr id="9" name="Image 1" descr="/Users/tcdtist/dev/uit/cs114/assignments/Final/draft/scam-detection/reports/figures/precision_recall_curves.png">    </p:cNvPr>
           <p:cNvPicPr>
             <a:picLocks noChangeAspect="1"/>
           </p:cNvPicPr>
@@ -5998,8 +5998,8 @@
         </p:nvSpPr>
         <p:spPr>
           <a:xfrm>
-            <a:off x="457200" y="4718304"/>
-            <a:ext cx="7040880" cy="384048"/>
+            <a:off x="457200" y="4736592"/>
+            <a:ext cx="7040880" cy="329184"/>
           </a:xfrm>
           <a:prstGeom prst="rect">
             <a:avLst/>
@@ -6015,7 +6015,7 @@
               <a:buNone/>
             </a:pPr>
             <a:r>
-              <a:rPr lang="en-US" sz="1000" dirty="0">
+              <a:rPr lang="en-US" sz="950" dirty="0">
                 <a:solidFill>
                   <a:srgbClr val="6B7280"/>
                 </a:solidFill>
@@ -6025,14 +6025,14 @@
               </a:rPr>
               <a:t>CS114: Máy học — Nhóm 10 — Báo cáo Đồ án:</a:t>
             </a:r>
-            <a:endParaRPr lang="en-US" sz="1000" dirty="0"/>
+            <a:endParaRPr lang="en-US" sz="950" dirty="0"/>
           </a:p>
           <a:p>
             <a:pPr indent="0" marL="0">
               <a:buNone/>
             </a:pPr>
             <a:r>
-              <a:rPr lang="en-US" sz="1000" dirty="0">
+              <a:rPr lang="en-US" sz="950" dirty="0">
                 <a:solidFill>
                   <a:srgbClr val="6B7280"/>
                 </a:solidFill>
@@ -6042,7 +6042,7 @@
               </a:rPr>
               <a:t>Phát hiện Tin nhắn &amp; Kịch bản Thao túng Tâm lý Lừa đảo nhắm vào Người cao tuổi tại Việt Nam</a:t>
             </a:r>
-            <a:endParaRPr lang="en-US" sz="1000" dirty="0"/>
+            <a:endParaRPr lang="en-US" sz="950" dirty="0"/>
           </a:p>
         </p:txBody>
       </p:sp>
@@ -6054,8 +6054,8 @@
         </p:nvSpPr>
         <p:spPr>
           <a:xfrm>
-            <a:off x="7589520" y="4718304"/>
-            <a:ext cx="1097280" cy="384048"/>
+            <a:off x="7589520" y="4736592"/>
+            <a:ext cx="1097280" cy="329184"/>
           </a:xfrm>
           <a:prstGeom prst="rect">
             <a:avLst/>
@@ -6071,7 +6071,7 @@
               <a:buNone/>
             </a:pPr>
             <a:r>
-              <a:rPr lang="en-US" sz="1100" b="1" dirty="0">
+              <a:rPr lang="en-US" sz="1050" b="1" dirty="0">
                 <a:solidFill>
                   <a:srgbClr val="1E40AF"/>
                 </a:solidFill>
@@ -6081,7 +6081,7 @@
               </a:rPr>
               <a:t>11 / 22</a:t>
             </a:r>
-            <a:endParaRPr lang="en-US" sz="1100" dirty="0"/>
+            <a:endParaRPr lang="en-US" sz="1050" dirty="0"/>
           </a:p>
         </p:txBody>
       </p:sp>
@@ -6428,7 +6428,7 @@
       </p:sp>
       <p:pic>
         <p:nvPicPr>
-          <p:cNvPr id="8" name="Image 0" descr="C:\Users\ADMIN\OneDrive\Documents\MÁY HỌC\ĐỒ ÁN MÔN MÁY HỌC\CS114-Team10-Elderly-Scam-Detection\draft\scam-detection\reports\figures\shap_summary.png">    </p:cNvPr>
+          <p:cNvPr id="8" name="Image 0" descr="/Users/tcdtist/dev/uit/cs114/assignments/Final/draft/scam-detection/reports/figures/shap_summary.png">    </p:cNvPr>
           <p:cNvPicPr>
             <a:picLocks noChangeAspect="1"/>
           </p:cNvPicPr>
@@ -6458,8 +6458,8 @@
         </p:nvSpPr>
         <p:spPr>
           <a:xfrm>
-            <a:off x="457200" y="4718304"/>
-            <a:ext cx="7040880" cy="384048"/>
+            <a:off x="457200" y="4736592"/>
+            <a:ext cx="7040880" cy="329184"/>
           </a:xfrm>
           <a:prstGeom prst="rect">
             <a:avLst/>
@@ -6475,7 +6475,7 @@
               <a:buNone/>
             </a:pPr>
             <a:r>
-              <a:rPr lang="en-US" sz="1000" dirty="0">
+              <a:rPr lang="en-US" sz="950" dirty="0">
                 <a:solidFill>
                   <a:srgbClr val="6B7280"/>
                 </a:solidFill>
@@ -6485,14 +6485,14 @@
               </a:rPr>
               <a:t>CS114: Máy học — Nhóm 10 — Báo cáo Đồ án:</a:t>
             </a:r>
-            <a:endParaRPr lang="en-US" sz="1000" dirty="0"/>
+            <a:endParaRPr lang="en-US" sz="950" dirty="0"/>
           </a:p>
           <a:p>
             <a:pPr indent="0" marL="0">
               <a:buNone/>
             </a:pPr>
             <a:r>
-              <a:rPr lang="en-US" sz="1000" dirty="0">
+              <a:rPr lang="en-US" sz="950" dirty="0">
                 <a:solidFill>
                   <a:srgbClr val="6B7280"/>
                 </a:solidFill>
@@ -6502,7 +6502,7 @@
               </a:rPr>
               <a:t>Phát hiện Tin nhắn &amp; Kịch bản Thao túng Tâm lý Lừa đảo nhắm vào Người cao tuổi tại Việt Nam</a:t>
             </a:r>
-            <a:endParaRPr lang="en-US" sz="1000" dirty="0"/>
+            <a:endParaRPr lang="en-US" sz="950" dirty="0"/>
           </a:p>
         </p:txBody>
       </p:sp>
@@ -6514,8 +6514,8 @@
         </p:nvSpPr>
         <p:spPr>
           <a:xfrm>
-            <a:off x="7589520" y="4718304"/>
-            <a:ext cx="1097280" cy="384048"/>
+            <a:off x="7589520" y="4736592"/>
+            <a:ext cx="1097280" cy="329184"/>
           </a:xfrm>
           <a:prstGeom prst="rect">
             <a:avLst/>
@@ -6531,7 +6531,7 @@
               <a:buNone/>
             </a:pPr>
             <a:r>
-              <a:rPr lang="en-US" sz="1100" b="1" dirty="0">
+              <a:rPr lang="en-US" sz="1050" b="1" dirty="0">
                 <a:solidFill>
                   <a:srgbClr val="1E40AF"/>
                 </a:solidFill>
@@ -6541,7 +6541,7 @@
               </a:rPr>
               <a:t>12 / 22</a:t>
             </a:r>
-            <a:endParaRPr lang="en-US" sz="1100" dirty="0"/>
+            <a:endParaRPr lang="en-US" sz="1050" dirty="0"/>
           </a:p>
         </p:txBody>
       </p:sp>
@@ -6926,7 +6926,7 @@
       </p:sp>
       <p:pic>
         <p:nvPicPr>
-          <p:cNvPr id="7" name="Image 0" descr="C:\Users\ADMIN\OneDrive\Documents\MÁY HỌC\ĐỒ ÁN MÔN MÁY HỌC\CS114-Team10-Elderly-Scam-Detection\draft\scam-detection\reports\figures\demo_03_scam_detection_verdict.png">    </p:cNvPr>
+          <p:cNvPr id="7" name="Image 0" descr="/Users/tcdtist/dev/uit/cs114/assignments/Final/draft/scam-detection/reports/figures/demo_03_scam_detection_verdict.png">    </p:cNvPr>
           <p:cNvPicPr>
             <a:picLocks noChangeAspect="1"/>
           </p:cNvPicPr>
@@ -7166,8 +7166,8 @@
         </p:nvSpPr>
         <p:spPr>
           <a:xfrm>
-            <a:off x="457200" y="4718304"/>
-            <a:ext cx="7040880" cy="384048"/>
+            <a:off x="457200" y="4736592"/>
+            <a:ext cx="7040880" cy="329184"/>
           </a:xfrm>
           <a:prstGeom prst="rect">
             <a:avLst/>
@@ -7183,7 +7183,7 @@
               <a:buNone/>
             </a:pPr>
             <a:r>
-              <a:rPr lang="en-US" sz="1000" dirty="0">
+              <a:rPr lang="en-US" sz="950" dirty="0">
                 <a:solidFill>
                   <a:srgbClr val="6B7280"/>
                 </a:solidFill>
@@ -7193,14 +7193,14 @@
               </a:rPr>
               <a:t>CS114: Máy học — Nhóm 10 — Báo cáo Đồ án:</a:t>
             </a:r>
-            <a:endParaRPr lang="en-US" sz="1000" dirty="0"/>
+            <a:endParaRPr lang="en-US" sz="950" dirty="0"/>
           </a:p>
           <a:p>
             <a:pPr indent="0" marL="0">
               <a:buNone/>
             </a:pPr>
             <a:r>
-              <a:rPr lang="en-US" sz="1000" dirty="0">
+              <a:rPr lang="en-US" sz="950" dirty="0">
                 <a:solidFill>
                   <a:srgbClr val="6B7280"/>
                 </a:solidFill>
@@ -7210,7 +7210,7 @@
               </a:rPr>
               <a:t>Phát hiện Tin nhắn &amp; Kịch bản Thao túng Tâm lý Lừa đảo nhắm vào Người cao tuổi tại Việt Nam</a:t>
             </a:r>
-            <a:endParaRPr lang="en-US" sz="1000" dirty="0"/>
+            <a:endParaRPr lang="en-US" sz="950" dirty="0"/>
           </a:p>
         </p:txBody>
       </p:sp>
@@ -7222,8 +7222,8 @@
         </p:nvSpPr>
         <p:spPr>
           <a:xfrm>
-            <a:off x="7589520" y="4718304"/>
-            <a:ext cx="1097280" cy="384048"/>
+            <a:off x="7589520" y="4736592"/>
+            <a:ext cx="1097280" cy="329184"/>
           </a:xfrm>
           <a:prstGeom prst="rect">
             <a:avLst/>
@@ -7239,7 +7239,7 @@
               <a:buNone/>
             </a:pPr>
             <a:r>
-              <a:rPr lang="en-US" sz="1100" b="1" dirty="0">
+              <a:rPr lang="en-US" sz="1050" b="1" dirty="0">
                 <a:solidFill>
                   <a:srgbClr val="1E40AF"/>
                 </a:solidFill>
@@ -7249,7 +7249,7 @@
               </a:rPr>
               <a:t>14 / 22</a:t>
             </a:r>
-            <a:endParaRPr lang="en-US" sz="1100" dirty="0"/>
+            <a:endParaRPr lang="en-US" sz="1050" dirty="0"/>
           </a:p>
         </p:txBody>
       </p:sp>
@@ -8177,8 +8177,8 @@
         </p:nvSpPr>
         <p:spPr>
           <a:xfrm>
-            <a:off x="457200" y="4718304"/>
-            <a:ext cx="7040880" cy="384048"/>
+            <a:off x="457200" y="4736592"/>
+            <a:ext cx="7040880" cy="329184"/>
           </a:xfrm>
           <a:prstGeom prst="rect">
             <a:avLst/>
@@ -8194,7 +8194,7 @@
               <a:buNone/>
             </a:pPr>
             <a:r>
-              <a:rPr lang="en-US" sz="1000" dirty="0">
+              <a:rPr lang="en-US" sz="950" dirty="0">
                 <a:solidFill>
                   <a:srgbClr val="6B7280"/>
                 </a:solidFill>
@@ -8204,14 +8204,14 @@
               </a:rPr>
               <a:t>CS114: Máy học — Nhóm 10 — Báo cáo Đồ án:</a:t>
             </a:r>
-            <a:endParaRPr lang="en-US" sz="1000" dirty="0"/>
+            <a:endParaRPr lang="en-US" sz="950" dirty="0"/>
           </a:p>
           <a:p>
             <a:pPr indent="0" marL="0">
               <a:buNone/>
             </a:pPr>
             <a:r>
-              <a:rPr lang="en-US" sz="1000" dirty="0">
+              <a:rPr lang="en-US" sz="950" dirty="0">
                 <a:solidFill>
                   <a:srgbClr val="6B7280"/>
                 </a:solidFill>
@@ -8221,7 +8221,7 @@
               </a:rPr>
               <a:t>Phát hiện Tin nhắn &amp; Kịch bản Thao túng Tâm lý Lừa đảo nhắm vào Người cao tuổi tại Việt Nam</a:t>
             </a:r>
-            <a:endParaRPr lang="en-US" sz="1000" dirty="0"/>
+            <a:endParaRPr lang="en-US" sz="950" dirty="0"/>
           </a:p>
         </p:txBody>
       </p:sp>
@@ -8233,8 +8233,8 @@
         </p:nvSpPr>
         <p:spPr>
           <a:xfrm>
-            <a:off x="7589520" y="4718304"/>
-            <a:ext cx="1097280" cy="384048"/>
+            <a:off x="7589520" y="4736592"/>
+            <a:ext cx="1097280" cy="329184"/>
           </a:xfrm>
           <a:prstGeom prst="rect">
             <a:avLst/>
@@ -8250,7 +8250,7 @@
               <a:buNone/>
             </a:pPr>
             <a:r>
-              <a:rPr lang="en-US" sz="1100" b="1" dirty="0">
+              <a:rPr lang="en-US" sz="1050" b="1" dirty="0">
                 <a:solidFill>
                   <a:srgbClr val="1E40AF"/>
                 </a:solidFill>
@@ -8260,7 +8260,7 @@
               </a:rPr>
               <a:t>16 / 22</a:t>
             </a:r>
-            <a:endParaRPr lang="en-US" sz="1100" dirty="0"/>
+            <a:endParaRPr lang="en-US" sz="1050" dirty="0"/>
           </a:p>
         </p:txBody>
       </p:sp>
@@ -8463,8 +8463,8 @@
         </p:nvSpPr>
         <p:spPr>
           <a:xfrm>
-            <a:off x="457200" y="1051560"/>
-            <a:ext cx="4023360" cy="3383280"/>
+            <a:off x="457200" y="1078992"/>
+            <a:ext cx="4023360" cy="3246120"/>
           </a:xfrm>
           <a:prstGeom prst="rect">
             <a:avLst/>
@@ -8481,12 +8481,12 @@
                 <a:spcPct val="95000"/>
               </a:lnSpc>
               <a:spcAft>
-                <a:spcPts val="200"/>
+                <a:spcPts val="150"/>
               </a:spcAft>
               <a:buNone/>
             </a:pPr>
             <a:r>
-              <a:rPr lang="en-US" sz="1050" b="1" dirty="0">
+              <a:rPr lang="en-US" sz="1000" b="1" dirty="0">
                 <a:solidFill>
                   <a:srgbClr val="1E40AF"/>
                 </a:solidFill>
@@ -8496,7 +8496,7 @@
               </a:rPr>
               <a:t>NGUỒN DỮ LIỆU</a:t>
             </a:r>
-            <a:endParaRPr lang="en-US" sz="1050" dirty="0"/>
+            <a:endParaRPr lang="en-US" sz="1000" dirty="0"/>
           </a:p>
           <a:p>
             <a:pPr indent="0" marL="0">
@@ -8504,12 +8504,12 @@
                 <a:spcPct val="95000"/>
               </a:lnSpc>
               <a:spcAft>
-                <a:spcPts val="250"/>
+                <a:spcPts val="150"/>
               </a:spcAft>
               <a:buNone/>
             </a:pPr>
             <a:r>
-              <a:rPr lang="en-US" sz="1000" b="1" dirty="0">
+              <a:rPr lang="en-US" sz="950" b="1" dirty="0">
                 <a:solidFill>
                   <a:srgbClr val="1E40AF"/>
                 </a:solidFill>
@@ -8524,12 +8524,12 @@
                 <a:spcPct val="95000"/>
               </a:lnSpc>
               <a:spcAft>
-                <a:spcPts val="250"/>
+                <a:spcPts val="150"/>
               </a:spcAft>
               <a:buNone/>
             </a:pPr>
             <a:r>
-              <a:rPr lang="en-US" sz="1000" dirty="0">
+              <a:rPr lang="en-US" sz="950" dirty="0">
                 <a:solidFill>
                   <a:srgbClr val="1F2937"/>
                 </a:solidFill>
@@ -8539,7 +8539,7 @@
               </a:rPr>
               <a:t>N. T. T. Tran et al., “Vietnamese SMS Dataset with Quality Assurance,” IEEE Access, 2026 (theo trích dẫn của tác giả; chưa có tập/DOI). GitHub: trannguyenthaituan251209/vietnamese_sms_dataset.</a:t>
             </a:r>
-            <a:endParaRPr lang="en-US" sz="1050" dirty="0"/>
+            <a:endParaRPr lang="en-US" sz="1000" dirty="0"/>
           </a:p>
           <a:p>
             <a:pPr indent="0" marL="0">
@@ -8547,12 +8547,12 @@
                 <a:spcPct val="95000"/>
               </a:lnSpc>
               <a:spcAft>
-                <a:spcPts val="250"/>
+                <a:spcPts val="150"/>
               </a:spcAft>
               <a:buNone/>
             </a:pPr>
             <a:r>
-              <a:rPr lang="en-US" sz="1000" b="1" dirty="0">
+              <a:rPr lang="en-US" sz="950" b="1" dirty="0">
                 <a:solidFill>
                   <a:srgbClr val="1E40AF"/>
                 </a:solidFill>
@@ -8567,12 +8567,12 @@
                 <a:spcPct val="95000"/>
               </a:lnSpc>
               <a:spcAft>
-                <a:spcPts val="250"/>
+                <a:spcPts val="150"/>
               </a:spcAft>
               <a:buNone/>
             </a:pPr>
             <a:r>
-              <a:rPr lang="en-US" sz="1000" dirty="0">
+              <a:rPr lang="en-US" sz="950" dirty="0">
                 <a:solidFill>
                   <a:srgbClr val="1F2937"/>
                 </a:solidFill>
@@ -8582,7 +8582,7 @@
               </a:rPr>
               <a:t>Nguồn bổ sung của tập lừa đảo (249/420 mẫu): GitHub ghitatruongle/lachancuocgoi, duynguyenhoang22/SMS_Phishing_Detection và ViSmish_Detection; báo chí, VTV24 (13 mẫu).</a:t>
             </a:r>
-            <a:endParaRPr lang="en-US" sz="1050" dirty="0"/>
+            <a:endParaRPr lang="en-US" sz="1000" dirty="0"/>
           </a:p>
           <a:p>
             <a:pPr indent="0" marL="0">
@@ -8590,15 +8590,15 @@
                 <a:spcPct val="95000"/>
               </a:lnSpc>
               <a:spcBef>
-                <a:spcPts val="500"/>
+                <a:spcPts val="300"/>
               </a:spcBef>
               <a:spcAft>
-                <a:spcPts val="200"/>
+                <a:spcPts val="150"/>
               </a:spcAft>
               <a:buNone/>
             </a:pPr>
             <a:r>
-              <a:rPr lang="en-US" sz="1050" b="1" dirty="0">
+              <a:rPr lang="en-US" sz="1000" b="1" dirty="0">
                 <a:solidFill>
                   <a:srgbClr val="1E40AF"/>
                 </a:solidFill>
@@ -8608,7 +8608,7 @@
               </a:rPr>
               <a:t>TIỀN XỬ LÝ NLP</a:t>
             </a:r>
-            <a:endParaRPr lang="en-US" sz="1050" dirty="0"/>
+            <a:endParaRPr lang="en-US" sz="1000" dirty="0"/>
           </a:p>
           <a:p>
             <a:pPr indent="0" marL="0">
@@ -8616,12 +8616,12 @@
                 <a:spcPct val="95000"/>
               </a:lnSpc>
               <a:spcAft>
-                <a:spcPts val="250"/>
+                <a:spcPts val="150"/>
               </a:spcAft>
               <a:buNone/>
             </a:pPr>
             <a:r>
-              <a:rPr lang="en-US" sz="1000" b="1" dirty="0">
+              <a:rPr lang="en-US" sz="950" b="1" dirty="0">
                 <a:solidFill>
                   <a:srgbClr val="1E40AF"/>
                 </a:solidFill>
@@ -8636,12 +8636,12 @@
                 <a:spcPct val="95000"/>
               </a:lnSpc>
               <a:spcAft>
-                <a:spcPts val="250"/>
+                <a:spcPts val="150"/>
               </a:spcAft>
               <a:buNone/>
             </a:pPr>
             <a:r>
-              <a:rPr lang="en-US" sz="1000" dirty="0">
+              <a:rPr lang="en-US" sz="950" dirty="0">
                 <a:solidFill>
                   <a:srgbClr val="1F2937"/>
                 </a:solidFill>
@@ -8651,7 +8651,7 @@
               </a:rPr>
               <a:t>Unicode Consortium, “UAX #15: Unicode Normalization Forms,” Unicode 18.0.0, 12 Aug. 2026.</a:t>
             </a:r>
-            <a:endParaRPr lang="en-US" sz="1050" dirty="0"/>
+            <a:endParaRPr lang="en-US" sz="1000" dirty="0"/>
           </a:p>
           <a:p>
             <a:pPr indent="0" marL="0">
@@ -8659,12 +8659,12 @@
                 <a:spcPct val="95000"/>
               </a:lnSpc>
               <a:spcAft>
-                <a:spcPts val="250"/>
+                <a:spcPts val="150"/>
               </a:spcAft>
               <a:buNone/>
             </a:pPr>
             <a:r>
-              <a:rPr lang="en-US" sz="1000" b="1" dirty="0">
+              <a:rPr lang="en-US" sz="950" b="1" dirty="0">
                 <a:solidFill>
                   <a:srgbClr val="1E40AF"/>
                 </a:solidFill>
@@ -8679,12 +8679,12 @@
                 <a:spcPct val="95000"/>
               </a:lnSpc>
               <a:spcAft>
-                <a:spcPts val="250"/>
+                <a:spcPts val="150"/>
               </a:spcAft>
               <a:buNone/>
             </a:pPr>
             <a:r>
-              <a:rPr lang="en-US" sz="1000" dirty="0">
+              <a:rPr lang="en-US" sz="950" dirty="0">
                 <a:solidFill>
                   <a:srgbClr val="1F2937"/>
                 </a:solidFill>
@@ -8694,7 +8694,7 @@
               </a:rPr>
               <a:t>V.-T. Tran, “PyVi: Python Vietnamese Toolkit,” v0.1.1. GitHub: trungtv/pyvi.</a:t>
             </a:r>
-            <a:endParaRPr lang="en-US" sz="1050" dirty="0"/>
+            <a:endParaRPr lang="en-US" sz="1000" dirty="0"/>
           </a:p>
           <a:p>
             <a:pPr indent="0" marL="0">
@@ -8702,12 +8702,12 @@
                 <a:spcPct val="95000"/>
               </a:lnSpc>
               <a:spcAft>
-                <a:spcPts val="250"/>
+                <a:spcPts val="150"/>
               </a:spcAft>
               <a:buNone/>
             </a:pPr>
             <a:r>
-              <a:rPr lang="en-US" sz="1000" b="1" dirty="0">
+              <a:rPr lang="en-US" sz="950" b="1" dirty="0">
                 <a:solidFill>
                   <a:srgbClr val="1E40AF"/>
                 </a:solidFill>
@@ -8722,12 +8722,12 @@
                 <a:spcPct val="95000"/>
               </a:lnSpc>
               <a:spcAft>
-                <a:spcPts val="250"/>
+                <a:spcPts val="150"/>
               </a:spcAft>
               <a:buNone/>
             </a:pPr>
             <a:r>
-              <a:rPr lang="en-US" sz="1000" dirty="0">
+              <a:rPr lang="en-US" sz="950" dirty="0">
                 <a:solidFill>
                   <a:srgbClr val="1F2937"/>
                 </a:solidFill>
@@ -8737,7 +8737,7 @@
               </a:rPr>
               <a:t>Underthesea NLP, “underthesea: Vietnamese NLP Toolkit,” v9.5.0. GitHub: undertheseanlp/underthesea.</a:t>
             </a:r>
-            <a:endParaRPr lang="en-US" sz="1050" dirty="0"/>
+            <a:endParaRPr lang="en-US" sz="1000" dirty="0"/>
           </a:p>
           <a:p>
             <a:pPr indent="0" marL="0">
@@ -8745,12 +8745,12 @@
                 <a:spcPct val="95000"/>
               </a:lnSpc>
               <a:spcAft>
-                <a:spcPts val="250"/>
+                <a:spcPts val="150"/>
               </a:spcAft>
               <a:buNone/>
             </a:pPr>
             <a:r>
-              <a:rPr lang="en-US" sz="1000" b="1" dirty="0">
+              <a:rPr lang="en-US" sz="950" b="1" dirty="0">
                 <a:solidFill>
                   <a:srgbClr val="1E40AF"/>
                 </a:solidFill>
@@ -8765,12 +8765,12 @@
                 <a:spcPct val="95000"/>
               </a:lnSpc>
               <a:spcAft>
-                <a:spcPts val="250"/>
+                <a:spcPts val="150"/>
               </a:spcAft>
               <a:buNone/>
             </a:pPr>
             <a:r>
-              <a:rPr lang="en-US" sz="1000" dirty="0">
+              <a:rPr lang="en-US" sz="950" dirty="0">
                 <a:solidFill>
                   <a:srgbClr val="1F2937"/>
                 </a:solidFill>
@@ -8780,7 +8780,7 @@
               </a:rPr>
               <a:t>G. Salton and C. Buckley, “Term-weighting approaches in automatic text retrieval,” Inf. Process. Manage., 24(5):513–523, 1988.</a:t>
             </a:r>
-            <a:endParaRPr lang="en-US" sz="1050" dirty="0"/>
+            <a:endParaRPr lang="en-US" sz="1000" dirty="0"/>
           </a:p>
           <a:p>
             <a:pPr indent="0" marL="0">
@@ -8788,15 +8788,15 @@
                 <a:spcPct val="95000"/>
               </a:lnSpc>
               <a:spcBef>
-                <a:spcPts val="500"/>
+                <a:spcPts val="300"/>
               </a:spcBef>
               <a:spcAft>
-                <a:spcPts val="200"/>
+                <a:spcPts val="150"/>
               </a:spcAft>
               <a:buNone/>
             </a:pPr>
             <a:r>
-              <a:rPr lang="en-US" sz="1050" b="1" dirty="0">
+              <a:rPr lang="en-US" sz="1000" b="1" dirty="0">
                 <a:solidFill>
                   <a:srgbClr val="1E40AF"/>
                 </a:solidFill>
@@ -8806,7 +8806,7 @@
               </a:rPr>
               <a:t>THUẬT TOÁN HỌC MÁY</a:t>
             </a:r>
-            <a:endParaRPr lang="en-US" sz="1050" dirty="0"/>
+            <a:endParaRPr lang="en-US" sz="1000" dirty="0"/>
           </a:p>
           <a:p>
             <a:pPr indent="0" marL="0">
@@ -8814,12 +8814,12 @@
                 <a:spcPct val="95000"/>
               </a:lnSpc>
               <a:spcAft>
-                <a:spcPts val="250"/>
+                <a:spcPts val="150"/>
               </a:spcAft>
               <a:buNone/>
             </a:pPr>
             <a:r>
-              <a:rPr lang="en-US" sz="1000" b="1" dirty="0">
+              <a:rPr lang="en-US" sz="950" b="1" dirty="0">
                 <a:solidFill>
                   <a:srgbClr val="1E40AF"/>
                 </a:solidFill>
@@ -8834,12 +8834,12 @@
                 <a:spcPct val="95000"/>
               </a:lnSpc>
               <a:spcAft>
-                <a:spcPts val="250"/>
+                <a:spcPts val="150"/>
               </a:spcAft>
               <a:buNone/>
             </a:pPr>
             <a:r>
-              <a:rPr lang="en-US" sz="1000" dirty="0">
+              <a:rPr lang="en-US" sz="950" dirty="0">
                 <a:solidFill>
                   <a:srgbClr val="1F2937"/>
                 </a:solidFill>
@@ -8849,7 +8849,7 @@
               </a:rPr>
               <a:t>T. Chen and C. Guestrin, “XGBoost: A scalable tree boosting system,” KDD 2016, pp. 785–794.</a:t>
             </a:r>
-            <a:endParaRPr lang="en-US" sz="1050" dirty="0"/>
+            <a:endParaRPr lang="en-US" sz="1000" dirty="0"/>
           </a:p>
           <a:p>
             <a:pPr indent="0" marL="0">
@@ -8857,12 +8857,12 @@
                 <a:spcPct val="95000"/>
               </a:lnSpc>
               <a:spcAft>
-                <a:spcPts val="250"/>
+                <a:spcPts val="150"/>
               </a:spcAft>
               <a:buNone/>
             </a:pPr>
             <a:r>
-              <a:rPr lang="en-US" sz="1000" b="1" dirty="0">
+              <a:rPr lang="en-US" sz="950" b="1" dirty="0">
                 <a:solidFill>
                   <a:srgbClr val="1E40AF"/>
                 </a:solidFill>
@@ -8877,12 +8877,12 @@
                 <a:spcPct val="95000"/>
               </a:lnSpc>
               <a:spcAft>
-                <a:spcPts val="250"/>
+                <a:spcPts val="150"/>
               </a:spcAft>
               <a:buNone/>
             </a:pPr>
             <a:r>
-              <a:rPr lang="en-US" sz="1000" dirty="0">
+              <a:rPr lang="en-US" sz="950" dirty="0">
                 <a:solidFill>
                   <a:srgbClr val="1F2937"/>
                 </a:solidFill>
@@ -8892,7 +8892,7 @@
               </a:rPr>
               <a:t>L. Breiman, “Random forests,” Mach. Learn., 45(1):5–32, 2001.</a:t>
             </a:r>
-            <a:endParaRPr lang="en-US" sz="1050" dirty="0"/>
+            <a:endParaRPr lang="en-US" sz="1000" dirty="0"/>
           </a:p>
         </p:txBody>
       </p:sp>
@@ -8904,8 +8904,8 @@
         </p:nvSpPr>
         <p:spPr>
           <a:xfrm>
-            <a:off x="4663440" y="1051560"/>
-            <a:ext cx="4023360" cy="3383280"/>
+            <a:off x="4663440" y="1078992"/>
+            <a:ext cx="4023360" cy="3246120"/>
           </a:xfrm>
           <a:prstGeom prst="rect">
             <a:avLst/>
@@ -8922,12 +8922,12 @@
                 <a:spcPct val="95000"/>
               </a:lnSpc>
               <a:spcAft>
-                <a:spcPts val="200"/>
+                <a:spcPts val="150"/>
               </a:spcAft>
               <a:buNone/>
             </a:pPr>
             <a:r>
-              <a:rPr lang="en-US" sz="1050" b="1" dirty="0">
+              <a:rPr lang="en-US" sz="1000" b="1" dirty="0">
                 <a:solidFill>
                   <a:srgbClr val="1E40AF"/>
                 </a:solidFill>
@@ -8937,7 +8937,7 @@
               </a:rPr>
               <a:t>THUẬT TOÁN HỌC MÁY (TIẾP)</a:t>
             </a:r>
-            <a:endParaRPr lang="en-US" sz="1050" dirty="0"/>
+            <a:endParaRPr lang="en-US" sz="1000" dirty="0"/>
           </a:p>
           <a:p>
             <a:pPr indent="0" marL="0">
@@ -8945,12 +8945,12 @@
                 <a:spcPct val="95000"/>
               </a:lnSpc>
               <a:spcAft>
-                <a:spcPts val="250"/>
+                <a:spcPts val="150"/>
               </a:spcAft>
               <a:buNone/>
             </a:pPr>
             <a:r>
-              <a:rPr lang="en-US" sz="1000" b="1" dirty="0">
+              <a:rPr lang="en-US" sz="950" b="1" dirty="0">
                 <a:solidFill>
                   <a:srgbClr val="1E40AF"/>
                 </a:solidFill>
@@ -8965,12 +8965,12 @@
                 <a:spcPct val="95000"/>
               </a:lnSpc>
               <a:spcAft>
-                <a:spcPts val="250"/>
+                <a:spcPts val="150"/>
               </a:spcAft>
               <a:buNone/>
             </a:pPr>
             <a:r>
-              <a:rPr lang="en-US" sz="1000" dirty="0">
+              <a:rPr lang="en-US" sz="950" dirty="0">
                 <a:solidFill>
                   <a:srgbClr val="1F2937"/>
                 </a:solidFill>
@@ -8980,7 +8980,7 @@
               </a:rPr>
               <a:t>C. Cortes and V. Vapnik, “Support-vector networks,” Mach. Learn., 20(3):273–297, 1995.</a:t>
             </a:r>
-            <a:endParaRPr lang="en-US" sz="1050" dirty="0"/>
+            <a:endParaRPr lang="en-US" sz="1000" dirty="0"/>
           </a:p>
           <a:p>
             <a:pPr indent="0" marL="0">
@@ -8988,12 +8988,12 @@
                 <a:spcPct val="95000"/>
               </a:lnSpc>
               <a:spcAft>
-                <a:spcPts val="250"/>
+                <a:spcPts val="150"/>
               </a:spcAft>
               <a:buNone/>
             </a:pPr>
             <a:r>
-              <a:rPr lang="en-US" sz="1000" b="1" dirty="0">
+              <a:rPr lang="en-US" sz="950" b="1" dirty="0">
                 <a:solidFill>
                   <a:srgbClr val="1E40AF"/>
                 </a:solidFill>
@@ -9008,12 +9008,12 @@
                 <a:spcPct val="95000"/>
               </a:lnSpc>
               <a:spcAft>
-                <a:spcPts val="250"/>
+                <a:spcPts val="150"/>
               </a:spcAft>
               <a:buNone/>
             </a:pPr>
             <a:r>
-              <a:rPr lang="en-US" sz="1000" dirty="0">
+              <a:rPr lang="en-US" sz="950" dirty="0">
                 <a:solidFill>
                   <a:srgbClr val="1F2937"/>
                 </a:solidFill>
@@ -9023,7 +9023,7 @@
               </a:rPr>
               <a:t>J. Platt, “Probabilities for SV machines,” in Advances in Large-Margin Classifiers, MIT Press, 2000, pp. 61–74.</a:t>
             </a:r>
-            <a:endParaRPr lang="en-US" sz="1050" dirty="0"/>
+            <a:endParaRPr lang="en-US" sz="1000" dirty="0"/>
           </a:p>
           <a:p>
             <a:pPr indent="0" marL="0">
@@ -9031,12 +9031,12 @@
                 <a:spcPct val="95000"/>
               </a:lnSpc>
               <a:spcAft>
-                <a:spcPts val="250"/>
+                <a:spcPts val="150"/>
               </a:spcAft>
               <a:buNone/>
             </a:pPr>
             <a:r>
-              <a:rPr lang="en-US" sz="1000" b="1" dirty="0">
+              <a:rPr lang="en-US" sz="950" b="1" dirty="0">
                 <a:solidFill>
                   <a:srgbClr val="1E40AF"/>
                 </a:solidFill>
@@ -9051,12 +9051,12 @@
                 <a:spcPct val="95000"/>
               </a:lnSpc>
               <a:spcAft>
-                <a:spcPts val="250"/>
+                <a:spcPts val="150"/>
               </a:spcAft>
               <a:buNone/>
             </a:pPr>
             <a:r>
-              <a:rPr lang="en-US" sz="1000" dirty="0">
+              <a:rPr lang="en-US" sz="950" dirty="0">
                 <a:solidFill>
                   <a:srgbClr val="1F2937"/>
                 </a:solidFill>
@@ -9066,7 +9066,7 @@
               </a:rPr>
               <a:t>F. Pedregosa et al., “Scikit-learn: Machine learning in Python,” JMLR 12:2825–2830, 2011.</a:t>
             </a:r>
-            <a:endParaRPr lang="en-US" sz="1050" dirty="0"/>
+            <a:endParaRPr lang="en-US" sz="1000" dirty="0"/>
           </a:p>
           <a:p>
             <a:pPr indent="0" marL="0">
@@ -9074,15 +9074,15 @@
                 <a:spcPct val="95000"/>
               </a:lnSpc>
               <a:spcBef>
-                <a:spcPts val="500"/>
+                <a:spcPts val="300"/>
               </a:spcBef>
               <a:spcAft>
-                <a:spcPts val="200"/>
+                <a:spcPts val="150"/>
               </a:spcAft>
               <a:buNone/>
             </a:pPr>
             <a:r>
-              <a:rPr lang="en-US" sz="1050" b="1" dirty="0">
+              <a:rPr lang="en-US" sz="1000" b="1" dirty="0">
                 <a:solidFill>
                   <a:srgbClr val="1E40AF"/>
                 </a:solidFill>
@@ -9092,7 +9092,7 @@
               </a:rPr>
               <a:t>GIẢI THÍCH MÔ HÌNH (XAI)</a:t>
             </a:r>
-            <a:endParaRPr lang="en-US" sz="1050" dirty="0"/>
+            <a:endParaRPr lang="en-US" sz="1000" dirty="0"/>
           </a:p>
           <a:p>
             <a:pPr indent="0" marL="0">
@@ -9100,12 +9100,12 @@
                 <a:spcPct val="95000"/>
               </a:lnSpc>
               <a:spcAft>
-                <a:spcPts val="250"/>
+                <a:spcPts val="150"/>
               </a:spcAft>
               <a:buNone/>
             </a:pPr>
             <a:r>
-              <a:rPr lang="en-US" sz="1000" b="1" dirty="0">
+              <a:rPr lang="en-US" sz="950" b="1" dirty="0">
                 <a:solidFill>
                   <a:srgbClr val="1E40AF"/>
                 </a:solidFill>
@@ -9120,12 +9120,12 @@
                 <a:spcPct val="95000"/>
               </a:lnSpc>
               <a:spcAft>
-                <a:spcPts val="250"/>
+                <a:spcPts val="150"/>
               </a:spcAft>
               <a:buNone/>
             </a:pPr>
             <a:r>
-              <a:rPr lang="en-US" sz="1000" dirty="0">
+              <a:rPr lang="en-US" sz="950" dirty="0">
                 <a:solidFill>
                   <a:srgbClr val="1F2937"/>
                 </a:solidFill>
@@ -9135,7 +9135,7 @@
               </a:rPr>
               <a:t>S. M. Lundberg and S.-I. Lee, “A unified approach to interpreting model predictions,” NeurIPS 30, 2017.</a:t>
             </a:r>
-            <a:endParaRPr lang="en-US" sz="1050" dirty="0"/>
+            <a:endParaRPr lang="en-US" sz="1000" dirty="0"/>
           </a:p>
           <a:p>
             <a:pPr indent="0" marL="0">
@@ -9143,12 +9143,12 @@
                 <a:spcPct val="95000"/>
               </a:lnSpc>
               <a:spcAft>
-                <a:spcPts val="250"/>
+                <a:spcPts val="150"/>
               </a:spcAft>
               <a:buNone/>
             </a:pPr>
             <a:r>
-              <a:rPr lang="en-US" sz="1000" b="1" dirty="0">
+              <a:rPr lang="en-US" sz="950" b="1" dirty="0">
                 <a:solidFill>
                   <a:srgbClr val="1E40AF"/>
                 </a:solidFill>
@@ -9163,12 +9163,12 @@
                 <a:spcPct val="95000"/>
               </a:lnSpc>
               <a:spcAft>
-                <a:spcPts val="250"/>
+                <a:spcPts val="150"/>
               </a:spcAft>
               <a:buNone/>
             </a:pPr>
             <a:r>
-              <a:rPr lang="en-US" sz="1000" dirty="0">
+              <a:rPr lang="en-US" sz="950" dirty="0">
                 <a:solidFill>
                   <a:srgbClr val="1F2937"/>
                 </a:solidFill>
@@ -9178,7 +9178,7 @@
               </a:rPr>
               <a:t>S. M. Lundberg et al., “From local explanations to global understanding with explainable AI for trees,” Nat. Mach. Intell., 2(1):56–67, 2020.</a:t>
             </a:r>
-            <a:endParaRPr lang="en-US" sz="1050" dirty="0"/>
+            <a:endParaRPr lang="en-US" sz="1000" dirty="0"/>
           </a:p>
           <a:p>
             <a:pPr indent="0" marL="0">
@@ -9186,15 +9186,15 @@
                 <a:spcPct val="95000"/>
               </a:lnSpc>
               <a:spcBef>
-                <a:spcPts val="500"/>
+                <a:spcPts val="300"/>
               </a:spcBef>
               <a:spcAft>
-                <a:spcPts val="200"/>
+                <a:spcPts val="150"/>
               </a:spcAft>
               <a:buNone/>
             </a:pPr>
             <a:r>
-              <a:rPr lang="en-US" sz="1050" b="1" dirty="0">
+              <a:rPr lang="en-US" sz="1000" b="1" dirty="0">
                 <a:solidFill>
                   <a:srgbClr val="1E40AF"/>
                 </a:solidFill>
@@ -9204,7 +9204,7 @@
               </a:rPr>
               <a:t>TRỢ NĂNG WEB</a:t>
             </a:r>
-            <a:endParaRPr lang="en-US" sz="1050" dirty="0"/>
+            <a:endParaRPr lang="en-US" sz="1000" dirty="0"/>
           </a:p>
           <a:p>
             <a:pPr indent="0" marL="0">
@@ -9212,12 +9212,12 @@
                 <a:spcPct val="95000"/>
               </a:lnSpc>
               <a:spcAft>
-                <a:spcPts val="250"/>
+                <a:spcPts val="150"/>
               </a:spcAft>
               <a:buNone/>
             </a:pPr>
             <a:r>
-              <a:rPr lang="en-US" sz="1000" b="1" dirty="0">
+              <a:rPr lang="en-US" sz="950" b="1" dirty="0">
                 <a:solidFill>
                   <a:srgbClr val="1E40AF"/>
                 </a:solidFill>
@@ -9232,12 +9232,12 @@
                 <a:spcPct val="95000"/>
               </a:lnSpc>
               <a:spcAft>
-                <a:spcPts val="250"/>
+                <a:spcPts val="150"/>
               </a:spcAft>
               <a:buNone/>
             </a:pPr>
             <a:r>
-              <a:rPr lang="en-US" sz="1000" dirty="0">
+              <a:rPr lang="en-US" sz="950" dirty="0">
                 <a:solidFill>
                   <a:srgbClr val="1F2937"/>
                 </a:solidFill>
@@ -9247,7 +9247,7 @@
               </a:rPr>
               <a:t>W3C, “Web Content Accessibility Guidelines (WCAG) 2.1,” Recommendation, 5 Jun. 2018 (updated 6 May 2025).</a:t>
             </a:r>
-            <a:endParaRPr lang="en-US" sz="1050" dirty="0"/>
+            <a:endParaRPr lang="en-US" sz="1000" dirty="0"/>
           </a:p>
           <a:p>
             <a:pPr indent="0" marL="0">
@@ -9255,15 +9255,15 @@
                 <a:spcPct val="95000"/>
               </a:lnSpc>
               <a:spcBef>
-                <a:spcPts val="500"/>
+                <a:spcPts val="300"/>
               </a:spcBef>
               <a:spcAft>
-                <a:spcPts val="200"/>
+                <a:spcPts val="150"/>
               </a:spcAft>
               <a:buNone/>
             </a:pPr>
             <a:r>
-              <a:rPr lang="en-US" sz="1050" b="1" dirty="0">
+              <a:rPr lang="en-US" sz="1000" b="1" dirty="0">
                 <a:solidFill>
                   <a:srgbClr val="1E40AF"/>
                 </a:solidFill>
@@ -9273,7 +9273,7 @@
               </a:rPr>
               <a:t>HƯỚNG PHÁT TRIỂN</a:t>
             </a:r>
-            <a:endParaRPr lang="en-US" sz="1050" dirty="0"/>
+            <a:endParaRPr lang="en-US" sz="1000" dirty="0"/>
           </a:p>
           <a:p>
             <a:pPr indent="0" marL="0">
@@ -9281,12 +9281,12 @@
                 <a:spcPct val="95000"/>
               </a:lnSpc>
               <a:spcAft>
-                <a:spcPts val="250"/>
+                <a:spcPts val="150"/>
               </a:spcAft>
               <a:buNone/>
             </a:pPr>
             <a:r>
-              <a:rPr lang="en-US" sz="1000" b="1" dirty="0">
+              <a:rPr lang="en-US" sz="950" b="1" dirty="0">
                 <a:solidFill>
                   <a:srgbClr val="1E40AF"/>
                 </a:solidFill>
@@ -9301,12 +9301,12 @@
                 <a:spcPct val="95000"/>
               </a:lnSpc>
               <a:spcAft>
-                <a:spcPts val="250"/>
+                <a:spcPts val="150"/>
               </a:spcAft>
               <a:buNone/>
             </a:pPr>
             <a:r>
-              <a:rPr lang="en-US" sz="1000" dirty="0">
+              <a:rPr lang="en-US" sz="950" dirty="0">
                 <a:solidFill>
                   <a:srgbClr val="1F2937"/>
                 </a:solidFill>
@@ -9316,7 +9316,7 @@
               </a:rPr>
               <a:t>D. Q. Nguyen and A. T. Nguyen, “PhoBERT: Pre-trained language models for Vietnamese,” Findings of EMNLP, 2020, pp. 1037–1042.</a:t>
             </a:r>
-            <a:endParaRPr lang="en-US" sz="1050" dirty="0"/>
+            <a:endParaRPr lang="en-US" sz="1000" dirty="0"/>
           </a:p>
         </p:txBody>
       </p:sp>
@@ -9328,7 +9328,7 @@
         </p:nvSpPr>
         <p:spPr>
           <a:xfrm>
-            <a:off x="457200" y="4480560"/>
+            <a:off x="457200" y="4389120"/>
             <a:ext cx="8229600" cy="201168"/>
           </a:xfrm>
           <a:prstGeom prst="rect">
@@ -9369,8 +9369,8 @@
         </p:nvSpPr>
         <p:spPr>
           <a:xfrm>
-            <a:off x="457200" y="4718304"/>
-            <a:ext cx="7040880" cy="384048"/>
+            <a:off x="457200" y="4736592"/>
+            <a:ext cx="7040880" cy="329184"/>
           </a:xfrm>
           <a:prstGeom prst="rect">
             <a:avLst/>
@@ -9386,7 +9386,7 @@
               <a:buNone/>
             </a:pPr>
             <a:r>
-              <a:rPr lang="en-US" sz="1000" dirty="0">
+              <a:rPr lang="en-US" sz="950" dirty="0">
                 <a:solidFill>
                   <a:srgbClr val="6B7280"/>
                 </a:solidFill>
@@ -9396,14 +9396,14 @@
               </a:rPr>
               <a:t>CS114: Máy học — Nhóm 10 — Báo cáo Đồ án:</a:t>
             </a:r>
-            <a:endParaRPr lang="en-US" sz="1000" dirty="0"/>
+            <a:endParaRPr lang="en-US" sz="950" dirty="0"/>
           </a:p>
           <a:p>
             <a:pPr indent="0" marL="0">
               <a:buNone/>
             </a:pPr>
             <a:r>
-              <a:rPr lang="en-US" sz="1000" dirty="0">
+              <a:rPr lang="en-US" sz="950" dirty="0">
                 <a:solidFill>
                   <a:srgbClr val="6B7280"/>
                 </a:solidFill>
@@ -9413,7 +9413,7 @@
               </a:rPr>
               <a:t>Phát hiện Tin nhắn &amp; Kịch bản Thao túng Tâm lý Lừa đảo nhắm vào Người cao tuổi tại Việt Nam</a:t>
             </a:r>
-            <a:endParaRPr lang="en-US" sz="1000" dirty="0"/>
+            <a:endParaRPr lang="en-US" sz="950" dirty="0"/>
           </a:p>
         </p:txBody>
       </p:sp>
@@ -9425,8 +9425,8 @@
         </p:nvSpPr>
         <p:spPr>
           <a:xfrm>
-            <a:off x="7589520" y="4718304"/>
-            <a:ext cx="1097280" cy="384048"/>
+            <a:off x="7589520" y="4736592"/>
+            <a:ext cx="1097280" cy="329184"/>
           </a:xfrm>
           <a:prstGeom prst="rect">
             <a:avLst/>
@@ -9442,7 +9442,7 @@
               <a:buNone/>
             </a:pPr>
             <a:r>
-              <a:rPr lang="en-US" sz="1100" b="1" dirty="0">
+              <a:rPr lang="en-US" sz="1050" b="1" dirty="0">
                 <a:solidFill>
                   <a:srgbClr val="1E40AF"/>
                 </a:solidFill>
@@ -9452,7 +9452,7 @@
               </a:rPr>
               <a:t>17 / 22</a:t>
             </a:r>
-            <a:endParaRPr lang="en-US" sz="1100" dirty="0"/>
+            <a:endParaRPr lang="en-US" sz="1050" dirty="0"/>
           </a:p>
         </p:txBody>
       </p:sp>
@@ -9490,7 +9490,7 @@
       </p:grpSpPr>
       <p:pic>
         <p:nvPicPr>
-          <p:cNvPr id="2" name="Image 0" descr="C:\Users\ADMIN\OneDrive\Documents\MÁY HỌC\ĐỒ ÁN MÔN MÁY HỌC\CS114-Team10-Elderly-Scam-Detection\draft\scam-detection\reports\slides\assets\logo_uit_dhqg_trang.png">    </p:cNvPr>
+          <p:cNvPr id="2" name="Image 0" descr="/Users/tcdtist/dev/uit/cs114/assignments/Final/draft/scam-detection/reports/slides/assets/logo_uit_dhqg_trang.png">    </p:cNvPr>
           <p:cNvPicPr>
             <a:picLocks noChangeAspect="1"/>
           </p:cNvPicPr>
@@ -11226,8 +11226,8 @@
         </p:nvSpPr>
         <p:spPr>
           <a:xfrm>
-            <a:off x="457200" y="4718304"/>
-            <a:ext cx="7040880" cy="384048"/>
+            <a:off x="457200" y="4736592"/>
+            <a:ext cx="7040880" cy="329184"/>
           </a:xfrm>
           <a:prstGeom prst="rect">
             <a:avLst/>
@@ -11243,7 +11243,7 @@
               <a:buNone/>
             </a:pPr>
             <a:r>
-              <a:rPr lang="en-US" sz="1000" dirty="0">
+              <a:rPr lang="en-US" sz="950" dirty="0">
                 <a:solidFill>
                   <a:srgbClr val="6B7280"/>
                 </a:solidFill>
@@ -11253,14 +11253,14 @@
               </a:rPr>
               <a:t>CS114: Máy học — Nhóm 10 — Báo cáo Đồ án:</a:t>
             </a:r>
-            <a:endParaRPr lang="en-US" sz="1000" dirty="0"/>
+            <a:endParaRPr lang="en-US" sz="950" dirty="0"/>
           </a:p>
           <a:p>
             <a:pPr indent="0" marL="0">
               <a:buNone/>
             </a:pPr>
             <a:r>
-              <a:rPr lang="en-US" sz="1000" dirty="0">
+              <a:rPr lang="en-US" sz="950" dirty="0">
                 <a:solidFill>
                   <a:srgbClr val="6B7280"/>
                 </a:solidFill>
@@ -11270,7 +11270,7 @@
               </a:rPr>
               <a:t>Phát hiện Tin nhắn &amp; Kịch bản Thao túng Tâm lý Lừa đảo nhắm vào Người cao tuổi tại Việt Nam</a:t>
             </a:r>
-            <a:endParaRPr lang="en-US" sz="1000" dirty="0"/>
+            <a:endParaRPr lang="en-US" sz="950" dirty="0"/>
           </a:p>
         </p:txBody>
       </p:sp>
@@ -11282,8 +11282,8 @@
         </p:nvSpPr>
         <p:spPr>
           <a:xfrm>
-            <a:off x="7589520" y="4718304"/>
-            <a:ext cx="1097280" cy="384048"/>
+            <a:off x="7589520" y="4736592"/>
+            <a:ext cx="1097280" cy="329184"/>
           </a:xfrm>
           <a:prstGeom prst="rect">
             <a:avLst/>
@@ -11299,7 +11299,7 @@
               <a:buNone/>
             </a:pPr>
             <a:r>
-              <a:rPr lang="en-US" sz="1100" b="1" dirty="0">
+              <a:rPr lang="en-US" sz="1050" b="1" dirty="0">
                 <a:solidFill>
                   <a:srgbClr val="1E40AF"/>
                 </a:solidFill>
@@ -11309,7 +11309,7 @@
               </a:rPr>
               <a:t>02 / 22</a:t>
             </a:r>
-            <a:endParaRPr lang="en-US" sz="1100" dirty="0"/>
+            <a:endParaRPr lang="en-US" sz="1050" dirty="0"/>
           </a:p>
         </p:txBody>
       </p:sp>
@@ -12949,8 +12949,8 @@
         </p:nvSpPr>
         <p:spPr>
           <a:xfrm>
-            <a:off x="457200" y="4718304"/>
-            <a:ext cx="7040880" cy="384048"/>
+            <a:off x="457200" y="4736592"/>
+            <a:ext cx="7040880" cy="329184"/>
           </a:xfrm>
           <a:prstGeom prst="rect">
             <a:avLst/>
@@ -12966,7 +12966,7 @@
               <a:buNone/>
             </a:pPr>
             <a:r>
-              <a:rPr lang="en-US" sz="1000" dirty="0">
+              <a:rPr lang="en-US" sz="950" dirty="0">
                 <a:solidFill>
                   <a:srgbClr val="6B7280"/>
                 </a:solidFill>
@@ -12976,14 +12976,14 @@
               </a:rPr>
               <a:t>CS114: Máy học — Nhóm 10 — Báo cáo Đồ án:</a:t>
             </a:r>
-            <a:endParaRPr lang="en-US" sz="1000" dirty="0"/>
+            <a:endParaRPr lang="en-US" sz="950" dirty="0"/>
           </a:p>
           <a:p>
             <a:pPr indent="0" marL="0">
               <a:buNone/>
             </a:pPr>
             <a:r>
-              <a:rPr lang="en-US" sz="1000" dirty="0">
+              <a:rPr lang="en-US" sz="950" dirty="0">
                 <a:solidFill>
                   <a:srgbClr val="6B7280"/>
                 </a:solidFill>
@@ -12993,7 +12993,7 @@
               </a:rPr>
               <a:t>Phát hiện Tin nhắn &amp; Kịch bản Thao túng Tâm lý Lừa đảo nhắm vào Người cao tuổi tại Việt Nam</a:t>
             </a:r>
-            <a:endParaRPr lang="en-US" sz="1000" dirty="0"/>
+            <a:endParaRPr lang="en-US" sz="950" dirty="0"/>
           </a:p>
         </p:txBody>
       </p:sp>
@@ -13005,8 +13005,8 @@
         </p:nvSpPr>
         <p:spPr>
           <a:xfrm>
-            <a:off x="7589520" y="4718304"/>
-            <a:ext cx="1097280" cy="384048"/>
+            <a:off x="7589520" y="4736592"/>
+            <a:ext cx="1097280" cy="329184"/>
           </a:xfrm>
           <a:prstGeom prst="rect">
             <a:avLst/>
@@ -13022,7 +13022,7 @@
               <a:buNone/>
             </a:pPr>
             <a:r>
-              <a:rPr lang="en-US" sz="1100" b="1" dirty="0">
+              <a:rPr lang="en-US" sz="1050" b="1" dirty="0">
                 <a:solidFill>
                   <a:srgbClr val="1E40AF"/>
                 </a:solidFill>
@@ -13032,7 +13032,7 @@
               </a:rPr>
               <a:t>20 / 22</a:t>
             </a:r>
-            <a:endParaRPr lang="en-US" sz="1100" dirty="0"/>
+            <a:endParaRPr lang="en-US" sz="1050" dirty="0"/>
           </a:p>
         </p:txBody>
       </p:sp>
@@ -13229,7 +13229,7 @@
       </p:sp>
       <p:pic>
         <p:nvPicPr>
-          <p:cNvPr id="7" name="Image 0" descr="C:\Users\ADMIN\OneDrive\Documents\MÁY HỌC\ĐỒ ÁN MÔN MÁY HỌC\CS114-Team10-Elderly-Scam-Detection\draft\scam-detection\reports\figures\confusion_matrices_all.png">    </p:cNvPr>
+          <p:cNvPr id="7" name="Image 0" descr="/Users/tcdtist/dev/uit/cs114/assignments/Final/draft/scam-detection/reports/figures/confusion_matrices_all.png">    </p:cNvPr>
           <p:cNvPicPr>
             <a:picLocks noChangeAspect="1"/>
           </p:cNvPicPr>
@@ -14457,8 +14457,8 @@
         </p:nvSpPr>
         <p:spPr>
           <a:xfrm>
-            <a:off x="457200" y="4718304"/>
-            <a:ext cx="7040880" cy="384048"/>
+            <a:off x="457200" y="4736592"/>
+            <a:ext cx="7040880" cy="329184"/>
           </a:xfrm>
           <a:prstGeom prst="rect">
             <a:avLst/>
@@ -14474,7 +14474,7 @@
               <a:buNone/>
             </a:pPr>
             <a:r>
-              <a:rPr lang="en-US" sz="1000" dirty="0">
+              <a:rPr lang="en-US" sz="950" dirty="0">
                 <a:solidFill>
                   <a:srgbClr val="6B7280"/>
                 </a:solidFill>
@@ -14484,14 +14484,14 @@
               </a:rPr>
               <a:t>CS114: Máy học — Nhóm 10 — Báo cáo Đồ án:</a:t>
             </a:r>
-            <a:endParaRPr lang="en-US" sz="1000" dirty="0"/>
+            <a:endParaRPr lang="en-US" sz="950" dirty="0"/>
           </a:p>
           <a:p>
             <a:pPr indent="0" marL="0">
               <a:buNone/>
             </a:pPr>
             <a:r>
-              <a:rPr lang="en-US" sz="1000" dirty="0">
+              <a:rPr lang="en-US" sz="950" dirty="0">
                 <a:solidFill>
                   <a:srgbClr val="6B7280"/>
                 </a:solidFill>
@@ -14501,7 +14501,7 @@
               </a:rPr>
               <a:t>Phát hiện Tin nhắn &amp; Kịch bản Thao túng Tâm lý Lừa đảo nhắm vào Người cao tuổi tại Việt Nam</a:t>
             </a:r>
-            <a:endParaRPr lang="en-US" sz="1000" dirty="0"/>
+            <a:endParaRPr lang="en-US" sz="950" dirty="0"/>
           </a:p>
         </p:txBody>
       </p:sp>
@@ -14513,8 +14513,8 @@
         </p:nvSpPr>
         <p:spPr>
           <a:xfrm>
-            <a:off x="7589520" y="4718304"/>
-            <a:ext cx="1097280" cy="384048"/>
+            <a:off x="7589520" y="4736592"/>
+            <a:ext cx="1097280" cy="329184"/>
           </a:xfrm>
           <a:prstGeom prst="rect">
             <a:avLst/>
@@ -14530,7 +14530,7 @@
               <a:buNone/>
             </a:pPr>
             <a:r>
-              <a:rPr lang="en-US" sz="1100" b="1" dirty="0">
+              <a:rPr lang="en-US" sz="1050" b="1" dirty="0">
                 <a:solidFill>
                   <a:srgbClr val="1E40AF"/>
                 </a:solidFill>
@@ -14540,7 +14540,7 @@
               </a:rPr>
               <a:t>21 / 22</a:t>
             </a:r>
-            <a:endParaRPr lang="en-US" sz="1100" dirty="0"/>
+            <a:endParaRPr lang="en-US" sz="1050" dirty="0"/>
           </a:p>
         </p:txBody>
       </p:sp>
@@ -14737,7 +14737,7 @@
       </p:sp>
       <p:pic>
         <p:nvPicPr>
-          <p:cNvPr id="7" name="Image 0" descr="C:\Users\ADMIN\OneDrive\Documents\MÁY HỌC\ĐỒ ÁN MÔN MÁY HỌC\CS114-Team10-Elderly-Scam-Detection\draft\scam-detection\reports\figures\learning_curves_summary.png">    </p:cNvPr>
+          <p:cNvPr id="7" name="Image 0" descr="/Users/tcdtist/dev/uit/cs114/assignments/Final/draft/scam-detection/reports/figures/learning_curves_summary.png">    </p:cNvPr>
           <p:cNvPicPr>
             <a:picLocks noChangeAspect="1"/>
           </p:cNvPicPr>
@@ -14940,8 +14940,8 @@
         </p:nvSpPr>
         <p:spPr>
           <a:xfrm>
-            <a:off x="457200" y="4718304"/>
-            <a:ext cx="7040880" cy="384048"/>
+            <a:off x="457200" y="4736592"/>
+            <a:ext cx="7040880" cy="329184"/>
           </a:xfrm>
           <a:prstGeom prst="rect">
             <a:avLst/>
@@ -14957,7 +14957,7 @@
               <a:buNone/>
             </a:pPr>
             <a:r>
-              <a:rPr lang="en-US" sz="1000" dirty="0">
+              <a:rPr lang="en-US" sz="950" dirty="0">
                 <a:solidFill>
                   <a:srgbClr val="6B7280"/>
                 </a:solidFill>
@@ -14967,14 +14967,14 @@
               </a:rPr>
               <a:t>CS114: Máy học — Nhóm 10 — Báo cáo Đồ án:</a:t>
             </a:r>
-            <a:endParaRPr lang="en-US" sz="1000" dirty="0"/>
+            <a:endParaRPr lang="en-US" sz="950" dirty="0"/>
           </a:p>
           <a:p>
             <a:pPr indent="0" marL="0">
               <a:buNone/>
             </a:pPr>
             <a:r>
-              <a:rPr lang="en-US" sz="1000" dirty="0">
+              <a:rPr lang="en-US" sz="950" dirty="0">
                 <a:solidFill>
                   <a:srgbClr val="6B7280"/>
                 </a:solidFill>
@@ -14984,7 +14984,7 @@
               </a:rPr>
               <a:t>Phát hiện Tin nhắn &amp; Kịch bản Thao túng Tâm lý Lừa đảo nhắm vào Người cao tuổi tại Việt Nam</a:t>
             </a:r>
-            <a:endParaRPr lang="en-US" sz="1000" dirty="0"/>
+            <a:endParaRPr lang="en-US" sz="950" dirty="0"/>
           </a:p>
         </p:txBody>
       </p:sp>
@@ -14996,8 +14996,8 @@
         </p:nvSpPr>
         <p:spPr>
           <a:xfrm>
-            <a:off x="7589520" y="4718304"/>
-            <a:ext cx="1097280" cy="384048"/>
+            <a:off x="7589520" y="4736592"/>
+            <a:ext cx="1097280" cy="329184"/>
           </a:xfrm>
           <a:prstGeom prst="rect">
             <a:avLst/>
@@ -15013,7 +15013,7 @@
               <a:buNone/>
             </a:pPr>
             <a:r>
-              <a:rPr lang="en-US" sz="1100" b="1" dirty="0">
+              <a:rPr lang="en-US" sz="1050" b="1" dirty="0">
                 <a:solidFill>
                   <a:srgbClr val="1E40AF"/>
                 </a:solidFill>
@@ -15023,7 +15023,7 @@
               </a:rPr>
               <a:t>22 / 22</a:t>
             </a:r>
-            <a:endParaRPr lang="en-US" sz="1100" dirty="0"/>
+            <a:endParaRPr lang="en-US" sz="1050" dirty="0"/>
           </a:p>
         </p:txBody>
       </p:sp>
@@ -15908,8 +15908,8 @@
         </p:nvSpPr>
         <p:spPr>
           <a:xfrm>
-            <a:off x="457200" y="4718304"/>
-            <a:ext cx="7040880" cy="384048"/>
+            <a:off x="457200" y="4736592"/>
+            <a:ext cx="7040880" cy="329184"/>
           </a:xfrm>
           <a:prstGeom prst="rect">
             <a:avLst/>
@@ -15925,7 +15925,7 @@
               <a:buNone/>
             </a:pPr>
             <a:r>
-              <a:rPr lang="en-US" sz="1000" dirty="0">
+              <a:rPr lang="en-US" sz="950" dirty="0">
                 <a:solidFill>
                   <a:srgbClr val="6B7280"/>
                 </a:solidFill>
@@ -15935,14 +15935,14 @@
               </a:rPr>
               <a:t>CS114: Máy học — Nhóm 10 — Báo cáo Đồ án:</a:t>
             </a:r>
-            <a:endParaRPr lang="en-US" sz="1000" dirty="0"/>
+            <a:endParaRPr lang="en-US" sz="950" dirty="0"/>
           </a:p>
           <a:p>
             <a:pPr indent="0" marL="0">
               <a:buNone/>
             </a:pPr>
             <a:r>
-              <a:rPr lang="en-US" sz="1000" dirty="0">
+              <a:rPr lang="en-US" sz="950" dirty="0">
                 <a:solidFill>
                   <a:srgbClr val="6B7280"/>
                 </a:solidFill>
@@ -15952,7 +15952,7 @@
               </a:rPr>
               <a:t>Phát hiện Tin nhắn &amp; Kịch bản Thao túng Tâm lý Lừa đảo nhắm vào Người cao tuổi tại Việt Nam</a:t>
             </a:r>
-            <a:endParaRPr lang="en-US" sz="1000" dirty="0"/>
+            <a:endParaRPr lang="en-US" sz="950" dirty="0"/>
           </a:p>
         </p:txBody>
       </p:sp>
@@ -15964,8 +15964,8 @@
         </p:nvSpPr>
         <p:spPr>
           <a:xfrm>
-            <a:off x="7589520" y="4718304"/>
-            <a:ext cx="1097280" cy="384048"/>
+            <a:off x="7589520" y="4736592"/>
+            <a:ext cx="1097280" cy="329184"/>
           </a:xfrm>
           <a:prstGeom prst="rect">
             <a:avLst/>
@@ -15981,7 +15981,7 @@
               <a:buNone/>
             </a:pPr>
             <a:r>
-              <a:rPr lang="en-US" sz="1100" b="1" dirty="0">
+              <a:rPr lang="en-US" sz="1050" b="1" dirty="0">
                 <a:solidFill>
                   <a:srgbClr val="1E40AF"/>
                 </a:solidFill>
@@ -15991,7 +15991,7 @@
               </a:rPr>
               <a:t>03 / 22</a:t>
             </a:r>
-            <a:endParaRPr lang="en-US" sz="1100" dirty="0"/>
+            <a:endParaRPr lang="en-US" sz="1050" dirty="0"/>
           </a:p>
         </p:txBody>
       </p:sp>
@@ -16886,8 +16886,8 @@
         </p:nvSpPr>
         <p:spPr>
           <a:xfrm>
-            <a:off x="457200" y="4718304"/>
-            <a:ext cx="7040880" cy="384048"/>
+            <a:off x="457200" y="4736592"/>
+            <a:ext cx="7040880" cy="329184"/>
           </a:xfrm>
           <a:prstGeom prst="rect">
             <a:avLst/>
@@ -16903,7 +16903,7 @@
               <a:buNone/>
             </a:pPr>
             <a:r>
-              <a:rPr lang="en-US" sz="1000" dirty="0">
+              <a:rPr lang="en-US" sz="950" dirty="0">
                 <a:solidFill>
                   <a:srgbClr val="6B7280"/>
                 </a:solidFill>
@@ -16913,14 +16913,14 @@
               </a:rPr>
               <a:t>CS114: Máy học — Nhóm 10 — Báo cáo Đồ án:</a:t>
             </a:r>
-            <a:endParaRPr lang="en-US" sz="1000" dirty="0"/>
+            <a:endParaRPr lang="en-US" sz="950" dirty="0"/>
           </a:p>
           <a:p>
             <a:pPr indent="0" marL="0">
               <a:buNone/>
             </a:pPr>
             <a:r>
-              <a:rPr lang="en-US" sz="1000" dirty="0">
+              <a:rPr lang="en-US" sz="950" dirty="0">
                 <a:solidFill>
                   <a:srgbClr val="6B7280"/>
                 </a:solidFill>
@@ -16930,7 +16930,7 @@
               </a:rPr>
               <a:t>Phát hiện Tin nhắn &amp; Kịch bản Thao túng Tâm lý Lừa đảo nhắm vào Người cao tuổi tại Việt Nam</a:t>
             </a:r>
-            <a:endParaRPr lang="en-US" sz="1000" dirty="0"/>
+            <a:endParaRPr lang="en-US" sz="950" dirty="0"/>
           </a:p>
         </p:txBody>
       </p:sp>
@@ -16942,8 +16942,8 @@
         </p:nvSpPr>
         <p:spPr>
           <a:xfrm>
-            <a:off x="7589520" y="4718304"/>
-            <a:ext cx="1097280" cy="384048"/>
+            <a:off x="7589520" y="4736592"/>
+            <a:ext cx="1097280" cy="329184"/>
           </a:xfrm>
           <a:prstGeom prst="rect">
             <a:avLst/>
@@ -16959,7 +16959,7 @@
               <a:buNone/>
             </a:pPr>
             <a:r>
-              <a:rPr lang="en-US" sz="1100" b="1" dirty="0">
+              <a:rPr lang="en-US" sz="1050" b="1" dirty="0">
                 <a:solidFill>
                   <a:srgbClr val="1E40AF"/>
                 </a:solidFill>
@@ -16969,7 +16969,7 @@
               </a:rPr>
               <a:t>04 / 22</a:t>
             </a:r>
-            <a:endParaRPr lang="en-US" sz="1100" dirty="0"/>
+            <a:endParaRPr lang="en-US" sz="1050" dirty="0"/>
           </a:p>
         </p:txBody>
       </p:sp>
@@ -17504,7 +17504,7 @@
       </p:sp>
       <p:pic>
         <p:nvPicPr>
-          <p:cNvPr id="8" name="Image 0" descr="C:\Users\ADMIN\OneDrive\Documents\MÁY HỌC\ĐỒ ÁN MÔN MÁY HỌC\CS114-Team10-Elderly-Scam-Detection\draft\scam-detection\reports\figures\label_distribution.png">    </p:cNvPr>
+          <p:cNvPr id="8" name="Image 0" descr="/Users/tcdtist/dev/uit/cs114/assignments/Final/draft/scam-detection/reports/figures/label_distribution.png">    </p:cNvPr>
           <p:cNvPicPr>
             <a:picLocks noChangeAspect="1"/>
           </p:cNvPicPr>
@@ -17659,8 +17659,8 @@
         </p:nvSpPr>
         <p:spPr>
           <a:xfrm>
-            <a:off x="457200" y="4718304"/>
-            <a:ext cx="7040880" cy="384048"/>
+            <a:off x="457200" y="4736592"/>
+            <a:ext cx="7040880" cy="329184"/>
           </a:xfrm>
           <a:prstGeom prst="rect">
             <a:avLst/>
@@ -17676,7 +17676,7 @@
               <a:buNone/>
             </a:pPr>
             <a:r>
-              <a:rPr lang="en-US" sz="1000" dirty="0">
+              <a:rPr lang="en-US" sz="950" dirty="0">
                 <a:solidFill>
                   <a:srgbClr val="6B7280"/>
                 </a:solidFill>
@@ -17686,14 +17686,14 @@
               </a:rPr>
               <a:t>CS114: Máy học — Nhóm 10 — Báo cáo Đồ án:</a:t>
             </a:r>
-            <a:endParaRPr lang="en-US" sz="1000" dirty="0"/>
+            <a:endParaRPr lang="en-US" sz="950" dirty="0"/>
           </a:p>
           <a:p>
             <a:pPr indent="0" marL="0">
               <a:buNone/>
             </a:pPr>
             <a:r>
-              <a:rPr lang="en-US" sz="1000" dirty="0">
+              <a:rPr lang="en-US" sz="950" dirty="0">
                 <a:solidFill>
                   <a:srgbClr val="6B7280"/>
                 </a:solidFill>
@@ -17703,7 +17703,7 @@
               </a:rPr>
               <a:t>Phát hiện Tin nhắn &amp; Kịch bản Thao túng Tâm lý Lừa đảo nhắm vào Người cao tuổi tại Việt Nam</a:t>
             </a:r>
-            <a:endParaRPr lang="en-US" sz="1000" dirty="0"/>
+            <a:endParaRPr lang="en-US" sz="950" dirty="0"/>
           </a:p>
         </p:txBody>
       </p:sp>
@@ -17715,8 +17715,8 @@
         </p:nvSpPr>
         <p:spPr>
           <a:xfrm>
-            <a:off x="7589520" y="4718304"/>
-            <a:ext cx="1097280" cy="384048"/>
+            <a:off x="7589520" y="4736592"/>
+            <a:ext cx="1097280" cy="329184"/>
           </a:xfrm>
           <a:prstGeom prst="rect">
             <a:avLst/>
@@ -17732,7 +17732,7 @@
               <a:buNone/>
             </a:pPr>
             <a:r>
-              <a:rPr lang="en-US" sz="1100" b="1" dirty="0">
+              <a:rPr lang="en-US" sz="1050" b="1" dirty="0">
                 <a:solidFill>
                   <a:srgbClr val="1E40AF"/>
                 </a:solidFill>
@@ -17742,7 +17742,7 @@
               </a:rPr>
               <a:t>06 / 22</a:t>
             </a:r>
-            <a:endParaRPr lang="en-US" sz="1100" dirty="0"/>
+            <a:endParaRPr lang="en-US" sz="1050" dirty="0"/>
           </a:p>
         </p:txBody>
       </p:sp>
@@ -17939,7 +17939,7 @@
       </p:sp>
       <p:pic>
         <p:nvPicPr>
-          <p:cNvPr id="7" name="Image 0" descr="C:\Users\ADMIN\OneDrive\Documents\MÁY HỌC\ĐỒ ÁN MÔN MÁY HỌC\CS114-Team10-Elderly-Scam-Detection\draft\scam-detection\reports\figures\scam_category_distribution.png">    </p:cNvPr>
+          <p:cNvPr id="7" name="Image 0" descr="/Users/tcdtist/dev/uit/cs114/assignments/Final/draft/scam-detection/reports/figures/scam_category_distribution.png">    </p:cNvPr>
           <p:cNvPicPr>
             <a:picLocks noChangeAspect="1"/>
           </p:cNvPicPr>
@@ -19119,8 +19119,8 @@
         </p:nvSpPr>
         <p:spPr>
           <a:xfrm>
-            <a:off x="457200" y="4718304"/>
-            <a:ext cx="7040880" cy="384048"/>
+            <a:off x="457200" y="4736592"/>
+            <a:ext cx="7040880" cy="329184"/>
           </a:xfrm>
           <a:prstGeom prst="rect">
             <a:avLst/>
@@ -19136,7 +19136,7 @@
               <a:buNone/>
             </a:pPr>
             <a:r>
-              <a:rPr lang="en-US" sz="1000" dirty="0">
+              <a:rPr lang="en-US" sz="950" dirty="0">
                 <a:solidFill>
                   <a:srgbClr val="6B7280"/>
                 </a:solidFill>
@@ -19146,14 +19146,14 @@
               </a:rPr>
               <a:t>CS114: Máy học — Nhóm 10 — Báo cáo Đồ án:</a:t>
             </a:r>
-            <a:endParaRPr lang="en-US" sz="1000" dirty="0"/>
+            <a:endParaRPr lang="en-US" sz="950" dirty="0"/>
           </a:p>
           <a:p>
             <a:pPr indent="0" marL="0">
               <a:buNone/>
             </a:pPr>
             <a:r>
-              <a:rPr lang="en-US" sz="1000" dirty="0">
+              <a:rPr lang="en-US" sz="950" dirty="0">
                 <a:solidFill>
                   <a:srgbClr val="6B7280"/>
                 </a:solidFill>
@@ -19163,7 +19163,7 @@
               </a:rPr>
               <a:t>Phát hiện Tin nhắn &amp; Kịch bản Thao túng Tâm lý Lừa đảo nhắm vào Người cao tuổi tại Việt Nam</a:t>
             </a:r>
-            <a:endParaRPr lang="en-US" sz="1000" dirty="0"/>
+            <a:endParaRPr lang="en-US" sz="950" dirty="0"/>
           </a:p>
         </p:txBody>
       </p:sp>
@@ -19175,8 +19175,8 @@
         </p:nvSpPr>
         <p:spPr>
           <a:xfrm>
-            <a:off x="7589520" y="4718304"/>
-            <a:ext cx="1097280" cy="384048"/>
+            <a:off x="7589520" y="4736592"/>
+            <a:ext cx="1097280" cy="329184"/>
           </a:xfrm>
           <a:prstGeom prst="rect">
             <a:avLst/>
@@ -19192,7 +19192,7 @@
               <a:buNone/>
             </a:pPr>
             <a:r>
-              <a:rPr lang="en-US" sz="1100" b="1" dirty="0">
+              <a:rPr lang="en-US" sz="1050" b="1" dirty="0">
                 <a:solidFill>
                   <a:srgbClr val="1E40AF"/>
                 </a:solidFill>
@@ -19202,7 +19202,7 @@
               </a:rPr>
               <a:t>07 / 22</a:t>
             </a:r>
-            <a:endParaRPr lang="en-US" sz="1100" dirty="0"/>
+            <a:endParaRPr lang="en-US" sz="1050" dirty="0"/>
           </a:p>
         </p:txBody>
       </p:sp>
@@ -20466,8 +20466,8 @@
         </p:nvSpPr>
         <p:spPr>
           <a:xfrm>
-            <a:off x="457200" y="4718304"/>
-            <a:ext cx="7040880" cy="384048"/>
+            <a:off x="457200" y="4736592"/>
+            <a:ext cx="7040880" cy="329184"/>
           </a:xfrm>
           <a:prstGeom prst="rect">
             <a:avLst/>
@@ -20483,7 +20483,7 @@
               <a:buNone/>
             </a:pPr>
             <a:r>
-              <a:rPr lang="en-US" sz="1000" dirty="0">
+              <a:rPr lang="en-US" sz="950" dirty="0">
                 <a:solidFill>
                   <a:srgbClr val="6B7280"/>
                 </a:solidFill>
@@ -20493,14 +20493,14 @@
               </a:rPr>
               <a:t>CS114: Máy học — Nhóm 10 — Báo cáo Đồ án:</a:t>
             </a:r>
-            <a:endParaRPr lang="en-US" sz="1000" dirty="0"/>
+            <a:endParaRPr lang="en-US" sz="950" dirty="0"/>
           </a:p>
           <a:p>
             <a:pPr indent="0" marL="0">
               <a:buNone/>
             </a:pPr>
             <a:r>
-              <a:rPr lang="en-US" sz="1000" dirty="0">
+              <a:rPr lang="en-US" sz="950" dirty="0">
                 <a:solidFill>
                   <a:srgbClr val="6B7280"/>
                 </a:solidFill>
@@ -20510,7 +20510,7 @@
               </a:rPr>
               <a:t>Phát hiện Tin nhắn &amp; Kịch bản Thao túng Tâm lý Lừa đảo nhắm vào Người cao tuổi tại Việt Nam</a:t>
             </a:r>
-            <a:endParaRPr lang="en-US" sz="1000" dirty="0"/>
+            <a:endParaRPr lang="en-US" sz="950" dirty="0"/>
           </a:p>
         </p:txBody>
       </p:sp>
@@ -20522,8 +20522,8 @@
         </p:nvSpPr>
         <p:spPr>
           <a:xfrm>
-            <a:off x="7589520" y="4718304"/>
-            <a:ext cx="1097280" cy="384048"/>
+            <a:off x="7589520" y="4736592"/>
+            <a:ext cx="1097280" cy="329184"/>
           </a:xfrm>
           <a:prstGeom prst="rect">
             <a:avLst/>
@@ -20539,7 +20539,7 @@
               <a:buNone/>
             </a:pPr>
             <a:r>
-              <a:rPr lang="en-US" sz="1100" b="1" dirty="0">
+              <a:rPr lang="en-US" sz="1050" b="1" dirty="0">
                 <a:solidFill>
                   <a:srgbClr val="1E40AF"/>
                 </a:solidFill>
@@ -20549,7 +20549,7 @@
               </a:rPr>
               <a:t>08 / 22</a:t>
             </a:r>
-            <a:endParaRPr lang="en-US" sz="1100" dirty="0"/>
+            <a:endParaRPr lang="en-US" sz="1050" dirty="0"/>
           </a:p>
         </p:txBody>
       </p:sp>

</xml_diff>

<commit_message>
fix(phase09): use phone number wording on the pipeline slide
- Slide 8 lists "SĐT" instead of "Hotline" among the auxiliary features:
  the real feature is num_phone_numbers, which also counts the [hotline] tag.
- Keep generate_slides.js in sync with the hand edit made in PowerPoint so
  regenerating the deck does not revert it.
- Re-export phase09_presentation.pdf from PowerPoint so the PDF matches the
  .pptx (22 pages).
</commit_message>
<xml_diff>
--- a/draft/scam-detection/reports/slides/phase09_presentation.pptx
+++ b/draft/scam-detection/reports/slides/phase09_presentation.pptx
@@ -131,6 +131,43 @@
     </p:ext>
   </p:extLst>
 </p:presentation>
+</file>
+
+<file path=ppt/revisionInfo.xml><?xml version="1.0" encoding="utf-8"?>
+<p1510:revInfo xmlns:a="http://schemas.openxmlformats.org/drawingml/2006/main" xmlns:r="http://schemas.openxmlformats.org/officeDocument/2006/relationships" xmlns:p1510="http://schemas.microsoft.com/office/powerpoint/2015/10/main">
+  <p1510:revLst>
+    <p1510:client id="{A95AAAD3-F305-402A-8795-FA7C7B45CF37}" v="2" dt="2026-09-21T19:26:51.094"/>
+  </p1510:revLst>
+</p1510:revInfo>
+</file>
+
+<file path=ppt/changesInfos/changesInfo1.xml><?xml version="1.0" encoding="utf-8"?>
+<pc:chgInfo xmlns:a="http://schemas.openxmlformats.org/drawingml/2006/main" xmlns:r="http://schemas.openxmlformats.org/officeDocument/2006/relationships" xmlns:ac="http://schemas.microsoft.com/office/drawing/2013/main/command" xmlns:pc="http://schemas.microsoft.com/office/powerpoint/2013/main/command">
+  <pc:docChgLst>
+    <pc:chgData name="Mỷ Cẩm" userId="2f7d1b655b90127a" providerId="LiveId" clId="{BE1B56B2-9ED1-4C5B-8C1B-0C71FE67AC87}"/>
+    <pc:docChg chg="modSld">
+      <pc:chgData name="Mỷ Cẩm" userId="2f7d1b655b90127a" providerId="LiveId" clId="{BE1B56B2-9ED1-4C5B-8C1B-0C71FE67AC87}" dt="2026-09-21T19:27:11.373" v="29" actId="20577"/>
+      <pc:docMkLst>
+        <pc:docMk/>
+      </pc:docMkLst>
+      <pc:sldChg chg="modSp mod">
+        <pc:chgData name="Mỷ Cẩm" userId="2f7d1b655b90127a" providerId="LiveId" clId="{BE1B56B2-9ED1-4C5B-8C1B-0C71FE67AC87}" dt="2026-09-21T19:27:11.373" v="29" actId="20577"/>
+        <pc:sldMkLst>
+          <pc:docMk/>
+          <pc:sldMk cId="0" sldId="263"/>
+        </pc:sldMkLst>
+        <pc:spChg chg="mod">
+          <ac:chgData name="Mỷ Cẩm" userId="2f7d1b655b90127a" providerId="LiveId" clId="{BE1B56B2-9ED1-4C5B-8C1B-0C71FE67AC87}" dt="2026-09-21T19:27:11.373" v="29" actId="20577"/>
+          <ac:spMkLst>
+            <pc:docMk/>
+            <pc:sldMk cId="0" sldId="263"/>
+            <ac:spMk id="32" creationId="{00000000-0000-0000-0000-000000000000}"/>
+          </ac:spMkLst>
+        </pc:spChg>
+      </pc:sldChg>
+    </pc:docChg>
+  </pc:docChgLst>
+</pc:chgInfo>
 </file>
 
 <file path=ppt/notesMasters/notesMaster1.xml><?xml version="1.0" encoding="utf-8"?>
@@ -10049,13 +10086,13 @@
   <p:clrMapOvr>
     <a:masterClrMapping/>
   </p:clrMapOvr>
-  <mc:AlternateContent xmlns:mc="http://schemas.openxmlformats.org/markup-compatibility/2006">
-    <mc:Choice xmlns:p15="http://schemas.microsoft.com/office/powerpoint/2012/main" Requires="p15">
+  <mc:AlternateContent xmlns:mc="http://schemas.openxmlformats.org/markup-compatibility/2006" xmlns:p15="http://schemas.microsoft.com/office/powerpoint/2012/main">
+    <mc:Choice Requires="p15">
       <p:transition xmlns:p14="http://schemas.microsoft.com/office/powerpoint/2010/main" spd="slow" p14:dur="2000">
         <p15:prstTrans prst="crush"/>
       </p:transition>
     </mc:Choice>
-    <mc:Fallback>
+    <mc:Fallback xmlns="">
       <p:transition spd="slow">
         <p:fade/>
       </p:transition>
@@ -21448,7 +21485,40 @@
                 <a:ea typeface="Calibri" pitchFamily="34" charset="-122"/>
                 <a:cs typeface="Calibri" pitchFamily="34" charset="-120"/>
               </a:rPr>
-              <a:t>• 5.000 đặc trưng từ vựng n-gram + 15 đặc trưng miền tâm lý (URL, OTP, Hotline...)  •  Naive Bayes chỉ dùng 5.000 TF-IDF</a:t>
+              <a:t>• 5.000 đặc trưng từ vựng n-gram + 15 đặc trưng miền tâm lý (URL, OTP</a:t>
+            </a:r>
+            <a:r>
+              <a:rPr lang="en-US" sz="950">
+                <a:solidFill>
+                  <a:srgbClr val="CBD5E1"/>
+                </a:solidFill>
+                <a:latin typeface="Calibri" pitchFamily="34" charset="0"/>
+                <a:ea typeface="Calibri" pitchFamily="34" charset="-122"/>
+                <a:cs typeface="Calibri" pitchFamily="34" charset="-120"/>
+              </a:rPr>
+              <a:t>, </a:t>
+            </a:r>
+            <a:r>
+              <a:rPr lang="vi-VN" sz="950">
+                <a:solidFill>
+                  <a:srgbClr val="CBD5E1"/>
+                </a:solidFill>
+                <a:latin typeface="Calibri" pitchFamily="34" charset="0"/>
+                <a:ea typeface="Calibri" pitchFamily="34" charset="-122"/>
+                <a:cs typeface="Calibri" pitchFamily="34" charset="-120"/>
+              </a:rPr>
+              <a:t>SĐT</a:t>
+            </a:r>
+            <a:r>
+              <a:rPr lang="en-US" sz="950" dirty="0">
+                <a:solidFill>
+                  <a:srgbClr val="CBD5E1"/>
+                </a:solidFill>
+                <a:latin typeface="Calibri" pitchFamily="34" charset="0"/>
+                <a:ea typeface="Calibri" pitchFamily="34" charset="-122"/>
+                <a:cs typeface="Calibri" pitchFamily="34" charset="-120"/>
+              </a:rPr>
+              <a:t>...)  •  Naive Bayes chỉ dùng 5.000 TF-IDF</a:t>
             </a:r>
             <a:endParaRPr lang="en-US" sz="1100" dirty="0"/>
           </a:p>

</xml_diff>

<commit_message>
fix(phase09): update presentation slides and exported pdf
</commit_message>
<xml_diff>
--- a/draft/scam-detection/reports/slides/phase09_presentation.pptx
+++ b/draft/scam-detection/reports/slides/phase09_presentation.pptx
@@ -131,43 +131,6 @@
     </p:ext>
   </p:extLst>
 </p:presentation>
-</file>
-
-<file path=ppt/revisionInfo.xml><?xml version="1.0" encoding="utf-8"?>
-<p1510:revInfo xmlns:a="http://schemas.openxmlformats.org/drawingml/2006/main" xmlns:r="http://schemas.openxmlformats.org/officeDocument/2006/relationships" xmlns:p1510="http://schemas.microsoft.com/office/powerpoint/2015/10/main">
-  <p1510:revLst>
-    <p1510:client id="{A95AAAD3-F305-402A-8795-FA7C7B45CF37}" v="2" dt="2026-09-21T19:26:51.094"/>
-  </p1510:revLst>
-</p1510:revInfo>
-</file>
-
-<file path=ppt/changesInfos/changesInfo1.xml><?xml version="1.0" encoding="utf-8"?>
-<pc:chgInfo xmlns:a="http://schemas.openxmlformats.org/drawingml/2006/main" xmlns:r="http://schemas.openxmlformats.org/officeDocument/2006/relationships" xmlns:ac="http://schemas.microsoft.com/office/drawing/2013/main/command" xmlns:pc="http://schemas.microsoft.com/office/powerpoint/2013/main/command">
-  <pc:docChgLst>
-    <pc:chgData name="Mỷ Cẩm" userId="2f7d1b655b90127a" providerId="LiveId" clId="{BE1B56B2-9ED1-4C5B-8C1B-0C71FE67AC87}"/>
-    <pc:docChg chg="modSld">
-      <pc:chgData name="Mỷ Cẩm" userId="2f7d1b655b90127a" providerId="LiveId" clId="{BE1B56B2-9ED1-4C5B-8C1B-0C71FE67AC87}" dt="2026-09-21T19:27:11.373" v="29" actId="20577"/>
-      <pc:docMkLst>
-        <pc:docMk/>
-      </pc:docMkLst>
-      <pc:sldChg chg="modSp mod">
-        <pc:chgData name="Mỷ Cẩm" userId="2f7d1b655b90127a" providerId="LiveId" clId="{BE1B56B2-9ED1-4C5B-8C1B-0C71FE67AC87}" dt="2026-09-21T19:27:11.373" v="29" actId="20577"/>
-        <pc:sldMkLst>
-          <pc:docMk/>
-          <pc:sldMk cId="0" sldId="263"/>
-        </pc:sldMkLst>
-        <pc:spChg chg="mod">
-          <ac:chgData name="Mỷ Cẩm" userId="2f7d1b655b90127a" providerId="LiveId" clId="{BE1B56B2-9ED1-4C5B-8C1B-0C71FE67AC87}" dt="2026-09-21T19:27:11.373" v="29" actId="20577"/>
-          <ac:spMkLst>
-            <pc:docMk/>
-            <pc:sldMk cId="0" sldId="263"/>
-            <ac:spMk id="32" creationId="{00000000-0000-0000-0000-000000000000}"/>
-          </ac:spMkLst>
-        </pc:spChg>
-      </pc:sldChg>
-    </pc:docChg>
-  </pc:docChgLst>
-</pc:chgInfo>
 </file>
 
 <file path=ppt/notesMasters/notesMaster1.xml><?xml version="1.0" encoding="utf-8"?>
@@ -2620,7 +2583,7 @@
         </p:blipFill>
         <p:spPr>
           <a:xfrm>
-            <a:off x="3200400" y="365760"/>
+            <a:off x="3200400" y="219787"/>
             <a:ext cx="2743200" cy="406965"/>
           </a:xfrm>
           <a:prstGeom prst="rect">
@@ -2636,8 +2599,8 @@
         </p:nvSpPr>
         <p:spPr>
           <a:xfrm>
-            <a:off x="457200" y="978408"/>
-            <a:ext cx="8229600" cy="1188720"/>
+            <a:off x="457200" y="706019"/>
+            <a:ext cx="8229600" cy="1593342"/>
           </a:xfrm>
           <a:prstGeom prst="rect">
             <a:avLst/>
@@ -2652,6 +2615,9 @@
           <a:lstStyle/>
           <a:p>
             <a:pPr marL="0" indent="0" algn="ctr">
+              <a:lnSpc>
+                <a:spcPct val="110000"/>
+              </a:lnSpc>
               <a:buNone/>
             </a:pPr>
             <a:r>
@@ -2669,6 +2635,9 @@
           </a:p>
           <a:p>
             <a:pPr marL="0" indent="0" algn="ctr">
+              <a:lnSpc>
+                <a:spcPct val="110000"/>
+              </a:lnSpc>
               <a:buNone/>
             </a:pPr>
             <a:r>
@@ -2686,6 +2655,9 @@
           </a:p>
           <a:p>
             <a:pPr marL="0" indent="0" algn="ctr">
+              <a:lnSpc>
+                <a:spcPct val="110000"/>
+              </a:lnSpc>
               <a:buNone/>
             </a:pPr>
             <a:r>
@@ -7154,26 +7126,318 @@
           </a:p>
         </p:txBody>
       </p:sp>
+      <p:sp>
+        <p:nvSpPr>
+          <p:cNvPr id="10" name="Text 7"/>
+          <p:cNvSpPr/>
+          <p:nvPr/>
+        </p:nvSpPr>
+        <p:spPr>
+          <a:xfrm>
+            <a:off x="433290" y="4539996"/>
+            <a:ext cx="4937760" cy="201168"/>
+          </a:xfrm>
+          <a:prstGeom prst="rect">
+            <a:avLst/>
+          </a:prstGeom>
+          <a:noFill/>
+          <a:ln/>
+        </p:spPr>
+        <p:txBody>
+          <a:bodyPr wrap="square" rtlCol="0" anchor="ctr"/>
+          <a:lstStyle/>
+          <a:p>
+            <a:pPr marL="0" indent="0" algn="ctr">
+              <a:buNone/>
+            </a:pPr>
+            <a:r>
+              <a:rPr lang="en-US" sz="1000" i="1" dirty="0">
+                <a:solidFill>
+                  <a:srgbClr val="6B7280"/>
+                </a:solidFill>
+                <a:latin typeface="Calibri" pitchFamily="34" charset="0"/>
+                <a:ea typeface="Calibri" pitchFamily="34" charset="-122"/>
+                <a:cs typeface="Calibri" pitchFamily="34" charset="-120"/>
+              </a:rPr>
+              <a:t>Giao diện phân tích tin nhắn thời gian thực với trợ năng người cao tuổi</a:t>
+            </a:r>
+            <a:endParaRPr lang="en-US" sz="1000" dirty="0"/>
+          </a:p>
+        </p:txBody>
+      </p:sp>
+      <p:sp>
+        <p:nvSpPr>
+          <p:cNvPr id="11" name="Text 8"/>
+          <p:cNvSpPr/>
+          <p:nvPr/>
+        </p:nvSpPr>
+        <p:spPr>
+          <a:xfrm>
+            <a:off x="5669280" y="1143000"/>
+            <a:ext cx="3017520" cy="3474720"/>
+          </a:xfrm>
+          <a:prstGeom prst="rect">
+            <a:avLst/>
+          </a:prstGeom>
+          <a:noFill/>
+          <a:ln/>
+        </p:spPr>
+        <p:txBody>
+          <a:bodyPr wrap="square" lIns="25400" tIns="0" rIns="0" bIns="50800" rtlCol="0" anchor="t">
+            <a:normAutofit/>
+          </a:bodyPr>
+          <a:lstStyle/>
+          <a:p>
+            <a:pPr marL="177800" indent="-177800">
+              <a:spcAft>
+                <a:spcPts val="500"/>
+              </a:spcAft>
+              <a:buSzPct val="100000"/>
+              <a:buChar char="•"/>
+            </a:pPr>
+            <a:r>
+              <a:rPr lang="en-US" sz="1350" dirty="0">
+                <a:solidFill>
+                  <a:srgbClr val="1F2937"/>
+                </a:solidFill>
+                <a:latin typeface="Calibri" pitchFamily="34" charset="0"/>
+                <a:ea typeface="Calibri" pitchFamily="34" charset="-122"/>
+                <a:cs typeface="Calibri" pitchFamily="34" charset="-120"/>
+              </a:rPr>
+              <a:t>4 mô hình trong 1 ứng dụng (mặc định XGBoost)</a:t>
+            </a:r>
+            <a:endParaRPr lang="en-US" sz="1350" dirty="0"/>
+          </a:p>
+          <a:p>
+            <a:pPr marL="177800" indent="-177800">
+              <a:spcAft>
+                <a:spcPts val="500"/>
+              </a:spcAft>
+              <a:buSzPct val="100000"/>
+              <a:buChar char="•"/>
+            </a:pPr>
+            <a:r>
+              <a:rPr lang="en-US" sz="1350" dirty="0">
+                <a:solidFill>
+                  <a:srgbClr val="1F2937"/>
+                </a:solidFill>
+                <a:latin typeface="Calibri" pitchFamily="34" charset="0"/>
+                <a:ea typeface="Calibri" pitchFamily="34" charset="-122"/>
+                <a:cs typeface="Calibri" pitchFamily="34" charset="-120"/>
+              </a:rPr>
+              <a:t>Chỉnh cỡ chữ 100% · 125% · 150%</a:t>
+            </a:r>
+            <a:endParaRPr lang="en-US" sz="1350" dirty="0"/>
+          </a:p>
+          <a:p>
+            <a:pPr marL="177800" indent="-177800">
+              <a:spcAft>
+                <a:spcPts val="500"/>
+              </a:spcAft>
+              <a:buSzPct val="100000"/>
+              <a:buChar char="•"/>
+            </a:pPr>
+            <a:r>
+              <a:rPr lang="en-US" sz="1350" dirty="0">
+                <a:solidFill>
+                  <a:srgbClr val="1F2937"/>
+                </a:solidFill>
+                <a:latin typeface="Calibri" pitchFamily="34" charset="0"/>
+                <a:ea typeface="Calibri" pitchFamily="34" charset="-122"/>
+                <a:cs typeface="Calibri" pitchFamily="34" charset="-120"/>
+              </a:rPr>
+              <a:t>Tương phản chữ 14.6:1, vượt mức WCAG 2.1 AA (4.5:1) [14]</a:t>
+            </a:r>
+            <a:endParaRPr lang="en-US" sz="1350" dirty="0"/>
+          </a:p>
+          <a:p>
+            <a:pPr marL="177800" indent="-177800">
+              <a:spcAft>
+                <a:spcPts val="500"/>
+              </a:spcAft>
+              <a:buSzPct val="100000"/>
+              <a:buChar char="•"/>
+            </a:pPr>
+            <a:r>
+              <a:rPr lang="en-US" sz="1350" dirty="0">
+                <a:solidFill>
+                  <a:srgbClr val="1F2937"/>
+                </a:solidFill>
+                <a:latin typeface="Calibri" pitchFamily="34" charset="0"/>
+                <a:ea typeface="Calibri" pitchFamily="34" charset="-122"/>
+                <a:cs typeface="Calibri" pitchFamily="34" charset="-120"/>
+              </a:rPr>
+              <a:t>Hotline khẩn cấp 156 / 113 gọi 1 chạm</a:t>
+            </a:r>
+            <a:endParaRPr lang="en-US" sz="1350" dirty="0"/>
+          </a:p>
+          <a:p>
+            <a:pPr marL="177800" indent="-177800">
+              <a:spcAft>
+                <a:spcPts val="500"/>
+              </a:spcAft>
+              <a:buSzPct val="100000"/>
+              <a:buChar char="•"/>
+            </a:pPr>
+            <a:r>
+              <a:rPr lang="en-US" sz="1350" dirty="0">
+                <a:solidFill>
+                  <a:srgbClr val="1F2937"/>
+                </a:solidFill>
+                <a:latin typeface="Calibri" pitchFamily="34" charset="0"/>
+                <a:ea typeface="Calibri" pitchFamily="34" charset="-122"/>
+                <a:cs typeface="Calibri" pitchFamily="34" charset="-120"/>
+              </a:rPr>
+              <a:t>Dán tin nhắn → tự động phân tích</a:t>
+            </a:r>
+            <a:endParaRPr lang="en-US" sz="1350" dirty="0"/>
+          </a:p>
+          <a:p>
+            <a:pPr marL="177800" indent="-177800">
+              <a:spcAft>
+                <a:spcPts val="500"/>
+              </a:spcAft>
+              <a:buSzPct val="100000"/>
+              <a:buChar char="•"/>
+            </a:pPr>
+            <a:r>
+              <a:rPr lang="en-US" sz="1350" dirty="0">
+                <a:solidFill>
+                  <a:srgbClr val="1F2937"/>
+                </a:solidFill>
+                <a:latin typeface="Calibri" pitchFamily="34" charset="0"/>
+                <a:ea typeface="Calibri" pitchFamily="34" charset="-122"/>
+                <a:cs typeface="Calibri" pitchFamily="34" charset="-120"/>
+              </a:rPr>
+              <a:t>Trích xuất 15 đặc trưng tâm lý theo thời gian thực</a:t>
+            </a:r>
+            <a:endParaRPr lang="en-US" sz="1350" dirty="0"/>
+          </a:p>
+          <a:p>
+            <a:pPr marL="177800" indent="-177800">
+              <a:spcAft>
+                <a:spcPts val="500"/>
+              </a:spcAft>
+              <a:buSzPct val="100000"/>
+              <a:buChar char="•"/>
+            </a:pPr>
+            <a:r>
+              <a:rPr lang="en-US" sz="1350" dirty="0">
+                <a:solidFill>
+                  <a:srgbClr val="1F2937"/>
+                </a:solidFill>
+                <a:latin typeface="Calibri" pitchFamily="34" charset="0"/>
+                <a:ea typeface="Calibri" pitchFamily="34" charset="-122"/>
+                <a:cs typeface="Calibri" pitchFamily="34" charset="-120"/>
+              </a:rPr>
+              <a:t>Tối ưu điện thoại · 16/16 kiểm thử E2E Playwright</a:t>
+            </a:r>
+            <a:endParaRPr lang="en-US" sz="1350" dirty="0"/>
+          </a:p>
+        </p:txBody>
+      </p:sp>
+      <p:sp>
+        <p:nvSpPr>
+          <p:cNvPr id="13" name="Text 9"/>
+          <p:cNvSpPr/>
+          <p:nvPr/>
+        </p:nvSpPr>
+        <p:spPr>
+          <a:xfrm>
+            <a:off x="457200" y="4773168"/>
+            <a:ext cx="7040880" cy="228600"/>
+          </a:xfrm>
+          <a:prstGeom prst="rect">
+            <a:avLst/>
+          </a:prstGeom>
+          <a:noFill/>
+          <a:ln/>
+        </p:spPr>
+        <p:txBody>
+          <a:bodyPr wrap="none" lIns="0" tIns="0" rIns="0" bIns="0" rtlCol="0" anchor="ctr"/>
+          <a:lstStyle/>
+          <a:p>
+            <a:pPr marL="0" indent="0">
+              <a:buNone/>
+            </a:pPr>
+            <a:r>
+              <a:rPr lang="en-US" sz="720" dirty="0">
+                <a:solidFill>
+                  <a:srgbClr val="6B7280"/>
+                </a:solidFill>
+                <a:latin typeface="Calibri" pitchFamily="34" charset="0"/>
+                <a:ea typeface="Calibri" pitchFamily="34" charset="-122"/>
+                <a:cs typeface="Calibri" pitchFamily="34" charset="-120"/>
+              </a:rPr>
+              <a:t>CS114: Máy học — Nhóm 10 — Báo cáo Đồ án: Phát hiện Tin nhắn &amp; Kịch bản Thao túng Tâm lý Lừa đảo nhắm vào Người cao tuổi tại Việt Nam</a:t>
+            </a:r>
+            <a:endParaRPr lang="en-US" sz="720" dirty="0"/>
+          </a:p>
+        </p:txBody>
+      </p:sp>
+      <p:sp>
+        <p:nvSpPr>
+          <p:cNvPr id="14" name="Text 10"/>
+          <p:cNvSpPr/>
+          <p:nvPr/>
+        </p:nvSpPr>
+        <p:spPr>
+          <a:xfrm>
+            <a:off x="7589520" y="4773168"/>
+            <a:ext cx="1097280" cy="228600"/>
+          </a:xfrm>
+          <a:prstGeom prst="rect">
+            <a:avLst/>
+          </a:prstGeom>
+          <a:noFill/>
+          <a:ln/>
+        </p:spPr>
+        <p:txBody>
+          <a:bodyPr wrap="square" lIns="0" tIns="0" rIns="0" bIns="0" rtlCol="0" anchor="ctr"/>
+          <a:lstStyle/>
+          <a:p>
+            <a:pPr marL="0" indent="0" algn="r">
+              <a:buNone/>
+            </a:pPr>
+            <a:r>
+              <a:rPr lang="en-US" sz="950" b="1" dirty="0">
+                <a:solidFill>
+                  <a:srgbClr val="1E40AF"/>
+                </a:solidFill>
+                <a:latin typeface="Calibri" pitchFamily="34" charset="0"/>
+                <a:ea typeface="Calibri" pitchFamily="34" charset="-122"/>
+                <a:cs typeface="Calibri" pitchFamily="34" charset="-120"/>
+              </a:rPr>
+              <a:t>14 / 22</a:t>
+            </a:r>
+            <a:endParaRPr lang="en-US" sz="950" dirty="0"/>
+          </a:p>
+        </p:txBody>
+      </p:sp>
       <p:pic>
         <p:nvPicPr>
-          <p:cNvPr id="9" name="Image 0" descr="/Users/tcdtist/dev/uit/cs114/assignments/Final/draft/scam-detection/reports/figures/demo_03_scam_detection_verdict.png"/>
+          <p:cNvPr id="16" name="Picture 15" descr="A screenshot of a web page&#10;&#10;AI-generated content may be incorrect.">
+            <a:extLst>
+              <a:ext uri="{FF2B5EF4-FFF2-40B4-BE49-F238E27FC236}">
+                <a16:creationId xmlns:a16="http://schemas.microsoft.com/office/drawing/2014/main" id="{654FF8A9-1076-1FA0-63E6-B6E174247E15}"/>
+              </a:ext>
+            </a:extLst>
+          </p:cNvPr>
           <p:cNvPicPr>
             <a:picLocks noChangeAspect="1"/>
           </p:cNvPicPr>
           <p:nvPr/>
         </p:nvPicPr>
         <p:blipFill>
-          <a:blip r:embed="rId3">
-            <a:alphaModFix/>
-          </a:blip>
+          <a:blip r:embed="rId3"/>
           <a:stretch>
             <a:fillRect/>
           </a:stretch>
         </p:blipFill>
         <p:spPr>
           <a:xfrm>
-            <a:off x="479502" y="1110327"/>
-            <a:ext cx="4915458" cy="3276972"/>
+            <a:off x="433290" y="1019556"/>
+            <a:ext cx="4913850" cy="3359220"/>
           </a:xfrm>
           <a:prstGeom prst="roundRect">
             <a:avLst>
@@ -7206,294 +7470,6 @@
           </a:sp3d>
         </p:spPr>
       </p:pic>
-      <p:sp>
-        <p:nvSpPr>
-          <p:cNvPr id="10" name="Text 7"/>
-          <p:cNvSpPr/>
-          <p:nvPr/>
-        </p:nvSpPr>
-        <p:spPr>
-          <a:xfrm>
-            <a:off x="433290" y="4494276"/>
-            <a:ext cx="4937760" cy="201168"/>
-          </a:xfrm>
-          <a:prstGeom prst="rect">
-            <a:avLst/>
-          </a:prstGeom>
-          <a:noFill/>
-          <a:ln/>
-        </p:spPr>
-        <p:txBody>
-          <a:bodyPr wrap="square" rtlCol="0" anchor="ctr"/>
-          <a:lstStyle/>
-          <a:p>
-            <a:pPr marL="0" indent="0" algn="ctr">
-              <a:buNone/>
-            </a:pPr>
-            <a:r>
-              <a:rPr lang="en-US" sz="1000" i="1" dirty="0">
-                <a:solidFill>
-                  <a:srgbClr val="6B7280"/>
-                </a:solidFill>
-                <a:latin typeface="Calibri" pitchFamily="34" charset="0"/>
-                <a:ea typeface="Calibri" pitchFamily="34" charset="-122"/>
-                <a:cs typeface="Calibri" pitchFamily="34" charset="-120"/>
-              </a:rPr>
-              <a:t>Giao diện phân tích tin nhắn thời gian thực với trợ năng người cao tuổi</a:t>
-            </a:r>
-            <a:endParaRPr lang="en-US" sz="1000" dirty="0"/>
-          </a:p>
-        </p:txBody>
-      </p:sp>
-      <p:sp>
-        <p:nvSpPr>
-          <p:cNvPr id="11" name="Text 8"/>
-          <p:cNvSpPr/>
-          <p:nvPr/>
-        </p:nvSpPr>
-        <p:spPr>
-          <a:xfrm>
-            <a:off x="5669280" y="1143000"/>
-            <a:ext cx="3017520" cy="3474720"/>
-          </a:xfrm>
-          <a:prstGeom prst="rect">
-            <a:avLst/>
-          </a:prstGeom>
-          <a:noFill/>
-          <a:ln/>
-        </p:spPr>
-        <p:txBody>
-          <a:bodyPr wrap="square" lIns="25400" tIns="0" rIns="0" bIns="50800" rtlCol="0" anchor="t">
-            <a:normAutofit/>
-          </a:bodyPr>
-          <a:lstStyle/>
-          <a:p>
-            <a:pPr marL="177800" indent="-177800">
-              <a:spcAft>
-                <a:spcPts val="500"/>
-              </a:spcAft>
-              <a:buSzPct val="100000"/>
-              <a:buChar char="•"/>
-            </a:pPr>
-            <a:r>
-              <a:rPr lang="en-US" sz="1350" dirty="0">
-                <a:solidFill>
-                  <a:srgbClr val="1F2937"/>
-                </a:solidFill>
-                <a:latin typeface="Calibri" pitchFamily="34" charset="0"/>
-                <a:ea typeface="Calibri" pitchFamily="34" charset="-122"/>
-                <a:cs typeface="Calibri" pitchFamily="34" charset="-120"/>
-              </a:rPr>
-              <a:t>4 mô hình trong 1 ứng dụng (mặc định XGBoost)</a:t>
-            </a:r>
-            <a:endParaRPr lang="en-US" sz="1350" dirty="0"/>
-          </a:p>
-          <a:p>
-            <a:pPr marL="177800" indent="-177800">
-              <a:spcAft>
-                <a:spcPts val="500"/>
-              </a:spcAft>
-              <a:buSzPct val="100000"/>
-              <a:buChar char="•"/>
-            </a:pPr>
-            <a:r>
-              <a:rPr lang="en-US" sz="1350" dirty="0">
-                <a:solidFill>
-                  <a:srgbClr val="1F2937"/>
-                </a:solidFill>
-                <a:latin typeface="Calibri" pitchFamily="34" charset="0"/>
-                <a:ea typeface="Calibri" pitchFamily="34" charset="-122"/>
-                <a:cs typeface="Calibri" pitchFamily="34" charset="-120"/>
-              </a:rPr>
-              <a:t>Chỉnh cỡ chữ 100% · 125% · 150%</a:t>
-            </a:r>
-            <a:endParaRPr lang="en-US" sz="1350" dirty="0"/>
-          </a:p>
-          <a:p>
-            <a:pPr marL="177800" indent="-177800">
-              <a:spcAft>
-                <a:spcPts val="500"/>
-              </a:spcAft>
-              <a:buSzPct val="100000"/>
-              <a:buChar char="•"/>
-            </a:pPr>
-            <a:r>
-              <a:rPr lang="en-US" sz="1350" dirty="0">
-                <a:solidFill>
-                  <a:srgbClr val="1F2937"/>
-                </a:solidFill>
-                <a:latin typeface="Calibri" pitchFamily="34" charset="0"/>
-                <a:ea typeface="Calibri" pitchFamily="34" charset="-122"/>
-                <a:cs typeface="Calibri" pitchFamily="34" charset="-120"/>
-              </a:rPr>
-              <a:t>Tương phản chữ 14.6:1, vượt mức WCAG 2.1 AA (4.5:1) [14]</a:t>
-            </a:r>
-            <a:endParaRPr lang="en-US" sz="1350" dirty="0"/>
-          </a:p>
-          <a:p>
-            <a:pPr marL="177800" indent="-177800">
-              <a:spcAft>
-                <a:spcPts val="500"/>
-              </a:spcAft>
-              <a:buSzPct val="100000"/>
-              <a:buChar char="•"/>
-            </a:pPr>
-            <a:r>
-              <a:rPr lang="en-US" sz="1350" dirty="0">
-                <a:solidFill>
-                  <a:srgbClr val="1F2937"/>
-                </a:solidFill>
-                <a:latin typeface="Calibri" pitchFamily="34" charset="0"/>
-                <a:ea typeface="Calibri" pitchFamily="34" charset="-122"/>
-                <a:cs typeface="Calibri" pitchFamily="34" charset="-120"/>
-              </a:rPr>
-              <a:t>Hotline khẩn cấp 156 / 113 gọi 1 chạm</a:t>
-            </a:r>
-            <a:endParaRPr lang="en-US" sz="1350" dirty="0"/>
-          </a:p>
-          <a:p>
-            <a:pPr marL="177800" indent="-177800">
-              <a:spcAft>
-                <a:spcPts val="500"/>
-              </a:spcAft>
-              <a:buSzPct val="100000"/>
-              <a:buChar char="•"/>
-            </a:pPr>
-            <a:r>
-              <a:rPr lang="en-US" sz="1350" dirty="0">
-                <a:solidFill>
-                  <a:srgbClr val="1F2937"/>
-                </a:solidFill>
-                <a:latin typeface="Calibri" pitchFamily="34" charset="0"/>
-                <a:ea typeface="Calibri" pitchFamily="34" charset="-122"/>
-                <a:cs typeface="Calibri" pitchFamily="34" charset="-120"/>
-              </a:rPr>
-              <a:t>Dán tin nhắn → tự động phân tích</a:t>
-            </a:r>
-            <a:endParaRPr lang="en-US" sz="1350" dirty="0"/>
-          </a:p>
-          <a:p>
-            <a:pPr marL="177800" indent="-177800">
-              <a:spcAft>
-                <a:spcPts val="500"/>
-              </a:spcAft>
-              <a:buSzPct val="100000"/>
-              <a:buChar char="•"/>
-            </a:pPr>
-            <a:r>
-              <a:rPr lang="en-US" sz="1350" dirty="0">
-                <a:solidFill>
-                  <a:srgbClr val="1F2937"/>
-                </a:solidFill>
-                <a:latin typeface="Calibri" pitchFamily="34" charset="0"/>
-                <a:ea typeface="Calibri" pitchFamily="34" charset="-122"/>
-                <a:cs typeface="Calibri" pitchFamily="34" charset="-120"/>
-              </a:rPr>
-              <a:t>Trích xuất 15 đặc trưng tâm lý theo thời gian thực</a:t>
-            </a:r>
-            <a:endParaRPr lang="en-US" sz="1350" dirty="0"/>
-          </a:p>
-          <a:p>
-            <a:pPr marL="177800" indent="-177800">
-              <a:spcAft>
-                <a:spcPts val="500"/>
-              </a:spcAft>
-              <a:buSzPct val="100000"/>
-              <a:buChar char="•"/>
-            </a:pPr>
-            <a:r>
-              <a:rPr lang="en-US" sz="1350" dirty="0">
-                <a:solidFill>
-                  <a:srgbClr val="1F2937"/>
-                </a:solidFill>
-                <a:latin typeface="Calibri" pitchFamily="34" charset="0"/>
-                <a:ea typeface="Calibri" pitchFamily="34" charset="-122"/>
-                <a:cs typeface="Calibri" pitchFamily="34" charset="-120"/>
-              </a:rPr>
-              <a:t>Tối ưu điện thoại · 16/16 kiểm thử E2E Playwright</a:t>
-            </a:r>
-            <a:endParaRPr lang="en-US" sz="1350" dirty="0"/>
-          </a:p>
-        </p:txBody>
-      </p:sp>
-      <p:sp>
-        <p:nvSpPr>
-          <p:cNvPr id="13" name="Text 9"/>
-          <p:cNvSpPr/>
-          <p:nvPr/>
-        </p:nvSpPr>
-        <p:spPr>
-          <a:xfrm>
-            <a:off x="457200" y="4773168"/>
-            <a:ext cx="7040880" cy="228600"/>
-          </a:xfrm>
-          <a:prstGeom prst="rect">
-            <a:avLst/>
-          </a:prstGeom>
-          <a:noFill/>
-          <a:ln/>
-        </p:spPr>
-        <p:txBody>
-          <a:bodyPr wrap="none" lIns="0" tIns="0" rIns="0" bIns="0" rtlCol="0" anchor="ctr"/>
-          <a:lstStyle/>
-          <a:p>
-            <a:pPr marL="0" indent="0">
-              <a:buNone/>
-            </a:pPr>
-            <a:r>
-              <a:rPr lang="en-US" sz="720" dirty="0">
-                <a:solidFill>
-                  <a:srgbClr val="6B7280"/>
-                </a:solidFill>
-                <a:latin typeface="Calibri" pitchFamily="34" charset="0"/>
-                <a:ea typeface="Calibri" pitchFamily="34" charset="-122"/>
-                <a:cs typeface="Calibri" pitchFamily="34" charset="-120"/>
-              </a:rPr>
-              <a:t>CS114: Máy học — Nhóm 10 — Báo cáo Đồ án: Phát hiện Tin nhắn &amp; Kịch bản Thao túng Tâm lý Lừa đảo nhắm vào Người cao tuổi tại Việt Nam</a:t>
-            </a:r>
-            <a:endParaRPr lang="en-US" sz="720" dirty="0"/>
-          </a:p>
-        </p:txBody>
-      </p:sp>
-      <p:sp>
-        <p:nvSpPr>
-          <p:cNvPr id="14" name="Text 10"/>
-          <p:cNvSpPr/>
-          <p:nvPr/>
-        </p:nvSpPr>
-        <p:spPr>
-          <a:xfrm>
-            <a:off x="7589520" y="4773168"/>
-            <a:ext cx="1097280" cy="228600"/>
-          </a:xfrm>
-          <a:prstGeom prst="rect">
-            <a:avLst/>
-          </a:prstGeom>
-          <a:noFill/>
-          <a:ln/>
-        </p:spPr>
-        <p:txBody>
-          <a:bodyPr wrap="square" lIns="0" tIns="0" rIns="0" bIns="0" rtlCol="0" anchor="ctr"/>
-          <a:lstStyle/>
-          <a:p>
-            <a:pPr marL="0" indent="0" algn="r">
-              <a:buNone/>
-            </a:pPr>
-            <a:r>
-              <a:rPr lang="en-US" sz="950" b="1" dirty="0">
-                <a:solidFill>
-                  <a:srgbClr val="1E40AF"/>
-                </a:solidFill>
-                <a:latin typeface="Calibri" pitchFamily="34" charset="0"/>
-                <a:ea typeface="Calibri" pitchFamily="34" charset="-122"/>
-                <a:cs typeface="Calibri" pitchFamily="34" charset="-120"/>
-              </a:rPr>
-              <a:t>14 / 22</a:t>
-            </a:r>
-            <a:endParaRPr lang="en-US" sz="950" dirty="0"/>
-          </a:p>
-        </p:txBody>
-      </p:sp>
     </p:spTree>
   </p:cSld>
   <p:clrMapOvr>
@@ -21485,40 +21461,7 @@
                 <a:ea typeface="Calibri" pitchFamily="34" charset="-122"/>
                 <a:cs typeface="Calibri" pitchFamily="34" charset="-120"/>
               </a:rPr>
-              <a:t>• 5.000 đặc trưng từ vựng n-gram + 15 đặc trưng miền tâm lý (URL, OTP</a:t>
-            </a:r>
-            <a:r>
-              <a:rPr lang="en-US" sz="950">
-                <a:solidFill>
-                  <a:srgbClr val="CBD5E1"/>
-                </a:solidFill>
-                <a:latin typeface="Calibri" pitchFamily="34" charset="0"/>
-                <a:ea typeface="Calibri" pitchFamily="34" charset="-122"/>
-                <a:cs typeface="Calibri" pitchFamily="34" charset="-120"/>
-              </a:rPr>
-              <a:t>, </a:t>
-            </a:r>
-            <a:r>
-              <a:rPr lang="vi-VN" sz="950">
-                <a:solidFill>
-                  <a:srgbClr val="CBD5E1"/>
-                </a:solidFill>
-                <a:latin typeface="Calibri" pitchFamily="34" charset="0"/>
-                <a:ea typeface="Calibri" pitchFamily="34" charset="-122"/>
-                <a:cs typeface="Calibri" pitchFamily="34" charset="-120"/>
-              </a:rPr>
-              <a:t>SĐT</a:t>
-            </a:r>
-            <a:r>
-              <a:rPr lang="en-US" sz="950" dirty="0">
-                <a:solidFill>
-                  <a:srgbClr val="CBD5E1"/>
-                </a:solidFill>
-                <a:latin typeface="Calibri" pitchFamily="34" charset="0"/>
-                <a:ea typeface="Calibri" pitchFamily="34" charset="-122"/>
-                <a:cs typeface="Calibri" pitchFamily="34" charset="-120"/>
-              </a:rPr>
-              <a:t>...)  •  Naive Bayes chỉ dùng 5.000 TF-IDF</a:t>
+              <a:t>• 5.000 đặc trưng từ vựng n-gram + 15 đặc trưng miền tâm lý (URL, OTP, SĐT...)  •  Naive Bayes chỉ dùng 5.000 TF-IDF</a:t>
             </a:r>
             <a:endParaRPr lang="en-US" sz="1100" dirty="0"/>
           </a:p>

</xml_diff>

<commit_message>
Fix Auxiliary Feature Wording on Pipeline Slide (#29)
- Sửa lỗi chú thích sai trên slide Pipeline (PHẦN 2):
- `draft/scam-detection/reports/slides/generate_slides.js`: đổi
`Hotline` thành `SĐT` trong danh sách 15 đặc trưng miền tâm lý ở dòng mô
tả không gian vector đặc trưng; đặc trưng thực tế là `num_phone_numbers`
(đếm số điện thoại, gồm cả tag [hotline]), không phải một đặc trưng
riêng tên "Hotline".
- Đồng bộ chỉnh sửa thủ công đã thực hiện trên PowerPoint vào script
sinh slide, tránh bị ghi đè khi regenerate deck.
- Xuất lại `phase09_presentation.pdf` (22 trang) từ PowerPoint để khớp
với `.pptx` đã cập nhật.
- Xác minh kiểm định thực nghiệm:
- Đối chiếu thủ công nội dung script build với bản PowerPoint đã lưu,
xác nhận khớp 100% trên slide liên quan.
- Dung lượng `.pptx` (2.75 MB) và `.pdf` (699 KB) an toàn Git (< 50MB).
</commit_message>
<xml_diff>
--- a/draft/scam-detection/reports/slides/phase09_presentation.pptx
+++ b/draft/scam-detection/reports/slides/phase09_presentation.pptx
@@ -2583,7 +2583,7 @@
         </p:blipFill>
         <p:spPr>
           <a:xfrm>
-            <a:off x="3200400" y="365760"/>
+            <a:off x="3200400" y="219787"/>
             <a:ext cx="2743200" cy="406965"/>
           </a:xfrm>
           <a:prstGeom prst="rect">
@@ -2599,8 +2599,8 @@
         </p:nvSpPr>
         <p:spPr>
           <a:xfrm>
-            <a:off x="457200" y="978408"/>
-            <a:ext cx="8229600" cy="1188720"/>
+            <a:off x="457200" y="706019"/>
+            <a:ext cx="8229600" cy="1593342"/>
           </a:xfrm>
           <a:prstGeom prst="rect">
             <a:avLst/>
@@ -2615,6 +2615,9 @@
           <a:lstStyle/>
           <a:p>
             <a:pPr marL="0" indent="0" algn="ctr">
+              <a:lnSpc>
+                <a:spcPct val="110000"/>
+              </a:lnSpc>
               <a:buNone/>
             </a:pPr>
             <a:r>
@@ -2632,6 +2635,9 @@
           </a:p>
           <a:p>
             <a:pPr marL="0" indent="0" algn="ctr">
+              <a:lnSpc>
+                <a:spcPct val="110000"/>
+              </a:lnSpc>
               <a:buNone/>
             </a:pPr>
             <a:r>
@@ -2649,6 +2655,9 @@
           </a:p>
           <a:p>
             <a:pPr marL="0" indent="0" algn="ctr">
+              <a:lnSpc>
+                <a:spcPct val="110000"/>
+              </a:lnSpc>
               <a:buNone/>
             </a:pPr>
             <a:r>
@@ -7117,26 +7126,318 @@
           </a:p>
         </p:txBody>
       </p:sp>
+      <p:sp>
+        <p:nvSpPr>
+          <p:cNvPr id="10" name="Text 7"/>
+          <p:cNvSpPr/>
+          <p:nvPr/>
+        </p:nvSpPr>
+        <p:spPr>
+          <a:xfrm>
+            <a:off x="433290" y="4539996"/>
+            <a:ext cx="4937760" cy="201168"/>
+          </a:xfrm>
+          <a:prstGeom prst="rect">
+            <a:avLst/>
+          </a:prstGeom>
+          <a:noFill/>
+          <a:ln/>
+        </p:spPr>
+        <p:txBody>
+          <a:bodyPr wrap="square" rtlCol="0" anchor="ctr"/>
+          <a:lstStyle/>
+          <a:p>
+            <a:pPr marL="0" indent="0" algn="ctr">
+              <a:buNone/>
+            </a:pPr>
+            <a:r>
+              <a:rPr lang="en-US" sz="1000" i="1" dirty="0">
+                <a:solidFill>
+                  <a:srgbClr val="6B7280"/>
+                </a:solidFill>
+                <a:latin typeface="Calibri" pitchFamily="34" charset="0"/>
+                <a:ea typeface="Calibri" pitchFamily="34" charset="-122"/>
+                <a:cs typeface="Calibri" pitchFamily="34" charset="-120"/>
+              </a:rPr>
+              <a:t>Giao diện phân tích tin nhắn thời gian thực với trợ năng người cao tuổi</a:t>
+            </a:r>
+            <a:endParaRPr lang="en-US" sz="1000" dirty="0"/>
+          </a:p>
+        </p:txBody>
+      </p:sp>
+      <p:sp>
+        <p:nvSpPr>
+          <p:cNvPr id="11" name="Text 8"/>
+          <p:cNvSpPr/>
+          <p:nvPr/>
+        </p:nvSpPr>
+        <p:spPr>
+          <a:xfrm>
+            <a:off x="5669280" y="1143000"/>
+            <a:ext cx="3017520" cy="3474720"/>
+          </a:xfrm>
+          <a:prstGeom prst="rect">
+            <a:avLst/>
+          </a:prstGeom>
+          <a:noFill/>
+          <a:ln/>
+        </p:spPr>
+        <p:txBody>
+          <a:bodyPr wrap="square" lIns="25400" tIns="0" rIns="0" bIns="50800" rtlCol="0" anchor="t">
+            <a:normAutofit/>
+          </a:bodyPr>
+          <a:lstStyle/>
+          <a:p>
+            <a:pPr marL="177800" indent="-177800">
+              <a:spcAft>
+                <a:spcPts val="500"/>
+              </a:spcAft>
+              <a:buSzPct val="100000"/>
+              <a:buChar char="•"/>
+            </a:pPr>
+            <a:r>
+              <a:rPr lang="en-US" sz="1350" dirty="0">
+                <a:solidFill>
+                  <a:srgbClr val="1F2937"/>
+                </a:solidFill>
+                <a:latin typeface="Calibri" pitchFamily="34" charset="0"/>
+                <a:ea typeface="Calibri" pitchFamily="34" charset="-122"/>
+                <a:cs typeface="Calibri" pitchFamily="34" charset="-120"/>
+              </a:rPr>
+              <a:t>4 mô hình trong 1 ứng dụng (mặc định XGBoost)</a:t>
+            </a:r>
+            <a:endParaRPr lang="en-US" sz="1350" dirty="0"/>
+          </a:p>
+          <a:p>
+            <a:pPr marL="177800" indent="-177800">
+              <a:spcAft>
+                <a:spcPts val="500"/>
+              </a:spcAft>
+              <a:buSzPct val="100000"/>
+              <a:buChar char="•"/>
+            </a:pPr>
+            <a:r>
+              <a:rPr lang="en-US" sz="1350" dirty="0">
+                <a:solidFill>
+                  <a:srgbClr val="1F2937"/>
+                </a:solidFill>
+                <a:latin typeface="Calibri" pitchFamily="34" charset="0"/>
+                <a:ea typeface="Calibri" pitchFamily="34" charset="-122"/>
+                <a:cs typeface="Calibri" pitchFamily="34" charset="-120"/>
+              </a:rPr>
+              <a:t>Chỉnh cỡ chữ 100% · 125% · 150%</a:t>
+            </a:r>
+            <a:endParaRPr lang="en-US" sz="1350" dirty="0"/>
+          </a:p>
+          <a:p>
+            <a:pPr marL="177800" indent="-177800">
+              <a:spcAft>
+                <a:spcPts val="500"/>
+              </a:spcAft>
+              <a:buSzPct val="100000"/>
+              <a:buChar char="•"/>
+            </a:pPr>
+            <a:r>
+              <a:rPr lang="en-US" sz="1350" dirty="0">
+                <a:solidFill>
+                  <a:srgbClr val="1F2937"/>
+                </a:solidFill>
+                <a:latin typeface="Calibri" pitchFamily="34" charset="0"/>
+                <a:ea typeface="Calibri" pitchFamily="34" charset="-122"/>
+                <a:cs typeface="Calibri" pitchFamily="34" charset="-120"/>
+              </a:rPr>
+              <a:t>Tương phản chữ 14.6:1, vượt mức WCAG 2.1 AA (4.5:1) [14]</a:t>
+            </a:r>
+            <a:endParaRPr lang="en-US" sz="1350" dirty="0"/>
+          </a:p>
+          <a:p>
+            <a:pPr marL="177800" indent="-177800">
+              <a:spcAft>
+                <a:spcPts val="500"/>
+              </a:spcAft>
+              <a:buSzPct val="100000"/>
+              <a:buChar char="•"/>
+            </a:pPr>
+            <a:r>
+              <a:rPr lang="en-US" sz="1350" dirty="0">
+                <a:solidFill>
+                  <a:srgbClr val="1F2937"/>
+                </a:solidFill>
+                <a:latin typeface="Calibri" pitchFamily="34" charset="0"/>
+                <a:ea typeface="Calibri" pitchFamily="34" charset="-122"/>
+                <a:cs typeface="Calibri" pitchFamily="34" charset="-120"/>
+              </a:rPr>
+              <a:t>Hotline khẩn cấp 156 / 113 gọi 1 chạm</a:t>
+            </a:r>
+            <a:endParaRPr lang="en-US" sz="1350" dirty="0"/>
+          </a:p>
+          <a:p>
+            <a:pPr marL="177800" indent="-177800">
+              <a:spcAft>
+                <a:spcPts val="500"/>
+              </a:spcAft>
+              <a:buSzPct val="100000"/>
+              <a:buChar char="•"/>
+            </a:pPr>
+            <a:r>
+              <a:rPr lang="en-US" sz="1350" dirty="0">
+                <a:solidFill>
+                  <a:srgbClr val="1F2937"/>
+                </a:solidFill>
+                <a:latin typeface="Calibri" pitchFamily="34" charset="0"/>
+                <a:ea typeface="Calibri" pitchFamily="34" charset="-122"/>
+                <a:cs typeface="Calibri" pitchFamily="34" charset="-120"/>
+              </a:rPr>
+              <a:t>Dán tin nhắn → tự động phân tích</a:t>
+            </a:r>
+            <a:endParaRPr lang="en-US" sz="1350" dirty="0"/>
+          </a:p>
+          <a:p>
+            <a:pPr marL="177800" indent="-177800">
+              <a:spcAft>
+                <a:spcPts val="500"/>
+              </a:spcAft>
+              <a:buSzPct val="100000"/>
+              <a:buChar char="•"/>
+            </a:pPr>
+            <a:r>
+              <a:rPr lang="en-US" sz="1350" dirty="0">
+                <a:solidFill>
+                  <a:srgbClr val="1F2937"/>
+                </a:solidFill>
+                <a:latin typeface="Calibri" pitchFamily="34" charset="0"/>
+                <a:ea typeface="Calibri" pitchFamily="34" charset="-122"/>
+                <a:cs typeface="Calibri" pitchFamily="34" charset="-120"/>
+              </a:rPr>
+              <a:t>Trích xuất 15 đặc trưng tâm lý theo thời gian thực</a:t>
+            </a:r>
+            <a:endParaRPr lang="en-US" sz="1350" dirty="0"/>
+          </a:p>
+          <a:p>
+            <a:pPr marL="177800" indent="-177800">
+              <a:spcAft>
+                <a:spcPts val="500"/>
+              </a:spcAft>
+              <a:buSzPct val="100000"/>
+              <a:buChar char="•"/>
+            </a:pPr>
+            <a:r>
+              <a:rPr lang="en-US" sz="1350" dirty="0">
+                <a:solidFill>
+                  <a:srgbClr val="1F2937"/>
+                </a:solidFill>
+                <a:latin typeface="Calibri" pitchFamily="34" charset="0"/>
+                <a:ea typeface="Calibri" pitchFamily="34" charset="-122"/>
+                <a:cs typeface="Calibri" pitchFamily="34" charset="-120"/>
+              </a:rPr>
+              <a:t>Tối ưu điện thoại · 16/16 kiểm thử E2E Playwright</a:t>
+            </a:r>
+            <a:endParaRPr lang="en-US" sz="1350" dirty="0"/>
+          </a:p>
+        </p:txBody>
+      </p:sp>
+      <p:sp>
+        <p:nvSpPr>
+          <p:cNvPr id="13" name="Text 9"/>
+          <p:cNvSpPr/>
+          <p:nvPr/>
+        </p:nvSpPr>
+        <p:spPr>
+          <a:xfrm>
+            <a:off x="457200" y="4773168"/>
+            <a:ext cx="7040880" cy="228600"/>
+          </a:xfrm>
+          <a:prstGeom prst="rect">
+            <a:avLst/>
+          </a:prstGeom>
+          <a:noFill/>
+          <a:ln/>
+        </p:spPr>
+        <p:txBody>
+          <a:bodyPr wrap="none" lIns="0" tIns="0" rIns="0" bIns="0" rtlCol="0" anchor="ctr"/>
+          <a:lstStyle/>
+          <a:p>
+            <a:pPr marL="0" indent="0">
+              <a:buNone/>
+            </a:pPr>
+            <a:r>
+              <a:rPr lang="en-US" sz="720" dirty="0">
+                <a:solidFill>
+                  <a:srgbClr val="6B7280"/>
+                </a:solidFill>
+                <a:latin typeface="Calibri" pitchFamily="34" charset="0"/>
+                <a:ea typeface="Calibri" pitchFamily="34" charset="-122"/>
+                <a:cs typeface="Calibri" pitchFamily="34" charset="-120"/>
+              </a:rPr>
+              <a:t>CS114: Máy học — Nhóm 10 — Báo cáo Đồ án: Phát hiện Tin nhắn &amp; Kịch bản Thao túng Tâm lý Lừa đảo nhắm vào Người cao tuổi tại Việt Nam</a:t>
+            </a:r>
+            <a:endParaRPr lang="en-US" sz="720" dirty="0"/>
+          </a:p>
+        </p:txBody>
+      </p:sp>
+      <p:sp>
+        <p:nvSpPr>
+          <p:cNvPr id="14" name="Text 10"/>
+          <p:cNvSpPr/>
+          <p:nvPr/>
+        </p:nvSpPr>
+        <p:spPr>
+          <a:xfrm>
+            <a:off x="7589520" y="4773168"/>
+            <a:ext cx="1097280" cy="228600"/>
+          </a:xfrm>
+          <a:prstGeom prst="rect">
+            <a:avLst/>
+          </a:prstGeom>
+          <a:noFill/>
+          <a:ln/>
+        </p:spPr>
+        <p:txBody>
+          <a:bodyPr wrap="square" lIns="0" tIns="0" rIns="0" bIns="0" rtlCol="0" anchor="ctr"/>
+          <a:lstStyle/>
+          <a:p>
+            <a:pPr marL="0" indent="0" algn="r">
+              <a:buNone/>
+            </a:pPr>
+            <a:r>
+              <a:rPr lang="en-US" sz="950" b="1" dirty="0">
+                <a:solidFill>
+                  <a:srgbClr val="1E40AF"/>
+                </a:solidFill>
+                <a:latin typeface="Calibri" pitchFamily="34" charset="0"/>
+                <a:ea typeface="Calibri" pitchFamily="34" charset="-122"/>
+                <a:cs typeface="Calibri" pitchFamily="34" charset="-120"/>
+              </a:rPr>
+              <a:t>14 / 22</a:t>
+            </a:r>
+            <a:endParaRPr lang="en-US" sz="950" dirty="0"/>
+          </a:p>
+        </p:txBody>
+      </p:sp>
       <p:pic>
         <p:nvPicPr>
-          <p:cNvPr id="9" name="Image 0" descr="/Users/tcdtist/dev/uit/cs114/assignments/Final/draft/scam-detection/reports/figures/demo_03_scam_detection_verdict.png"/>
+          <p:cNvPr id="16" name="Picture 15" descr="A screenshot of a web page&#10;&#10;AI-generated content may be incorrect.">
+            <a:extLst>
+              <a:ext uri="{FF2B5EF4-FFF2-40B4-BE49-F238E27FC236}">
+                <a16:creationId xmlns:a16="http://schemas.microsoft.com/office/drawing/2014/main" id="{654FF8A9-1076-1FA0-63E6-B6E174247E15}"/>
+              </a:ext>
+            </a:extLst>
+          </p:cNvPr>
           <p:cNvPicPr>
             <a:picLocks noChangeAspect="1"/>
           </p:cNvPicPr>
           <p:nvPr/>
         </p:nvPicPr>
         <p:blipFill>
-          <a:blip r:embed="rId3">
-            <a:alphaModFix/>
-          </a:blip>
+          <a:blip r:embed="rId3"/>
           <a:stretch>
             <a:fillRect/>
           </a:stretch>
         </p:blipFill>
         <p:spPr>
           <a:xfrm>
-            <a:off x="479502" y="1110327"/>
-            <a:ext cx="4915458" cy="3276972"/>
+            <a:off x="433290" y="1019556"/>
+            <a:ext cx="4913850" cy="3359220"/>
           </a:xfrm>
           <a:prstGeom prst="roundRect">
             <a:avLst>
@@ -7169,294 +7470,6 @@
           </a:sp3d>
         </p:spPr>
       </p:pic>
-      <p:sp>
-        <p:nvSpPr>
-          <p:cNvPr id="10" name="Text 7"/>
-          <p:cNvSpPr/>
-          <p:nvPr/>
-        </p:nvSpPr>
-        <p:spPr>
-          <a:xfrm>
-            <a:off x="433290" y="4494276"/>
-            <a:ext cx="4937760" cy="201168"/>
-          </a:xfrm>
-          <a:prstGeom prst="rect">
-            <a:avLst/>
-          </a:prstGeom>
-          <a:noFill/>
-          <a:ln/>
-        </p:spPr>
-        <p:txBody>
-          <a:bodyPr wrap="square" rtlCol="0" anchor="ctr"/>
-          <a:lstStyle/>
-          <a:p>
-            <a:pPr marL="0" indent="0" algn="ctr">
-              <a:buNone/>
-            </a:pPr>
-            <a:r>
-              <a:rPr lang="en-US" sz="1000" i="1" dirty="0">
-                <a:solidFill>
-                  <a:srgbClr val="6B7280"/>
-                </a:solidFill>
-                <a:latin typeface="Calibri" pitchFamily="34" charset="0"/>
-                <a:ea typeface="Calibri" pitchFamily="34" charset="-122"/>
-                <a:cs typeface="Calibri" pitchFamily="34" charset="-120"/>
-              </a:rPr>
-              <a:t>Giao diện phân tích tin nhắn thời gian thực với trợ năng người cao tuổi</a:t>
-            </a:r>
-            <a:endParaRPr lang="en-US" sz="1000" dirty="0"/>
-          </a:p>
-        </p:txBody>
-      </p:sp>
-      <p:sp>
-        <p:nvSpPr>
-          <p:cNvPr id="11" name="Text 8"/>
-          <p:cNvSpPr/>
-          <p:nvPr/>
-        </p:nvSpPr>
-        <p:spPr>
-          <a:xfrm>
-            <a:off x="5669280" y="1143000"/>
-            <a:ext cx="3017520" cy="3474720"/>
-          </a:xfrm>
-          <a:prstGeom prst="rect">
-            <a:avLst/>
-          </a:prstGeom>
-          <a:noFill/>
-          <a:ln/>
-        </p:spPr>
-        <p:txBody>
-          <a:bodyPr wrap="square" lIns="25400" tIns="0" rIns="0" bIns="50800" rtlCol="0" anchor="t">
-            <a:normAutofit/>
-          </a:bodyPr>
-          <a:lstStyle/>
-          <a:p>
-            <a:pPr marL="177800" indent="-177800">
-              <a:spcAft>
-                <a:spcPts val="500"/>
-              </a:spcAft>
-              <a:buSzPct val="100000"/>
-              <a:buChar char="•"/>
-            </a:pPr>
-            <a:r>
-              <a:rPr lang="en-US" sz="1350" dirty="0">
-                <a:solidFill>
-                  <a:srgbClr val="1F2937"/>
-                </a:solidFill>
-                <a:latin typeface="Calibri" pitchFamily="34" charset="0"/>
-                <a:ea typeface="Calibri" pitchFamily="34" charset="-122"/>
-                <a:cs typeface="Calibri" pitchFamily="34" charset="-120"/>
-              </a:rPr>
-              <a:t>4 mô hình trong 1 ứng dụng (mặc định XGBoost)</a:t>
-            </a:r>
-            <a:endParaRPr lang="en-US" sz="1350" dirty="0"/>
-          </a:p>
-          <a:p>
-            <a:pPr marL="177800" indent="-177800">
-              <a:spcAft>
-                <a:spcPts val="500"/>
-              </a:spcAft>
-              <a:buSzPct val="100000"/>
-              <a:buChar char="•"/>
-            </a:pPr>
-            <a:r>
-              <a:rPr lang="en-US" sz="1350" dirty="0">
-                <a:solidFill>
-                  <a:srgbClr val="1F2937"/>
-                </a:solidFill>
-                <a:latin typeface="Calibri" pitchFamily="34" charset="0"/>
-                <a:ea typeface="Calibri" pitchFamily="34" charset="-122"/>
-                <a:cs typeface="Calibri" pitchFamily="34" charset="-120"/>
-              </a:rPr>
-              <a:t>Chỉnh cỡ chữ 100% · 125% · 150%</a:t>
-            </a:r>
-            <a:endParaRPr lang="en-US" sz="1350" dirty="0"/>
-          </a:p>
-          <a:p>
-            <a:pPr marL="177800" indent="-177800">
-              <a:spcAft>
-                <a:spcPts val="500"/>
-              </a:spcAft>
-              <a:buSzPct val="100000"/>
-              <a:buChar char="•"/>
-            </a:pPr>
-            <a:r>
-              <a:rPr lang="en-US" sz="1350" dirty="0">
-                <a:solidFill>
-                  <a:srgbClr val="1F2937"/>
-                </a:solidFill>
-                <a:latin typeface="Calibri" pitchFamily="34" charset="0"/>
-                <a:ea typeface="Calibri" pitchFamily="34" charset="-122"/>
-                <a:cs typeface="Calibri" pitchFamily="34" charset="-120"/>
-              </a:rPr>
-              <a:t>Tương phản chữ 14.6:1, vượt mức WCAG 2.1 AA (4.5:1) [14]</a:t>
-            </a:r>
-            <a:endParaRPr lang="en-US" sz="1350" dirty="0"/>
-          </a:p>
-          <a:p>
-            <a:pPr marL="177800" indent="-177800">
-              <a:spcAft>
-                <a:spcPts val="500"/>
-              </a:spcAft>
-              <a:buSzPct val="100000"/>
-              <a:buChar char="•"/>
-            </a:pPr>
-            <a:r>
-              <a:rPr lang="en-US" sz="1350" dirty="0">
-                <a:solidFill>
-                  <a:srgbClr val="1F2937"/>
-                </a:solidFill>
-                <a:latin typeface="Calibri" pitchFamily="34" charset="0"/>
-                <a:ea typeface="Calibri" pitchFamily="34" charset="-122"/>
-                <a:cs typeface="Calibri" pitchFamily="34" charset="-120"/>
-              </a:rPr>
-              <a:t>Hotline khẩn cấp 156 / 113 gọi 1 chạm</a:t>
-            </a:r>
-            <a:endParaRPr lang="en-US" sz="1350" dirty="0"/>
-          </a:p>
-          <a:p>
-            <a:pPr marL="177800" indent="-177800">
-              <a:spcAft>
-                <a:spcPts val="500"/>
-              </a:spcAft>
-              <a:buSzPct val="100000"/>
-              <a:buChar char="•"/>
-            </a:pPr>
-            <a:r>
-              <a:rPr lang="en-US" sz="1350" dirty="0">
-                <a:solidFill>
-                  <a:srgbClr val="1F2937"/>
-                </a:solidFill>
-                <a:latin typeface="Calibri" pitchFamily="34" charset="0"/>
-                <a:ea typeface="Calibri" pitchFamily="34" charset="-122"/>
-                <a:cs typeface="Calibri" pitchFamily="34" charset="-120"/>
-              </a:rPr>
-              <a:t>Dán tin nhắn → tự động phân tích</a:t>
-            </a:r>
-            <a:endParaRPr lang="en-US" sz="1350" dirty="0"/>
-          </a:p>
-          <a:p>
-            <a:pPr marL="177800" indent="-177800">
-              <a:spcAft>
-                <a:spcPts val="500"/>
-              </a:spcAft>
-              <a:buSzPct val="100000"/>
-              <a:buChar char="•"/>
-            </a:pPr>
-            <a:r>
-              <a:rPr lang="en-US" sz="1350" dirty="0">
-                <a:solidFill>
-                  <a:srgbClr val="1F2937"/>
-                </a:solidFill>
-                <a:latin typeface="Calibri" pitchFamily="34" charset="0"/>
-                <a:ea typeface="Calibri" pitchFamily="34" charset="-122"/>
-                <a:cs typeface="Calibri" pitchFamily="34" charset="-120"/>
-              </a:rPr>
-              <a:t>Trích xuất 15 đặc trưng tâm lý theo thời gian thực</a:t>
-            </a:r>
-            <a:endParaRPr lang="en-US" sz="1350" dirty="0"/>
-          </a:p>
-          <a:p>
-            <a:pPr marL="177800" indent="-177800">
-              <a:spcAft>
-                <a:spcPts val="500"/>
-              </a:spcAft>
-              <a:buSzPct val="100000"/>
-              <a:buChar char="•"/>
-            </a:pPr>
-            <a:r>
-              <a:rPr lang="en-US" sz="1350" dirty="0">
-                <a:solidFill>
-                  <a:srgbClr val="1F2937"/>
-                </a:solidFill>
-                <a:latin typeface="Calibri" pitchFamily="34" charset="0"/>
-                <a:ea typeface="Calibri" pitchFamily="34" charset="-122"/>
-                <a:cs typeface="Calibri" pitchFamily="34" charset="-120"/>
-              </a:rPr>
-              <a:t>Tối ưu điện thoại · 16/16 kiểm thử E2E Playwright</a:t>
-            </a:r>
-            <a:endParaRPr lang="en-US" sz="1350" dirty="0"/>
-          </a:p>
-        </p:txBody>
-      </p:sp>
-      <p:sp>
-        <p:nvSpPr>
-          <p:cNvPr id="13" name="Text 9"/>
-          <p:cNvSpPr/>
-          <p:nvPr/>
-        </p:nvSpPr>
-        <p:spPr>
-          <a:xfrm>
-            <a:off x="457200" y="4773168"/>
-            <a:ext cx="7040880" cy="228600"/>
-          </a:xfrm>
-          <a:prstGeom prst="rect">
-            <a:avLst/>
-          </a:prstGeom>
-          <a:noFill/>
-          <a:ln/>
-        </p:spPr>
-        <p:txBody>
-          <a:bodyPr wrap="none" lIns="0" tIns="0" rIns="0" bIns="0" rtlCol="0" anchor="ctr"/>
-          <a:lstStyle/>
-          <a:p>
-            <a:pPr marL="0" indent="0">
-              <a:buNone/>
-            </a:pPr>
-            <a:r>
-              <a:rPr lang="en-US" sz="720" dirty="0">
-                <a:solidFill>
-                  <a:srgbClr val="6B7280"/>
-                </a:solidFill>
-                <a:latin typeface="Calibri" pitchFamily="34" charset="0"/>
-                <a:ea typeface="Calibri" pitchFamily="34" charset="-122"/>
-                <a:cs typeface="Calibri" pitchFamily="34" charset="-120"/>
-              </a:rPr>
-              <a:t>CS114: Máy học — Nhóm 10 — Báo cáo Đồ án: Phát hiện Tin nhắn &amp; Kịch bản Thao túng Tâm lý Lừa đảo nhắm vào Người cao tuổi tại Việt Nam</a:t>
-            </a:r>
-            <a:endParaRPr lang="en-US" sz="720" dirty="0"/>
-          </a:p>
-        </p:txBody>
-      </p:sp>
-      <p:sp>
-        <p:nvSpPr>
-          <p:cNvPr id="14" name="Text 10"/>
-          <p:cNvSpPr/>
-          <p:nvPr/>
-        </p:nvSpPr>
-        <p:spPr>
-          <a:xfrm>
-            <a:off x="7589520" y="4773168"/>
-            <a:ext cx="1097280" cy="228600"/>
-          </a:xfrm>
-          <a:prstGeom prst="rect">
-            <a:avLst/>
-          </a:prstGeom>
-          <a:noFill/>
-          <a:ln/>
-        </p:spPr>
-        <p:txBody>
-          <a:bodyPr wrap="square" lIns="0" tIns="0" rIns="0" bIns="0" rtlCol="0" anchor="ctr"/>
-          <a:lstStyle/>
-          <a:p>
-            <a:pPr marL="0" indent="0" algn="r">
-              <a:buNone/>
-            </a:pPr>
-            <a:r>
-              <a:rPr lang="en-US" sz="950" b="1" dirty="0">
-                <a:solidFill>
-                  <a:srgbClr val="1E40AF"/>
-                </a:solidFill>
-                <a:latin typeface="Calibri" pitchFamily="34" charset="0"/>
-                <a:ea typeface="Calibri" pitchFamily="34" charset="-122"/>
-                <a:cs typeface="Calibri" pitchFamily="34" charset="-120"/>
-              </a:rPr>
-              <a:t>14 / 22</a:t>
-            </a:r>
-            <a:endParaRPr lang="en-US" sz="950" dirty="0"/>
-          </a:p>
-        </p:txBody>
-      </p:sp>
     </p:spTree>
   </p:cSld>
   <p:clrMapOvr>
@@ -10049,13 +10062,13 @@
   <p:clrMapOvr>
     <a:masterClrMapping/>
   </p:clrMapOvr>
-  <mc:AlternateContent xmlns:mc="http://schemas.openxmlformats.org/markup-compatibility/2006">
-    <mc:Choice xmlns:p15="http://schemas.microsoft.com/office/powerpoint/2012/main" Requires="p15">
+  <mc:AlternateContent xmlns:mc="http://schemas.openxmlformats.org/markup-compatibility/2006" xmlns:p15="http://schemas.microsoft.com/office/powerpoint/2012/main">
+    <mc:Choice Requires="p15">
       <p:transition xmlns:p14="http://schemas.microsoft.com/office/powerpoint/2010/main" spd="slow" p14:dur="2000">
         <p15:prstTrans prst="crush"/>
       </p:transition>
     </mc:Choice>
-    <mc:Fallback>
+    <mc:Fallback xmlns="">
       <p:transition spd="slow">
         <p:fade/>
       </p:transition>
@@ -21448,7 +21461,7 @@
                 <a:ea typeface="Calibri" pitchFamily="34" charset="-122"/>
                 <a:cs typeface="Calibri" pitchFamily="34" charset="-120"/>
               </a:rPr>
-              <a:t>• 5.000 đặc trưng từ vựng n-gram + 15 đặc trưng miền tâm lý (URL, OTP, Hotline...)  •  Naive Bayes chỉ dùng 5.000 TF-IDF</a:t>
+              <a:t>• 5.000 đặc trưng từ vựng n-gram + 15 đặc trưng miền tâm lý (URL, OTP, SĐT...)  •  Naive Bayes chỉ dùng 5.000 TF-IDF</a:t>
             </a:r>
             <a:endParaRPr lang="en-US" sz="1100" dirty="0"/>
           </a:p>

</xml_diff>